<commit_message>
Complete deliverables with identity and schema drift controls
</commit_message>
<xml_diff>
--- a/deliverables/Amazon_Q2_2026_Leadership_Presentation.pptx
+++ b/deliverables/Amazon_Q2_2026_Leadership_Presentation.pptx
@@ -2,22 +2,22 @@
 <file path=ppt/presentation.xml><?xml version="1.0" encoding="utf-8"?>
 <p:presentation xmlns:p="http://schemas.openxmlformats.org/presentationml/2006/main">
   <p:sldMasterIdLst>
-    <p:sldMasterId xmlns:r="http://schemas.openxmlformats.org/officeDocument/2006/relationships" id="2147483648" r:id="R8faa2b5bedc841eb"/>
+    <p:sldMasterId xmlns:r="http://schemas.openxmlformats.org/officeDocument/2006/relationships" id="2147483648" r:id="Rf3fa090a7c07443b"/>
   </p:sldMasterIdLst>
   <p:notesMasterIdLst>
-    <p:notesMasterId xmlns:r="http://schemas.openxmlformats.org/officeDocument/2006/relationships" r:id="R9359f8f47fe54a91"/>
+    <p:notesMasterId xmlns:r="http://schemas.openxmlformats.org/officeDocument/2006/relationships" r:id="Rc6a8e1b0c1904ef1"/>
   </p:notesMasterIdLst>
   <p:sldIdLst>
-    <p:sldId xmlns:r="http://schemas.openxmlformats.org/officeDocument/2006/relationships" id="256" r:id="R5310ee9f68b441f6"/>
-    <p:sldId xmlns:r="http://schemas.openxmlformats.org/officeDocument/2006/relationships" id="257" r:id="R37ec93f6e4354ec7"/>
-    <p:sldId xmlns:r="http://schemas.openxmlformats.org/officeDocument/2006/relationships" id="258" r:id="R3ecf7deb491340cd"/>
-    <p:sldId xmlns:r="http://schemas.openxmlformats.org/officeDocument/2006/relationships" id="259" r:id="R981dcab6be0d4f4d"/>
-    <p:sldId xmlns:r="http://schemas.openxmlformats.org/officeDocument/2006/relationships" id="260" r:id="Rf6f34c5e08074e0a"/>
-    <p:sldId xmlns:r="http://schemas.openxmlformats.org/officeDocument/2006/relationships" id="261" r:id="R8b7679ec3abd41be"/>
-    <p:sldId xmlns:r="http://schemas.openxmlformats.org/officeDocument/2006/relationships" id="262" r:id="R930ff45194c74ba8"/>
-    <p:sldId xmlns:r="http://schemas.openxmlformats.org/officeDocument/2006/relationships" id="263" r:id="R696d6dd909bb4a41"/>
-    <p:sldId xmlns:r="http://schemas.openxmlformats.org/officeDocument/2006/relationships" id="264" r:id="Rf11a42f8dd6b48da"/>
-    <p:sldId xmlns:r="http://schemas.openxmlformats.org/officeDocument/2006/relationships" id="265" r:id="Raf2095dd40ad4c7c"/>
+    <p:sldId xmlns:r="http://schemas.openxmlformats.org/officeDocument/2006/relationships" id="256" r:id="Re4adbabdf9824d8e"/>
+    <p:sldId xmlns:r="http://schemas.openxmlformats.org/officeDocument/2006/relationships" id="257" r:id="Rdfbe48eeac784ef9"/>
+    <p:sldId xmlns:r="http://schemas.openxmlformats.org/officeDocument/2006/relationships" id="258" r:id="R0a4ba87c39aa4c0f"/>
+    <p:sldId xmlns:r="http://schemas.openxmlformats.org/officeDocument/2006/relationships" id="259" r:id="Rcf83e56cf2ef47ff"/>
+    <p:sldId xmlns:r="http://schemas.openxmlformats.org/officeDocument/2006/relationships" id="260" r:id="R0510e3bbbcd1423c"/>
+    <p:sldId xmlns:r="http://schemas.openxmlformats.org/officeDocument/2006/relationships" id="261" r:id="Re10c068907c64850"/>
+    <p:sldId xmlns:r="http://schemas.openxmlformats.org/officeDocument/2006/relationships" id="262" r:id="Rccca3cce016247ac"/>
+    <p:sldId xmlns:r="http://schemas.openxmlformats.org/officeDocument/2006/relationships" id="263" r:id="R2757c3f934dc4a2e"/>
+    <p:sldId xmlns:r="http://schemas.openxmlformats.org/officeDocument/2006/relationships" id="264" r:id="Re21f9c3cf0054983"/>
+    <p:sldId xmlns:r="http://schemas.openxmlformats.org/officeDocument/2006/relationships" id="265" r:id="R6fd247134f0e429c"/>
   </p:sldIdLst>
   <p:sldSz cx="12192000" cy="6858000"/>
   <p:notesSz cx="6858000" cy="9144000"/>
@@ -736,7 +736,7 @@
           <a:lstStyle xmlns:a="http://schemas.openxmlformats.org/drawingml/2006/main"/>
           <a:p xmlns:a="http://schemas.openxmlformats.org/drawingml/2006/main">
             <a:r>
-              <a:t>Explain that the identifier bridge is the key scaling decision. SKU is authoritative in this sample, but aliases, ASINs, UPCs, marketplaces, and effective dates must resolve through one governed bridge. Prefix parsing is only a fallback.</a:t>
+              <a:t>Explain that Bronze, Silver, and Gold are business contracts rather than vendor-specific labels. The identifier bridge is the key scaling decision: SKU is authoritative in this sample, while aliases, ASINs, marketplaces, and effective dates resolve once before facts publish.</a:t>
             </a:r>
           </a:p>
           <a:p xmlns:a="http://schemas.openxmlformats.org/drawingml/2006/main">
@@ -756,7 +756,7 @@
           </a:p>
           <a:p xmlns:a="http://schemas.openxmlformats.org/drawingml/2006/main">
             <a:r>
-              <a:t>- Candidate-proposed architecture documented in data_model.md and the assessment brief.</a:t>
+              <a:t>- Candidate-proposed architecture documented in data_model.md, architecture_options.md, and the assessment brief.</a:t>
             </a:r>
           </a:p>
           <a:p xmlns:a="http://schemas.openxmlformats.org/drawingml/2006/main">
@@ -1301,7 +1301,7 @@
           <a:lstStyle xmlns:a="http://schemas.openxmlformats.org/drawingml/2006/main"/>
           <a:p xmlns:a="http://schemas.openxmlformats.org/drawingml/2006/main">
             <a:r>
-              <a:t>Present this as an order of operations. Days 1–30 eliminate manual extraction and uncontrolled mappings. Days 31–60 produce the trusted P&amp;L and close reconciliation. Days 61–90 add the missing lifecycle and attribution detail that enables forward-looking actions.</a:t>
+              <a:t>Present the first month as common and non-negotiable. Recommend the efficient path unless connector reliability and implementation speed justify managed ELT. Both options still deliver the management P&amp;L by day 60 and forward-looking inventory/ad actions by day 90 because the Bronze-Silver-Gold contracts are identical.</a:t>
             </a:r>
           </a:p>
           <a:p xmlns:a="http://schemas.openxmlformats.org/drawingml/2006/main">
@@ -1321,7 +1321,27 @@
           </a:p>
           <a:p xmlns:a="http://schemas.openxmlformats.org/drawingml/2006/main">
             <a:r>
-              <a:t>- Candidate automation proposal documented in automation_90_day_plan.md and the assessment brief.</a:t>
+              <a:t>- Candidate automation proposal documented in automation_90_day_plan.md, architecture_options.md, and the assessment brief.</a:t>
+            </a:r>
+          </a:p>
+          <a:p xmlns:a="http://schemas.openxmlformats.org/drawingml/2006/main">
+            <a:r>
+              <a:t>- https://docs.cloud.google.com/dataform/docs/overview</a:t>
+            </a:r>
+          </a:p>
+          <a:p xmlns:a="http://schemas.openxmlformats.org/drawingml/2006/main">
+            <a:r>
+              <a:t>- https://docs.cloud.google.com/bigquery/docs/connected-sheets</a:t>
+            </a:r>
+          </a:p>
+          <a:p xmlns:a="http://schemas.openxmlformats.org/drawingml/2006/main">
+            <a:r>
+              <a:t>- https://fivetran.com/docs/connectors/applications/amazon-selling-partner/setup-guide</a:t>
+            </a:r>
+          </a:p>
+          <a:p xmlns:a="http://schemas.openxmlformats.org/drawingml/2006/main">
+            <a:r>
+              <a:t>- https://fivetran.com/docs/connectors/applications/quickbooks</a:t>
             </a:r>
           </a:p>
           <a:p xmlns:a="http://schemas.openxmlformats.org/drawingml/2006/main">
@@ -1394,7 +1414,7 @@
   </p:cSld>
   <p:clrMap bg1="lt1" tx1="dk1" bg2="lt2" tx2="dk2" accent1="accent1" accent2="accent2" accent3="accent3" accent4="accent4" accent5="accent5" accent6="accent6" hlink="hlink" folHlink="folHlink"/>
   <p:sldLayoutIdLst>
-    <p:sldLayoutId xmlns:r="http://schemas.openxmlformats.org/officeDocument/2006/relationships" id="2147483649" r:id="R7a25697a817a4ea0"/>
+    <p:sldLayoutId xmlns:r="http://schemas.openxmlformats.org/officeDocument/2006/relationships" id="2147483649" r:id="Red3ca2f5289d4143"/>
   </p:sldLayoutIdLst>
   <p:txStyles>
     <p:titleStyle>
@@ -2564,7 +2584,7 @@
           <p:cNvPr id="9" name="cover-eyebrow">
             <a:extLst xmlns:a="http://schemas.openxmlformats.org/drawingml/2006/main">
               <a:ext uri="{FF2B5EF4-FFF2-40B4-BE49-F238E27FC236}">
-                <a16:creationId xmlns:a16="http://schemas.microsoft.com/office/drawing/2014/main" id="{FFF83020-DAAA-4C4E-8FAB-19630FD7D70D}"/>
+                <a16:creationId xmlns:a16="http://schemas.microsoft.com/office/drawing/2014/main" id="{AEECFC06-FD4A-4EEB-8173-29648D4854F5}"/>
               </a:ext>
             </a:extLst>
           </p:cNvPr>
@@ -2620,7 +2640,7 @@
           <p:cNvPr id="2" name="cover-title">
             <a:extLst xmlns:a="http://schemas.openxmlformats.org/drawingml/2006/main">
               <a:ext uri="{FF2B5EF4-FFF2-40B4-BE49-F238E27FC236}">
-                <a16:creationId xmlns:a16="http://schemas.microsoft.com/office/drawing/2014/main" id="{E1A5DD93-C09A-446C-9342-58A089255BCE}"/>
+                <a16:creationId xmlns:a16="http://schemas.microsoft.com/office/drawing/2014/main" id="{9D1A01A9-E15E-45C0-88BA-7E74B0D7DE5E}"/>
               </a:ext>
             </a:extLst>
           </p:cNvPr>
@@ -2676,7 +2696,7 @@
           <p:cNvPr id="3" name="cover-subtitle">
             <a:extLst xmlns:a="http://schemas.openxmlformats.org/drawingml/2006/main">
               <a:ext uri="{FF2B5EF4-FFF2-40B4-BE49-F238E27FC236}">
-                <a16:creationId xmlns:a16="http://schemas.microsoft.com/office/drawing/2014/main" id="{DBE80C59-459E-4A93-B23A-2CB6FEFC1A44}"/>
+                <a16:creationId xmlns:a16="http://schemas.microsoft.com/office/drawing/2014/main" id="{8962E0A2-CD03-4368-BDF8-F8848D36CCF2}"/>
               </a:ext>
             </a:extLst>
           </p:cNvPr>
@@ -2732,7 +2752,7 @@
           <p:cNvPr id="4" name="cover-field">
             <a:extLst xmlns:a="http://schemas.openxmlformats.org/drawingml/2006/main">
               <a:ext uri="{FF2B5EF4-FFF2-40B4-BE49-F238E27FC236}">
-                <a16:creationId xmlns:a16="http://schemas.microsoft.com/office/drawing/2014/main" id="{7D1376EA-936A-48F6-8100-A1A8F782D4EF}"/>
+                <a16:creationId xmlns:a16="http://schemas.microsoft.com/office/drawing/2014/main" id="{69AE3BEB-1CFD-4FFF-AF95-E37EE7502F36}"/>
               </a:ext>
             </a:extLst>
           </p:cNvPr>
@@ -2765,7 +2785,7 @@
           <p:cNvPr id="5" name="cover-field-value">
             <a:extLst xmlns:a="http://schemas.openxmlformats.org/drawingml/2006/main">
               <a:ext uri="{FF2B5EF4-FFF2-40B4-BE49-F238E27FC236}">
-                <a16:creationId xmlns:a16="http://schemas.microsoft.com/office/drawing/2014/main" id="{7071971F-E19B-4E2D-BC0B-FBA39B0D4B21}"/>
+                <a16:creationId xmlns:a16="http://schemas.microsoft.com/office/drawing/2014/main" id="{1647F242-8F51-4AC0-BA05-4C265C31897D}"/>
               </a:ext>
             </a:extLst>
           </p:cNvPr>
@@ -2821,7 +2841,7 @@
           <p:cNvPr id="6" name="cover-field-label">
             <a:extLst xmlns:a="http://schemas.openxmlformats.org/drawingml/2006/main">
               <a:ext uri="{FF2B5EF4-FFF2-40B4-BE49-F238E27FC236}">
-                <a16:creationId xmlns:a16="http://schemas.microsoft.com/office/drawing/2014/main" id="{BDF4D17A-8445-4330-9E1A-A102C1E234F9}"/>
+                <a16:creationId xmlns:a16="http://schemas.microsoft.com/office/drawing/2014/main" id="{62DB7AB7-E13B-4730-86D5-3774766359C1}"/>
               </a:ext>
             </a:extLst>
           </p:cNvPr>
@@ -2877,7 +2897,7 @@
           <p:cNvPr id="7" name="cover-field-note">
             <a:extLst xmlns:a="http://schemas.openxmlformats.org/drawingml/2006/main">
               <a:ext uri="{FF2B5EF4-FFF2-40B4-BE49-F238E27FC236}">
-                <a16:creationId xmlns:a16="http://schemas.microsoft.com/office/drawing/2014/main" id="{C3EE9F1E-C59A-4B58-9256-E55651A89988}"/>
+                <a16:creationId xmlns:a16="http://schemas.microsoft.com/office/drawing/2014/main" id="{7B01E4F9-97A9-4616-B3ED-395B42AA9619}"/>
               </a:ext>
             </a:extLst>
           </p:cNvPr>
@@ -2933,7 +2953,7 @@
           <p:cNvPr id="8" name="cover-footer">
             <a:extLst xmlns:a="http://schemas.openxmlformats.org/drawingml/2006/main">
               <a:ext uri="{FF2B5EF4-FFF2-40B4-BE49-F238E27FC236}">
-                <a16:creationId xmlns:a16="http://schemas.microsoft.com/office/drawing/2014/main" id="{B7CDED27-2768-44B3-959A-5551DC502963}"/>
+                <a16:creationId xmlns:a16="http://schemas.microsoft.com/office/drawing/2014/main" id="{D9EE83D4-1035-4D12-802D-664A988F0E4F}"/>
               </a:ext>
             </a:extLst>
           </p:cNvPr>
@@ -2987,7 +3007,7 @@
     </p:spTree>
     <p:extLst>
       <p:ext uri="{BB962C8B-B14F-4D97-AF65-F5344CB8AC3E}">
-        <p14:creationId xmlns:p14="http://schemas.microsoft.com/office/powerpoint/2010/main" val="1331287918"/>
+        <p14:creationId xmlns:p14="http://schemas.microsoft.com/office/powerpoint/2010/main" val="733146647"/>
       </p:ext>
     </p:extLst>
   </p:cSld>
@@ -3018,7 +3038,7 @@
           <p:cNvPr id="18" name="eyebrow-10">
             <a:extLst xmlns:a="http://schemas.openxmlformats.org/drawingml/2006/main">
               <a:ext uri="{FF2B5EF4-FFF2-40B4-BE49-F238E27FC236}">
-                <a16:creationId xmlns:a16="http://schemas.microsoft.com/office/drawing/2014/main" id="{17DADCB7-2F07-4E7E-826F-50CFE628280A}"/>
+                <a16:creationId xmlns:a16="http://schemas.microsoft.com/office/drawing/2014/main" id="{F80C0FF9-049E-4076-A4AD-660DD90417B5}"/>
               </a:ext>
             </a:extLst>
           </p:cNvPr>
@@ -3074,7 +3094,7 @@
           <p:cNvPr id="2" name="title-10">
             <a:extLst xmlns:a="http://schemas.openxmlformats.org/drawingml/2006/main">
               <a:ext uri="{FF2B5EF4-FFF2-40B4-BE49-F238E27FC236}">
-                <a16:creationId xmlns:a16="http://schemas.microsoft.com/office/drawing/2014/main" id="{D34ABF4A-3A0B-4C66-BA9D-F45BABC3EC2D}"/>
+                <a16:creationId xmlns:a16="http://schemas.microsoft.com/office/drawing/2014/main" id="{F6CEF9A9-A270-4759-BEBE-9972A738A09F}"/>
               </a:ext>
             </a:extLst>
           </p:cNvPr>
@@ -3130,7 +3150,7 @@
           <p:cNvPr id="3" name="footer-10">
             <a:extLst xmlns:a="http://schemas.openxmlformats.org/drawingml/2006/main">
               <a:ext uri="{FF2B5EF4-FFF2-40B4-BE49-F238E27FC236}">
-                <a16:creationId xmlns:a16="http://schemas.microsoft.com/office/drawing/2014/main" id="{F7B8594F-365E-424C-A3E1-B59ED60EF907}"/>
+                <a16:creationId xmlns:a16="http://schemas.microsoft.com/office/drawing/2014/main" id="{B4143414-51A6-4F44-A8FD-C381C8E766EB}"/>
               </a:ext>
             </a:extLst>
           </p:cNvPr>
@@ -3186,7 +3206,7 @@
           <p:cNvPr id="4" name="s10-lead">
             <a:extLst xmlns:a="http://schemas.openxmlformats.org/drawingml/2006/main">
               <a:ext uri="{FF2B5EF4-FFF2-40B4-BE49-F238E27FC236}">
-                <a16:creationId xmlns:a16="http://schemas.microsoft.com/office/drawing/2014/main" id="{C36F0BC3-5500-406B-894C-BDC04F49F565}"/>
+                <a16:creationId xmlns:a16="http://schemas.microsoft.com/office/drawing/2014/main" id="{BECF3906-D619-4B20-B06B-BA466A725BF8}"/>
               </a:ext>
             </a:extLst>
           </p:cNvPr>
@@ -3242,7 +3262,7 @@
           <p:cNvPr id="5" name="s10-num-0">
             <a:extLst xmlns:a="http://schemas.openxmlformats.org/drawingml/2006/main">
               <a:ext uri="{FF2B5EF4-FFF2-40B4-BE49-F238E27FC236}">
-                <a16:creationId xmlns:a16="http://schemas.microsoft.com/office/drawing/2014/main" id="{705D7C6B-E48A-43BF-A989-6CC3CBC5D875}"/>
+                <a16:creationId xmlns:a16="http://schemas.microsoft.com/office/drawing/2014/main" id="{8241941C-30B4-40C4-86BE-73C1BD2316DF}"/>
               </a:ext>
             </a:extLst>
           </p:cNvPr>
@@ -3298,7 +3318,7 @@
           <p:cNvPr id="6" name="s10-title-0">
             <a:extLst xmlns:a="http://schemas.openxmlformats.org/drawingml/2006/main">
               <a:ext uri="{FF2B5EF4-FFF2-40B4-BE49-F238E27FC236}">
-                <a16:creationId xmlns:a16="http://schemas.microsoft.com/office/drawing/2014/main" id="{2B0DD78C-D554-4707-8550-D9C4976F67FB}"/>
+                <a16:creationId xmlns:a16="http://schemas.microsoft.com/office/drawing/2014/main" id="{BFA888A7-515E-4408-A759-6AAB118A3C70}"/>
               </a:ext>
             </a:extLst>
           </p:cNvPr>
@@ -3354,7 +3374,7 @@
           <p:cNvPr id="7" name="s10-body-0">
             <a:extLst xmlns:a="http://schemas.openxmlformats.org/drawingml/2006/main">
               <a:ext uri="{FF2B5EF4-FFF2-40B4-BE49-F238E27FC236}">
-                <a16:creationId xmlns:a16="http://schemas.microsoft.com/office/drawing/2014/main" id="{E848B346-95AD-445D-893D-38EDA3C50151}"/>
+                <a16:creationId xmlns:a16="http://schemas.microsoft.com/office/drawing/2014/main" id="{D9AED9DB-228C-417D-9798-47B1617EF3B7}"/>
               </a:ext>
             </a:extLst>
           </p:cNvPr>
@@ -3410,7 +3430,7 @@
           <p:cNvPr id="8" name="s10-rule-0">
             <a:extLst xmlns:a="http://schemas.openxmlformats.org/drawingml/2006/main">
               <a:ext uri="{FF2B5EF4-FFF2-40B4-BE49-F238E27FC236}">
-                <a16:creationId xmlns:a16="http://schemas.microsoft.com/office/drawing/2014/main" id="{B02D2F60-5ED2-46D6-851A-D7B1C26E4EF8}"/>
+                <a16:creationId xmlns:a16="http://schemas.microsoft.com/office/drawing/2014/main" id="{A4E557E7-AA13-4143-9583-6DA0F9503306}"/>
               </a:ext>
             </a:extLst>
           </p:cNvPr>
@@ -3441,7 +3461,7 @@
           <p:cNvPr id="9" name="s10-num-1">
             <a:extLst xmlns:a="http://schemas.openxmlformats.org/drawingml/2006/main">
               <a:ext uri="{FF2B5EF4-FFF2-40B4-BE49-F238E27FC236}">
-                <a16:creationId xmlns:a16="http://schemas.microsoft.com/office/drawing/2014/main" id="{D0AA3F25-035A-4E4F-A836-FE6E11A40E1B}"/>
+                <a16:creationId xmlns:a16="http://schemas.microsoft.com/office/drawing/2014/main" id="{81E3A8D7-7E46-493C-9EDF-91DC3444D62D}"/>
               </a:ext>
             </a:extLst>
           </p:cNvPr>
@@ -3497,7 +3517,7 @@
           <p:cNvPr id="10" name="s10-title-1">
             <a:extLst xmlns:a="http://schemas.openxmlformats.org/drawingml/2006/main">
               <a:ext uri="{FF2B5EF4-FFF2-40B4-BE49-F238E27FC236}">
-                <a16:creationId xmlns:a16="http://schemas.microsoft.com/office/drawing/2014/main" id="{CECFF9C0-6AA4-47D0-A17E-404EDFB90B05}"/>
+                <a16:creationId xmlns:a16="http://schemas.microsoft.com/office/drawing/2014/main" id="{37D6B5AB-F998-4F14-83E7-44CC84F9C12C}"/>
               </a:ext>
             </a:extLst>
           </p:cNvPr>
@@ -3553,7 +3573,7 @@
           <p:cNvPr id="11" name="s10-body-1">
             <a:extLst xmlns:a="http://schemas.openxmlformats.org/drawingml/2006/main">
               <a:ext uri="{FF2B5EF4-FFF2-40B4-BE49-F238E27FC236}">
-                <a16:creationId xmlns:a16="http://schemas.microsoft.com/office/drawing/2014/main" id="{51C58DB9-2EE4-4C25-A1BA-3EFBB888D0A5}"/>
+                <a16:creationId xmlns:a16="http://schemas.microsoft.com/office/drawing/2014/main" id="{D40999FD-0B7D-4138-932D-9D5307C6AFC3}"/>
               </a:ext>
             </a:extLst>
           </p:cNvPr>
@@ -3609,7 +3629,7 @@
           <p:cNvPr id="12" name="s10-rule-1">
             <a:extLst xmlns:a="http://schemas.openxmlformats.org/drawingml/2006/main">
               <a:ext uri="{FF2B5EF4-FFF2-40B4-BE49-F238E27FC236}">
-                <a16:creationId xmlns:a16="http://schemas.microsoft.com/office/drawing/2014/main" id="{1B956796-928F-47DD-A1C4-4A9BD06B3E21}"/>
+                <a16:creationId xmlns:a16="http://schemas.microsoft.com/office/drawing/2014/main" id="{97ACF58F-E516-4C93-A6E1-26321FBEF6CA}"/>
               </a:ext>
             </a:extLst>
           </p:cNvPr>
@@ -3640,7 +3660,7 @@
           <p:cNvPr id="13" name="s10-num-2">
             <a:extLst xmlns:a="http://schemas.openxmlformats.org/drawingml/2006/main">
               <a:ext uri="{FF2B5EF4-FFF2-40B4-BE49-F238E27FC236}">
-                <a16:creationId xmlns:a16="http://schemas.microsoft.com/office/drawing/2014/main" id="{090FF9D9-A412-4525-99D4-C37DAF06F504}"/>
+                <a16:creationId xmlns:a16="http://schemas.microsoft.com/office/drawing/2014/main" id="{E0359092-1F84-464F-9499-1F2D00A97405}"/>
               </a:ext>
             </a:extLst>
           </p:cNvPr>
@@ -3696,7 +3716,7 @@
           <p:cNvPr id="14" name="s10-title-2">
             <a:extLst xmlns:a="http://schemas.openxmlformats.org/drawingml/2006/main">
               <a:ext uri="{FF2B5EF4-FFF2-40B4-BE49-F238E27FC236}">
-                <a16:creationId xmlns:a16="http://schemas.microsoft.com/office/drawing/2014/main" id="{39BA55C2-87C3-4327-BEF7-58CE1D583CF7}"/>
+                <a16:creationId xmlns:a16="http://schemas.microsoft.com/office/drawing/2014/main" id="{307FDBD1-44E0-49C6-8A39-36794AE81417}"/>
               </a:ext>
             </a:extLst>
           </p:cNvPr>
@@ -3742,7 +3762,7 @@
                 <a:ea typeface="Arial"/>
                 <a:cs typeface="Arial"/>
               </a:rPr>
-              <a:t>Fund the data foundation</a:t>
+              <a:t>Choose the operating path</a:t>
             </a:r>
           </a:p>
         </p:txBody>
@@ -3752,7 +3772,7 @@
           <p:cNvPr id="15" name="s10-body-2">
             <a:extLst xmlns:a="http://schemas.openxmlformats.org/drawingml/2006/main">
               <a:ext uri="{FF2B5EF4-FFF2-40B4-BE49-F238E27FC236}">
-                <a16:creationId xmlns:a16="http://schemas.microsoft.com/office/drawing/2014/main" id="{D6C2FCFA-317F-4A59-8D34-79EADEC90D72}"/>
+                <a16:creationId xmlns:a16="http://schemas.microsoft.com/office/drawing/2014/main" id="{77C39345-0A4B-45BD-8EA5-9C320158E505}"/>
               </a:ext>
             </a:extLst>
           </p:cNvPr>
@@ -3798,7 +3818,7 @@
                 <a:ea typeface="Arial"/>
                 <a:cs typeface="Arial"/>
               </a:rPr>
-              <a:t>Approve BigQuery + dbt/Dataform controls, SKU/cost governance, and Amazon-to-QuickBooks reconciliation.</a:t>
+              <a:t>Start cost-aware; buy managed ingestion only if connector SLAs and rollout speed justify the subscription.</a:t>
             </a:r>
           </a:p>
         </p:txBody>
@@ -3808,7 +3828,7 @@
           <p:cNvPr id="16" name="s10-final">
             <a:extLst xmlns:a="http://schemas.openxmlformats.org/drawingml/2006/main">
               <a:ext uri="{FF2B5EF4-FFF2-40B4-BE49-F238E27FC236}">
-                <a16:creationId xmlns:a16="http://schemas.microsoft.com/office/drawing/2014/main" id="{49EEB1E3-A940-487A-9BB5-ED3F7604A7A0}"/>
+                <a16:creationId xmlns:a16="http://schemas.microsoft.com/office/drawing/2014/main" id="{96E1763F-1B51-4347-BDBE-21C472F9BD17}"/>
               </a:ext>
             </a:extLst>
           </p:cNvPr>
@@ -3839,7 +3859,7 @@
           <p:cNvPr id="17" name="s10-final-text">
             <a:extLst xmlns:a="http://schemas.openxmlformats.org/drawingml/2006/main">
               <a:ext uri="{FF2B5EF4-FFF2-40B4-BE49-F238E27FC236}">
-                <a16:creationId xmlns:a16="http://schemas.microsoft.com/office/drawing/2014/main" id="{AF54CC89-5FE0-483D-B786-4A4C7C2957B3}"/>
+                <a16:creationId xmlns:a16="http://schemas.microsoft.com/office/drawing/2014/main" id="{22BCCD50-CC04-4B55-9146-0D222A08CCB5}"/>
               </a:ext>
             </a:extLst>
           </p:cNvPr>
@@ -3893,7 +3913,7 @@
     </p:spTree>
     <p:extLst>
       <p:ext uri="{BB962C8B-B14F-4D97-AF65-F5344CB8AC3E}">
-        <p14:creationId xmlns:p14="http://schemas.microsoft.com/office/powerpoint/2010/main" val="2022773181"/>
+        <p14:creationId xmlns:p14="http://schemas.microsoft.com/office/powerpoint/2010/main" val="750627781"/>
       </p:ext>
     </p:extLst>
   </p:cSld>
@@ -3924,7 +3944,7 @@
           <p:cNvPr id="17" name="eyebrow-2">
             <a:extLst xmlns:a="http://schemas.openxmlformats.org/drawingml/2006/main">
               <a:ext uri="{FF2B5EF4-FFF2-40B4-BE49-F238E27FC236}">
-                <a16:creationId xmlns:a16="http://schemas.microsoft.com/office/drawing/2014/main" id="{9EF79C81-7373-413B-B906-F2ACE34A3BB8}"/>
+                <a16:creationId xmlns:a16="http://schemas.microsoft.com/office/drawing/2014/main" id="{42977B12-7491-4661-ADF8-5E948E9FCEFC}"/>
               </a:ext>
             </a:extLst>
           </p:cNvPr>
@@ -3980,7 +4000,7 @@
           <p:cNvPr id="2" name="title-2">
             <a:extLst xmlns:a="http://schemas.openxmlformats.org/drawingml/2006/main">
               <a:ext uri="{FF2B5EF4-FFF2-40B4-BE49-F238E27FC236}">
-                <a16:creationId xmlns:a16="http://schemas.microsoft.com/office/drawing/2014/main" id="{DCC9EE61-15DB-4A8D-A112-BAB4B6E910B7}"/>
+                <a16:creationId xmlns:a16="http://schemas.microsoft.com/office/drawing/2014/main" id="{3D81BE8F-A7E6-4DFD-81D4-860037E17D08}"/>
               </a:ext>
             </a:extLst>
           </p:cNvPr>
@@ -4036,7 +4056,7 @@
           <p:cNvPr id="3" name="footer-2">
             <a:extLst xmlns:a="http://schemas.openxmlformats.org/drawingml/2006/main">
               <a:ext uri="{FF2B5EF4-FFF2-40B4-BE49-F238E27FC236}">
-                <a16:creationId xmlns:a16="http://schemas.microsoft.com/office/drawing/2014/main" id="{995D656F-49EF-4629-A397-092EA34FE406}"/>
+                <a16:creationId xmlns:a16="http://schemas.microsoft.com/office/drawing/2014/main" id="{85955E27-35EC-49F9-A449-93BF333397E8}"/>
               </a:ext>
             </a:extLst>
           </p:cNvPr>
@@ -4092,7 +4112,7 @@
           <p:cNvPr id="4" name="s2-context">
             <a:extLst xmlns:a="http://schemas.openxmlformats.org/drawingml/2006/main">
               <a:ext uri="{FF2B5EF4-FFF2-40B4-BE49-F238E27FC236}">
-                <a16:creationId xmlns:a16="http://schemas.microsoft.com/office/drawing/2014/main" id="{A495A5C7-B873-45CE-9811-5179AB4F0C76}"/>
+                <a16:creationId xmlns:a16="http://schemas.microsoft.com/office/drawing/2014/main" id="{49C935AC-F4C6-4986-8AF4-3A0AB3DB8C74}"/>
               </a:ext>
             </a:extLst>
           </p:cNvPr>
@@ -4148,7 +4168,7 @@
           <p:cNvPr id="5" name="s2-net-sales-panel">
             <a:extLst xmlns:a="http://schemas.openxmlformats.org/drawingml/2006/main">
               <a:ext uri="{FF2B5EF4-FFF2-40B4-BE49-F238E27FC236}">
-                <a16:creationId xmlns:a16="http://schemas.microsoft.com/office/drawing/2014/main" id="{A8832D1F-3722-4EAB-853C-DA8121292DEE}"/>
+                <a16:creationId xmlns:a16="http://schemas.microsoft.com/office/drawing/2014/main" id="{CE780840-4980-44AC-ADF1-9897E0B12220}"/>
               </a:ext>
             </a:extLst>
           </p:cNvPr>
@@ -4179,7 +4199,7 @@
           <p:cNvPr id="6" name="s2-net-sales-value">
             <a:extLst xmlns:a="http://schemas.openxmlformats.org/drawingml/2006/main">
               <a:ext uri="{FF2B5EF4-FFF2-40B4-BE49-F238E27FC236}">
-                <a16:creationId xmlns:a16="http://schemas.microsoft.com/office/drawing/2014/main" id="{C0B88FD4-E97B-4E14-A9D7-0A2C60054DA6}"/>
+                <a16:creationId xmlns:a16="http://schemas.microsoft.com/office/drawing/2014/main" id="{C2B82964-7237-4DA5-B7E8-4693B36BD8BA}"/>
               </a:ext>
             </a:extLst>
           </p:cNvPr>
@@ -4235,7 +4255,7 @@
           <p:cNvPr id="7" name="s2-net-sales-label">
             <a:extLst xmlns:a="http://schemas.openxmlformats.org/drawingml/2006/main">
               <a:ext uri="{FF2B5EF4-FFF2-40B4-BE49-F238E27FC236}">
-                <a16:creationId xmlns:a16="http://schemas.microsoft.com/office/drawing/2014/main" id="{C445D126-916E-49D4-8EB0-39F8B457295D}"/>
+                <a16:creationId xmlns:a16="http://schemas.microsoft.com/office/drawing/2014/main" id="{EFC7A048-D8C6-4525-9E95-6CC7B57C18E6}"/>
               </a:ext>
             </a:extLst>
           </p:cNvPr>
@@ -4291,7 +4311,7 @@
           <p:cNvPr id="8" name="s2-net-sales-detail">
             <a:extLst xmlns:a="http://schemas.openxmlformats.org/drawingml/2006/main">
               <a:ext uri="{FF2B5EF4-FFF2-40B4-BE49-F238E27FC236}">
-                <a16:creationId xmlns:a16="http://schemas.microsoft.com/office/drawing/2014/main" id="{D64F655C-AB4F-4D48-B96C-E96B9C5C7202}"/>
+                <a16:creationId xmlns:a16="http://schemas.microsoft.com/office/drawing/2014/main" id="{A359D985-2092-4B96-B63B-F50A3F409310}"/>
               </a:ext>
             </a:extLst>
           </p:cNvPr>
@@ -4347,7 +4367,7 @@
           <p:cNvPr id="9" name="s2-cm-panel">
             <a:extLst xmlns:a="http://schemas.openxmlformats.org/drawingml/2006/main">
               <a:ext uri="{FF2B5EF4-FFF2-40B4-BE49-F238E27FC236}">
-                <a16:creationId xmlns:a16="http://schemas.microsoft.com/office/drawing/2014/main" id="{568FDA7B-E09D-43A1-827D-011F75F3E3BC}"/>
+                <a16:creationId xmlns:a16="http://schemas.microsoft.com/office/drawing/2014/main" id="{8E32429C-0192-44A0-9EA5-B2C3DFE6F2FB}"/>
               </a:ext>
             </a:extLst>
           </p:cNvPr>
@@ -4378,7 +4398,7 @@
           <p:cNvPr id="10" name="s2-cm-value">
             <a:extLst xmlns:a="http://schemas.openxmlformats.org/drawingml/2006/main">
               <a:ext uri="{FF2B5EF4-FFF2-40B4-BE49-F238E27FC236}">
-                <a16:creationId xmlns:a16="http://schemas.microsoft.com/office/drawing/2014/main" id="{39433EDB-F2BB-4FB9-AD08-21BAAEC64442}"/>
+                <a16:creationId xmlns:a16="http://schemas.microsoft.com/office/drawing/2014/main" id="{52D393C1-B593-41D2-9630-FB4CF05B2C1B}"/>
               </a:ext>
             </a:extLst>
           </p:cNvPr>
@@ -4434,7 +4454,7 @@
           <p:cNvPr id="11" name="s2-cm-label">
             <a:extLst xmlns:a="http://schemas.openxmlformats.org/drawingml/2006/main">
               <a:ext uri="{FF2B5EF4-FFF2-40B4-BE49-F238E27FC236}">
-                <a16:creationId xmlns:a16="http://schemas.microsoft.com/office/drawing/2014/main" id="{1349AB60-6C2C-463C-A163-E95189EB848F}"/>
+                <a16:creationId xmlns:a16="http://schemas.microsoft.com/office/drawing/2014/main" id="{99D4949A-8A04-4911-82D7-690BDE7F2451}"/>
               </a:ext>
             </a:extLst>
           </p:cNvPr>
@@ -4490,7 +4510,7 @@
           <p:cNvPr id="12" name="s2-cm-detail">
             <a:extLst xmlns:a="http://schemas.openxmlformats.org/drawingml/2006/main">
               <a:ext uri="{FF2B5EF4-FFF2-40B4-BE49-F238E27FC236}">
-                <a16:creationId xmlns:a16="http://schemas.microsoft.com/office/drawing/2014/main" id="{30CF1E57-4969-4210-ADE2-A7D13B1436E1}"/>
+                <a16:creationId xmlns:a16="http://schemas.microsoft.com/office/drawing/2014/main" id="{DDCC314F-3467-4C00-AEAD-2FDF679FCEDB}"/>
               </a:ext>
             </a:extLst>
           </p:cNvPr>
@@ -4546,7 +4566,7 @@
           <p:cNvPr id="13" name="s2-after-panel">
             <a:extLst xmlns:a="http://schemas.openxmlformats.org/drawingml/2006/main">
               <a:ext uri="{FF2B5EF4-FFF2-40B4-BE49-F238E27FC236}">
-                <a16:creationId xmlns:a16="http://schemas.microsoft.com/office/drawing/2014/main" id="{025D006A-939D-405D-B497-12A45049ED82}"/>
+                <a16:creationId xmlns:a16="http://schemas.microsoft.com/office/drawing/2014/main" id="{E7586F55-11A5-47E0-97EF-D096EF437DD0}"/>
               </a:ext>
             </a:extLst>
           </p:cNvPr>
@@ -4577,7 +4597,7 @@
           <p:cNvPr id="14" name="s2-after-value">
             <a:extLst xmlns:a="http://schemas.openxmlformats.org/drawingml/2006/main">
               <a:ext uri="{FF2B5EF4-FFF2-40B4-BE49-F238E27FC236}">
-                <a16:creationId xmlns:a16="http://schemas.microsoft.com/office/drawing/2014/main" id="{04EC5D1C-DF73-4DA0-B67C-4859A23B530B}"/>
+                <a16:creationId xmlns:a16="http://schemas.microsoft.com/office/drawing/2014/main" id="{89EE10CA-AAC9-42EB-92A7-48D1EAB4A186}"/>
               </a:ext>
             </a:extLst>
           </p:cNvPr>
@@ -4633,7 +4653,7 @@
           <p:cNvPr id="15" name="s2-after-label">
             <a:extLst xmlns:a="http://schemas.openxmlformats.org/drawingml/2006/main">
               <a:ext uri="{FF2B5EF4-FFF2-40B4-BE49-F238E27FC236}">
-                <a16:creationId xmlns:a16="http://schemas.microsoft.com/office/drawing/2014/main" id="{8C2D9AE0-792E-4126-94B4-E27D0ACB6E58}"/>
+                <a16:creationId xmlns:a16="http://schemas.microsoft.com/office/drawing/2014/main" id="{FAF043F2-D05A-48EB-93F0-5FEABDCAC01A}"/>
               </a:ext>
             </a:extLst>
           </p:cNvPr>
@@ -4689,7 +4709,7 @@
           <p:cNvPr id="16" name="s2-after-detail">
             <a:extLst xmlns:a="http://schemas.openxmlformats.org/drawingml/2006/main">
               <a:ext uri="{FF2B5EF4-FFF2-40B4-BE49-F238E27FC236}">
-                <a16:creationId xmlns:a16="http://schemas.microsoft.com/office/drawing/2014/main" id="{5D4B0D29-8B68-42F3-828C-100573376FB7}"/>
+                <a16:creationId xmlns:a16="http://schemas.microsoft.com/office/drawing/2014/main" id="{27D5490F-9813-4A6E-B384-31480731C8F0}"/>
               </a:ext>
             </a:extLst>
           </p:cNvPr>
@@ -4743,7 +4763,7 @@
     </p:spTree>
     <p:extLst>
       <p:ext uri="{BB962C8B-B14F-4D97-AF65-F5344CB8AC3E}">
-        <p14:creationId xmlns:p14="http://schemas.microsoft.com/office/powerpoint/2010/main" val="1623426145"/>
+        <p14:creationId xmlns:p14="http://schemas.microsoft.com/office/powerpoint/2010/main" val="1559007013"/>
       </p:ext>
     </p:extLst>
   </p:cSld>
@@ -4774,7 +4794,7 @@
           <p:cNvPr id="26" name="eyebrow-3">
             <a:extLst xmlns:a="http://schemas.openxmlformats.org/drawingml/2006/main">
               <a:ext uri="{FF2B5EF4-FFF2-40B4-BE49-F238E27FC236}">
-                <a16:creationId xmlns:a16="http://schemas.microsoft.com/office/drawing/2014/main" id="{6BB3B4AB-7BC7-480A-A987-588616504CF1}"/>
+                <a16:creationId xmlns:a16="http://schemas.microsoft.com/office/drawing/2014/main" id="{4D22E542-AE14-46D6-8492-73462DABAE52}"/>
               </a:ext>
             </a:extLst>
           </p:cNvPr>
@@ -4820,7 +4840,7 @@
                 <a:ea typeface="Arial"/>
                 <a:cs typeface="Arial"/>
               </a:rPr>
-              <a:t>PROPOSED BIGQUERY FOUNDATION</a:t>
+              <a:t>DELIVERABLE 1 • BIGQUERY DATA MODEL</a:t>
             </a:r>
           </a:p>
         </p:txBody>
@@ -4830,7 +4850,7 @@
           <p:cNvPr id="2" name="title-3">
             <a:extLst xmlns:a="http://schemas.openxmlformats.org/drawingml/2006/main">
               <a:ext uri="{FF2B5EF4-FFF2-40B4-BE49-F238E27FC236}">
-                <a16:creationId xmlns:a16="http://schemas.microsoft.com/office/drawing/2014/main" id="{BE093F09-FC96-4E8E-B4DC-094CFE8153EF}"/>
+                <a16:creationId xmlns:a16="http://schemas.microsoft.com/office/drawing/2014/main" id="{88A043D6-3199-4E38-A0F0-422DF49F95DB}"/>
               </a:ext>
             </a:extLst>
           </p:cNvPr>
@@ -4876,7 +4896,7 @@
                 <a:ea typeface="Arial"/>
                 <a:cs typeface="Arial"/>
               </a:rPr>
-              <a:t>A single source of truth starts with stable product identity—not a dashboard</a:t>
+              <a:t>One medallion model supports both implementation paths</a:t>
             </a:r>
           </a:p>
         </p:txBody>
@@ -4886,7 +4906,7 @@
           <p:cNvPr id="3" name="footer-3">
             <a:extLst xmlns:a="http://schemas.openxmlformats.org/drawingml/2006/main">
               <a:ext uri="{FF2B5EF4-FFF2-40B4-BE49-F238E27FC236}">
-                <a16:creationId xmlns:a16="http://schemas.microsoft.com/office/drawing/2014/main" id="{FAADD25C-06F8-45FB-A7FE-825C49C26DB7}"/>
+                <a16:creationId xmlns:a16="http://schemas.microsoft.com/office/drawing/2014/main" id="{CFDB2195-4E88-4C46-AE95-6FF2BE272F4D}"/>
               </a:ext>
             </a:extLst>
           </p:cNvPr>
@@ -4942,7 +4962,7 @@
           <p:cNvPr id="4" name="s3-intro">
             <a:extLst xmlns:a="http://schemas.openxmlformats.org/drawingml/2006/main">
               <a:ext uri="{FF2B5EF4-FFF2-40B4-BE49-F238E27FC236}">
-                <a16:creationId xmlns:a16="http://schemas.microsoft.com/office/drawing/2014/main" id="{BBBA89AD-919C-4428-9839-1B4B7A31BC19}"/>
+                <a16:creationId xmlns:a16="http://schemas.microsoft.com/office/drawing/2014/main" id="{E4CC6514-0C5C-4FF2-8913-3604F494E829}"/>
               </a:ext>
             </a:extLst>
           </p:cNvPr>
@@ -4988,7 +5008,7 @@
                 <a:ea typeface="Arial"/>
                 <a:cs typeface="Arial"/>
               </a:rPr>
-              <a:t>Preserve raw evidence, standardize source contracts, resolve identifiers once, and publish finance marts only after controls pass.</a:t>
+              <a:t>Keep the business contracts stable; choose whether the team owns or buys ingestion, orchestration, and observability.</a:t>
             </a:r>
           </a:p>
         </p:txBody>
@@ -4998,7 +5018,7 @@
           <p:cNvPr id="5" name="s3-arrow-0">
             <a:extLst xmlns:a="http://schemas.openxmlformats.org/drawingml/2006/main">
               <a:ext uri="{FF2B5EF4-FFF2-40B4-BE49-F238E27FC236}">
-                <a16:creationId xmlns:a16="http://schemas.microsoft.com/office/drawing/2014/main" id="{A259E378-8B44-4564-8001-48427B10EC0C}"/>
+                <a16:creationId xmlns:a16="http://schemas.microsoft.com/office/drawing/2014/main" id="{A585336A-1102-45DE-B492-CE66DF803BDE}"/>
               </a:ext>
             </a:extLst>
           </p:cNvPr>
@@ -5029,7 +5049,7 @@
           <p:cNvPr id="6" name="s3-arrow-1">
             <a:extLst xmlns:a="http://schemas.openxmlformats.org/drawingml/2006/main">
               <a:ext uri="{FF2B5EF4-FFF2-40B4-BE49-F238E27FC236}">
-                <a16:creationId xmlns:a16="http://schemas.microsoft.com/office/drawing/2014/main" id="{2744FBA1-F644-40F7-B607-6EE766EBB0BD}"/>
+                <a16:creationId xmlns:a16="http://schemas.microsoft.com/office/drawing/2014/main" id="{02377F46-69E6-47C0-AD8F-7916165B4B93}"/>
               </a:ext>
             </a:extLst>
           </p:cNvPr>
@@ -5060,7 +5080,7 @@
           <p:cNvPr id="7" name="s3-arrow-2">
             <a:extLst xmlns:a="http://schemas.openxmlformats.org/drawingml/2006/main">
               <a:ext uri="{FF2B5EF4-FFF2-40B4-BE49-F238E27FC236}">
-                <a16:creationId xmlns:a16="http://schemas.microsoft.com/office/drawing/2014/main" id="{FF67240A-16A9-4C3A-ABBA-865901119862}"/>
+                <a16:creationId xmlns:a16="http://schemas.microsoft.com/office/drawing/2014/main" id="{4BD357AF-600B-4FA8-960F-212905D19D4A}"/>
               </a:ext>
             </a:extLst>
           </p:cNvPr>
@@ -5091,7 +5111,7 @@
           <p:cNvPr id="8" name="s3-arrow-3">
             <a:extLst xmlns:a="http://schemas.openxmlformats.org/drawingml/2006/main">
               <a:ext uri="{FF2B5EF4-FFF2-40B4-BE49-F238E27FC236}">
-                <a16:creationId xmlns:a16="http://schemas.microsoft.com/office/drawing/2014/main" id="{6684D999-A9B6-438D-9DC8-0D233EA3CAF1}"/>
+                <a16:creationId xmlns:a16="http://schemas.microsoft.com/office/drawing/2014/main" id="{A4635C1E-9A1A-4EDF-971A-097A989E7C7B}"/>
               </a:ext>
             </a:extLst>
           </p:cNvPr>
@@ -5122,7 +5142,7 @@
           <p:cNvPr id="9" name="s3-node-0">
             <a:extLst xmlns:a="http://schemas.openxmlformats.org/drawingml/2006/main">
               <a:ext uri="{FF2B5EF4-FFF2-40B4-BE49-F238E27FC236}">
-                <a16:creationId xmlns:a16="http://schemas.microsoft.com/office/drawing/2014/main" id="{09448C60-7F85-4DFE-8904-CBC72BAC8304}"/>
+                <a16:creationId xmlns:a16="http://schemas.microsoft.com/office/drawing/2014/main" id="{14A0166F-3AFD-41E7-90D7-19CFBDB3BD5E}"/>
               </a:ext>
             </a:extLst>
           </p:cNvPr>
@@ -5155,7 +5175,7 @@
           <p:cNvPr id="10" name="s3-node-title-0">
             <a:extLst xmlns:a="http://schemas.openxmlformats.org/drawingml/2006/main">
               <a:ext uri="{FF2B5EF4-FFF2-40B4-BE49-F238E27FC236}">
-                <a16:creationId xmlns:a16="http://schemas.microsoft.com/office/drawing/2014/main" id="{7212267B-F1D7-4A49-9A69-347A283C31DD}"/>
+                <a16:creationId xmlns:a16="http://schemas.microsoft.com/office/drawing/2014/main" id="{27D5AF89-D242-433E-8858-0EC7DF63CE95}"/>
               </a:ext>
             </a:extLst>
           </p:cNvPr>
@@ -5211,7 +5231,7 @@
           <p:cNvPr id="11" name="s3-node-body-0">
             <a:extLst xmlns:a="http://schemas.openxmlformats.org/drawingml/2006/main">
               <a:ext uri="{FF2B5EF4-FFF2-40B4-BE49-F238E27FC236}">
-                <a16:creationId xmlns:a16="http://schemas.microsoft.com/office/drawing/2014/main" id="{1609AFC0-226D-4551-8750-6C584FBDFFEC}"/>
+                <a16:creationId xmlns:a16="http://schemas.microsoft.com/office/drawing/2014/main" id="{1D08B39E-9946-4AEA-ADE3-35CA27E4F1F4}"/>
               </a:ext>
             </a:extLst>
           </p:cNvPr>
@@ -5336,7 +5356,7 @@
           <p:cNvPr id="12" name="s3-node-1">
             <a:extLst xmlns:a="http://schemas.openxmlformats.org/drawingml/2006/main">
               <a:ext uri="{FF2B5EF4-FFF2-40B4-BE49-F238E27FC236}">
-                <a16:creationId xmlns:a16="http://schemas.microsoft.com/office/drawing/2014/main" id="{D34CD4E8-B953-44FB-BDF3-74A73F32AE71}"/>
+                <a16:creationId xmlns:a16="http://schemas.microsoft.com/office/drawing/2014/main" id="{3C398CFD-B058-48E0-AA9E-4A4D51A2E5C7}"/>
               </a:ext>
             </a:extLst>
           </p:cNvPr>
@@ -5369,7 +5389,7 @@
           <p:cNvPr id="13" name="s3-node-title-1">
             <a:extLst xmlns:a="http://schemas.openxmlformats.org/drawingml/2006/main">
               <a:ext uri="{FF2B5EF4-FFF2-40B4-BE49-F238E27FC236}">
-                <a16:creationId xmlns:a16="http://schemas.microsoft.com/office/drawing/2014/main" id="{A1C3B437-D2CF-4EB2-854B-3FE92D45195E}"/>
+                <a16:creationId xmlns:a16="http://schemas.microsoft.com/office/drawing/2014/main" id="{72DC04A1-4D79-4FE1-BEE0-F2E703123326}"/>
               </a:ext>
             </a:extLst>
           </p:cNvPr>
@@ -5415,7 +5435,7 @@
                 <a:ea typeface="Arial"/>
                 <a:cs typeface="Arial"/>
               </a:rPr>
-              <a:t>Raw</a:t>
+              <a:t>Bronze</a:t>
             </a:r>
           </a:p>
         </p:txBody>
@@ -5425,7 +5445,7 @@
           <p:cNvPr id="14" name="s3-node-body-1">
             <a:extLst xmlns:a="http://schemas.openxmlformats.org/drawingml/2006/main">
               <a:ext uri="{FF2B5EF4-FFF2-40B4-BE49-F238E27FC236}">
-                <a16:creationId xmlns:a16="http://schemas.microsoft.com/office/drawing/2014/main" id="{69F7B48D-2B94-4EBD-ABF8-F6AB18C034AB}"/>
+                <a16:creationId xmlns:a16="http://schemas.microsoft.com/office/drawing/2014/main" id="{FA679F7F-59BE-45D5-8208-C5081CD21D87}"/>
               </a:ext>
             </a:extLst>
           </p:cNvPr>
@@ -5471,7 +5491,7 @@
                 <a:ea typeface="Arial"/>
                 <a:cs typeface="Arial"/>
               </a:rPr>
-              <a:t>Immutable files</a:t>
+              <a:t>Immutable raw</a:t>
             </a:r>
           </a:p>
           <a:p xmlns:a="http://schemas.openxmlformats.org/drawingml/2006/main">
@@ -5527,7 +5547,7 @@
           <p:cNvPr id="15" name="s3-node-2">
             <a:extLst xmlns:a="http://schemas.openxmlformats.org/drawingml/2006/main">
               <a:ext uri="{FF2B5EF4-FFF2-40B4-BE49-F238E27FC236}">
-                <a16:creationId xmlns:a16="http://schemas.microsoft.com/office/drawing/2014/main" id="{C6D4315B-8840-4E9F-94FD-002916B794EC}"/>
+                <a16:creationId xmlns:a16="http://schemas.microsoft.com/office/drawing/2014/main" id="{4D49B23E-9E69-4155-B7AE-7E923B577239}"/>
               </a:ext>
             </a:extLst>
           </p:cNvPr>
@@ -5560,7 +5580,7 @@
           <p:cNvPr id="16" name="s3-node-title-2">
             <a:extLst xmlns:a="http://schemas.openxmlformats.org/drawingml/2006/main">
               <a:ext uri="{FF2B5EF4-FFF2-40B4-BE49-F238E27FC236}">
-                <a16:creationId xmlns:a16="http://schemas.microsoft.com/office/drawing/2014/main" id="{0657E889-9A08-4D9C-8A23-FA4781A353FB}"/>
+                <a16:creationId xmlns:a16="http://schemas.microsoft.com/office/drawing/2014/main" id="{B1133891-0267-4DBB-A29B-258459B2B091}"/>
               </a:ext>
             </a:extLst>
           </p:cNvPr>
@@ -5606,7 +5626,7 @@
                 <a:ea typeface="Arial"/>
                 <a:cs typeface="Arial"/>
               </a:rPr>
-              <a:t>Staging</a:t>
+              <a:t>Silver</a:t>
             </a:r>
           </a:p>
         </p:txBody>
@@ -5616,7 +5636,7 @@
           <p:cNvPr id="17" name="s3-node-body-2">
             <a:extLst xmlns:a="http://schemas.openxmlformats.org/drawingml/2006/main">
               <a:ext uri="{FF2B5EF4-FFF2-40B4-BE49-F238E27FC236}">
-                <a16:creationId xmlns:a16="http://schemas.microsoft.com/office/drawing/2014/main" id="{F459DF6B-D9C0-429B-BAF8-C91319972DCF}"/>
+                <a16:creationId xmlns:a16="http://schemas.microsoft.com/office/drawing/2014/main" id="{84E539FA-A087-49BA-9AB6-AEEECDC9485D}"/>
               </a:ext>
             </a:extLst>
           </p:cNvPr>
@@ -5662,7 +5682,7 @@
                 <a:ea typeface="Arial"/>
                 <a:cs typeface="Arial"/>
               </a:rPr>
-              <a:t>Typed fields</a:t>
+              <a:t>Typed staging</a:t>
             </a:r>
           </a:p>
           <a:p xmlns:a="http://schemas.openxmlformats.org/drawingml/2006/main">
@@ -5685,7 +5705,7 @@
                 <a:ea typeface="Arial"/>
                 <a:cs typeface="Arial"/>
               </a:rPr>
-              <a:t>Deduplication</a:t>
+              <a:t>Replay-safe merge</a:t>
             </a:r>
           </a:p>
           <a:p xmlns:a="http://schemas.openxmlformats.org/drawingml/2006/main">
@@ -5718,7 +5738,7 @@
           <p:cNvPr id="18" name="s3-node-3">
             <a:extLst xmlns:a="http://schemas.openxmlformats.org/drawingml/2006/main">
               <a:ext uri="{FF2B5EF4-FFF2-40B4-BE49-F238E27FC236}">
-                <a16:creationId xmlns:a16="http://schemas.microsoft.com/office/drawing/2014/main" id="{E16D3C41-5D77-4465-843F-30F50BD43F06}"/>
+                <a16:creationId xmlns:a16="http://schemas.microsoft.com/office/drawing/2014/main" id="{F3003BAC-C9E6-45A6-956A-33FC155EA027}"/>
               </a:ext>
             </a:extLst>
           </p:cNvPr>
@@ -5751,7 +5771,7 @@
           <p:cNvPr id="19" name="s3-node-title-3">
             <a:extLst xmlns:a="http://schemas.openxmlformats.org/drawingml/2006/main">
               <a:ext uri="{FF2B5EF4-FFF2-40B4-BE49-F238E27FC236}">
-                <a16:creationId xmlns:a16="http://schemas.microsoft.com/office/drawing/2014/main" id="{290E2ED8-87F8-439C-BAA8-6DE1838FF5A9}"/>
+                <a16:creationId xmlns:a16="http://schemas.microsoft.com/office/drawing/2014/main" id="{AB68D127-AB1F-4833-B8BA-A9F181EF5491}"/>
               </a:ext>
             </a:extLst>
           </p:cNvPr>
@@ -5797,7 +5817,7 @@
                 <a:ea typeface="Arial"/>
                 <a:cs typeface="Arial"/>
               </a:rPr>
-              <a:t>Core</a:t>
+              <a:t>Silver core</a:t>
             </a:r>
           </a:p>
         </p:txBody>
@@ -5807,7 +5827,7 @@
           <p:cNvPr id="20" name="s3-node-body-3">
             <a:extLst xmlns:a="http://schemas.openxmlformats.org/drawingml/2006/main">
               <a:ext uri="{FF2B5EF4-FFF2-40B4-BE49-F238E27FC236}">
-                <a16:creationId xmlns:a16="http://schemas.microsoft.com/office/drawing/2014/main" id="{B8CF3B86-DEA1-4407-B6F2-3534AC5D9279}"/>
+                <a16:creationId xmlns:a16="http://schemas.microsoft.com/office/drawing/2014/main" id="{E37E08ED-FB61-4689-8AE1-3980E02F9536}"/>
               </a:ext>
             </a:extLst>
           </p:cNvPr>
@@ -5853,7 +5873,7 @@
                 <a:ea typeface="Arial"/>
                 <a:cs typeface="Arial"/>
               </a:rPr>
-              <a:t>Dimensions</a:t>
+              <a:t>Dimensions + facts</a:t>
             </a:r>
           </a:p>
           <a:p xmlns:a="http://schemas.openxmlformats.org/drawingml/2006/main">
@@ -5876,29 +5896,6 @@
                 <a:ea typeface="Arial"/>
                 <a:cs typeface="Arial"/>
               </a:rPr>
-              <a:t>Facts</a:t>
-            </a:r>
-          </a:p>
-          <a:p xmlns:a="http://schemas.openxmlformats.org/drawingml/2006/main">
-            <a:pPr algn="ctr">
-              <a:defRPr sz="1350" b="0">
-                <a:solidFill>
-                  <a:srgbClr val="000000"/>
-                </a:solidFill>
-                <a:latin typeface="Arial"/>
-                <a:ea typeface="Arial"/>
-                <a:cs typeface="Arial"/>
-              </a:defRPr>
-            </a:pPr>
-            <a:r>
-              <a:rPr sz="1350" b="0">
-                <a:solidFill>
-                  <a:srgbClr val="000000"/>
-                </a:solidFill>
-                <a:latin typeface="Arial"/>
-                <a:ea typeface="Arial"/>
-                <a:cs typeface="Arial"/>
-              </a:rPr>
               <a:t>Identifier/UOM bridges</a:t>
             </a:r>
           </a:p>
@@ -5909,7 +5906,7 @@
           <p:cNvPr id="21" name="s3-node-4">
             <a:extLst xmlns:a="http://schemas.openxmlformats.org/drawingml/2006/main">
               <a:ext uri="{FF2B5EF4-FFF2-40B4-BE49-F238E27FC236}">
-                <a16:creationId xmlns:a16="http://schemas.microsoft.com/office/drawing/2014/main" id="{3E366290-AAD8-44C5-948E-325ACA3EC502}"/>
+                <a16:creationId xmlns:a16="http://schemas.microsoft.com/office/drawing/2014/main" id="{764476AC-290C-4518-83AD-E51440C37764}"/>
               </a:ext>
             </a:extLst>
           </p:cNvPr>
@@ -5942,7 +5939,7 @@
           <p:cNvPr id="22" name="s3-node-title-4">
             <a:extLst xmlns:a="http://schemas.openxmlformats.org/drawingml/2006/main">
               <a:ext uri="{FF2B5EF4-FFF2-40B4-BE49-F238E27FC236}">
-                <a16:creationId xmlns:a16="http://schemas.microsoft.com/office/drawing/2014/main" id="{95EF5BE8-7410-4EB1-A2BF-27E979800575}"/>
+                <a16:creationId xmlns:a16="http://schemas.microsoft.com/office/drawing/2014/main" id="{5EA577CF-786F-4D33-A780-28C6FA20A4AB}"/>
               </a:ext>
             </a:extLst>
           </p:cNvPr>
@@ -5988,7 +5985,7 @@
                 <a:ea typeface="Arial"/>
                 <a:cs typeface="Arial"/>
               </a:rPr>
-              <a:t>Marts</a:t>
+              <a:t>Gold</a:t>
             </a:r>
           </a:p>
         </p:txBody>
@@ -5998,7 +5995,7 @@
           <p:cNvPr id="23" name="s3-node-body-4">
             <a:extLst xmlns:a="http://schemas.openxmlformats.org/drawingml/2006/main">
               <a:ext uri="{FF2B5EF4-FFF2-40B4-BE49-F238E27FC236}">
-                <a16:creationId xmlns:a16="http://schemas.microsoft.com/office/drawing/2014/main" id="{E4885B98-319A-4836-A9AA-5993E32CD959}"/>
+                <a16:creationId xmlns:a16="http://schemas.microsoft.com/office/drawing/2014/main" id="{846308C6-9E51-4957-B7BF-9CB48950CF4A}"/>
               </a:ext>
             </a:extLst>
           </p:cNvPr>
@@ -6100,7 +6097,7 @@
           <p:cNvPr id="24" name="s3-quality">
             <a:extLst xmlns:a="http://schemas.openxmlformats.org/drawingml/2006/main">
               <a:ext uri="{FF2B5EF4-FFF2-40B4-BE49-F238E27FC236}">
-                <a16:creationId xmlns:a16="http://schemas.microsoft.com/office/drawing/2014/main" id="{7B403EE5-1D44-435B-BA81-3CF1F1CC3E5C}"/>
+                <a16:creationId xmlns:a16="http://schemas.microsoft.com/office/drawing/2014/main" id="{068CF427-E4B7-43C8-9B58-287EE2E4106E}"/>
               </a:ext>
             </a:extLst>
           </p:cNvPr>
@@ -6133,7 +6130,7 @@
           <p:cNvPr id="25" name="s3-quality-text">
             <a:extLst xmlns:a="http://schemas.openxmlformats.org/drawingml/2006/main">
               <a:ext uri="{FF2B5EF4-FFF2-40B4-BE49-F238E27FC236}">
-                <a16:creationId xmlns:a16="http://schemas.microsoft.com/office/drawing/2014/main" id="{06094C12-8370-41CD-A726-8BE90614DD8D}"/>
+                <a16:creationId xmlns:a16="http://schemas.microsoft.com/office/drawing/2014/main" id="{76AC6232-E899-4F1C-80A9-4B1077DB52A6}"/>
               </a:ext>
             </a:extLst>
           </p:cNvPr>
@@ -6179,7 +6176,7 @@
                 <a:ea typeface="Arial"/>
                 <a:cs typeface="Arial"/>
               </a:rPr>
-              <a:t>Quality plane: freshness • uniqueness • amount tie-outs • mapping coverage • quarantined exceptions with owners</a:t>
+              <a:t>Quality plane: schema drift • dedup audit • amount tie-outs • mapping coverage • owned exceptions</a:t>
             </a:r>
           </a:p>
         </p:txBody>
@@ -6187,7 +6184,7 @@
     </p:spTree>
     <p:extLst>
       <p:ext uri="{BB962C8B-B14F-4D97-AF65-F5344CB8AC3E}">
-        <p14:creationId xmlns:p14="http://schemas.microsoft.com/office/powerpoint/2010/main" val="1155087573"/>
+        <p14:creationId xmlns:p14="http://schemas.microsoft.com/office/powerpoint/2010/main" val="1024296084"/>
       </p:ext>
     </p:extLst>
   </p:cSld>
@@ -6218,7 +6215,7 @@
           <p:cNvPr id="7" name="eyebrow-4">
             <a:extLst xmlns:a="http://schemas.openxmlformats.org/drawingml/2006/main">
               <a:ext uri="{FF2B5EF4-FFF2-40B4-BE49-F238E27FC236}">
-                <a16:creationId xmlns:a16="http://schemas.microsoft.com/office/drawing/2014/main" id="{028F0472-F2DD-4A51-95F1-9BEF286E126B}"/>
+                <a16:creationId xmlns:a16="http://schemas.microsoft.com/office/drawing/2014/main" id="{B7EFB36D-FEF2-437C-8574-66E7270F8667}"/>
               </a:ext>
             </a:extLst>
           </p:cNvPr>
@@ -6274,7 +6271,7 @@
           <p:cNvPr id="2" name="title-4">
             <a:extLst xmlns:a="http://schemas.openxmlformats.org/drawingml/2006/main">
               <a:ext uri="{FF2B5EF4-FFF2-40B4-BE49-F238E27FC236}">
-                <a16:creationId xmlns:a16="http://schemas.microsoft.com/office/drawing/2014/main" id="{26614726-9DDC-4B75-8B15-17BCE47D91A3}"/>
+                <a16:creationId xmlns:a16="http://schemas.microsoft.com/office/drawing/2014/main" id="{13041A5A-9853-4F7F-B709-44EA57641CBF}"/>
               </a:ext>
             </a:extLst>
           </p:cNvPr>
@@ -6330,7 +6327,7 @@
           <p:cNvPr id="3" name="footer-4">
             <a:extLst xmlns:a="http://schemas.openxmlformats.org/drawingml/2006/main">
               <a:ext uri="{FF2B5EF4-FFF2-40B4-BE49-F238E27FC236}">
-                <a16:creationId xmlns:a16="http://schemas.microsoft.com/office/drawing/2014/main" id="{68967C0A-9981-4847-AA8D-5F3EC3ACA260}"/>
+                <a16:creationId xmlns:a16="http://schemas.microsoft.com/office/drawing/2014/main" id="{C1442B56-F79B-4DC4-804D-D2B197C9BBAD}"/>
               </a:ext>
             </a:extLst>
           </p:cNvPr>
@@ -6386,7 +6383,7 @@
           <p:cNvPr id="4" name="s4-intro">
             <a:extLst xmlns:a="http://schemas.openxmlformats.org/drawingml/2006/main">
               <a:ext uri="{FF2B5EF4-FFF2-40B4-BE49-F238E27FC236}">
-                <a16:creationId xmlns:a16="http://schemas.microsoft.com/office/drawing/2014/main" id="{82E5C4BF-16D2-48E1-87D3-DE9B3B26EBAF}"/>
+                <a16:creationId xmlns:a16="http://schemas.microsoft.com/office/drawing/2014/main" id="{45F90ABA-C066-4990-BFF4-F5A2C42419D3}"/>
               </a:ext>
             </a:extLst>
           </p:cNvPr>
@@ -6994,7 +6991,7 @@
           <p:cNvPr id="6" name="s4-foot">
             <a:extLst xmlns:a="http://schemas.openxmlformats.org/drawingml/2006/main">
               <a:ext uri="{FF2B5EF4-FFF2-40B4-BE49-F238E27FC236}">
-                <a16:creationId xmlns:a16="http://schemas.microsoft.com/office/drawing/2014/main" id="{0651683B-FF9F-4D5A-AF36-BA81550B346A}"/>
+                <a16:creationId xmlns:a16="http://schemas.microsoft.com/office/drawing/2014/main" id="{9EB5DFF9-5494-434E-90C6-1CE3A557925C}"/>
               </a:ext>
             </a:extLst>
           </p:cNvPr>
@@ -7048,7 +7045,7 @@
     </p:spTree>
     <p:extLst>
       <p:ext uri="{BB962C8B-B14F-4D97-AF65-F5344CB8AC3E}">
-        <p14:creationId xmlns:p14="http://schemas.microsoft.com/office/powerpoint/2010/main" val="1052363060"/>
+        <p14:creationId xmlns:p14="http://schemas.microsoft.com/office/powerpoint/2010/main" val="122950605"/>
       </p:ext>
     </p:extLst>
   </p:cSld>
@@ -7079,7 +7076,7 @@
           <p:cNvPr id="17" name="eyebrow-5">
             <a:extLst xmlns:a="http://schemas.openxmlformats.org/drawingml/2006/main">
               <a:ext uri="{FF2B5EF4-FFF2-40B4-BE49-F238E27FC236}">
-                <a16:creationId xmlns:a16="http://schemas.microsoft.com/office/drawing/2014/main" id="{F9F17721-5259-4150-A68B-6755774FBC0B}"/>
+                <a16:creationId xmlns:a16="http://schemas.microsoft.com/office/drawing/2014/main" id="{585AAAFF-515F-4F2D-9782-5849C8359D2C}"/>
               </a:ext>
             </a:extLst>
           </p:cNvPr>
@@ -7135,7 +7132,7 @@
           <p:cNvPr id="2" name="title-5">
             <a:extLst xmlns:a="http://schemas.openxmlformats.org/drawingml/2006/main">
               <a:ext uri="{FF2B5EF4-FFF2-40B4-BE49-F238E27FC236}">
-                <a16:creationId xmlns:a16="http://schemas.microsoft.com/office/drawing/2014/main" id="{65CD89E0-E8E5-4AEC-B5E8-DBA3C40DC931}"/>
+                <a16:creationId xmlns:a16="http://schemas.microsoft.com/office/drawing/2014/main" id="{C544E648-2236-4757-B877-A0D7CE252ACC}"/>
               </a:ext>
             </a:extLst>
           </p:cNvPr>
@@ -7191,7 +7188,7 @@
           <p:cNvPr id="3" name="footer-5">
             <a:extLst xmlns:a="http://schemas.openxmlformats.org/drawingml/2006/main">
               <a:ext uri="{FF2B5EF4-FFF2-40B4-BE49-F238E27FC236}">
-                <a16:creationId xmlns:a16="http://schemas.microsoft.com/office/drawing/2014/main" id="{24D2666A-3E59-4EB3-8A8A-5502D38AB8AC}"/>
+                <a16:creationId xmlns:a16="http://schemas.microsoft.com/office/drawing/2014/main" id="{52F86A62-7B79-479C-92F9-C1DE21848E87}"/>
               </a:ext>
             </a:extLst>
           </p:cNvPr>
@@ -7254,7 +7251,7 @@
         </p:xfrm>
         <a:graphic xmlns:a="http://schemas.openxmlformats.org/drawingml/2006/main">
           <a:graphicData uri="http://schemas.openxmlformats.org/drawingml/2006/chart">
-            <c:chart xmlns:r="http://schemas.openxmlformats.org/officeDocument/2006/relationships" xmlns:c="http://schemas.openxmlformats.org/drawingml/2006/chart" r:id="R92493e6e6b554344"/>
+            <c:chart xmlns:r="http://schemas.openxmlformats.org/officeDocument/2006/relationships" xmlns:c="http://schemas.openxmlformats.org/drawingml/2006/chart" r:id="R59262ba5c1e44a1c"/>
           </a:graphicData>
         </a:graphic>
       </p:graphicFrame>
@@ -7263,7 +7260,7 @@
           <p:cNvPr id="5" name="s5-rail-0">
             <a:extLst xmlns:a="http://schemas.openxmlformats.org/drawingml/2006/main">
               <a:ext uri="{FF2B5EF4-FFF2-40B4-BE49-F238E27FC236}">
-                <a16:creationId xmlns:a16="http://schemas.microsoft.com/office/drawing/2014/main" id="{97117798-1AFB-4E3E-B006-7599757097CE}"/>
+                <a16:creationId xmlns:a16="http://schemas.microsoft.com/office/drawing/2014/main" id="{429F3CDD-1A30-4F10-9433-A71168895E4A}"/>
               </a:ext>
             </a:extLst>
           </p:cNvPr>
@@ -7294,7 +7291,7 @@
           <p:cNvPr id="6" name="s5-rail-title-0">
             <a:extLst xmlns:a="http://schemas.openxmlformats.org/drawingml/2006/main">
               <a:ext uri="{FF2B5EF4-FFF2-40B4-BE49-F238E27FC236}">
-                <a16:creationId xmlns:a16="http://schemas.microsoft.com/office/drawing/2014/main" id="{F662992B-0888-4CA7-9D1E-38F97C4D2698}"/>
+                <a16:creationId xmlns:a16="http://schemas.microsoft.com/office/drawing/2014/main" id="{0D815549-9020-4534-8C7B-DE03562C5F0E}"/>
               </a:ext>
             </a:extLst>
           </p:cNvPr>
@@ -7350,7 +7347,7 @@
           <p:cNvPr id="7" name="s5-rail-stat-0">
             <a:extLst xmlns:a="http://schemas.openxmlformats.org/drawingml/2006/main">
               <a:ext uri="{FF2B5EF4-FFF2-40B4-BE49-F238E27FC236}">
-                <a16:creationId xmlns:a16="http://schemas.microsoft.com/office/drawing/2014/main" id="{81DEBBCF-621E-4F8A-8ECB-910C56B6BBA8}"/>
+                <a16:creationId xmlns:a16="http://schemas.microsoft.com/office/drawing/2014/main" id="{DB62C4A8-5562-4894-9FBD-D8138508B6D4}"/>
               </a:ext>
             </a:extLst>
           </p:cNvPr>
@@ -7406,7 +7403,7 @@
           <p:cNvPr id="8" name="s5-rail-detail-0">
             <a:extLst xmlns:a="http://schemas.openxmlformats.org/drawingml/2006/main">
               <a:ext uri="{FF2B5EF4-FFF2-40B4-BE49-F238E27FC236}">
-                <a16:creationId xmlns:a16="http://schemas.microsoft.com/office/drawing/2014/main" id="{D93B758C-9AC4-4260-9D73-C2E2C2A0D95F}"/>
+                <a16:creationId xmlns:a16="http://schemas.microsoft.com/office/drawing/2014/main" id="{8F7606D7-9208-4F16-8788-136D58E3D8B6}"/>
               </a:ext>
             </a:extLst>
           </p:cNvPr>
@@ -7462,7 +7459,7 @@
           <p:cNvPr id="9" name="s5-rail-1">
             <a:extLst xmlns:a="http://schemas.openxmlformats.org/drawingml/2006/main">
               <a:ext uri="{FF2B5EF4-FFF2-40B4-BE49-F238E27FC236}">
-                <a16:creationId xmlns:a16="http://schemas.microsoft.com/office/drawing/2014/main" id="{23ECEE6C-0CB6-493A-8EB2-382E59652F23}"/>
+                <a16:creationId xmlns:a16="http://schemas.microsoft.com/office/drawing/2014/main" id="{2F3DCFE2-95A3-4ACC-8163-7FE612B6CD1E}"/>
               </a:ext>
             </a:extLst>
           </p:cNvPr>
@@ -7493,7 +7490,7 @@
           <p:cNvPr id="10" name="s5-rail-title-1">
             <a:extLst xmlns:a="http://schemas.openxmlformats.org/drawingml/2006/main">
               <a:ext uri="{FF2B5EF4-FFF2-40B4-BE49-F238E27FC236}">
-                <a16:creationId xmlns:a16="http://schemas.microsoft.com/office/drawing/2014/main" id="{0668945C-251E-4576-8FF7-6959AA8D9473}"/>
+                <a16:creationId xmlns:a16="http://schemas.microsoft.com/office/drawing/2014/main" id="{62F53F59-509B-4346-AB11-230C9D97834A}"/>
               </a:ext>
             </a:extLst>
           </p:cNvPr>
@@ -7549,7 +7546,7 @@
           <p:cNvPr id="11" name="s5-rail-stat-1">
             <a:extLst xmlns:a="http://schemas.openxmlformats.org/drawingml/2006/main">
               <a:ext uri="{FF2B5EF4-FFF2-40B4-BE49-F238E27FC236}">
-                <a16:creationId xmlns:a16="http://schemas.microsoft.com/office/drawing/2014/main" id="{3FE73001-90AA-4205-A44A-ED4285356132}"/>
+                <a16:creationId xmlns:a16="http://schemas.microsoft.com/office/drawing/2014/main" id="{3E63FFCE-E2DF-4E4B-AAD5-072F379F1C53}"/>
               </a:ext>
             </a:extLst>
           </p:cNvPr>
@@ -7605,7 +7602,7 @@
           <p:cNvPr id="12" name="s5-rail-detail-1">
             <a:extLst xmlns:a="http://schemas.openxmlformats.org/drawingml/2006/main">
               <a:ext uri="{FF2B5EF4-FFF2-40B4-BE49-F238E27FC236}">
-                <a16:creationId xmlns:a16="http://schemas.microsoft.com/office/drawing/2014/main" id="{A3FC525E-F3AA-4D7B-B80B-67CA179D87E7}"/>
+                <a16:creationId xmlns:a16="http://schemas.microsoft.com/office/drawing/2014/main" id="{79CFB034-E138-4377-B4B7-BAE559211DD1}"/>
               </a:ext>
             </a:extLst>
           </p:cNvPr>
@@ -7661,7 +7658,7 @@
           <p:cNvPr id="13" name="s5-rail-2">
             <a:extLst xmlns:a="http://schemas.openxmlformats.org/drawingml/2006/main">
               <a:ext uri="{FF2B5EF4-FFF2-40B4-BE49-F238E27FC236}">
-                <a16:creationId xmlns:a16="http://schemas.microsoft.com/office/drawing/2014/main" id="{252335D0-94D1-4F6B-8488-EC0ACB11EFF9}"/>
+                <a16:creationId xmlns:a16="http://schemas.microsoft.com/office/drawing/2014/main" id="{669FAC41-FFAE-4853-B37B-378D52AB3524}"/>
               </a:ext>
             </a:extLst>
           </p:cNvPr>
@@ -7692,7 +7689,7 @@
           <p:cNvPr id="14" name="s5-rail-title-2">
             <a:extLst xmlns:a="http://schemas.openxmlformats.org/drawingml/2006/main">
               <a:ext uri="{FF2B5EF4-FFF2-40B4-BE49-F238E27FC236}">
-                <a16:creationId xmlns:a16="http://schemas.microsoft.com/office/drawing/2014/main" id="{28E038D0-96F2-44E6-86EC-070D9435C21A}"/>
+                <a16:creationId xmlns:a16="http://schemas.microsoft.com/office/drawing/2014/main" id="{0883BCC8-6A05-4283-9EFA-C844E1CD63F3}"/>
               </a:ext>
             </a:extLst>
           </p:cNvPr>
@@ -7748,7 +7745,7 @@
           <p:cNvPr id="15" name="s5-rail-stat-2">
             <a:extLst xmlns:a="http://schemas.openxmlformats.org/drawingml/2006/main">
               <a:ext uri="{FF2B5EF4-FFF2-40B4-BE49-F238E27FC236}">
-                <a16:creationId xmlns:a16="http://schemas.microsoft.com/office/drawing/2014/main" id="{279BCC63-00F9-4A18-A38B-E29AD07B327F}"/>
+                <a16:creationId xmlns:a16="http://schemas.microsoft.com/office/drawing/2014/main" id="{7C081982-2767-404B-86F3-D6874AC66529}"/>
               </a:ext>
             </a:extLst>
           </p:cNvPr>
@@ -7804,7 +7801,7 @@
           <p:cNvPr id="16" name="s5-rail-detail-2">
             <a:extLst xmlns:a="http://schemas.openxmlformats.org/drawingml/2006/main">
               <a:ext uri="{FF2B5EF4-FFF2-40B4-BE49-F238E27FC236}">
-                <a16:creationId xmlns:a16="http://schemas.microsoft.com/office/drawing/2014/main" id="{DA695141-B121-463D-985B-26623AD419AD}"/>
+                <a16:creationId xmlns:a16="http://schemas.microsoft.com/office/drawing/2014/main" id="{14E244D6-D29C-4372-998E-6AC291CC45F0}"/>
               </a:ext>
             </a:extLst>
           </p:cNvPr>
@@ -7858,7 +7855,7 @@
     </p:spTree>
     <p:extLst>
       <p:ext uri="{BB962C8B-B14F-4D97-AF65-F5344CB8AC3E}">
-        <p14:creationId xmlns:p14="http://schemas.microsoft.com/office/powerpoint/2010/main" val="1339694442"/>
+        <p14:creationId xmlns:p14="http://schemas.microsoft.com/office/powerpoint/2010/main" val="1774666662"/>
       </p:ext>
     </p:extLst>
   </p:cSld>
@@ -7889,7 +7886,7 @@
           <p:cNvPr id="11" name="eyebrow-6">
             <a:extLst xmlns:a="http://schemas.openxmlformats.org/drawingml/2006/main">
               <a:ext uri="{FF2B5EF4-FFF2-40B4-BE49-F238E27FC236}">
-                <a16:creationId xmlns:a16="http://schemas.microsoft.com/office/drawing/2014/main" id="{037EA66F-98B6-4494-A901-57690A96D6C6}"/>
+                <a16:creationId xmlns:a16="http://schemas.microsoft.com/office/drawing/2014/main" id="{7A0E267B-4EAD-4258-84A3-7DEF99BFFB7B}"/>
               </a:ext>
             </a:extLst>
           </p:cNvPr>
@@ -7945,19 +7942,19 @@
           <p:cNvPr id="2" name="title-6">
             <a:extLst xmlns:a="http://schemas.openxmlformats.org/drawingml/2006/main">
               <a:ext uri="{FF2B5EF4-FFF2-40B4-BE49-F238E27FC236}">
-                <a16:creationId xmlns:a16="http://schemas.microsoft.com/office/drawing/2014/main" id="{D37E06E3-EFFE-4882-9C69-CB46EE6FA257}"/>
-              </a:ext>
-            </a:extLst>
-          </p:cNvPr>
-          <p:cNvSpPr>
-            <a:spLocks xmlns:a="http://schemas.openxmlformats.org/drawingml/2006/main" noGrp="1"/>
-          </p:cNvSpPr>
-          <p:nvPr/>
-        </p:nvSpPr>
-        <p:spPr>
-          <a:xfrm xmlns:a="http://schemas.openxmlformats.org/drawingml/2006/main">
-            <a:off x="533400" y="590550"/>
-            <a:ext cx="11125200" cy="838200"/>
+                <a16:creationId xmlns:a16="http://schemas.microsoft.com/office/drawing/2014/main" id="{E506476C-7897-4117-9370-3F3AE5C4B5D8}"/>
+              </a:ext>
+            </a:extLst>
+          </p:cNvPr>
+          <p:cNvSpPr>
+            <a:spLocks xmlns:a="http://schemas.openxmlformats.org/drawingml/2006/main" noGrp="1"/>
+          </p:cNvSpPr>
+          <p:nvPr/>
+        </p:nvSpPr>
+        <p:spPr>
+          <a:xfrm xmlns:a="http://schemas.openxmlformats.org/drawingml/2006/main">
+            <a:off x="533400" y="762000"/>
+            <a:ext cx="11125200" cy="609600"/>
           </a:xfrm>
           <a:prstGeom xmlns:a="http://schemas.openxmlformats.org/drawingml/2006/main" prst="rect">
             <a:avLst/>
@@ -8001,7 +7998,7 @@
           <p:cNvPr id="3" name="footer-6">
             <a:extLst xmlns:a="http://schemas.openxmlformats.org/drawingml/2006/main">
               <a:ext uri="{FF2B5EF4-FFF2-40B4-BE49-F238E27FC236}">
-                <a16:creationId xmlns:a16="http://schemas.microsoft.com/office/drawing/2014/main" id="{6653F836-7D30-409F-A838-1572495905DE}"/>
+                <a16:creationId xmlns:a16="http://schemas.microsoft.com/office/drawing/2014/main" id="{199AE8B4-A5D0-4F93-8D58-6D6A7C367689}"/>
               </a:ext>
             </a:extLst>
           </p:cNvPr>
@@ -8064,7 +8061,7 @@
         </p:xfrm>
         <a:graphic xmlns:a="http://schemas.openxmlformats.org/drawingml/2006/main">
           <a:graphicData uri="http://schemas.openxmlformats.org/drawingml/2006/chart">
-            <c:chart xmlns:r="http://schemas.openxmlformats.org/officeDocument/2006/relationships" xmlns:c="http://schemas.openxmlformats.org/drawingml/2006/chart" r:id="Rd18e186638a14b07"/>
+            <c:chart xmlns:r="http://schemas.openxmlformats.org/officeDocument/2006/relationships" xmlns:c="http://schemas.openxmlformats.org/drawingml/2006/chart" r:id="R7771e4135cca4d28"/>
           </a:graphicData>
         </a:graphic>
       </p:graphicFrame>
@@ -8073,7 +8070,7 @@
           <p:cNvPr id="5" name="s6-callout-a">
             <a:extLst xmlns:a="http://schemas.openxmlformats.org/drawingml/2006/main">
               <a:ext uri="{FF2B5EF4-FFF2-40B4-BE49-F238E27FC236}">
-                <a16:creationId xmlns:a16="http://schemas.microsoft.com/office/drawing/2014/main" id="{75A9181B-D788-4B48-8EF8-A9967C9482D5}"/>
+                <a16:creationId xmlns:a16="http://schemas.microsoft.com/office/drawing/2014/main" id="{56EAE49D-8129-4515-9A7C-60879D1BD33F}"/>
               </a:ext>
             </a:extLst>
           </p:cNvPr>
@@ -8104,7 +8101,7 @@
           <p:cNvPr id="6" name="s6-callout-a-title">
             <a:extLst xmlns:a="http://schemas.openxmlformats.org/drawingml/2006/main">
               <a:ext uri="{FF2B5EF4-FFF2-40B4-BE49-F238E27FC236}">
-                <a16:creationId xmlns:a16="http://schemas.microsoft.com/office/drawing/2014/main" id="{D186D967-3447-4CE8-845B-735D9EE0884B}"/>
+                <a16:creationId xmlns:a16="http://schemas.microsoft.com/office/drawing/2014/main" id="{2214EA55-719D-4D3E-B8F8-BABE59F0F5BA}"/>
               </a:ext>
             </a:extLst>
           </p:cNvPr>
@@ -8160,7 +8157,7 @@
           <p:cNvPr id="7" name="s6-callout-a-body">
             <a:extLst xmlns:a="http://schemas.openxmlformats.org/drawingml/2006/main">
               <a:ext uri="{FF2B5EF4-FFF2-40B4-BE49-F238E27FC236}">
-                <a16:creationId xmlns:a16="http://schemas.microsoft.com/office/drawing/2014/main" id="{ABFCE2BE-987E-4148-A9BF-63EAA027FEE1}"/>
+                <a16:creationId xmlns:a16="http://schemas.microsoft.com/office/drawing/2014/main" id="{F72868F9-4559-4D35-9998-C044E430A999}"/>
               </a:ext>
             </a:extLst>
           </p:cNvPr>
@@ -8239,7 +8236,7 @@
           <p:cNvPr id="8" name="s6-callout-b">
             <a:extLst xmlns:a="http://schemas.openxmlformats.org/drawingml/2006/main">
               <a:ext uri="{FF2B5EF4-FFF2-40B4-BE49-F238E27FC236}">
-                <a16:creationId xmlns:a16="http://schemas.microsoft.com/office/drawing/2014/main" id="{99BBEF3F-DF0A-4C99-AB8C-78A1F329D603}"/>
+                <a16:creationId xmlns:a16="http://schemas.microsoft.com/office/drawing/2014/main" id="{7B3D5554-B8F4-403E-B67A-FE7F3E156B69}"/>
               </a:ext>
             </a:extLst>
           </p:cNvPr>
@@ -8270,7 +8267,7 @@
           <p:cNvPr id="9" name="s6-callout-b-title">
             <a:extLst xmlns:a="http://schemas.openxmlformats.org/drawingml/2006/main">
               <a:ext uri="{FF2B5EF4-FFF2-40B4-BE49-F238E27FC236}">
-                <a16:creationId xmlns:a16="http://schemas.microsoft.com/office/drawing/2014/main" id="{5DF7E2EC-25C7-4C48-A74C-6B3046A3548C}"/>
+                <a16:creationId xmlns:a16="http://schemas.microsoft.com/office/drawing/2014/main" id="{E49D7AE9-385D-4B36-983C-108631074112}"/>
               </a:ext>
             </a:extLst>
           </p:cNvPr>
@@ -8326,7 +8323,7 @@
           <p:cNvPr id="10" name="s6-callout-b-body">
             <a:extLst xmlns:a="http://schemas.openxmlformats.org/drawingml/2006/main">
               <a:ext uri="{FF2B5EF4-FFF2-40B4-BE49-F238E27FC236}">
-                <a16:creationId xmlns:a16="http://schemas.microsoft.com/office/drawing/2014/main" id="{100CE077-34CB-4E9D-BDDD-E5C61159B59C}"/>
+                <a16:creationId xmlns:a16="http://schemas.microsoft.com/office/drawing/2014/main" id="{6378E184-B20F-4311-80C6-3F952972EE01}"/>
               </a:ext>
             </a:extLst>
           </p:cNvPr>
@@ -8380,7 +8377,7 @@
     </p:spTree>
     <p:extLst>
       <p:ext uri="{BB962C8B-B14F-4D97-AF65-F5344CB8AC3E}">
-        <p14:creationId xmlns:p14="http://schemas.microsoft.com/office/powerpoint/2010/main" val="1260889715"/>
+        <p14:creationId xmlns:p14="http://schemas.microsoft.com/office/powerpoint/2010/main" val="1399357563"/>
       </p:ext>
     </p:extLst>
   </p:cSld>
@@ -8411,7 +8408,7 @@
           <p:cNvPr id="11" name="eyebrow-7">
             <a:extLst xmlns:a="http://schemas.openxmlformats.org/drawingml/2006/main">
               <a:ext uri="{FF2B5EF4-FFF2-40B4-BE49-F238E27FC236}">
-                <a16:creationId xmlns:a16="http://schemas.microsoft.com/office/drawing/2014/main" id="{F625E759-3706-47FC-8412-C9FD745D42CB}"/>
+                <a16:creationId xmlns:a16="http://schemas.microsoft.com/office/drawing/2014/main" id="{6C2F059B-7BA9-4FEB-A571-80E87526D736}"/>
               </a:ext>
             </a:extLst>
           </p:cNvPr>
@@ -8467,7 +8464,7 @@
           <p:cNvPr id="2" name="title-7">
             <a:extLst xmlns:a="http://schemas.openxmlformats.org/drawingml/2006/main">
               <a:ext uri="{FF2B5EF4-FFF2-40B4-BE49-F238E27FC236}">
-                <a16:creationId xmlns:a16="http://schemas.microsoft.com/office/drawing/2014/main" id="{4B8035B7-3D39-4FF9-A9C9-2270728C78E0}"/>
+                <a16:creationId xmlns:a16="http://schemas.microsoft.com/office/drawing/2014/main" id="{94DF72DC-DF66-4440-B609-DF8A831AE6D9}"/>
               </a:ext>
             </a:extLst>
           </p:cNvPr>
@@ -8523,7 +8520,7 @@
           <p:cNvPr id="3" name="footer-7">
             <a:extLst xmlns:a="http://schemas.openxmlformats.org/drawingml/2006/main">
               <a:ext uri="{FF2B5EF4-FFF2-40B4-BE49-F238E27FC236}">
-                <a16:creationId xmlns:a16="http://schemas.microsoft.com/office/drawing/2014/main" id="{AD63C872-F20A-45A5-948D-3A42B8237BE1}"/>
+                <a16:creationId xmlns:a16="http://schemas.microsoft.com/office/drawing/2014/main" id="{28DA2E30-C563-4B52-851D-E37D6B76DABC}"/>
               </a:ext>
             </a:extLst>
           </p:cNvPr>
@@ -8586,7 +8583,7 @@
         </p:xfrm>
         <a:graphic xmlns:a="http://schemas.openxmlformats.org/drawingml/2006/main">
           <a:graphicData uri="http://schemas.openxmlformats.org/drawingml/2006/chart">
-            <c:chart xmlns:r="http://schemas.openxmlformats.org/officeDocument/2006/relationships" xmlns:c="http://schemas.openxmlformats.org/drawingml/2006/chart" r:id="R17511e0de92a4a6d"/>
+            <c:chart xmlns:r="http://schemas.openxmlformats.org/officeDocument/2006/relationships" xmlns:c="http://schemas.openxmlformats.org/drawingml/2006/chart" r:id="R75d248f3a40f47cc"/>
           </a:graphicData>
         </a:graphic>
       </p:graphicFrame>
@@ -8595,7 +8592,7 @@
           <p:cNvPr id="5" name="s7-decision">
             <a:extLst xmlns:a="http://schemas.openxmlformats.org/drawingml/2006/main">
               <a:ext uri="{FF2B5EF4-FFF2-40B4-BE49-F238E27FC236}">
-                <a16:creationId xmlns:a16="http://schemas.microsoft.com/office/drawing/2014/main" id="{7CFD24F9-4265-4CC2-BE6F-DC71B12A9E05}"/>
+                <a16:creationId xmlns:a16="http://schemas.microsoft.com/office/drawing/2014/main" id="{8D980CA6-6CB1-4D4A-8AD9-E3DABBA162E3}"/>
               </a:ext>
             </a:extLst>
           </p:cNvPr>
@@ -8626,7 +8623,7 @@
           <p:cNvPr id="6" name="s7-decision-stat">
             <a:extLst xmlns:a="http://schemas.openxmlformats.org/drawingml/2006/main">
               <a:ext uri="{FF2B5EF4-FFF2-40B4-BE49-F238E27FC236}">
-                <a16:creationId xmlns:a16="http://schemas.microsoft.com/office/drawing/2014/main" id="{561F50A4-5F4E-418E-AC93-D783266D78A3}"/>
+                <a16:creationId xmlns:a16="http://schemas.microsoft.com/office/drawing/2014/main" id="{84039444-B310-4CAA-AD5E-B895EF593509}"/>
               </a:ext>
             </a:extLst>
           </p:cNvPr>
@@ -8682,7 +8679,7 @@
           <p:cNvPr id="7" name="s7-decision-label">
             <a:extLst xmlns:a="http://schemas.openxmlformats.org/drawingml/2006/main">
               <a:ext uri="{FF2B5EF4-FFF2-40B4-BE49-F238E27FC236}">
-                <a16:creationId xmlns:a16="http://schemas.microsoft.com/office/drawing/2014/main" id="{D85C781A-4D9B-4944-BBC3-DB0A24089CD8}"/>
+                <a16:creationId xmlns:a16="http://schemas.microsoft.com/office/drawing/2014/main" id="{02A130BA-45C7-4BF1-91A5-7738F0E83347}"/>
               </a:ext>
             </a:extLst>
           </p:cNvPr>
@@ -8738,7 +8735,7 @@
           <p:cNvPr id="8" name="s7-action">
             <a:extLst xmlns:a="http://schemas.openxmlformats.org/drawingml/2006/main">
               <a:ext uri="{FF2B5EF4-FFF2-40B4-BE49-F238E27FC236}">
-                <a16:creationId xmlns:a16="http://schemas.microsoft.com/office/drawing/2014/main" id="{8F49F4CA-A83C-474E-B6A0-0862C0D028E4}"/>
+                <a16:creationId xmlns:a16="http://schemas.microsoft.com/office/drawing/2014/main" id="{622248F0-0C9F-447B-B43F-5FA35EC10E6B}"/>
               </a:ext>
             </a:extLst>
           </p:cNvPr>
@@ -8769,7 +8766,7 @@
           <p:cNvPr id="9" name="s7-action-title">
             <a:extLst xmlns:a="http://schemas.openxmlformats.org/drawingml/2006/main">
               <a:ext uri="{FF2B5EF4-FFF2-40B4-BE49-F238E27FC236}">
-                <a16:creationId xmlns:a16="http://schemas.microsoft.com/office/drawing/2014/main" id="{9E28549C-8A91-4DD3-86D6-66C82DD18449}"/>
+                <a16:creationId xmlns:a16="http://schemas.microsoft.com/office/drawing/2014/main" id="{39C4C9A8-43E2-4FB1-9CC2-C39F14CC6CB5}"/>
               </a:ext>
             </a:extLst>
           </p:cNvPr>
@@ -8825,7 +8822,7 @@
           <p:cNvPr id="10" name="s7-action-body">
             <a:extLst xmlns:a="http://schemas.openxmlformats.org/drawingml/2006/main">
               <a:ext uri="{FF2B5EF4-FFF2-40B4-BE49-F238E27FC236}">
-                <a16:creationId xmlns:a16="http://schemas.microsoft.com/office/drawing/2014/main" id="{92572B79-7929-41E9-98C3-E48030A3DE16}"/>
+                <a16:creationId xmlns:a16="http://schemas.microsoft.com/office/drawing/2014/main" id="{FDDF0983-635D-44E3-971B-8AD77FEEBD0E}"/>
               </a:ext>
             </a:extLst>
           </p:cNvPr>
@@ -8879,7 +8876,7 @@
     </p:spTree>
     <p:extLst>
       <p:ext uri="{BB962C8B-B14F-4D97-AF65-F5344CB8AC3E}">
-        <p14:creationId xmlns:p14="http://schemas.microsoft.com/office/powerpoint/2010/main" val="950963832"/>
+        <p14:creationId xmlns:p14="http://schemas.microsoft.com/office/powerpoint/2010/main" val="1170761726"/>
       </p:ext>
     </p:extLst>
   </p:cSld>
@@ -8910,7 +8907,7 @@
           <p:cNvPr id="11" name="eyebrow-8">
             <a:extLst xmlns:a="http://schemas.openxmlformats.org/drawingml/2006/main">
               <a:ext uri="{FF2B5EF4-FFF2-40B4-BE49-F238E27FC236}">
-                <a16:creationId xmlns:a16="http://schemas.microsoft.com/office/drawing/2014/main" id="{FD6EF5F2-A8E8-43BF-BD45-C4A130331C0E}"/>
+                <a16:creationId xmlns:a16="http://schemas.microsoft.com/office/drawing/2014/main" id="{7C5BA9BE-BBC5-4346-B4A9-0F1E981936B7}"/>
               </a:ext>
             </a:extLst>
           </p:cNvPr>
@@ -8966,7 +8963,7 @@
           <p:cNvPr id="2" name="title-8">
             <a:extLst xmlns:a="http://schemas.openxmlformats.org/drawingml/2006/main">
               <a:ext uri="{FF2B5EF4-FFF2-40B4-BE49-F238E27FC236}">
-                <a16:creationId xmlns:a16="http://schemas.microsoft.com/office/drawing/2014/main" id="{4ADF60F4-C2E9-466E-9266-E2C7EBD48E79}"/>
+                <a16:creationId xmlns:a16="http://schemas.microsoft.com/office/drawing/2014/main" id="{5FEB1C03-20DC-4C97-A9AF-1B77136532DA}"/>
               </a:ext>
             </a:extLst>
           </p:cNvPr>
@@ -9022,7 +9019,7 @@
           <p:cNvPr id="3" name="footer-8">
             <a:extLst xmlns:a="http://schemas.openxmlformats.org/drawingml/2006/main">
               <a:ext uri="{FF2B5EF4-FFF2-40B4-BE49-F238E27FC236}">
-                <a16:creationId xmlns:a16="http://schemas.microsoft.com/office/drawing/2014/main" id="{DA068F9D-718F-4BC0-A66D-E425A712874D}"/>
+                <a16:creationId xmlns:a16="http://schemas.microsoft.com/office/drawing/2014/main" id="{6FA52589-14C2-4A82-886E-89B6ED1BE881}"/>
               </a:ext>
             </a:extLst>
           </p:cNvPr>
@@ -9078,7 +9075,7 @@
           <p:cNvPr id="4" name="s8-intro">
             <a:extLst xmlns:a="http://schemas.openxmlformats.org/drawingml/2006/main">
               <a:ext uri="{FF2B5EF4-FFF2-40B4-BE49-F238E27FC236}">
-                <a16:creationId xmlns:a16="http://schemas.microsoft.com/office/drawing/2014/main" id="{1CA2EB20-9061-4404-B246-C37427EFF4EB}"/>
+                <a16:creationId xmlns:a16="http://schemas.microsoft.com/office/drawing/2014/main" id="{3BB6CB81-5DAE-4C3E-A8F6-5C3D05204AC3}"/>
               </a:ext>
             </a:extLst>
           </p:cNvPr>
@@ -9134,7 +9131,7 @@
           <p:cNvPr id="5" name="s8-left-head">
             <a:extLst xmlns:a="http://schemas.openxmlformats.org/drawingml/2006/main">
               <a:ext uri="{FF2B5EF4-FFF2-40B4-BE49-F238E27FC236}">
-                <a16:creationId xmlns:a16="http://schemas.microsoft.com/office/drawing/2014/main" id="{52D095A8-678D-4B63-9A41-1DA4CE14A3F6}"/>
+                <a16:creationId xmlns:a16="http://schemas.microsoft.com/office/drawing/2014/main" id="{0A157C61-A90F-4146-8D5F-FDACB396FD13}"/>
               </a:ext>
             </a:extLst>
           </p:cNvPr>
@@ -9190,7 +9187,7 @@
           <p:cNvPr id="6" name="s8-right-head">
             <a:extLst xmlns:a="http://schemas.openxmlformats.org/drawingml/2006/main">
               <a:ext uri="{FF2B5EF4-FFF2-40B4-BE49-F238E27FC236}">
-                <a16:creationId xmlns:a16="http://schemas.microsoft.com/office/drawing/2014/main" id="{2ACBDC5C-F173-4166-A9A3-1754330B9DD4}"/>
+                <a16:creationId xmlns:a16="http://schemas.microsoft.com/office/drawing/2014/main" id="{1A09494E-4ACD-42C1-9135-09014E670D86}"/>
               </a:ext>
             </a:extLst>
           </p:cNvPr>
@@ -10064,7 +10061,7 @@
           <p:cNvPr id="9" name="s8-bottom">
             <a:extLst xmlns:a="http://schemas.openxmlformats.org/drawingml/2006/main">
               <a:ext uri="{FF2B5EF4-FFF2-40B4-BE49-F238E27FC236}">
-                <a16:creationId xmlns:a16="http://schemas.microsoft.com/office/drawing/2014/main" id="{3F2D99D9-F148-4EED-8283-BF8E48D900C1}"/>
+                <a16:creationId xmlns:a16="http://schemas.microsoft.com/office/drawing/2014/main" id="{8980F26F-0384-4F25-AA5F-FD7CCDF7B97C}"/>
               </a:ext>
             </a:extLst>
           </p:cNvPr>
@@ -10095,7 +10092,7 @@
           <p:cNvPr id="10" name="s8-bottom-text">
             <a:extLst xmlns:a="http://schemas.openxmlformats.org/drawingml/2006/main">
               <a:ext uri="{FF2B5EF4-FFF2-40B4-BE49-F238E27FC236}">
-                <a16:creationId xmlns:a16="http://schemas.microsoft.com/office/drawing/2014/main" id="{941366A6-F1D4-4FD9-9C50-A8FB38A672C1}"/>
+                <a16:creationId xmlns:a16="http://schemas.microsoft.com/office/drawing/2014/main" id="{AEAEB15B-4388-4EC1-BB9B-C9CB9B63457E}"/>
               </a:ext>
             </a:extLst>
           </p:cNvPr>
@@ -10149,7 +10146,7 @@
     </p:spTree>
     <p:extLst>
       <p:ext uri="{BB962C8B-B14F-4D97-AF65-F5344CB8AC3E}">
-        <p14:creationId xmlns:p14="http://schemas.microsoft.com/office/powerpoint/2010/main" val="1728597032"/>
+        <p14:creationId xmlns:p14="http://schemas.microsoft.com/office/powerpoint/2010/main" val="493063959"/>
       </p:ext>
     </p:extLst>
   </p:cSld>
@@ -10180,7 +10177,7 @@
           <p:cNvPr id="20" name="eyebrow-9">
             <a:extLst xmlns:a="http://schemas.openxmlformats.org/drawingml/2006/main">
               <a:ext uri="{FF2B5EF4-FFF2-40B4-BE49-F238E27FC236}">
-                <a16:creationId xmlns:a16="http://schemas.microsoft.com/office/drawing/2014/main" id="{34A9D187-9B8E-4C2F-B0D1-DB2C28E251F5}"/>
+                <a16:creationId xmlns:a16="http://schemas.microsoft.com/office/drawing/2014/main" id="{2F37A0FB-EB69-4490-A556-65AA371FFA9B}"/>
               </a:ext>
             </a:extLst>
           </p:cNvPr>
@@ -10226,7 +10223,7 @@
                 <a:ea typeface="Arial"/>
                 <a:cs typeface="Arial"/>
               </a:rPr>
-              <a:t>FIRST 90 DAYS</a:t>
+              <a:t>DELIVERABLE 3 • AUTOMATION</a:t>
             </a:r>
           </a:p>
         </p:txBody>
@@ -10236,7 +10233,7 @@
           <p:cNvPr id="2" name="title-9">
             <a:extLst xmlns:a="http://schemas.openxmlformats.org/drawingml/2006/main">
               <a:ext uri="{FF2B5EF4-FFF2-40B4-BE49-F238E27FC236}">
-                <a16:creationId xmlns:a16="http://schemas.microsoft.com/office/drawing/2014/main" id="{065B9C9C-36D7-4693-8C6B-533A46BAC86D}"/>
+                <a16:creationId xmlns:a16="http://schemas.microsoft.com/office/drawing/2014/main" id="{6E121127-3D04-44C2-B737-32169406659F}"/>
               </a:ext>
             </a:extLst>
           </p:cNvPr>
@@ -10282,7 +10279,7 @@
                 <a:ea typeface="Arial"/>
                 <a:cs typeface="Arial"/>
               </a:rPr>
-              <a:t>Automate trust first, the management P&amp;L second, and forward-looking actions third</a:t>
+              <a:t>One 90-day plan, two ways to operate the same model</a:t>
             </a:r>
           </a:p>
         </p:txBody>
@@ -10292,7 +10289,7 @@
           <p:cNvPr id="3" name="footer-9">
             <a:extLst xmlns:a="http://schemas.openxmlformats.org/drawingml/2006/main">
               <a:ext uri="{FF2B5EF4-FFF2-40B4-BE49-F238E27FC236}">
-                <a16:creationId xmlns:a16="http://schemas.microsoft.com/office/drawing/2014/main" id="{3D395EF6-653D-4F92-BCCB-EF98E6B20273}"/>
+                <a16:creationId xmlns:a16="http://schemas.microsoft.com/office/drawing/2014/main" id="{438EA34B-6A0D-4CA0-9F94-B4643E6C9EB8}"/>
               </a:ext>
             </a:extLst>
           </p:cNvPr>
@@ -10348,7 +10345,7 @@
           <p:cNvPr id="4" name="s9-intro">
             <a:extLst xmlns:a="http://schemas.openxmlformats.org/drawingml/2006/main">
               <a:ext uri="{FF2B5EF4-FFF2-40B4-BE49-F238E27FC236}">
-                <a16:creationId xmlns:a16="http://schemas.microsoft.com/office/drawing/2014/main" id="{7B65B4B7-F9C4-490D-885A-C340703C29B1}"/>
+                <a16:creationId xmlns:a16="http://schemas.microsoft.com/office/drawing/2014/main" id="{CDDC9FFC-9959-4C11-ADF1-C6915F26F8E2}"/>
               </a:ext>
             </a:extLst>
           </p:cNvPr>
@@ -10394,7 +10391,7 @@
                 <a:ea typeface="Arial"/>
                 <a:cs typeface="Arial"/>
               </a:rPr>
-              <a:t>Each phase creates the controlled inputs required by the next. The objective is a faster close and better decisions—not a larger tool stack.</a:t>
+              <a:t>Days 1–30 establish common controls. Leadership then chooses how much connector and platform operation to buy versus own.</a:t>
             </a:r>
           </a:p>
         </p:txBody>
@@ -10404,7 +10401,7 @@
           <p:cNvPr id="5" name="s9-phase-0">
             <a:extLst xmlns:a="http://schemas.openxmlformats.org/drawingml/2006/main">
               <a:ext uri="{FF2B5EF4-FFF2-40B4-BE49-F238E27FC236}">
-                <a16:creationId xmlns:a16="http://schemas.microsoft.com/office/drawing/2014/main" id="{18D8701B-A94C-4AAC-9401-EBFBB2DDF243}"/>
+                <a16:creationId xmlns:a16="http://schemas.microsoft.com/office/drawing/2014/main" id="{A2090CB9-CB63-4A74-95FF-6A9B4DC6769A}"/>
               </a:ext>
             </a:extLst>
           </p:cNvPr>
@@ -10437,7 +10434,7 @@
           <p:cNvPr id="6" name="s9-time-0">
             <a:extLst xmlns:a="http://schemas.openxmlformats.org/drawingml/2006/main">
               <a:ext uri="{FF2B5EF4-FFF2-40B4-BE49-F238E27FC236}">
-                <a16:creationId xmlns:a16="http://schemas.microsoft.com/office/drawing/2014/main" id="{FA5964A6-CD9E-49C2-B171-9DF8A36D9E21}"/>
+                <a16:creationId xmlns:a16="http://schemas.microsoft.com/office/drawing/2014/main" id="{588E101F-58F1-46BE-8EBC-58D0B99A4BF2}"/>
               </a:ext>
             </a:extLst>
           </p:cNvPr>
@@ -10493,7 +10490,7 @@
           <p:cNvPr id="7" name="s9-title-0">
             <a:extLst xmlns:a="http://schemas.openxmlformats.org/drawingml/2006/main">
               <a:ext uri="{FF2B5EF4-FFF2-40B4-BE49-F238E27FC236}">
-                <a16:creationId xmlns:a16="http://schemas.microsoft.com/office/drawing/2014/main" id="{23EF11A4-6AD5-48BE-9999-34FCE94378E6}"/>
+                <a16:creationId xmlns:a16="http://schemas.microsoft.com/office/drawing/2014/main" id="{B89D79DD-4D59-4C0D-A988-95136AB0C618}"/>
               </a:ext>
             </a:extLst>
           </p:cNvPr>
@@ -10539,7 +10536,7 @@
                 <a:ea typeface="Arial"/>
                 <a:cs typeface="Arial"/>
               </a:rPr>
-              <a:t>Control the sources</a:t>
+              <a:t>Common foundation</a:t>
             </a:r>
           </a:p>
         </p:txBody>
@@ -10549,7 +10546,7 @@
           <p:cNvPr id="8" name="s9-body-0">
             <a:extLst xmlns:a="http://schemas.openxmlformats.org/drawingml/2006/main">
               <a:ext uri="{FF2B5EF4-FFF2-40B4-BE49-F238E27FC236}">
-                <a16:creationId xmlns:a16="http://schemas.microsoft.com/office/drawing/2014/main" id="{13A52EB9-97F3-4D86-9D58-8E819DF99BBF}"/>
+                <a16:creationId xmlns:a16="http://schemas.microsoft.com/office/drawing/2014/main" id="{C7E01113-3868-40D1-B61B-0F9C2E834FD9}"/>
               </a:ext>
             </a:extLst>
           </p:cNvPr>
@@ -10595,7 +10592,7 @@
                 <a:ea typeface="Arial"/>
                 <a:cs typeface="Arial"/>
               </a:rPr>
-              <a:t>Scheduled ingestion</a:t>
+              <a:t>Schema drift + raw replay</a:t>
             </a:r>
           </a:p>
           <a:p xmlns:a="http://schemas.openxmlformats.org/drawingml/2006/main">
@@ -10618,7 +10615,7 @@
                 <a:ea typeface="Arial"/>
                 <a:cs typeface="Arial"/>
               </a:rPr>
-              <a:t>Product/UOM/alias governance</a:t>
+              <a:t>Product/UOM/identity bridge</a:t>
             </a:r>
           </a:p>
           <a:p xmlns:a="http://schemas.openxmlformats.org/drawingml/2006/main">
@@ -10641,7 +10638,7 @@
                 <a:ea typeface="Arial"/>
                 <a:cs typeface="Arial"/>
               </a:rPr>
-              <a:t>Freshness, schema, amount tests</a:t>
+              <a:t>Dedup + amount gates</a:t>
             </a:r>
           </a:p>
         </p:txBody>
@@ -10651,7 +10648,7 @@
           <p:cNvPr id="9" name="s9-output-0">
             <a:extLst xmlns:a="http://schemas.openxmlformats.org/drawingml/2006/main">
               <a:ext uri="{FF2B5EF4-FFF2-40B4-BE49-F238E27FC236}">
-                <a16:creationId xmlns:a16="http://schemas.microsoft.com/office/drawing/2014/main" id="{E650AF52-E550-47F9-BCC4-5D0F87E5A5C0}"/>
+                <a16:creationId xmlns:a16="http://schemas.microsoft.com/office/drawing/2014/main" id="{0F6C6952-C226-4A0B-AC3E-1D6FE65DBFE3}"/>
               </a:ext>
             </a:extLst>
           </p:cNvPr>
@@ -10697,7 +10694,7 @@
                 <a:ea typeface="Arial"/>
                 <a:cs typeface="Arial"/>
               </a:rPr>
-              <a:t>Daily source-control dashboard</a:t>
+              <a:t>Same medallion model</a:t>
             </a:r>
           </a:p>
           <a:p xmlns:a="http://schemas.openxmlformats.org/drawingml/2006/main">
@@ -10720,7 +10717,7 @@
                 <a:ea typeface="Arial"/>
                 <a:cs typeface="Arial"/>
               </a:rPr>
-              <a:t>Owned exception queue</a:t>
+              <a:t>Same finance controls</a:t>
             </a:r>
           </a:p>
         </p:txBody>
@@ -10730,7 +10727,7 @@
           <p:cNvPr id="10" name="s9-phase-1">
             <a:extLst xmlns:a="http://schemas.openxmlformats.org/drawingml/2006/main">
               <a:ext uri="{FF2B5EF4-FFF2-40B4-BE49-F238E27FC236}">
-                <a16:creationId xmlns:a16="http://schemas.microsoft.com/office/drawing/2014/main" id="{2A8B0CAC-D42A-438F-96FA-56D5F1114A6A}"/>
+                <a16:creationId xmlns:a16="http://schemas.microsoft.com/office/drawing/2014/main" id="{FE86BBBF-0AE3-4AA4-994D-047DB5CE4658}"/>
               </a:ext>
             </a:extLst>
           </p:cNvPr>
@@ -10763,7 +10760,7 @@
           <p:cNvPr id="11" name="s9-time-1">
             <a:extLst xmlns:a="http://schemas.openxmlformats.org/drawingml/2006/main">
               <a:ext uri="{FF2B5EF4-FFF2-40B4-BE49-F238E27FC236}">
-                <a16:creationId xmlns:a16="http://schemas.microsoft.com/office/drawing/2014/main" id="{A036B72A-06CE-43E3-BA55-D942F2614577}"/>
+                <a16:creationId xmlns:a16="http://schemas.microsoft.com/office/drawing/2014/main" id="{E1636103-AC98-4680-8037-C2C67A3DA43A}"/>
               </a:ext>
             </a:extLst>
           </p:cNvPr>
@@ -10809,7 +10806,7 @@
                 <a:ea typeface="Arial"/>
                 <a:cs typeface="Arial"/>
               </a:rPr>
-              <a:t>Days 31–60</a:t>
+              <a:t>Days 31–90</a:t>
             </a:r>
           </a:p>
         </p:txBody>
@@ -10819,7 +10816,7 @@
           <p:cNvPr id="12" name="s9-title-1">
             <a:extLst xmlns:a="http://schemas.openxmlformats.org/drawingml/2006/main">
               <a:ext uri="{FF2B5EF4-FFF2-40B4-BE49-F238E27FC236}">
-                <a16:creationId xmlns:a16="http://schemas.microsoft.com/office/drawing/2014/main" id="{E3E177F5-B3CD-4CF5-9B1C-DE1DA1265F23}"/>
+                <a16:creationId xmlns:a16="http://schemas.microsoft.com/office/drawing/2014/main" id="{C8245F19-C2BC-4073-9B87-4186778705E7}"/>
               </a:ext>
             </a:extLst>
           </p:cNvPr>
@@ -10865,7 +10862,7 @@
                 <a:ea typeface="Arial"/>
                 <a:cs typeface="Arial"/>
               </a:rPr>
-              <a:t>Automate the management P&amp;L</a:t>
+              <a:t>Efficient / cost-aware</a:t>
             </a:r>
           </a:p>
         </p:txBody>
@@ -10875,7 +10872,7 @@
           <p:cNvPr id="13" name="s9-body-1">
             <a:extLst xmlns:a="http://schemas.openxmlformats.org/drawingml/2006/main">
               <a:ext uri="{FF2B5EF4-FFF2-40B4-BE49-F238E27FC236}">
-                <a16:creationId xmlns:a16="http://schemas.microsoft.com/office/drawing/2014/main" id="{A9108A31-9FA4-4CA6-AC95-25FF211A8EB0}"/>
+                <a16:creationId xmlns:a16="http://schemas.microsoft.com/office/drawing/2014/main" id="{A27FC6F6-6A48-4506-A9BB-08B27BA0CBD1}"/>
               </a:ext>
             </a:extLst>
           </p:cNvPr>
@@ -10921,7 +10918,7 @@
                 <a:ea typeface="Arial"/>
                 <a:cs typeface="Arial"/>
               </a:rPr>
-              <a:t>Marketplace, cost, inventory, ad, GL facts</a:t>
+              <a:t>Cloud Run + Workflows</a:t>
             </a:r>
           </a:p>
           <a:p xmlns:a="http://schemas.openxmlformats.org/drawingml/2006/main">
@@ -10944,7 +10941,7 @@
                 <a:ea typeface="Arial"/>
                 <a:cs typeface="Arial"/>
               </a:rPr>
-              <a:t>SKU CM drill-through</a:t>
+              <a:t>BigQuery + Dataform</a:t>
             </a:r>
           </a:p>
           <a:p xmlns:a="http://schemas.openxmlformats.org/drawingml/2006/main">
@@ -10967,7 +10964,7 @@
                 <a:ea typeface="Arial"/>
                 <a:cs typeface="Arial"/>
               </a:rPr>
-              <a:t>Amazon-to-QuickBooks reconciliation</a:t>
+              <a:t>Connected Sheets / Looker Studio</a:t>
             </a:r>
           </a:p>
         </p:txBody>
@@ -10977,7 +10974,7 @@
           <p:cNvPr id="14" name="s9-output-1">
             <a:extLst xmlns:a="http://schemas.openxmlformats.org/drawingml/2006/main">
               <a:ext uri="{FF2B5EF4-FFF2-40B4-BE49-F238E27FC236}">
-                <a16:creationId xmlns:a16="http://schemas.microsoft.com/office/drawing/2014/main" id="{C1629A2C-765C-404C-BDD1-EBBC24F788CA}"/>
+                <a16:creationId xmlns:a16="http://schemas.microsoft.com/office/drawing/2014/main" id="{6C287174-ACD8-4F5F-9FB9-EF93F609115A}"/>
               </a:ext>
             </a:extLst>
           </p:cNvPr>
@@ -11023,7 +11020,7 @@
                 <a:ea typeface="Arial"/>
                 <a:cs typeface="Arial"/>
               </a:rPr>
-              <a:t>Close-ready channel P&amp;L</a:t>
+              <a:t>Lower recurring software cost</a:t>
             </a:r>
           </a:p>
           <a:p xmlns:a="http://schemas.openxmlformats.org/drawingml/2006/main">
@@ -11046,7 +11043,7 @@
                 <a:ea typeface="Arial"/>
                 <a:cs typeface="Arial"/>
               </a:rPr>
-              <a:t>Connected Sheets outputs</a:t>
+              <a:t>Team owns connectors</a:t>
             </a:r>
           </a:p>
         </p:txBody>
@@ -11056,7 +11053,7 @@
           <p:cNvPr id="15" name="s9-phase-2">
             <a:extLst xmlns:a="http://schemas.openxmlformats.org/drawingml/2006/main">
               <a:ext uri="{FF2B5EF4-FFF2-40B4-BE49-F238E27FC236}">
-                <a16:creationId xmlns:a16="http://schemas.microsoft.com/office/drawing/2014/main" id="{A506477B-9B95-4FF1-A729-9A9890571B0A}"/>
+                <a16:creationId xmlns:a16="http://schemas.microsoft.com/office/drawing/2014/main" id="{CF7F9EB3-9015-4303-855F-DD3764FCCAEC}"/>
               </a:ext>
             </a:extLst>
           </p:cNvPr>
@@ -11089,7 +11086,7 @@
           <p:cNvPr id="16" name="s9-time-2">
             <a:extLst xmlns:a="http://schemas.openxmlformats.org/drawingml/2006/main">
               <a:ext uri="{FF2B5EF4-FFF2-40B4-BE49-F238E27FC236}">
-                <a16:creationId xmlns:a16="http://schemas.microsoft.com/office/drawing/2014/main" id="{A875ED48-1F9A-45A5-AF88-C4EEEBDDA206}"/>
+                <a16:creationId xmlns:a16="http://schemas.microsoft.com/office/drawing/2014/main" id="{2BEAB6B7-88BA-4246-846F-DE1516DE1C86}"/>
               </a:ext>
             </a:extLst>
           </p:cNvPr>
@@ -11135,7 +11132,7 @@
                 <a:ea typeface="Arial"/>
                 <a:cs typeface="Arial"/>
               </a:rPr>
-              <a:t>Days 61–90</a:t>
+              <a:t>Days 31–90</a:t>
             </a:r>
           </a:p>
         </p:txBody>
@@ -11145,7 +11142,7 @@
           <p:cNvPr id="17" name="s9-title-2">
             <a:extLst xmlns:a="http://schemas.openxmlformats.org/drawingml/2006/main">
               <a:ext uri="{FF2B5EF4-FFF2-40B4-BE49-F238E27FC236}">
-                <a16:creationId xmlns:a16="http://schemas.microsoft.com/office/drawing/2014/main" id="{4F0609C4-8F16-434B-AFD9-13013C9DD259}"/>
+                <a16:creationId xmlns:a16="http://schemas.microsoft.com/office/drawing/2014/main" id="{52D0951D-6F30-4A11-973C-B40BCE66AD78}"/>
               </a:ext>
             </a:extLst>
           </p:cNvPr>
@@ -11191,7 +11188,7 @@
                 <a:ea typeface="Arial"/>
                 <a:cs typeface="Arial"/>
               </a:rPr>
-              <a:t>Turn history into action</a:t>
+              <a:t>Premium / managed</a:t>
             </a:r>
           </a:p>
         </p:txBody>
@@ -11201,7 +11198,7 @@
           <p:cNvPr id="18" name="s9-body-2">
             <a:extLst xmlns:a="http://schemas.openxmlformats.org/drawingml/2006/main">
               <a:ext uri="{FF2B5EF4-FFF2-40B4-BE49-F238E27FC236}">
-                <a16:creationId xmlns:a16="http://schemas.microsoft.com/office/drawing/2014/main" id="{D1301218-3BDC-4F6E-9E6C-37F427DD2513}"/>
+                <a16:creationId xmlns:a16="http://schemas.microsoft.com/office/drawing/2014/main" id="{35B0A708-5CAF-4FA7-A7F9-C9DB6326566F}"/>
               </a:ext>
             </a:extLst>
           </p:cNvPr>
@@ -11247,7 +11244,7 @@
                 <a:ea typeface="Arial"/>
                 <a:cs typeface="Arial"/>
               </a:rPr>
-              <a:t>PO lifecycle + receipts</a:t>
+              <a:t>Managed Amazon + QB ELT</a:t>
             </a:r>
           </a:p>
           <a:p xmlns:a="http://schemas.openxmlformats.org/drawingml/2006/main">
@@ -11270,7 +11267,7 @@
                 <a:ea typeface="Arial"/>
                 <a:cs typeface="Arial"/>
               </a:rPr>
-              <a:t>Stockout/excess/cash alerts</a:t>
+              <a:t>BigQuery + dbt Cloud</a:t>
             </a:r>
           </a:p>
           <a:p xmlns:a="http://schemas.openxmlformats.org/drawingml/2006/main">
@@ -11293,7 +11290,7 @@
                 <a:ea typeface="Arial"/>
                 <a:cs typeface="Arial"/>
               </a:rPr>
-              <a:t>Campaign-SKU attribution + forecast</a:t>
+              <a:t>Looker + observability</a:t>
             </a:r>
           </a:p>
         </p:txBody>
@@ -11303,7 +11300,7 @@
           <p:cNvPr id="19" name="s9-output-2">
             <a:extLst xmlns:a="http://schemas.openxmlformats.org/drawingml/2006/main">
               <a:ext uri="{FF2B5EF4-FFF2-40B4-BE49-F238E27FC236}">
-                <a16:creationId xmlns:a16="http://schemas.microsoft.com/office/drawing/2014/main" id="{04D71B60-054F-46F0-80CB-993497819957}"/>
+                <a16:creationId xmlns:a16="http://schemas.microsoft.com/office/drawing/2014/main" id="{30AE05A9-EB76-4729-9E4B-21A5D4D9E01D}"/>
               </a:ext>
             </a:extLst>
           </p:cNvPr>
@@ -11349,7 +11346,7 @@
                 <a:ea typeface="Arial"/>
                 <a:cs typeface="Arial"/>
               </a:rPr>
-              <a:t>Inventory/action dashboard</a:t>
+              <a:t>Faster rollout + stronger ops</a:t>
             </a:r>
           </a:p>
           <a:p xmlns:a="http://schemas.openxmlformats.org/drawingml/2006/main">
@@ -11372,7 +11369,7 @@
                 <a:ea typeface="Arial"/>
                 <a:cs typeface="Arial"/>
               </a:rPr>
-              <a:t>13-week cash/inventory outlook</a:t>
+              <a:t>Higher subscription cost</a:t>
             </a:r>
           </a:p>
         </p:txBody>
@@ -11380,7 +11377,7 @@
     </p:spTree>
     <p:extLst>
       <p:ext uri="{BB962C8B-B14F-4D97-AF65-F5344CB8AC3E}">
-        <p14:creationId xmlns:p14="http://schemas.microsoft.com/office/powerpoint/2010/main" val="1088366654"/>
+        <p14:creationId xmlns:p14="http://schemas.microsoft.com/office/powerpoint/2010/main" val="1393451286"/>
       </p:ext>
     </p:extLst>
   </p:cSld>

</xml_diff>

<commit_message>
Simplify assessment narrative and add review visuals
</commit_message>
<xml_diff>
--- a/deliverables/Amazon_Q2_2026_Leadership_Presentation.pptx
+++ b/deliverables/Amazon_Q2_2026_Leadership_Presentation.pptx
@@ -2,22 +2,22 @@
 <file path=ppt/presentation.xml><?xml version="1.0" encoding="utf-8"?>
 <p:presentation xmlns:p="http://schemas.openxmlformats.org/presentationml/2006/main">
   <p:sldMasterIdLst>
-    <p:sldMasterId xmlns:r="http://schemas.openxmlformats.org/officeDocument/2006/relationships" id="2147483648" r:id="Rf3fa090a7c07443b"/>
+    <p:sldMasterId xmlns:r="http://schemas.openxmlformats.org/officeDocument/2006/relationships" id="2147483648" r:id="R000d33a8c46b4e7a"/>
   </p:sldMasterIdLst>
   <p:notesMasterIdLst>
-    <p:notesMasterId xmlns:r="http://schemas.openxmlformats.org/officeDocument/2006/relationships" r:id="Rc6a8e1b0c1904ef1"/>
+    <p:notesMasterId xmlns:r="http://schemas.openxmlformats.org/officeDocument/2006/relationships" r:id="R2e37060f78144ef5"/>
   </p:notesMasterIdLst>
   <p:sldIdLst>
-    <p:sldId xmlns:r="http://schemas.openxmlformats.org/officeDocument/2006/relationships" id="256" r:id="Re4adbabdf9824d8e"/>
-    <p:sldId xmlns:r="http://schemas.openxmlformats.org/officeDocument/2006/relationships" id="257" r:id="Rdfbe48eeac784ef9"/>
-    <p:sldId xmlns:r="http://schemas.openxmlformats.org/officeDocument/2006/relationships" id="258" r:id="R0a4ba87c39aa4c0f"/>
-    <p:sldId xmlns:r="http://schemas.openxmlformats.org/officeDocument/2006/relationships" id="259" r:id="Rcf83e56cf2ef47ff"/>
-    <p:sldId xmlns:r="http://schemas.openxmlformats.org/officeDocument/2006/relationships" id="260" r:id="R0510e3bbbcd1423c"/>
-    <p:sldId xmlns:r="http://schemas.openxmlformats.org/officeDocument/2006/relationships" id="261" r:id="Re10c068907c64850"/>
-    <p:sldId xmlns:r="http://schemas.openxmlformats.org/officeDocument/2006/relationships" id="262" r:id="Rccca3cce016247ac"/>
-    <p:sldId xmlns:r="http://schemas.openxmlformats.org/officeDocument/2006/relationships" id="263" r:id="R2757c3f934dc4a2e"/>
-    <p:sldId xmlns:r="http://schemas.openxmlformats.org/officeDocument/2006/relationships" id="264" r:id="Re21f9c3cf0054983"/>
-    <p:sldId xmlns:r="http://schemas.openxmlformats.org/officeDocument/2006/relationships" id="265" r:id="R6fd247134f0e429c"/>
+    <p:sldId xmlns:r="http://schemas.openxmlformats.org/officeDocument/2006/relationships" id="256" r:id="R6be0aee02adf41fc"/>
+    <p:sldId xmlns:r="http://schemas.openxmlformats.org/officeDocument/2006/relationships" id="257" r:id="Rb1dce1597c264c7a"/>
+    <p:sldId xmlns:r="http://schemas.openxmlformats.org/officeDocument/2006/relationships" id="258" r:id="Rfe27d1b911be4571"/>
+    <p:sldId xmlns:r="http://schemas.openxmlformats.org/officeDocument/2006/relationships" id="259" r:id="R6c3a4c91b12d4327"/>
+    <p:sldId xmlns:r="http://schemas.openxmlformats.org/officeDocument/2006/relationships" id="260" r:id="Ra01e6eb7cc164f92"/>
+    <p:sldId xmlns:r="http://schemas.openxmlformats.org/officeDocument/2006/relationships" id="261" r:id="R5d69351410554c73"/>
+    <p:sldId xmlns:r="http://schemas.openxmlformats.org/officeDocument/2006/relationships" id="262" r:id="Rd16ad4e6eb6a4c02"/>
+    <p:sldId xmlns:r="http://schemas.openxmlformats.org/officeDocument/2006/relationships" id="263" r:id="Race9d69108f1487c"/>
+    <p:sldId xmlns:r="http://schemas.openxmlformats.org/officeDocument/2006/relationships" id="264" r:id="Rd405850ae0cf434d"/>
+    <p:sldId xmlns:r="http://schemas.openxmlformats.org/officeDocument/2006/relationships" id="265" r:id="R5529a233bbe14f7b"/>
   </p:sldIdLst>
   <p:sldSz cx="12192000" cy="6858000"/>
   <p:notesSz cx="6858000" cy="9144000"/>
@@ -451,7 +451,7 @@
           <a:lstStyle xmlns:a="http://schemas.openxmlformats.org/drawingml/2006/main"/>
           <a:p xmlns:a="http://schemas.openxmlformats.org/drawingml/2006/main">
             <a:r>
-              <a:t>Set the decision frame: the sales engine is contribution-positive, but the current spend and inventory layer destroys value. Preview that the analysis separates attributable economics from unallocated platform overhead.</a:t>
+              <a:t>Start with the main result: product contribution margin is positive, but the platform costs reported without SKU keys make the quarter negative. Explain that the analysis does not force those costs across products.</a:t>
             </a:r>
           </a:p>
           <a:p xmlns:a="http://schemas.openxmlformats.org/drawingml/2006/main">
@@ -636,7 +636,7 @@
           <a:lstStyle xmlns:a="http://schemas.openxmlformats.org/drawingml/2006/main"/>
           <a:p xmlns:a="http://schemas.openxmlformats.org/drawingml/2006/main">
             <a:r>
-              <a:t>Spend about two minutes here. Define CM1, explain why unallocated charges are kept below it, and state that the final negative result is a management signal—not a forced SKU allocation.</a:t>
+              <a:t>Define contribution margin, explain why unallocated charges are shown separately, and state that the final negative result is a management signal—not a forced SKU allocation.</a:t>
             </a:r>
           </a:p>
           <a:p xmlns:a="http://schemas.openxmlformats.org/drawingml/2006/main">
@@ -1016,7 +1016,7 @@
           <a:lstStyle xmlns:a="http://schemas.openxmlformats.org/drawingml/2006/main"/>
           <a:p xmlns:a="http://schemas.openxmlformats.org/drawingml/2006/main">
             <a:r>
-              <a:t>Recommend an action split: protect availability and efficient acquisition on the top contributors; separately validate the two missing-cost SKUs before pricing or assortment decisions. Mention that PH-BED-MED-GRY has known cost and only 6.1% CM1.</a:t>
+              <a:t>Recommend an action split: protect availability and efficient acquisition on the top contributors; separately validate the two missing-cost SKUs before pricing or assortment decisions. Mention that PH-BED-MED-GRY has known cost and only a 6.1% margin.</a:t>
             </a:r>
           </a:p>
           <a:p xmlns:a="http://schemas.openxmlformats.org/drawingml/2006/main">
@@ -1414,7 +1414,7 @@
   </p:cSld>
   <p:clrMap bg1="lt1" tx1="dk1" bg2="lt2" tx2="dk2" accent1="accent1" accent2="accent2" accent3="accent3" accent4="accent4" accent5="accent5" accent6="accent6" hlink="hlink" folHlink="folHlink"/>
   <p:sldLayoutIdLst>
-    <p:sldLayoutId xmlns:r="http://schemas.openxmlformats.org/officeDocument/2006/relationships" id="2147483649" r:id="Red3ca2f5289d4143"/>
+    <p:sldLayoutId xmlns:r="http://schemas.openxmlformats.org/officeDocument/2006/relationships" id="2147483649" r:id="R846141729427484d"/>
   </p:sldLayoutIdLst>
   <p:txStyles>
     <p:titleStyle>
@@ -2134,7 +2134,7 @@
           <c:idx val="0"/>
           <c:order val="0"/>
           <c:tx>
-            <c:v>CM1</c:v>
+            <c:v>Contribution margin</c:v>
           </c:tx>
           <c:spPr>
             <a:solidFill xmlns:a="http://schemas.openxmlformats.org/drawingml/2006/main">
@@ -2392,7 +2392,7 @@
             <c:strLit>
               <c:ptCount val="6"/>
               <c:pt idx="0">
-                <c:v>CM1</c:v>
+                <c:v>Contribution</c:v>
               </c:pt>
               <c:pt idx="1">
                 <c:v>Advertising</c:v>
@@ -2584,7 +2584,7 @@
           <p:cNvPr id="9" name="cover-eyebrow">
             <a:extLst xmlns:a="http://schemas.openxmlformats.org/drawingml/2006/main">
               <a:ext uri="{FF2B5EF4-FFF2-40B4-BE49-F238E27FC236}">
-                <a16:creationId xmlns:a16="http://schemas.microsoft.com/office/drawing/2014/main" id="{AEECFC06-FD4A-4EEB-8173-29648D4854F5}"/>
+                <a16:creationId xmlns:a16="http://schemas.microsoft.com/office/drawing/2014/main" id="{F1C2A517-9904-421D-8E66-8606AC637A3C}"/>
               </a:ext>
             </a:extLst>
           </p:cNvPr>
@@ -2640,7 +2640,7 @@
           <p:cNvPr id="2" name="cover-title">
             <a:extLst xmlns:a="http://schemas.openxmlformats.org/drawingml/2006/main">
               <a:ext uri="{FF2B5EF4-FFF2-40B4-BE49-F238E27FC236}">
-                <a16:creationId xmlns:a16="http://schemas.microsoft.com/office/drawing/2014/main" id="{9D1A01A9-E15E-45C0-88BA-7E74B0D7DE5E}"/>
+                <a16:creationId xmlns:a16="http://schemas.microsoft.com/office/drawing/2014/main" id="{3600AAAA-18E4-4530-9D0D-9620F5525859}"/>
               </a:ext>
             </a:extLst>
           </p:cNvPr>
@@ -2696,7 +2696,7 @@
           <p:cNvPr id="3" name="cover-subtitle">
             <a:extLst xmlns:a="http://schemas.openxmlformats.org/drawingml/2006/main">
               <a:ext uri="{FF2B5EF4-FFF2-40B4-BE49-F238E27FC236}">
-                <a16:creationId xmlns:a16="http://schemas.microsoft.com/office/drawing/2014/main" id="{8962E0A2-CD03-4368-BDF8-F8848D36CCF2}"/>
+                <a16:creationId xmlns:a16="http://schemas.microsoft.com/office/drawing/2014/main" id="{17000180-C834-4E3C-B6FB-B5D8BD425959}"/>
               </a:ext>
             </a:extLst>
           </p:cNvPr>
@@ -2752,7 +2752,7 @@
           <p:cNvPr id="4" name="cover-field">
             <a:extLst xmlns:a="http://schemas.openxmlformats.org/drawingml/2006/main">
               <a:ext uri="{FF2B5EF4-FFF2-40B4-BE49-F238E27FC236}">
-                <a16:creationId xmlns:a16="http://schemas.microsoft.com/office/drawing/2014/main" id="{69AE3BEB-1CFD-4FFF-AF95-E37EE7502F36}"/>
+                <a16:creationId xmlns:a16="http://schemas.microsoft.com/office/drawing/2014/main" id="{9BA6C61A-DAE5-48C1-B72F-174034C56998}"/>
               </a:ext>
             </a:extLst>
           </p:cNvPr>
@@ -2785,7 +2785,7 @@
           <p:cNvPr id="5" name="cover-field-value">
             <a:extLst xmlns:a="http://schemas.openxmlformats.org/drawingml/2006/main">
               <a:ext uri="{FF2B5EF4-FFF2-40B4-BE49-F238E27FC236}">
-                <a16:creationId xmlns:a16="http://schemas.microsoft.com/office/drawing/2014/main" id="{1647F242-8F51-4AC0-BA05-4C265C31897D}"/>
+                <a16:creationId xmlns:a16="http://schemas.microsoft.com/office/drawing/2014/main" id="{E007C754-76F5-4A5E-880E-C7015A63773B}"/>
               </a:ext>
             </a:extLst>
           </p:cNvPr>
@@ -2841,7 +2841,7 @@
           <p:cNvPr id="6" name="cover-field-label">
             <a:extLst xmlns:a="http://schemas.openxmlformats.org/drawingml/2006/main">
               <a:ext uri="{FF2B5EF4-FFF2-40B4-BE49-F238E27FC236}">
-                <a16:creationId xmlns:a16="http://schemas.microsoft.com/office/drawing/2014/main" id="{62DB7AB7-E13B-4730-86D5-3774766359C1}"/>
+                <a16:creationId xmlns:a16="http://schemas.microsoft.com/office/drawing/2014/main" id="{A492E893-0F17-4DBC-86E6-57BE1E867715}"/>
               </a:ext>
             </a:extLst>
           </p:cNvPr>
@@ -2887,7 +2887,7 @@
                 <a:ea typeface="Arial"/>
                 <a:cs typeface="Arial"/>
               </a:rPr>
-              <a:t>SKU-attributable CM1</a:t>
+              <a:t>Contribution margin</a:t>
             </a:r>
           </a:p>
         </p:txBody>
@@ -2897,7 +2897,7 @@
           <p:cNvPr id="7" name="cover-field-note">
             <a:extLst xmlns:a="http://schemas.openxmlformats.org/drawingml/2006/main">
               <a:ext uri="{FF2B5EF4-FFF2-40B4-BE49-F238E27FC236}">
-                <a16:creationId xmlns:a16="http://schemas.microsoft.com/office/drawing/2014/main" id="{7B01E4F9-97A9-4616-B3ED-395B42AA9619}"/>
+                <a16:creationId xmlns:a16="http://schemas.microsoft.com/office/drawing/2014/main" id="{AB50ADD1-AEAD-4CDC-9F74-B79C5AD5897E}"/>
               </a:ext>
             </a:extLst>
           </p:cNvPr>
@@ -2953,7 +2953,7 @@
           <p:cNvPr id="8" name="cover-footer">
             <a:extLst xmlns:a="http://schemas.openxmlformats.org/drawingml/2006/main">
               <a:ext uri="{FF2B5EF4-FFF2-40B4-BE49-F238E27FC236}">
-                <a16:creationId xmlns:a16="http://schemas.microsoft.com/office/drawing/2014/main" id="{D9EE83D4-1035-4D12-802D-664A988F0E4F}"/>
+                <a16:creationId xmlns:a16="http://schemas.microsoft.com/office/drawing/2014/main" id="{B5E2F4F7-153F-4DE4-BAB7-36023B385291}"/>
               </a:ext>
             </a:extLst>
           </p:cNvPr>
@@ -3007,7 +3007,7 @@
     </p:spTree>
     <p:extLst>
       <p:ext uri="{BB962C8B-B14F-4D97-AF65-F5344CB8AC3E}">
-        <p14:creationId xmlns:p14="http://schemas.microsoft.com/office/powerpoint/2010/main" val="733146647"/>
+        <p14:creationId xmlns:p14="http://schemas.microsoft.com/office/powerpoint/2010/main" val="275315359"/>
       </p:ext>
     </p:extLst>
   </p:cSld>
@@ -3038,7 +3038,7 @@
           <p:cNvPr id="18" name="eyebrow-10">
             <a:extLst xmlns:a="http://schemas.openxmlformats.org/drawingml/2006/main">
               <a:ext uri="{FF2B5EF4-FFF2-40B4-BE49-F238E27FC236}">
-                <a16:creationId xmlns:a16="http://schemas.microsoft.com/office/drawing/2014/main" id="{F80C0FF9-049E-4076-A4AD-660DD90417B5}"/>
+                <a16:creationId xmlns:a16="http://schemas.microsoft.com/office/drawing/2014/main" id="{DA160A4A-907B-4B46-8C37-A55427DAC1E8}"/>
               </a:ext>
             </a:extLst>
           </p:cNvPr>
@@ -3094,7 +3094,7 @@
           <p:cNvPr id="2" name="title-10">
             <a:extLst xmlns:a="http://schemas.openxmlformats.org/drawingml/2006/main">
               <a:ext uri="{FF2B5EF4-FFF2-40B4-BE49-F238E27FC236}">
-                <a16:creationId xmlns:a16="http://schemas.microsoft.com/office/drawing/2014/main" id="{F6CEF9A9-A270-4759-BEBE-9972A738A09F}"/>
+                <a16:creationId xmlns:a16="http://schemas.microsoft.com/office/drawing/2014/main" id="{C05FAC72-9AF5-4673-A1FD-0AEBF044080C}"/>
               </a:ext>
             </a:extLst>
           </p:cNvPr>
@@ -3140,7 +3140,7 @@
                 <a:ea typeface="Arial"/>
                 <a:cs typeface="Arial"/>
               </a:rPr>
-              <a:t>The opportunity is a controlled finance operating system—not another spreadsheet</a:t>
+              <a:t>Leadership can act now while closing three data gaps</a:t>
             </a:r>
           </a:p>
         </p:txBody>
@@ -3150,7 +3150,7 @@
           <p:cNvPr id="3" name="footer-10">
             <a:extLst xmlns:a="http://schemas.openxmlformats.org/drawingml/2006/main">
               <a:ext uri="{FF2B5EF4-FFF2-40B4-BE49-F238E27FC236}">
-                <a16:creationId xmlns:a16="http://schemas.microsoft.com/office/drawing/2014/main" id="{B4143414-51A6-4F44-A8FD-C381C8E766EB}"/>
+                <a16:creationId xmlns:a16="http://schemas.microsoft.com/office/drawing/2014/main" id="{F042E2F8-9B5D-4898-AAF5-EAA486B38C7D}"/>
               </a:ext>
             </a:extLst>
           </p:cNvPr>
@@ -3206,7 +3206,7 @@
           <p:cNvPr id="4" name="s10-lead">
             <a:extLst xmlns:a="http://schemas.openxmlformats.org/drawingml/2006/main">
               <a:ext uri="{FF2B5EF4-FFF2-40B4-BE49-F238E27FC236}">
-                <a16:creationId xmlns:a16="http://schemas.microsoft.com/office/drawing/2014/main" id="{BECF3906-D619-4B20-B06B-BA466A725BF8}"/>
+                <a16:creationId xmlns:a16="http://schemas.microsoft.com/office/drawing/2014/main" id="{7E5C2F7A-8D50-4B68-9CA0-1F5D558FCE75}"/>
               </a:ext>
             </a:extLst>
           </p:cNvPr>
@@ -3262,7 +3262,7 @@
           <p:cNvPr id="5" name="s10-num-0">
             <a:extLst xmlns:a="http://schemas.openxmlformats.org/drawingml/2006/main">
               <a:ext uri="{FF2B5EF4-FFF2-40B4-BE49-F238E27FC236}">
-                <a16:creationId xmlns:a16="http://schemas.microsoft.com/office/drawing/2014/main" id="{8241941C-30B4-40C4-86BE-73C1BD2316DF}"/>
+                <a16:creationId xmlns:a16="http://schemas.microsoft.com/office/drawing/2014/main" id="{DD6D571F-167F-48CC-ADB6-387BF0FBA0C0}"/>
               </a:ext>
             </a:extLst>
           </p:cNvPr>
@@ -3318,7 +3318,7 @@
           <p:cNvPr id="6" name="s10-title-0">
             <a:extLst xmlns:a="http://schemas.openxmlformats.org/drawingml/2006/main">
               <a:ext uri="{FF2B5EF4-FFF2-40B4-BE49-F238E27FC236}">
-                <a16:creationId xmlns:a16="http://schemas.microsoft.com/office/drawing/2014/main" id="{BFA888A7-515E-4408-A759-6AAB118A3C70}"/>
+                <a16:creationId xmlns:a16="http://schemas.microsoft.com/office/drawing/2014/main" id="{A39693FB-8529-480A-8559-AC338AE9243E}"/>
               </a:ext>
             </a:extLst>
           </p:cNvPr>
@@ -3364,7 +3364,7 @@
                 <a:ea typeface="Arial"/>
                 <a:cs typeface="Arial"/>
               </a:rPr>
-              <a:t>Protect the profit pool</a:t>
+              <a:t>Protect proven demand</a:t>
             </a:r>
           </a:p>
         </p:txBody>
@@ -3374,7 +3374,7 @@
           <p:cNvPr id="7" name="s10-body-0">
             <a:extLst xmlns:a="http://schemas.openxmlformats.org/drawingml/2006/main">
               <a:ext uri="{FF2B5EF4-FFF2-40B4-BE49-F238E27FC236}">
-                <a16:creationId xmlns:a16="http://schemas.microsoft.com/office/drawing/2014/main" id="{D9AED9DB-228C-417D-9798-47B1617EF3B7}"/>
+                <a16:creationId xmlns:a16="http://schemas.microsoft.com/office/drawing/2014/main" id="{D5730904-B396-40F3-8E1A-5CC77257E556}"/>
               </a:ext>
             </a:extLst>
           </p:cNvPr>
@@ -3430,7 +3430,7 @@
           <p:cNvPr id="8" name="s10-rule-0">
             <a:extLst xmlns:a="http://schemas.openxmlformats.org/drawingml/2006/main">
               <a:ext uri="{FF2B5EF4-FFF2-40B4-BE49-F238E27FC236}">
-                <a16:creationId xmlns:a16="http://schemas.microsoft.com/office/drawing/2014/main" id="{A4E557E7-AA13-4143-9583-6DA0F9503306}"/>
+                <a16:creationId xmlns:a16="http://schemas.microsoft.com/office/drawing/2014/main" id="{2902EDDA-7FE0-484A-BCEF-7466D5A30B1F}"/>
               </a:ext>
             </a:extLst>
           </p:cNvPr>
@@ -3461,7 +3461,7 @@
           <p:cNvPr id="9" name="s10-num-1">
             <a:extLst xmlns:a="http://schemas.openxmlformats.org/drawingml/2006/main">
               <a:ext uri="{FF2B5EF4-FFF2-40B4-BE49-F238E27FC236}">
-                <a16:creationId xmlns:a16="http://schemas.microsoft.com/office/drawing/2014/main" id="{81E3A8D7-7E46-493C-9EDF-91DC3444D62D}"/>
+                <a16:creationId xmlns:a16="http://schemas.microsoft.com/office/drawing/2014/main" id="{F154016A-0002-4257-B814-85ED097BD295}"/>
               </a:ext>
             </a:extLst>
           </p:cNvPr>
@@ -3517,7 +3517,7 @@
           <p:cNvPr id="10" name="s10-title-1">
             <a:extLst xmlns:a="http://schemas.openxmlformats.org/drawingml/2006/main">
               <a:ext uri="{FF2B5EF4-FFF2-40B4-BE49-F238E27FC236}">
-                <a16:creationId xmlns:a16="http://schemas.microsoft.com/office/drawing/2014/main" id="{37D6B5AB-F998-4F14-83E7-44CC84F9C12C}"/>
+                <a16:creationId xmlns:a16="http://schemas.microsoft.com/office/drawing/2014/main" id="{35E8F168-36D5-4813-93FB-CE924E8BEBA6}"/>
               </a:ext>
             </a:extLst>
           </p:cNvPr>
@@ -3573,7 +3573,7 @@
           <p:cNvPr id="11" name="s10-body-1">
             <a:extLst xmlns:a="http://schemas.openxmlformats.org/drawingml/2006/main">
               <a:ext uri="{FF2B5EF4-FFF2-40B4-BE49-F238E27FC236}">
-                <a16:creationId xmlns:a16="http://schemas.microsoft.com/office/drawing/2014/main" id="{D40999FD-0B7D-4138-932D-9D5307C6AFC3}"/>
+                <a16:creationId xmlns:a16="http://schemas.microsoft.com/office/drawing/2014/main" id="{CAA3706A-1B05-49E6-9FE8-390B3DAEA9A2}"/>
               </a:ext>
             </a:extLst>
           </p:cNvPr>
@@ -3629,7 +3629,7 @@
           <p:cNvPr id="12" name="s10-rule-1">
             <a:extLst xmlns:a="http://schemas.openxmlformats.org/drawingml/2006/main">
               <a:ext uri="{FF2B5EF4-FFF2-40B4-BE49-F238E27FC236}">
-                <a16:creationId xmlns:a16="http://schemas.microsoft.com/office/drawing/2014/main" id="{97ACF58F-E516-4C93-A6E1-26321FBEF6CA}"/>
+                <a16:creationId xmlns:a16="http://schemas.microsoft.com/office/drawing/2014/main" id="{C28771B3-EA34-4D08-B574-781F5D433F51}"/>
               </a:ext>
             </a:extLst>
           </p:cNvPr>
@@ -3660,7 +3660,7 @@
           <p:cNvPr id="13" name="s10-num-2">
             <a:extLst xmlns:a="http://schemas.openxmlformats.org/drawingml/2006/main">
               <a:ext uri="{FF2B5EF4-FFF2-40B4-BE49-F238E27FC236}">
-                <a16:creationId xmlns:a16="http://schemas.microsoft.com/office/drawing/2014/main" id="{E0359092-1F84-464F-9499-1F2D00A97405}"/>
+                <a16:creationId xmlns:a16="http://schemas.microsoft.com/office/drawing/2014/main" id="{7CB6735D-0AC4-444F-BCFD-19AF8138776A}"/>
               </a:ext>
             </a:extLst>
           </p:cNvPr>
@@ -3716,7 +3716,7 @@
           <p:cNvPr id="14" name="s10-title-2">
             <a:extLst xmlns:a="http://schemas.openxmlformats.org/drawingml/2006/main">
               <a:ext uri="{FF2B5EF4-FFF2-40B4-BE49-F238E27FC236}">
-                <a16:creationId xmlns:a16="http://schemas.microsoft.com/office/drawing/2014/main" id="{307FDBD1-44E0-49C6-8A39-36794AE81417}"/>
+                <a16:creationId xmlns:a16="http://schemas.microsoft.com/office/drawing/2014/main" id="{30C4E55E-7D60-4D80-975A-47715E96B61A}"/>
               </a:ext>
             </a:extLst>
           </p:cNvPr>
@@ -3772,7 +3772,7 @@
           <p:cNvPr id="15" name="s10-body-2">
             <a:extLst xmlns:a="http://schemas.openxmlformats.org/drawingml/2006/main">
               <a:ext uri="{FF2B5EF4-FFF2-40B4-BE49-F238E27FC236}">
-                <a16:creationId xmlns:a16="http://schemas.microsoft.com/office/drawing/2014/main" id="{77C39345-0A4B-45BD-8EA5-9C320158E505}"/>
+                <a16:creationId xmlns:a16="http://schemas.microsoft.com/office/drawing/2014/main" id="{37C5A83F-962E-49FC-8CBA-731B1FBD53A1}"/>
               </a:ext>
             </a:extLst>
           </p:cNvPr>
@@ -3828,7 +3828,7 @@
           <p:cNvPr id="16" name="s10-final">
             <a:extLst xmlns:a="http://schemas.openxmlformats.org/drawingml/2006/main">
               <a:ext uri="{FF2B5EF4-FFF2-40B4-BE49-F238E27FC236}">
-                <a16:creationId xmlns:a16="http://schemas.microsoft.com/office/drawing/2014/main" id="{96E1763F-1B51-4347-BDBE-21C472F9BD17}"/>
+                <a16:creationId xmlns:a16="http://schemas.microsoft.com/office/drawing/2014/main" id="{7D7B2648-2177-4A59-B12B-3827D38D3DD2}"/>
               </a:ext>
             </a:extLst>
           </p:cNvPr>
@@ -3859,7 +3859,7 @@
           <p:cNvPr id="17" name="s10-final-text">
             <a:extLst xmlns:a="http://schemas.openxmlformats.org/drawingml/2006/main">
               <a:ext uri="{FF2B5EF4-FFF2-40B4-BE49-F238E27FC236}">
-                <a16:creationId xmlns:a16="http://schemas.microsoft.com/office/drawing/2014/main" id="{22BCCD50-CC04-4B55-9146-0D222A08CCB5}"/>
+                <a16:creationId xmlns:a16="http://schemas.microsoft.com/office/drawing/2014/main" id="{CF68C43E-050F-4DB4-8DBE-16C5177406D2}"/>
               </a:ext>
             </a:extLst>
           </p:cNvPr>
@@ -3913,7 +3913,7 @@
     </p:spTree>
     <p:extLst>
       <p:ext uri="{BB962C8B-B14F-4D97-AF65-F5344CB8AC3E}">
-        <p14:creationId xmlns:p14="http://schemas.microsoft.com/office/powerpoint/2010/main" val="750627781"/>
+        <p14:creationId xmlns:p14="http://schemas.microsoft.com/office/powerpoint/2010/main" val="1379500171"/>
       </p:ext>
     </p:extLst>
   </p:cSld>
@@ -3944,7 +3944,7 @@
           <p:cNvPr id="17" name="eyebrow-2">
             <a:extLst xmlns:a="http://schemas.openxmlformats.org/drawingml/2006/main">
               <a:ext uri="{FF2B5EF4-FFF2-40B4-BE49-F238E27FC236}">
-                <a16:creationId xmlns:a16="http://schemas.microsoft.com/office/drawing/2014/main" id="{42977B12-7491-4661-ADF8-5E948E9FCEFC}"/>
+                <a16:creationId xmlns:a16="http://schemas.microsoft.com/office/drawing/2014/main" id="{B1EFFD2B-19EF-48F2-85CE-FC8A2C15858C}"/>
               </a:ext>
             </a:extLst>
           </p:cNvPr>
@@ -4000,7 +4000,7 @@
           <p:cNvPr id="2" name="title-2">
             <a:extLst xmlns:a="http://schemas.openxmlformats.org/drawingml/2006/main">
               <a:ext uri="{FF2B5EF4-FFF2-40B4-BE49-F238E27FC236}">
-                <a16:creationId xmlns:a16="http://schemas.microsoft.com/office/drawing/2014/main" id="{3D81BE8F-A7E6-4DFD-81D4-860037E17D08}"/>
+                <a16:creationId xmlns:a16="http://schemas.microsoft.com/office/drawing/2014/main" id="{8F3DCE6E-D6A4-40F5-BEB2-58E3356D813B}"/>
               </a:ext>
             </a:extLst>
           </p:cNvPr>
@@ -4046,7 +4046,7 @@
                 <a:ea typeface="Arial"/>
                 <a:cs typeface="Arial"/>
               </a:rPr>
-              <a:t>The core business produced 38.7% CM1, but platform overhead turned the quarter negative</a:t>
+              <a:t>Contribution margin was 38.7%; unallocated platform costs made the quarter negative</a:t>
             </a:r>
           </a:p>
         </p:txBody>
@@ -4056,7 +4056,7 @@
           <p:cNvPr id="3" name="footer-2">
             <a:extLst xmlns:a="http://schemas.openxmlformats.org/drawingml/2006/main">
               <a:ext uri="{FF2B5EF4-FFF2-40B4-BE49-F238E27FC236}">
-                <a16:creationId xmlns:a16="http://schemas.microsoft.com/office/drawing/2014/main" id="{85955E27-35EC-49F9-A449-93BF333397E8}"/>
+                <a16:creationId xmlns:a16="http://schemas.microsoft.com/office/drawing/2014/main" id="{0DFD388A-8C89-41C2-BC1C-B1F03F9240C7}"/>
               </a:ext>
             </a:extLst>
           </p:cNvPr>
@@ -4112,7 +4112,7 @@
           <p:cNvPr id="4" name="s2-context">
             <a:extLst xmlns:a="http://schemas.openxmlformats.org/drawingml/2006/main">
               <a:ext uri="{FF2B5EF4-FFF2-40B4-BE49-F238E27FC236}">
-                <a16:creationId xmlns:a16="http://schemas.microsoft.com/office/drawing/2014/main" id="{49C935AC-F4C6-4986-8AF4-3A0AB3DB8C74}"/>
+                <a16:creationId xmlns:a16="http://schemas.microsoft.com/office/drawing/2014/main" id="{0AF51C63-7C12-4C8A-9A03-7F6DEE6862BC}"/>
               </a:ext>
             </a:extLst>
           </p:cNvPr>
@@ -4158,7 +4158,7 @@
                 <a:ea typeface="Arial"/>
                 <a:cs typeface="Arial"/>
               </a:rPr>
-              <a:t>CM1 deliberately excludes SKU-less advertising, storage, subscriptions, and adjustments; those items are shown below the attributable margin line.</a:t>
+              <a:t>Contribution margin uses the costs that can be tied to SKU. Advertising, storage, subscriptions, and adjustments are shown separately because the file provides no reliable SKU allocation key.</a:t>
             </a:r>
           </a:p>
         </p:txBody>
@@ -4168,7 +4168,7 @@
           <p:cNvPr id="5" name="s2-net-sales-panel">
             <a:extLst xmlns:a="http://schemas.openxmlformats.org/drawingml/2006/main">
               <a:ext uri="{FF2B5EF4-FFF2-40B4-BE49-F238E27FC236}">
-                <a16:creationId xmlns:a16="http://schemas.microsoft.com/office/drawing/2014/main" id="{CE780840-4980-44AC-ADF1-9897E0B12220}"/>
+                <a16:creationId xmlns:a16="http://schemas.microsoft.com/office/drawing/2014/main" id="{B5852A6C-244E-40AF-A227-85D331FDECB0}"/>
               </a:ext>
             </a:extLst>
           </p:cNvPr>
@@ -4199,7 +4199,7 @@
           <p:cNvPr id="6" name="s2-net-sales-value">
             <a:extLst xmlns:a="http://schemas.openxmlformats.org/drawingml/2006/main">
               <a:ext uri="{FF2B5EF4-FFF2-40B4-BE49-F238E27FC236}">
-                <a16:creationId xmlns:a16="http://schemas.microsoft.com/office/drawing/2014/main" id="{C2B82964-7237-4DA5-B7E8-4693B36BD8BA}"/>
+                <a16:creationId xmlns:a16="http://schemas.microsoft.com/office/drawing/2014/main" id="{3DCDF81D-2AA9-4708-8CAE-2AE041301A43}"/>
               </a:ext>
             </a:extLst>
           </p:cNvPr>
@@ -4255,7 +4255,7 @@
           <p:cNvPr id="7" name="s2-net-sales-label">
             <a:extLst xmlns:a="http://schemas.openxmlformats.org/drawingml/2006/main">
               <a:ext uri="{FF2B5EF4-FFF2-40B4-BE49-F238E27FC236}">
-                <a16:creationId xmlns:a16="http://schemas.microsoft.com/office/drawing/2014/main" id="{EFC7A048-D8C6-4525-9E95-6CC7B57C18E6}"/>
+                <a16:creationId xmlns:a16="http://schemas.microsoft.com/office/drawing/2014/main" id="{70712A01-F2D1-41C2-B3E6-7A71068457B3}"/>
               </a:ext>
             </a:extLst>
           </p:cNvPr>
@@ -4311,7 +4311,7 @@
           <p:cNvPr id="8" name="s2-net-sales-detail">
             <a:extLst xmlns:a="http://schemas.openxmlformats.org/drawingml/2006/main">
               <a:ext uri="{FF2B5EF4-FFF2-40B4-BE49-F238E27FC236}">
-                <a16:creationId xmlns:a16="http://schemas.microsoft.com/office/drawing/2014/main" id="{A359D985-2092-4B96-B63B-F50A3F409310}"/>
+                <a16:creationId xmlns:a16="http://schemas.microsoft.com/office/drawing/2014/main" id="{0A05B59F-EF4C-4453-822D-95E3DE3060B0}"/>
               </a:ext>
             </a:extLst>
           </p:cNvPr>
@@ -4367,7 +4367,7 @@
           <p:cNvPr id="9" name="s2-cm-panel">
             <a:extLst xmlns:a="http://schemas.openxmlformats.org/drawingml/2006/main">
               <a:ext uri="{FF2B5EF4-FFF2-40B4-BE49-F238E27FC236}">
-                <a16:creationId xmlns:a16="http://schemas.microsoft.com/office/drawing/2014/main" id="{8E32429C-0192-44A0-9EA5-B2C3DFE6F2FB}"/>
+                <a16:creationId xmlns:a16="http://schemas.microsoft.com/office/drawing/2014/main" id="{B43ED053-25F2-4554-B32D-5C8DF77DAE84}"/>
               </a:ext>
             </a:extLst>
           </p:cNvPr>
@@ -4398,7 +4398,7 @@
           <p:cNvPr id="10" name="s2-cm-value">
             <a:extLst xmlns:a="http://schemas.openxmlformats.org/drawingml/2006/main">
               <a:ext uri="{FF2B5EF4-FFF2-40B4-BE49-F238E27FC236}">
-                <a16:creationId xmlns:a16="http://schemas.microsoft.com/office/drawing/2014/main" id="{52D393C1-B593-41D2-9630-FB4CF05B2C1B}"/>
+                <a16:creationId xmlns:a16="http://schemas.microsoft.com/office/drawing/2014/main" id="{C3A8C5C8-4666-44EF-AF8B-3BEE1872DEB5}"/>
               </a:ext>
             </a:extLst>
           </p:cNvPr>
@@ -4454,7 +4454,7 @@
           <p:cNvPr id="11" name="s2-cm-label">
             <a:extLst xmlns:a="http://schemas.openxmlformats.org/drawingml/2006/main">
               <a:ext uri="{FF2B5EF4-FFF2-40B4-BE49-F238E27FC236}">
-                <a16:creationId xmlns:a16="http://schemas.microsoft.com/office/drawing/2014/main" id="{99D4949A-8A04-4911-82D7-690BDE7F2451}"/>
+                <a16:creationId xmlns:a16="http://schemas.microsoft.com/office/drawing/2014/main" id="{E6553178-3768-4861-9296-2D1D60AFA2BB}"/>
               </a:ext>
             </a:extLst>
           </p:cNvPr>
@@ -4510,7 +4510,7 @@
           <p:cNvPr id="12" name="s2-cm-detail">
             <a:extLst xmlns:a="http://schemas.openxmlformats.org/drawingml/2006/main">
               <a:ext uri="{FF2B5EF4-FFF2-40B4-BE49-F238E27FC236}">
-                <a16:creationId xmlns:a16="http://schemas.microsoft.com/office/drawing/2014/main" id="{DDCC314F-3467-4C00-AEAD-2FDF679FCEDB}"/>
+                <a16:creationId xmlns:a16="http://schemas.microsoft.com/office/drawing/2014/main" id="{9137A265-BF55-4972-8A1E-CCA24A324BAF}"/>
               </a:ext>
             </a:extLst>
           </p:cNvPr>
@@ -4566,7 +4566,7 @@
           <p:cNvPr id="13" name="s2-after-panel">
             <a:extLst xmlns:a="http://schemas.openxmlformats.org/drawingml/2006/main">
               <a:ext uri="{FF2B5EF4-FFF2-40B4-BE49-F238E27FC236}">
-                <a16:creationId xmlns:a16="http://schemas.microsoft.com/office/drawing/2014/main" id="{E7586F55-11A5-47E0-97EF-D096EF437DD0}"/>
+                <a16:creationId xmlns:a16="http://schemas.microsoft.com/office/drawing/2014/main" id="{9B9766DC-ABB0-4A29-BA0B-A4AB8C5FF1D3}"/>
               </a:ext>
             </a:extLst>
           </p:cNvPr>
@@ -4597,7 +4597,7 @@
           <p:cNvPr id="14" name="s2-after-value">
             <a:extLst xmlns:a="http://schemas.openxmlformats.org/drawingml/2006/main">
               <a:ext uri="{FF2B5EF4-FFF2-40B4-BE49-F238E27FC236}">
-                <a16:creationId xmlns:a16="http://schemas.microsoft.com/office/drawing/2014/main" id="{89EE10CA-AAC9-42EB-92A7-48D1EAB4A186}"/>
+                <a16:creationId xmlns:a16="http://schemas.microsoft.com/office/drawing/2014/main" id="{3501B475-5B1D-4951-85EF-D5A1A7FCBCCA}"/>
               </a:ext>
             </a:extLst>
           </p:cNvPr>
@@ -4653,7 +4653,7 @@
           <p:cNvPr id="15" name="s2-after-label">
             <a:extLst xmlns:a="http://schemas.openxmlformats.org/drawingml/2006/main">
               <a:ext uri="{FF2B5EF4-FFF2-40B4-BE49-F238E27FC236}">
-                <a16:creationId xmlns:a16="http://schemas.microsoft.com/office/drawing/2014/main" id="{FAF043F2-D05A-48EB-93F0-5FEABDCAC01A}"/>
+                <a16:creationId xmlns:a16="http://schemas.microsoft.com/office/drawing/2014/main" id="{BA3C3ACF-36DF-4218-8643-09614A4CA569}"/>
               </a:ext>
             </a:extLst>
           </p:cNvPr>
@@ -4699,7 +4699,7 @@
                 <a:ea typeface="Arial"/>
                 <a:cs typeface="Arial"/>
               </a:rPr>
-              <a:t>After platform overhead</a:t>
+              <a:t>After platform costs</a:t>
             </a:r>
           </a:p>
         </p:txBody>
@@ -4709,7 +4709,7 @@
           <p:cNvPr id="16" name="s2-after-detail">
             <a:extLst xmlns:a="http://schemas.openxmlformats.org/drawingml/2006/main">
               <a:ext uri="{FF2B5EF4-FFF2-40B4-BE49-F238E27FC236}">
-                <a16:creationId xmlns:a16="http://schemas.microsoft.com/office/drawing/2014/main" id="{27D5490F-9813-4A6E-B384-31480731C8F0}"/>
+                <a16:creationId xmlns:a16="http://schemas.microsoft.com/office/drawing/2014/main" id="{4028C59D-1FAA-449A-8C65-F1426158C0C9}"/>
               </a:ext>
             </a:extLst>
           </p:cNvPr>
@@ -4755,7 +4755,7 @@
                 <a:ea typeface="Arial"/>
                 <a:cs typeface="Arial"/>
               </a:rPr>
-              <a:t>$56.8K overhead, plus $89 adjustments</a:t>
+              <a:t>$56.8K of costs, plus $89 of adjustments</a:t>
             </a:r>
           </a:p>
         </p:txBody>
@@ -4763,7 +4763,7 @@
     </p:spTree>
     <p:extLst>
       <p:ext uri="{BB962C8B-B14F-4D97-AF65-F5344CB8AC3E}">
-        <p14:creationId xmlns:p14="http://schemas.microsoft.com/office/powerpoint/2010/main" val="1559007013"/>
+        <p14:creationId xmlns:p14="http://schemas.microsoft.com/office/powerpoint/2010/main" val="620910295"/>
       </p:ext>
     </p:extLst>
   </p:cSld>
@@ -4794,7 +4794,7 @@
           <p:cNvPr id="26" name="eyebrow-3">
             <a:extLst xmlns:a="http://schemas.openxmlformats.org/drawingml/2006/main">
               <a:ext uri="{FF2B5EF4-FFF2-40B4-BE49-F238E27FC236}">
-                <a16:creationId xmlns:a16="http://schemas.microsoft.com/office/drawing/2014/main" id="{4D22E542-AE14-46D6-8492-73462DABAE52}"/>
+                <a16:creationId xmlns:a16="http://schemas.microsoft.com/office/drawing/2014/main" id="{50C07E64-80D3-4337-9646-736E83C07282}"/>
               </a:ext>
             </a:extLst>
           </p:cNvPr>
@@ -4850,7 +4850,7 @@
           <p:cNvPr id="2" name="title-3">
             <a:extLst xmlns:a="http://schemas.openxmlformats.org/drawingml/2006/main">
               <a:ext uri="{FF2B5EF4-FFF2-40B4-BE49-F238E27FC236}">
-                <a16:creationId xmlns:a16="http://schemas.microsoft.com/office/drawing/2014/main" id="{88A043D6-3199-4E38-A0F0-422DF49F95DB}"/>
+                <a16:creationId xmlns:a16="http://schemas.microsoft.com/office/drawing/2014/main" id="{45804015-E953-4E1F-8D44-88C76FC47699}"/>
               </a:ext>
             </a:extLst>
           </p:cNvPr>
@@ -4896,7 +4896,7 @@
                 <a:ea typeface="Arial"/>
                 <a:cs typeface="Arial"/>
               </a:rPr>
-              <a:t>One medallion model supports both implementation paths</a:t>
+              <a:t>The BigQuery model stays the same under either implementation option</a:t>
             </a:r>
           </a:p>
         </p:txBody>
@@ -4906,7 +4906,7 @@
           <p:cNvPr id="3" name="footer-3">
             <a:extLst xmlns:a="http://schemas.openxmlformats.org/drawingml/2006/main">
               <a:ext uri="{FF2B5EF4-FFF2-40B4-BE49-F238E27FC236}">
-                <a16:creationId xmlns:a16="http://schemas.microsoft.com/office/drawing/2014/main" id="{CFDB2195-4E88-4C46-AE95-6FF2BE272F4D}"/>
+                <a16:creationId xmlns:a16="http://schemas.microsoft.com/office/drawing/2014/main" id="{25671065-CDBC-4DE5-8F3E-22DB8FB6D435}"/>
               </a:ext>
             </a:extLst>
           </p:cNvPr>
@@ -4962,7 +4962,7 @@
           <p:cNvPr id="4" name="s3-intro">
             <a:extLst xmlns:a="http://schemas.openxmlformats.org/drawingml/2006/main">
               <a:ext uri="{FF2B5EF4-FFF2-40B4-BE49-F238E27FC236}">
-                <a16:creationId xmlns:a16="http://schemas.microsoft.com/office/drawing/2014/main" id="{E4CC6514-0C5C-4FF2-8913-3604F494E829}"/>
+                <a16:creationId xmlns:a16="http://schemas.microsoft.com/office/drawing/2014/main" id="{8E0EFD88-F9E4-4614-B64A-723294044275}"/>
               </a:ext>
             </a:extLst>
           </p:cNvPr>
@@ -5018,7 +5018,7 @@
           <p:cNvPr id="5" name="s3-arrow-0">
             <a:extLst xmlns:a="http://schemas.openxmlformats.org/drawingml/2006/main">
               <a:ext uri="{FF2B5EF4-FFF2-40B4-BE49-F238E27FC236}">
-                <a16:creationId xmlns:a16="http://schemas.microsoft.com/office/drawing/2014/main" id="{A585336A-1102-45DE-B492-CE66DF803BDE}"/>
+                <a16:creationId xmlns:a16="http://schemas.microsoft.com/office/drawing/2014/main" id="{C6D4E155-DB01-4310-AD1F-65C29D53BE66}"/>
               </a:ext>
             </a:extLst>
           </p:cNvPr>
@@ -5049,7 +5049,7 @@
           <p:cNvPr id="6" name="s3-arrow-1">
             <a:extLst xmlns:a="http://schemas.openxmlformats.org/drawingml/2006/main">
               <a:ext uri="{FF2B5EF4-FFF2-40B4-BE49-F238E27FC236}">
-                <a16:creationId xmlns:a16="http://schemas.microsoft.com/office/drawing/2014/main" id="{02377F46-69E6-47C0-AD8F-7916165B4B93}"/>
+                <a16:creationId xmlns:a16="http://schemas.microsoft.com/office/drawing/2014/main" id="{D5D31743-0B06-42B2-A761-8104F0107AA0}"/>
               </a:ext>
             </a:extLst>
           </p:cNvPr>
@@ -5080,7 +5080,7 @@
           <p:cNvPr id="7" name="s3-arrow-2">
             <a:extLst xmlns:a="http://schemas.openxmlformats.org/drawingml/2006/main">
               <a:ext uri="{FF2B5EF4-FFF2-40B4-BE49-F238E27FC236}">
-                <a16:creationId xmlns:a16="http://schemas.microsoft.com/office/drawing/2014/main" id="{4BD357AF-600B-4FA8-960F-212905D19D4A}"/>
+                <a16:creationId xmlns:a16="http://schemas.microsoft.com/office/drawing/2014/main" id="{6C4668C1-AA05-4A43-AE2B-2E6C308739DC}"/>
               </a:ext>
             </a:extLst>
           </p:cNvPr>
@@ -5111,7 +5111,7 @@
           <p:cNvPr id="8" name="s3-arrow-3">
             <a:extLst xmlns:a="http://schemas.openxmlformats.org/drawingml/2006/main">
               <a:ext uri="{FF2B5EF4-FFF2-40B4-BE49-F238E27FC236}">
-                <a16:creationId xmlns:a16="http://schemas.microsoft.com/office/drawing/2014/main" id="{A4635C1E-9A1A-4EDF-971A-097A989E7C7B}"/>
+                <a16:creationId xmlns:a16="http://schemas.microsoft.com/office/drawing/2014/main" id="{8FD633F0-CCDF-49EC-BF8E-7D966EEEFF3D}"/>
               </a:ext>
             </a:extLst>
           </p:cNvPr>
@@ -5142,7 +5142,7 @@
           <p:cNvPr id="9" name="s3-node-0">
             <a:extLst xmlns:a="http://schemas.openxmlformats.org/drawingml/2006/main">
               <a:ext uri="{FF2B5EF4-FFF2-40B4-BE49-F238E27FC236}">
-                <a16:creationId xmlns:a16="http://schemas.microsoft.com/office/drawing/2014/main" id="{14A0166F-3AFD-41E7-90D7-19CFBDB3BD5E}"/>
+                <a16:creationId xmlns:a16="http://schemas.microsoft.com/office/drawing/2014/main" id="{AF16CD62-6A54-41C0-88C1-FF41983BB88B}"/>
               </a:ext>
             </a:extLst>
           </p:cNvPr>
@@ -5175,7 +5175,7 @@
           <p:cNvPr id="10" name="s3-node-title-0">
             <a:extLst xmlns:a="http://schemas.openxmlformats.org/drawingml/2006/main">
               <a:ext uri="{FF2B5EF4-FFF2-40B4-BE49-F238E27FC236}">
-                <a16:creationId xmlns:a16="http://schemas.microsoft.com/office/drawing/2014/main" id="{27D5AF89-D242-433E-8858-0EC7DF63CE95}"/>
+                <a16:creationId xmlns:a16="http://schemas.microsoft.com/office/drawing/2014/main" id="{F36F00B3-F936-4922-8332-8840D74D7601}"/>
               </a:ext>
             </a:extLst>
           </p:cNvPr>
@@ -5231,7 +5231,7 @@
           <p:cNvPr id="11" name="s3-node-body-0">
             <a:extLst xmlns:a="http://schemas.openxmlformats.org/drawingml/2006/main">
               <a:ext uri="{FF2B5EF4-FFF2-40B4-BE49-F238E27FC236}">
-                <a16:creationId xmlns:a16="http://schemas.microsoft.com/office/drawing/2014/main" id="{1D08B39E-9946-4AEA-ADE3-35CA27E4F1F4}"/>
+                <a16:creationId xmlns:a16="http://schemas.microsoft.com/office/drawing/2014/main" id="{412E5997-3679-43C4-ACC9-E4CBDC459683}"/>
               </a:ext>
             </a:extLst>
           </p:cNvPr>
@@ -5356,7 +5356,7 @@
           <p:cNvPr id="12" name="s3-node-1">
             <a:extLst xmlns:a="http://schemas.openxmlformats.org/drawingml/2006/main">
               <a:ext uri="{FF2B5EF4-FFF2-40B4-BE49-F238E27FC236}">
-                <a16:creationId xmlns:a16="http://schemas.microsoft.com/office/drawing/2014/main" id="{3C398CFD-B058-48E0-AA9E-4A4D51A2E5C7}"/>
+                <a16:creationId xmlns:a16="http://schemas.microsoft.com/office/drawing/2014/main" id="{8B9A50C7-36A7-4F38-AB27-9C7D41AC9797}"/>
               </a:ext>
             </a:extLst>
           </p:cNvPr>
@@ -5389,7 +5389,7 @@
           <p:cNvPr id="13" name="s3-node-title-1">
             <a:extLst xmlns:a="http://schemas.openxmlformats.org/drawingml/2006/main">
               <a:ext uri="{FF2B5EF4-FFF2-40B4-BE49-F238E27FC236}">
-                <a16:creationId xmlns:a16="http://schemas.microsoft.com/office/drawing/2014/main" id="{72DC04A1-4D79-4FE1-BEE0-F2E703123326}"/>
+                <a16:creationId xmlns:a16="http://schemas.microsoft.com/office/drawing/2014/main" id="{85131783-8634-44B4-9B7C-A11A6258D6BB}"/>
               </a:ext>
             </a:extLst>
           </p:cNvPr>
@@ -5445,7 +5445,7 @@
           <p:cNvPr id="14" name="s3-node-body-1">
             <a:extLst xmlns:a="http://schemas.openxmlformats.org/drawingml/2006/main">
               <a:ext uri="{FF2B5EF4-FFF2-40B4-BE49-F238E27FC236}">
-                <a16:creationId xmlns:a16="http://schemas.microsoft.com/office/drawing/2014/main" id="{FA679F7F-59BE-45D5-8208-C5081CD21D87}"/>
+                <a16:creationId xmlns:a16="http://schemas.microsoft.com/office/drawing/2014/main" id="{0E94E8E6-C91B-46BF-8346-55BB13DC4096}"/>
               </a:ext>
             </a:extLst>
           </p:cNvPr>
@@ -5547,7 +5547,7 @@
           <p:cNvPr id="15" name="s3-node-2">
             <a:extLst xmlns:a="http://schemas.openxmlformats.org/drawingml/2006/main">
               <a:ext uri="{FF2B5EF4-FFF2-40B4-BE49-F238E27FC236}">
-                <a16:creationId xmlns:a16="http://schemas.microsoft.com/office/drawing/2014/main" id="{4D49B23E-9E69-4155-B7AE-7E923B577239}"/>
+                <a16:creationId xmlns:a16="http://schemas.microsoft.com/office/drawing/2014/main" id="{7B104197-CDEB-42FC-ADD7-1BC21B09CD8C}"/>
               </a:ext>
             </a:extLst>
           </p:cNvPr>
@@ -5580,7 +5580,7 @@
           <p:cNvPr id="16" name="s3-node-title-2">
             <a:extLst xmlns:a="http://schemas.openxmlformats.org/drawingml/2006/main">
               <a:ext uri="{FF2B5EF4-FFF2-40B4-BE49-F238E27FC236}">
-                <a16:creationId xmlns:a16="http://schemas.microsoft.com/office/drawing/2014/main" id="{B1133891-0267-4DBB-A29B-258459B2B091}"/>
+                <a16:creationId xmlns:a16="http://schemas.microsoft.com/office/drawing/2014/main" id="{DA4B2F3E-E5C6-4682-9236-5E659564D6A7}"/>
               </a:ext>
             </a:extLst>
           </p:cNvPr>
@@ -5636,7 +5636,7 @@
           <p:cNvPr id="17" name="s3-node-body-2">
             <a:extLst xmlns:a="http://schemas.openxmlformats.org/drawingml/2006/main">
               <a:ext uri="{FF2B5EF4-FFF2-40B4-BE49-F238E27FC236}">
-                <a16:creationId xmlns:a16="http://schemas.microsoft.com/office/drawing/2014/main" id="{84E539FA-A087-49BA-9AB6-AEEECDC9485D}"/>
+                <a16:creationId xmlns:a16="http://schemas.microsoft.com/office/drawing/2014/main" id="{B030A9F1-8DBB-4F7E-9A6D-D299755D8324}"/>
               </a:ext>
             </a:extLst>
           </p:cNvPr>
@@ -5738,7 +5738,7 @@
           <p:cNvPr id="18" name="s3-node-3">
             <a:extLst xmlns:a="http://schemas.openxmlformats.org/drawingml/2006/main">
               <a:ext uri="{FF2B5EF4-FFF2-40B4-BE49-F238E27FC236}">
-                <a16:creationId xmlns:a16="http://schemas.microsoft.com/office/drawing/2014/main" id="{F3003BAC-C9E6-45A6-956A-33FC155EA027}"/>
+                <a16:creationId xmlns:a16="http://schemas.microsoft.com/office/drawing/2014/main" id="{C0529E2D-CAEC-4A76-8F7D-1D19DF17E42F}"/>
               </a:ext>
             </a:extLst>
           </p:cNvPr>
@@ -5771,7 +5771,7 @@
           <p:cNvPr id="19" name="s3-node-title-3">
             <a:extLst xmlns:a="http://schemas.openxmlformats.org/drawingml/2006/main">
               <a:ext uri="{FF2B5EF4-FFF2-40B4-BE49-F238E27FC236}">
-                <a16:creationId xmlns:a16="http://schemas.microsoft.com/office/drawing/2014/main" id="{AB68D127-AB1F-4833-B8BA-A9F181EF5491}"/>
+                <a16:creationId xmlns:a16="http://schemas.microsoft.com/office/drawing/2014/main" id="{DC3446F5-5601-42A1-A657-580F69442741}"/>
               </a:ext>
             </a:extLst>
           </p:cNvPr>
@@ -5827,7 +5827,7 @@
           <p:cNvPr id="20" name="s3-node-body-3">
             <a:extLst xmlns:a="http://schemas.openxmlformats.org/drawingml/2006/main">
               <a:ext uri="{FF2B5EF4-FFF2-40B4-BE49-F238E27FC236}">
-                <a16:creationId xmlns:a16="http://schemas.microsoft.com/office/drawing/2014/main" id="{E37E08ED-FB61-4689-8AE1-3980E02F9536}"/>
+                <a16:creationId xmlns:a16="http://schemas.microsoft.com/office/drawing/2014/main" id="{9A70F1C4-E964-4962-AE09-0910E8746E35}"/>
               </a:ext>
             </a:extLst>
           </p:cNvPr>
@@ -5906,7 +5906,7 @@
           <p:cNvPr id="21" name="s3-node-4">
             <a:extLst xmlns:a="http://schemas.openxmlformats.org/drawingml/2006/main">
               <a:ext uri="{FF2B5EF4-FFF2-40B4-BE49-F238E27FC236}">
-                <a16:creationId xmlns:a16="http://schemas.microsoft.com/office/drawing/2014/main" id="{764476AC-290C-4518-83AD-E51440C37764}"/>
+                <a16:creationId xmlns:a16="http://schemas.microsoft.com/office/drawing/2014/main" id="{ECB00461-8AE5-4349-80D2-C9F22E8EFCC3}"/>
               </a:ext>
             </a:extLst>
           </p:cNvPr>
@@ -5939,7 +5939,7 @@
           <p:cNvPr id="22" name="s3-node-title-4">
             <a:extLst xmlns:a="http://schemas.openxmlformats.org/drawingml/2006/main">
               <a:ext uri="{FF2B5EF4-FFF2-40B4-BE49-F238E27FC236}">
-                <a16:creationId xmlns:a16="http://schemas.microsoft.com/office/drawing/2014/main" id="{5EA577CF-786F-4D33-A780-28C6FA20A4AB}"/>
+                <a16:creationId xmlns:a16="http://schemas.microsoft.com/office/drawing/2014/main" id="{3BB5F50D-F03D-46B1-AA89-1EDC6D420A4F}"/>
               </a:ext>
             </a:extLst>
           </p:cNvPr>
@@ -5995,7 +5995,7 @@
           <p:cNvPr id="23" name="s3-node-body-4">
             <a:extLst xmlns:a="http://schemas.openxmlformats.org/drawingml/2006/main">
               <a:ext uri="{FF2B5EF4-FFF2-40B4-BE49-F238E27FC236}">
-                <a16:creationId xmlns:a16="http://schemas.microsoft.com/office/drawing/2014/main" id="{846308C6-9E51-4957-B7BF-9CB48950CF4A}"/>
+                <a16:creationId xmlns:a16="http://schemas.microsoft.com/office/drawing/2014/main" id="{2613BB0E-DB2B-4364-B6C7-C878877CC8E9}"/>
               </a:ext>
             </a:extLst>
           </p:cNvPr>
@@ -6097,7 +6097,7 @@
           <p:cNvPr id="24" name="s3-quality">
             <a:extLst xmlns:a="http://schemas.openxmlformats.org/drawingml/2006/main">
               <a:ext uri="{FF2B5EF4-FFF2-40B4-BE49-F238E27FC236}">
-                <a16:creationId xmlns:a16="http://schemas.microsoft.com/office/drawing/2014/main" id="{068CF427-E4B7-43C8-9B58-287EE2E4106E}"/>
+                <a16:creationId xmlns:a16="http://schemas.microsoft.com/office/drawing/2014/main" id="{AD14A2CF-246E-4457-8911-D4DA1078D819}"/>
               </a:ext>
             </a:extLst>
           </p:cNvPr>
@@ -6130,7 +6130,7 @@
           <p:cNvPr id="25" name="s3-quality-text">
             <a:extLst xmlns:a="http://schemas.openxmlformats.org/drawingml/2006/main">
               <a:ext uri="{FF2B5EF4-FFF2-40B4-BE49-F238E27FC236}">
-                <a16:creationId xmlns:a16="http://schemas.microsoft.com/office/drawing/2014/main" id="{76AC6232-E899-4F1C-80A9-4B1077DB52A6}"/>
+                <a16:creationId xmlns:a16="http://schemas.microsoft.com/office/drawing/2014/main" id="{88E2327B-DD13-4CF4-A158-E4AB738946C3}"/>
               </a:ext>
             </a:extLst>
           </p:cNvPr>
@@ -6176,7 +6176,7 @@
                 <a:ea typeface="Arial"/>
                 <a:cs typeface="Arial"/>
               </a:rPr>
-              <a:t>Quality plane: schema drift • dedup audit • amount tie-outs • mapping coverage • owned exceptions</a:t>
+              <a:t>Checks: schema changes • duplicate handling • amount tie-outs • mapping coverage • open issues</a:t>
             </a:r>
           </a:p>
         </p:txBody>
@@ -6184,7 +6184,7 @@
     </p:spTree>
     <p:extLst>
       <p:ext uri="{BB962C8B-B14F-4D97-AF65-F5344CB8AC3E}">
-        <p14:creationId xmlns:p14="http://schemas.microsoft.com/office/powerpoint/2010/main" val="1024296084"/>
+        <p14:creationId xmlns:p14="http://schemas.microsoft.com/office/powerpoint/2010/main" val="1429830591"/>
       </p:ext>
     </p:extLst>
   </p:cSld>
@@ -6215,7 +6215,7 @@
           <p:cNvPr id="7" name="eyebrow-4">
             <a:extLst xmlns:a="http://schemas.openxmlformats.org/drawingml/2006/main">
               <a:ext uri="{FF2B5EF4-FFF2-40B4-BE49-F238E27FC236}">
-                <a16:creationId xmlns:a16="http://schemas.microsoft.com/office/drawing/2014/main" id="{B7EFB36D-FEF2-437C-8574-66E7270F8667}"/>
+                <a16:creationId xmlns:a16="http://schemas.microsoft.com/office/drawing/2014/main" id="{F3F34B65-7F81-4D24-B856-C5E1E1FD7C25}"/>
               </a:ext>
             </a:extLst>
           </p:cNvPr>
@@ -6271,7 +6271,7 @@
           <p:cNvPr id="2" name="title-4">
             <a:extLst xmlns:a="http://schemas.openxmlformats.org/drawingml/2006/main">
               <a:ext uri="{FF2B5EF4-FFF2-40B4-BE49-F238E27FC236}">
-                <a16:creationId xmlns:a16="http://schemas.microsoft.com/office/drawing/2014/main" id="{13041A5A-9853-4F7F-B709-44EA57641CBF}"/>
+                <a16:creationId xmlns:a16="http://schemas.microsoft.com/office/drawing/2014/main" id="{D4D56A49-59F5-48F2-8FCD-9C4BBEF09B6C}"/>
               </a:ext>
             </a:extLst>
           </p:cNvPr>
@@ -6317,7 +6317,7 @@
                 <a:ea typeface="Arial"/>
                 <a:cs typeface="Arial"/>
               </a:rPr>
-              <a:t>The material data issues are manageable—if they become monitored controls</a:t>
+              <a:t>Five material data issues become recurring controls</a:t>
             </a:r>
           </a:p>
         </p:txBody>
@@ -6327,7 +6327,7 @@
           <p:cNvPr id="3" name="footer-4">
             <a:extLst xmlns:a="http://schemas.openxmlformats.org/drawingml/2006/main">
               <a:ext uri="{FF2B5EF4-FFF2-40B4-BE49-F238E27FC236}">
-                <a16:creationId xmlns:a16="http://schemas.microsoft.com/office/drawing/2014/main" id="{C1442B56-F79B-4DC4-804D-D2B197C9BBAD}"/>
+                <a16:creationId xmlns:a16="http://schemas.microsoft.com/office/drawing/2014/main" id="{AA701FEC-56EA-4696-AB2F-535EA8C48974}"/>
               </a:ext>
             </a:extLst>
           </p:cNvPr>
@@ -6383,7 +6383,7 @@
           <p:cNvPr id="4" name="s4-intro">
             <a:extLst xmlns:a="http://schemas.openxmlformats.org/drawingml/2006/main">
               <a:ext uri="{FF2B5EF4-FFF2-40B4-BE49-F238E27FC236}">
-                <a16:creationId xmlns:a16="http://schemas.microsoft.com/office/drawing/2014/main" id="{45F90ABA-C066-4990-BFF4-F5A2C42419D3}"/>
+                <a16:creationId xmlns:a16="http://schemas.microsoft.com/office/drawing/2014/main" id="{F93B31C8-7220-40D4-ACFF-3188C10E54B9}"/>
               </a:ext>
             </a:extLst>
           </p:cNvPr>
@@ -6631,7 +6631,7 @@
                           <a:ea typeface="Arial"/>
                           <a:cs typeface="Arial"/>
                         </a:rPr>
-                        <a:t>Block final CM until approved</a:t>
+                        <a:t>Block final reporting until approved</a:t>
                       </a:r>
                     </a:p>
                   </a:txBody>
@@ -6991,7 +6991,7 @@
           <p:cNvPr id="6" name="s4-foot">
             <a:extLst xmlns:a="http://schemas.openxmlformats.org/drawingml/2006/main">
               <a:ext uri="{FF2B5EF4-FFF2-40B4-BE49-F238E27FC236}">
-                <a16:creationId xmlns:a16="http://schemas.microsoft.com/office/drawing/2014/main" id="{9EB5DFF9-5494-434E-90C6-1CE3A557925C}"/>
+                <a16:creationId xmlns:a16="http://schemas.microsoft.com/office/drawing/2014/main" id="{D507122F-22D5-4F0D-AADA-7A5DBA8500D9}"/>
               </a:ext>
             </a:extLst>
           </p:cNvPr>
@@ -7045,7 +7045,7 @@
     </p:spTree>
     <p:extLst>
       <p:ext uri="{BB962C8B-B14F-4D97-AF65-F5344CB8AC3E}">
-        <p14:creationId xmlns:p14="http://schemas.microsoft.com/office/powerpoint/2010/main" val="122950605"/>
+        <p14:creationId xmlns:p14="http://schemas.microsoft.com/office/powerpoint/2010/main" val="1248068724"/>
       </p:ext>
     </p:extLst>
   </p:cSld>
@@ -7076,7 +7076,7 @@
           <p:cNvPr id="17" name="eyebrow-5">
             <a:extLst xmlns:a="http://schemas.openxmlformats.org/drawingml/2006/main">
               <a:ext uri="{FF2B5EF4-FFF2-40B4-BE49-F238E27FC236}">
-                <a16:creationId xmlns:a16="http://schemas.microsoft.com/office/drawing/2014/main" id="{585AAAFF-515F-4F2D-9782-5849C8359D2C}"/>
+                <a16:creationId xmlns:a16="http://schemas.microsoft.com/office/drawing/2014/main" id="{06660144-426B-408E-9EF1-384643A27843}"/>
               </a:ext>
             </a:extLst>
           </p:cNvPr>
@@ -7132,7 +7132,7 @@
           <p:cNvPr id="2" name="title-5">
             <a:extLst xmlns:a="http://schemas.openxmlformats.org/drawingml/2006/main">
               <a:ext uri="{FF2B5EF4-FFF2-40B4-BE49-F238E27FC236}">
-                <a16:creationId xmlns:a16="http://schemas.microsoft.com/office/drawing/2014/main" id="{C544E648-2236-4757-B877-A0D7CE252ACC}"/>
+                <a16:creationId xmlns:a16="http://schemas.microsoft.com/office/drawing/2014/main" id="{01150DCD-EE4F-46F2-B49B-5690DBDCA2E5}"/>
               </a:ext>
             </a:extLst>
           </p:cNvPr>
@@ -7178,7 +7178,7 @@
                 <a:ea typeface="Arial"/>
                 <a:cs typeface="Arial"/>
               </a:rPr>
-              <a:t>Peak Fuel + GlowTheory generate 83% of CM1</a:t>
+              <a:t>Peak Fuel + GlowTheory generate 83% of contribution margin</a:t>
             </a:r>
           </a:p>
         </p:txBody>
@@ -7188,7 +7188,7 @@
           <p:cNvPr id="3" name="footer-5">
             <a:extLst xmlns:a="http://schemas.openxmlformats.org/drawingml/2006/main">
               <a:ext uri="{FF2B5EF4-FFF2-40B4-BE49-F238E27FC236}">
-                <a16:creationId xmlns:a16="http://schemas.microsoft.com/office/drawing/2014/main" id="{52F86A62-7B79-479C-92F9-C1DE21848E87}"/>
+                <a16:creationId xmlns:a16="http://schemas.microsoft.com/office/drawing/2014/main" id="{71BF67F6-AF3F-4E82-BCDE-CA9F941D2E38}"/>
               </a:ext>
             </a:extLst>
           </p:cNvPr>
@@ -7251,7 +7251,7 @@
         </p:xfrm>
         <a:graphic xmlns:a="http://schemas.openxmlformats.org/drawingml/2006/main">
           <a:graphicData uri="http://schemas.openxmlformats.org/drawingml/2006/chart">
-            <c:chart xmlns:r="http://schemas.openxmlformats.org/officeDocument/2006/relationships" xmlns:c="http://schemas.openxmlformats.org/drawingml/2006/chart" r:id="R59262ba5c1e44a1c"/>
+            <c:chart xmlns:r="http://schemas.openxmlformats.org/officeDocument/2006/relationships" xmlns:c="http://schemas.openxmlformats.org/drawingml/2006/chart" r:id="R431766dc35c645c3"/>
           </a:graphicData>
         </a:graphic>
       </p:graphicFrame>
@@ -7260,7 +7260,7 @@
           <p:cNvPr id="5" name="s5-rail-0">
             <a:extLst xmlns:a="http://schemas.openxmlformats.org/drawingml/2006/main">
               <a:ext uri="{FF2B5EF4-FFF2-40B4-BE49-F238E27FC236}">
-                <a16:creationId xmlns:a16="http://schemas.microsoft.com/office/drawing/2014/main" id="{429F3CDD-1A30-4F10-9433-A71168895E4A}"/>
+                <a16:creationId xmlns:a16="http://schemas.microsoft.com/office/drawing/2014/main" id="{56EA329A-2C59-45D9-92C6-E90117F9BA8D}"/>
               </a:ext>
             </a:extLst>
           </p:cNvPr>
@@ -7291,7 +7291,7 @@
           <p:cNvPr id="6" name="s5-rail-title-0">
             <a:extLst xmlns:a="http://schemas.openxmlformats.org/drawingml/2006/main">
               <a:ext uri="{FF2B5EF4-FFF2-40B4-BE49-F238E27FC236}">
-                <a16:creationId xmlns:a16="http://schemas.microsoft.com/office/drawing/2014/main" id="{0D815549-9020-4534-8C7B-DE03562C5F0E}"/>
+                <a16:creationId xmlns:a16="http://schemas.microsoft.com/office/drawing/2014/main" id="{205570F1-D0E4-45EA-8779-A6359945031F}"/>
               </a:ext>
             </a:extLst>
           </p:cNvPr>
@@ -7347,7 +7347,7 @@
           <p:cNvPr id="7" name="s5-rail-stat-0">
             <a:extLst xmlns:a="http://schemas.openxmlformats.org/drawingml/2006/main">
               <a:ext uri="{FF2B5EF4-FFF2-40B4-BE49-F238E27FC236}">
-                <a16:creationId xmlns:a16="http://schemas.microsoft.com/office/drawing/2014/main" id="{DB62C4A8-5562-4894-9FBD-D8138508B6D4}"/>
+                <a16:creationId xmlns:a16="http://schemas.microsoft.com/office/drawing/2014/main" id="{2AD1F3EA-4B93-489C-A99C-0C9C436C3E3C}"/>
               </a:ext>
             </a:extLst>
           </p:cNvPr>
@@ -7393,7 +7393,7 @@
                 <a:ea typeface="Arial"/>
                 <a:cs typeface="Arial"/>
               </a:rPr>
-              <a:t>47.9% CM1</a:t>
+              <a:t>47.9% margin</a:t>
             </a:r>
           </a:p>
         </p:txBody>
@@ -7403,7 +7403,7 @@
           <p:cNvPr id="8" name="s5-rail-detail-0">
             <a:extLst xmlns:a="http://schemas.openxmlformats.org/drawingml/2006/main">
               <a:ext uri="{FF2B5EF4-FFF2-40B4-BE49-F238E27FC236}">
-                <a16:creationId xmlns:a16="http://schemas.microsoft.com/office/drawing/2014/main" id="{8F7606D7-9208-4F16-8788-136D58E3D8B6}"/>
+                <a16:creationId xmlns:a16="http://schemas.microsoft.com/office/drawing/2014/main" id="{B004B049-81D8-4694-B628-C90A9A611476}"/>
               </a:ext>
             </a:extLst>
           </p:cNvPr>
@@ -7459,7 +7459,7 @@
           <p:cNvPr id="9" name="s5-rail-1">
             <a:extLst xmlns:a="http://schemas.openxmlformats.org/drawingml/2006/main">
               <a:ext uri="{FF2B5EF4-FFF2-40B4-BE49-F238E27FC236}">
-                <a16:creationId xmlns:a16="http://schemas.microsoft.com/office/drawing/2014/main" id="{2F3DCFE2-95A3-4ACC-8163-7FE612B6CD1E}"/>
+                <a16:creationId xmlns:a16="http://schemas.microsoft.com/office/drawing/2014/main" id="{E39EEA27-3FFF-4D5C-8BB9-65CB23E8B8F9}"/>
               </a:ext>
             </a:extLst>
           </p:cNvPr>
@@ -7490,7 +7490,7 @@
           <p:cNvPr id="10" name="s5-rail-title-1">
             <a:extLst xmlns:a="http://schemas.openxmlformats.org/drawingml/2006/main">
               <a:ext uri="{FF2B5EF4-FFF2-40B4-BE49-F238E27FC236}">
-                <a16:creationId xmlns:a16="http://schemas.microsoft.com/office/drawing/2014/main" id="{62F53F59-509B-4346-AB11-230C9D97834A}"/>
+                <a16:creationId xmlns:a16="http://schemas.microsoft.com/office/drawing/2014/main" id="{B90879C1-BED2-423E-9AED-CAE7D490BA72}"/>
               </a:ext>
             </a:extLst>
           </p:cNvPr>
@@ -7546,7 +7546,7 @@
           <p:cNvPr id="11" name="s5-rail-stat-1">
             <a:extLst xmlns:a="http://schemas.openxmlformats.org/drawingml/2006/main">
               <a:ext uri="{FF2B5EF4-FFF2-40B4-BE49-F238E27FC236}">
-                <a16:creationId xmlns:a16="http://schemas.microsoft.com/office/drawing/2014/main" id="{3E63FFCE-E2DF-4E4B-AAD5-072F379F1C53}"/>
+                <a16:creationId xmlns:a16="http://schemas.microsoft.com/office/drawing/2014/main" id="{EA79212C-18D1-40F7-9F4B-2BF79692E050}"/>
               </a:ext>
             </a:extLst>
           </p:cNvPr>
@@ -7592,7 +7592,7 @@
                 <a:ea typeface="Arial"/>
                 <a:cs typeface="Arial"/>
               </a:rPr>
-              <a:t>$22.0K CM1</a:t>
+              <a:t>$22.0K</a:t>
             </a:r>
           </a:p>
         </p:txBody>
@@ -7602,7 +7602,7 @@
           <p:cNvPr id="12" name="s5-rail-detail-1">
             <a:extLst xmlns:a="http://schemas.openxmlformats.org/drawingml/2006/main">
               <a:ext uri="{FF2B5EF4-FFF2-40B4-BE49-F238E27FC236}">
-                <a16:creationId xmlns:a16="http://schemas.microsoft.com/office/drawing/2014/main" id="{79CFB034-E138-4377-B4B7-BAE559211DD1}"/>
+                <a16:creationId xmlns:a16="http://schemas.microsoft.com/office/drawing/2014/main" id="{5EC32FC1-2F2C-4055-A3FE-104A957D475F}"/>
               </a:ext>
             </a:extLst>
           </p:cNvPr>
@@ -7648,7 +7648,7 @@
                 <a:ea typeface="Arial"/>
                 <a:cs typeface="Arial"/>
               </a:rPr>
-              <a:t>Largest profit pool; protect whey and creatine availability</a:t>
+              <a:t>Largest contribution margin; protect whey and creatine availability</a:t>
             </a:r>
           </a:p>
         </p:txBody>
@@ -7658,7 +7658,7 @@
           <p:cNvPr id="13" name="s5-rail-2">
             <a:extLst xmlns:a="http://schemas.openxmlformats.org/drawingml/2006/main">
               <a:ext uri="{FF2B5EF4-FFF2-40B4-BE49-F238E27FC236}">
-                <a16:creationId xmlns:a16="http://schemas.microsoft.com/office/drawing/2014/main" id="{669FAC41-FFAE-4853-B37B-378D52AB3524}"/>
+                <a16:creationId xmlns:a16="http://schemas.microsoft.com/office/drawing/2014/main" id="{AB48CB32-C1A8-4DA1-A6F4-14A14DD8F15C}"/>
               </a:ext>
             </a:extLst>
           </p:cNvPr>
@@ -7689,7 +7689,7 @@
           <p:cNvPr id="14" name="s5-rail-title-2">
             <a:extLst xmlns:a="http://schemas.openxmlformats.org/drawingml/2006/main">
               <a:ext uri="{FF2B5EF4-FFF2-40B4-BE49-F238E27FC236}">
-                <a16:creationId xmlns:a16="http://schemas.microsoft.com/office/drawing/2014/main" id="{0883BCC8-6A05-4283-9EFA-C844E1CD63F3}"/>
+                <a16:creationId xmlns:a16="http://schemas.microsoft.com/office/drawing/2014/main" id="{4DAB305B-87AC-44CA-9BBE-1F4633993AF4}"/>
               </a:ext>
             </a:extLst>
           </p:cNvPr>
@@ -7745,7 +7745,7 @@
           <p:cNvPr id="15" name="s5-rail-stat-2">
             <a:extLst xmlns:a="http://schemas.openxmlformats.org/drawingml/2006/main">
               <a:ext uri="{FF2B5EF4-FFF2-40B4-BE49-F238E27FC236}">
-                <a16:creationId xmlns:a16="http://schemas.microsoft.com/office/drawing/2014/main" id="{7C081982-2767-404B-86F3-D6874AC66529}"/>
+                <a16:creationId xmlns:a16="http://schemas.microsoft.com/office/drawing/2014/main" id="{35888AC2-FE0F-44C0-870F-F1510D856A1B}"/>
               </a:ext>
             </a:extLst>
           </p:cNvPr>
@@ -7791,7 +7791,7 @@
                 <a:ea typeface="Arial"/>
                 <a:cs typeface="Arial"/>
               </a:rPr>
-              <a:t>25.6% CM1</a:t>
+              <a:t>25.6% margin</a:t>
             </a:r>
           </a:p>
         </p:txBody>
@@ -7801,7 +7801,7 @@
           <p:cNvPr id="16" name="s5-rail-detail-2">
             <a:extLst xmlns:a="http://schemas.openxmlformats.org/drawingml/2006/main">
               <a:ext uri="{FF2B5EF4-FFF2-40B4-BE49-F238E27FC236}">
-                <a16:creationId xmlns:a16="http://schemas.microsoft.com/office/drawing/2014/main" id="{14E244D6-D29C-4372-998E-6AC291CC45F0}"/>
+                <a16:creationId xmlns:a16="http://schemas.microsoft.com/office/drawing/2014/main" id="{118C79D7-7272-4A55-B5AD-98BD7CFD183A}"/>
               </a:ext>
             </a:extLst>
           </p:cNvPr>
@@ -7855,7 +7855,7 @@
     </p:spTree>
     <p:extLst>
       <p:ext uri="{BB962C8B-B14F-4D97-AF65-F5344CB8AC3E}">
-        <p14:creationId xmlns:p14="http://schemas.microsoft.com/office/powerpoint/2010/main" val="1774666662"/>
+        <p14:creationId xmlns:p14="http://schemas.microsoft.com/office/powerpoint/2010/main" val="1955466966"/>
       </p:ext>
     </p:extLst>
   </p:cSld>
@@ -7886,7 +7886,7 @@
           <p:cNvPr id="11" name="eyebrow-6">
             <a:extLst xmlns:a="http://schemas.openxmlformats.org/drawingml/2006/main">
               <a:ext uri="{FF2B5EF4-FFF2-40B4-BE49-F238E27FC236}">
-                <a16:creationId xmlns:a16="http://schemas.microsoft.com/office/drawing/2014/main" id="{7A0E267B-4EAD-4258-84A3-7DEF99BFFB7B}"/>
+                <a16:creationId xmlns:a16="http://schemas.microsoft.com/office/drawing/2014/main" id="{24B838DA-0D1F-4A8A-8BA2-65DE0910430F}"/>
               </a:ext>
             </a:extLst>
           </p:cNvPr>
@@ -7932,7 +7932,7 @@
                 <a:ea typeface="Arial"/>
                 <a:cs typeface="Arial"/>
               </a:rPr>
-              <a:t>PROFITABILITY BY SKU</a:t>
+              <a:t>SKU PROFITABILITY</a:t>
             </a:r>
           </a:p>
         </p:txBody>
@@ -7942,7 +7942,7 @@
           <p:cNvPr id="2" name="title-6">
             <a:extLst xmlns:a="http://schemas.openxmlformats.org/drawingml/2006/main">
               <a:ext uri="{FF2B5EF4-FFF2-40B4-BE49-F238E27FC236}">
-                <a16:creationId xmlns:a16="http://schemas.microsoft.com/office/drawing/2014/main" id="{E506476C-7897-4117-9370-3F3AE5C4B5D8}"/>
+                <a16:creationId xmlns:a16="http://schemas.microsoft.com/office/drawing/2014/main" id="{F6D64C9D-6A3F-4AA7-8F08-A898F7448938}"/>
               </a:ext>
             </a:extLst>
           </p:cNvPr>
@@ -7988,7 +7988,7 @@
                 <a:ea typeface="Arial"/>
                 <a:cs typeface="Arial"/>
               </a:rPr>
-              <a:t>Two SKUs drive 28% of CM1</a:t>
+              <a:t>Two SKUs drive 28% of contribution margin</a:t>
             </a:r>
           </a:p>
         </p:txBody>
@@ -7998,7 +7998,7 @@
           <p:cNvPr id="3" name="footer-6">
             <a:extLst xmlns:a="http://schemas.openxmlformats.org/drawingml/2006/main">
               <a:ext uri="{FF2B5EF4-FFF2-40B4-BE49-F238E27FC236}">
-                <a16:creationId xmlns:a16="http://schemas.microsoft.com/office/drawing/2014/main" id="{199AE8B4-A5D0-4F93-8D58-6D6A7C367689}"/>
+                <a16:creationId xmlns:a16="http://schemas.microsoft.com/office/drawing/2014/main" id="{9CF8476B-B645-492C-9D3E-1D573DC139B8}"/>
               </a:ext>
             </a:extLst>
           </p:cNvPr>
@@ -8061,7 +8061,7 @@
         </p:xfrm>
         <a:graphic xmlns:a="http://schemas.openxmlformats.org/drawingml/2006/main">
           <a:graphicData uri="http://schemas.openxmlformats.org/drawingml/2006/chart">
-            <c:chart xmlns:r="http://schemas.openxmlformats.org/officeDocument/2006/relationships" xmlns:c="http://schemas.openxmlformats.org/drawingml/2006/chart" r:id="R7771e4135cca4d28"/>
+            <c:chart xmlns:r="http://schemas.openxmlformats.org/officeDocument/2006/relationships" xmlns:c="http://schemas.openxmlformats.org/drawingml/2006/chart" r:id="Ra137e4bf29314e72"/>
           </a:graphicData>
         </a:graphic>
       </p:graphicFrame>
@@ -8070,7 +8070,7 @@
           <p:cNvPr id="5" name="s6-callout-a">
             <a:extLst xmlns:a="http://schemas.openxmlformats.org/drawingml/2006/main">
               <a:ext uri="{FF2B5EF4-FFF2-40B4-BE49-F238E27FC236}">
-                <a16:creationId xmlns:a16="http://schemas.microsoft.com/office/drawing/2014/main" id="{56EAE49D-8129-4515-9A7C-60879D1BD33F}"/>
+                <a16:creationId xmlns:a16="http://schemas.microsoft.com/office/drawing/2014/main" id="{D3EE9B48-9E7B-440D-B3AD-705F03DEB8B2}"/>
               </a:ext>
             </a:extLst>
           </p:cNvPr>
@@ -8101,19 +8101,19 @@
           <p:cNvPr id="6" name="s6-callout-a-title">
             <a:extLst xmlns:a="http://schemas.openxmlformats.org/drawingml/2006/main">
               <a:ext uri="{FF2B5EF4-FFF2-40B4-BE49-F238E27FC236}">
-                <a16:creationId xmlns:a16="http://schemas.microsoft.com/office/drawing/2014/main" id="{2214EA55-719D-4D3E-B8F8-BABE59F0F5BA}"/>
-              </a:ext>
-            </a:extLst>
-          </p:cNvPr>
-          <p:cNvSpPr>
-            <a:spLocks xmlns:a="http://schemas.openxmlformats.org/drawingml/2006/main" noGrp="1"/>
-          </p:cNvSpPr>
-          <p:nvPr/>
-        </p:nvSpPr>
-        <p:spPr>
-          <a:xfrm xmlns:a="http://schemas.openxmlformats.org/drawingml/2006/main">
-            <a:off x="8515350" y="2019300"/>
-            <a:ext cx="2876550" cy="533400"/>
+                <a16:creationId xmlns:a16="http://schemas.microsoft.com/office/drawing/2014/main" id="{AFC2CC02-C1AF-4576-8D97-D4A857698AE9}"/>
+              </a:ext>
+            </a:extLst>
+          </p:cNvPr>
+          <p:cNvSpPr>
+            <a:spLocks xmlns:a="http://schemas.openxmlformats.org/drawingml/2006/main" noGrp="1"/>
+          </p:cNvSpPr>
+          <p:nvPr/>
+        </p:nvSpPr>
+        <p:spPr>
+          <a:xfrm xmlns:a="http://schemas.openxmlformats.org/drawingml/2006/main">
+            <a:off x="8515350" y="1981200"/>
+            <a:ext cx="2876550" cy="723900"/>
           </a:xfrm>
           <a:prstGeom xmlns:a="http://schemas.openxmlformats.org/drawingml/2006/main" prst="rect">
             <a:avLst/>
@@ -8129,7 +8129,7 @@
           <a:lstStyle xmlns:a="http://schemas.openxmlformats.org/drawingml/2006/main"/>
           <a:p xmlns:a="http://schemas.openxmlformats.org/drawingml/2006/main">
             <a:pPr algn="ctr">
-              <a:defRPr sz="2850" b="1">
+              <a:defRPr sz="2250" b="1">
                 <a:solidFill>
                   <a:srgbClr val="0B7A53"/>
                 </a:solidFill>
@@ -8139,7 +8139,7 @@
               </a:defRPr>
             </a:pPr>
             <a:r>
-              <a:rPr sz="2850" b="1">
+              <a:rPr sz="2250" b="1">
                 <a:solidFill>
                   <a:srgbClr val="0B7A53"/>
                 </a:solidFill>
@@ -8147,7 +8147,7 @@
                 <a:ea typeface="Arial"/>
                 <a:cs typeface="Arial"/>
               </a:rPr>
-              <a:t>$14.1K CM1</a:t>
+              <a:t>$14.1K contribution</a:t>
             </a:r>
           </a:p>
         </p:txBody>
@@ -8157,7 +8157,7 @@
           <p:cNvPr id="7" name="s6-callout-a-body">
             <a:extLst xmlns:a="http://schemas.openxmlformats.org/drawingml/2006/main">
               <a:ext uri="{FF2B5EF4-FFF2-40B4-BE49-F238E27FC236}">
-                <a16:creationId xmlns:a16="http://schemas.microsoft.com/office/drawing/2014/main" id="{F72868F9-4559-4D35-9998-C044E430A999}"/>
+                <a16:creationId xmlns:a16="http://schemas.microsoft.com/office/drawing/2014/main" id="{F290516D-E2B2-410E-B204-879BA673F7BA}"/>
               </a:ext>
             </a:extLst>
           </p:cNvPr>
@@ -8226,7 +8226,7 @@
                 <a:ea typeface="Arial"/>
                 <a:cs typeface="Arial"/>
               </a:rPr>
-              <a:t>= 27.6% of total CM1</a:t>
+              <a:t>= 27.6% of total</a:t>
             </a:r>
           </a:p>
         </p:txBody>
@@ -8236,7 +8236,7 @@
           <p:cNvPr id="8" name="s6-callout-b">
             <a:extLst xmlns:a="http://schemas.openxmlformats.org/drawingml/2006/main">
               <a:ext uri="{FF2B5EF4-FFF2-40B4-BE49-F238E27FC236}">
-                <a16:creationId xmlns:a16="http://schemas.microsoft.com/office/drawing/2014/main" id="{7B3D5554-B8F4-403E-B67A-FE7F3E156B69}"/>
+                <a16:creationId xmlns:a16="http://schemas.microsoft.com/office/drawing/2014/main" id="{21CDD029-C791-4C60-91F5-B51BF76238E6}"/>
               </a:ext>
             </a:extLst>
           </p:cNvPr>
@@ -8267,7 +8267,7 @@
           <p:cNvPr id="9" name="s6-callout-b-title">
             <a:extLst xmlns:a="http://schemas.openxmlformats.org/drawingml/2006/main">
               <a:ext uri="{FF2B5EF4-FFF2-40B4-BE49-F238E27FC236}">
-                <a16:creationId xmlns:a16="http://schemas.microsoft.com/office/drawing/2014/main" id="{E49D7AE9-385D-4B36-983C-108631074112}"/>
+                <a16:creationId xmlns:a16="http://schemas.microsoft.com/office/drawing/2014/main" id="{CE4809F0-9E6F-43DE-AA8B-BFB431C0BAD7}"/>
               </a:ext>
             </a:extLst>
           </p:cNvPr>
@@ -8323,7 +8323,7 @@
           <p:cNvPr id="10" name="s6-callout-b-body">
             <a:extLst xmlns:a="http://schemas.openxmlformats.org/drawingml/2006/main">
               <a:ext uri="{FF2B5EF4-FFF2-40B4-BE49-F238E27FC236}">
-                <a16:creationId xmlns:a16="http://schemas.microsoft.com/office/drawing/2014/main" id="{6378E184-B20F-4311-80C6-3F952972EE01}"/>
+                <a16:creationId xmlns:a16="http://schemas.microsoft.com/office/drawing/2014/main" id="{B412F181-31D8-4064-815B-5E005BAF2A38}"/>
               </a:ext>
             </a:extLst>
           </p:cNvPr>
@@ -8369,7 +8369,7 @@
                 <a:ea typeface="Arial"/>
                 <a:cs typeface="Arial"/>
               </a:rPr>
-              <a:t>GT-LIP-BALM and PH-TOY-ROPE-L use brand-median cost. Together: 2.3% of gross sales, but only 2.6% and 6.3% estimated CM1 rates.</a:t>
+              <a:t>GT-LIP-BALM and PH-TOY-ROPE-L use brand-median cost. Together: 2.3% of gross sales, with estimated margins of 2.6% and 6.3%.</a:t>
             </a:r>
           </a:p>
         </p:txBody>
@@ -8377,7 +8377,7 @@
     </p:spTree>
     <p:extLst>
       <p:ext uri="{BB962C8B-B14F-4D97-AF65-F5344CB8AC3E}">
-        <p14:creationId xmlns:p14="http://schemas.microsoft.com/office/powerpoint/2010/main" val="1399357563"/>
+        <p14:creationId xmlns:p14="http://schemas.microsoft.com/office/powerpoint/2010/main" val="227436902"/>
       </p:ext>
     </p:extLst>
   </p:cSld>
@@ -8408,7 +8408,7 @@
           <p:cNvPr id="11" name="eyebrow-7">
             <a:extLst xmlns:a="http://schemas.openxmlformats.org/drawingml/2006/main">
               <a:ext uri="{FF2B5EF4-FFF2-40B4-BE49-F238E27FC236}">
-                <a16:creationId xmlns:a16="http://schemas.microsoft.com/office/drawing/2014/main" id="{6C2F059B-7BA9-4FEB-A571-80E87526D736}"/>
+                <a16:creationId xmlns:a16="http://schemas.microsoft.com/office/drawing/2014/main" id="{5AF2F23D-C1A5-4DF3-ACF0-B32FC1465E47}"/>
               </a:ext>
             </a:extLst>
           </p:cNvPr>
@@ -8454,7 +8454,7 @@
                 <a:ea typeface="Arial"/>
                 <a:cs typeface="Arial"/>
               </a:rPr>
-              <a:t>BELOW-CM PLATFORM OVERHEAD</a:t>
+              <a:t>PLATFORM COSTS</a:t>
             </a:r>
           </a:p>
         </p:txBody>
@@ -8464,7 +8464,7 @@
           <p:cNvPr id="2" name="title-7">
             <a:extLst xmlns:a="http://schemas.openxmlformats.org/drawingml/2006/main">
               <a:ext uri="{FF2B5EF4-FFF2-40B4-BE49-F238E27FC236}">
-                <a16:creationId xmlns:a16="http://schemas.microsoft.com/office/drawing/2014/main" id="{94DF72DC-DF66-4440-B609-DF8A831AE6D9}"/>
+                <a16:creationId xmlns:a16="http://schemas.microsoft.com/office/drawing/2014/main" id="{CBEA015C-2CD9-4D69-822D-53012C817FBF}"/>
               </a:ext>
             </a:extLst>
           </p:cNvPr>
@@ -8510,7 +8510,7 @@
                 <a:ea typeface="Arial"/>
                 <a:cs typeface="Arial"/>
               </a:rPr>
-              <a:t>Advertising consumes 98.7% of CM1—and storage pushes the quarter further negative</a:t>
+              <a:t>Advertising equals 98.7% of contribution margin; storage increases the loss</a:t>
             </a:r>
           </a:p>
         </p:txBody>
@@ -8520,7 +8520,7 @@
           <p:cNvPr id="3" name="footer-7">
             <a:extLst xmlns:a="http://schemas.openxmlformats.org/drawingml/2006/main">
               <a:ext uri="{FF2B5EF4-FFF2-40B4-BE49-F238E27FC236}">
-                <a16:creationId xmlns:a16="http://schemas.microsoft.com/office/drawing/2014/main" id="{28DA2E30-C563-4B52-851D-E37D6B76DABC}"/>
+                <a16:creationId xmlns:a16="http://schemas.microsoft.com/office/drawing/2014/main" id="{26690886-22B0-45B9-B31C-774D26913109}"/>
               </a:ext>
             </a:extLst>
           </p:cNvPr>
@@ -8583,7 +8583,7 @@
         </p:xfrm>
         <a:graphic xmlns:a="http://schemas.openxmlformats.org/drawingml/2006/main">
           <a:graphicData uri="http://schemas.openxmlformats.org/drawingml/2006/chart">
-            <c:chart xmlns:r="http://schemas.openxmlformats.org/officeDocument/2006/relationships" xmlns:c="http://schemas.openxmlformats.org/drawingml/2006/chart" r:id="R75d248f3a40f47cc"/>
+            <c:chart xmlns:r="http://schemas.openxmlformats.org/officeDocument/2006/relationships" xmlns:c="http://schemas.openxmlformats.org/drawingml/2006/chart" r:id="R3026d7b1fd584efb"/>
           </a:graphicData>
         </a:graphic>
       </p:graphicFrame>
@@ -8592,7 +8592,7 @@
           <p:cNvPr id="5" name="s7-decision">
             <a:extLst xmlns:a="http://schemas.openxmlformats.org/drawingml/2006/main">
               <a:ext uri="{FF2B5EF4-FFF2-40B4-BE49-F238E27FC236}">
-                <a16:creationId xmlns:a16="http://schemas.microsoft.com/office/drawing/2014/main" id="{8D980CA6-6CB1-4D4A-8AD9-E3DABBA162E3}"/>
+                <a16:creationId xmlns:a16="http://schemas.microsoft.com/office/drawing/2014/main" id="{BF5897EF-870A-48F6-B444-39423B158F6D}"/>
               </a:ext>
             </a:extLst>
           </p:cNvPr>
@@ -8623,7 +8623,7 @@
           <p:cNvPr id="6" name="s7-decision-stat">
             <a:extLst xmlns:a="http://schemas.openxmlformats.org/drawingml/2006/main">
               <a:ext uri="{FF2B5EF4-FFF2-40B4-BE49-F238E27FC236}">
-                <a16:creationId xmlns:a16="http://schemas.microsoft.com/office/drawing/2014/main" id="{84039444-B310-4CAA-AD5E-B895EF593509}"/>
+                <a16:creationId xmlns:a16="http://schemas.microsoft.com/office/drawing/2014/main" id="{EA502461-93C3-41A7-8A33-0CA01DDDBE57}"/>
               </a:ext>
             </a:extLst>
           </p:cNvPr>
@@ -8679,7 +8679,7 @@
           <p:cNvPr id="7" name="s7-decision-label">
             <a:extLst xmlns:a="http://schemas.openxmlformats.org/drawingml/2006/main">
               <a:ext uri="{FF2B5EF4-FFF2-40B4-BE49-F238E27FC236}">
-                <a16:creationId xmlns:a16="http://schemas.microsoft.com/office/drawing/2014/main" id="{02A130BA-45C7-4BF1-91A5-7738F0E83347}"/>
+                <a16:creationId xmlns:a16="http://schemas.microsoft.com/office/drawing/2014/main" id="{AF91112F-05D6-4419-A03E-B314F9864BC8}"/>
               </a:ext>
             </a:extLst>
           </p:cNvPr>
@@ -8725,7 +8725,7 @@
                 <a:ea typeface="Arial"/>
                 <a:cs typeface="Arial"/>
               </a:rPr>
-              <a:t>After platform overhead</a:t>
+              <a:t>After platform costs</a:t>
             </a:r>
           </a:p>
         </p:txBody>
@@ -8735,7 +8735,7 @@
           <p:cNvPr id="8" name="s7-action">
             <a:extLst xmlns:a="http://schemas.openxmlformats.org/drawingml/2006/main">
               <a:ext uri="{FF2B5EF4-FFF2-40B4-BE49-F238E27FC236}">
-                <a16:creationId xmlns:a16="http://schemas.microsoft.com/office/drawing/2014/main" id="{622248F0-0C9F-447B-B43F-5FA35EC10E6B}"/>
+                <a16:creationId xmlns:a16="http://schemas.microsoft.com/office/drawing/2014/main" id="{1C609D27-CDC3-4A46-95CC-BBABB8E5EE81}"/>
               </a:ext>
             </a:extLst>
           </p:cNvPr>
@@ -8766,7 +8766,7 @@
           <p:cNvPr id="9" name="s7-action-title">
             <a:extLst xmlns:a="http://schemas.openxmlformats.org/drawingml/2006/main">
               <a:ext uri="{FF2B5EF4-FFF2-40B4-BE49-F238E27FC236}">
-                <a16:creationId xmlns:a16="http://schemas.microsoft.com/office/drawing/2014/main" id="{39C4C9A8-43E2-4FB1-9CC2-C39F14CC6CB5}"/>
+                <a16:creationId xmlns:a16="http://schemas.microsoft.com/office/drawing/2014/main" id="{21E37B9A-B604-4705-A01C-5B524B2FDE18}"/>
               </a:ext>
             </a:extLst>
           </p:cNvPr>
@@ -8822,7 +8822,7 @@
           <p:cNvPr id="10" name="s7-action-body">
             <a:extLst xmlns:a="http://schemas.openxmlformats.org/drawingml/2006/main">
               <a:ext uri="{FF2B5EF4-FFF2-40B4-BE49-F238E27FC236}">
-                <a16:creationId xmlns:a16="http://schemas.microsoft.com/office/drawing/2014/main" id="{FDDF0983-635D-44E3-971B-8AD77FEEBD0E}"/>
+                <a16:creationId xmlns:a16="http://schemas.microsoft.com/office/drawing/2014/main" id="{E9916C3E-2ADD-4743-8AA3-117639B2C325}"/>
               </a:ext>
             </a:extLst>
           </p:cNvPr>
@@ -8868,7 +8868,7 @@
                 <a:ea typeface="Arial"/>
                 <a:cs typeface="Arial"/>
               </a:rPr>
-              <a:t>Ingest campaign + advertised-SKU detail. Govern spend to CM after ads—not revenue or ROAS alone. Add SKU storage detail before allocating carrying cost.</a:t>
+              <a:t>Add campaign and advertised-SKU detail. Evaluate spend against profit after advertising, not revenue or ROAS alone. Add SKU storage detail before allocating carrying cost.</a:t>
             </a:r>
           </a:p>
         </p:txBody>
@@ -8876,7 +8876,7 @@
     </p:spTree>
     <p:extLst>
       <p:ext uri="{BB962C8B-B14F-4D97-AF65-F5344CB8AC3E}">
-        <p14:creationId xmlns:p14="http://schemas.microsoft.com/office/powerpoint/2010/main" val="1170761726"/>
+        <p14:creationId xmlns:p14="http://schemas.microsoft.com/office/powerpoint/2010/main" val="189774052"/>
       </p:ext>
     </p:extLst>
   </p:cSld>
@@ -8907,7 +8907,7 @@
           <p:cNvPr id="11" name="eyebrow-8">
             <a:extLst xmlns:a="http://schemas.openxmlformats.org/drawingml/2006/main">
               <a:ext uri="{FF2B5EF4-FFF2-40B4-BE49-F238E27FC236}">
-                <a16:creationId xmlns:a16="http://schemas.microsoft.com/office/drawing/2014/main" id="{7C5BA9BE-BBC5-4346-B4A9-0F1E981936B7}"/>
+                <a16:creationId xmlns:a16="http://schemas.microsoft.com/office/drawing/2014/main" id="{5435FC9A-CE3F-477F-939D-31EFD77799F4}"/>
               </a:ext>
             </a:extLst>
           </p:cNvPr>
@@ -8963,7 +8963,7 @@
           <p:cNvPr id="2" name="title-8">
             <a:extLst xmlns:a="http://schemas.openxmlformats.org/drawingml/2006/main">
               <a:ext uri="{FF2B5EF4-FFF2-40B4-BE49-F238E27FC236}">
-                <a16:creationId xmlns:a16="http://schemas.microsoft.com/office/drawing/2014/main" id="{5FEB1C03-20DC-4C97-A9AF-1B77136532DA}"/>
+                <a16:creationId xmlns:a16="http://schemas.microsoft.com/office/drawing/2014/main" id="{28DCC81A-0FAD-4058-AC9C-FCC958EC6965}"/>
               </a:ext>
             </a:extLst>
           </p:cNvPr>
@@ -9019,7 +9019,7 @@
           <p:cNvPr id="3" name="footer-8">
             <a:extLst xmlns:a="http://schemas.openxmlformats.org/drawingml/2006/main">
               <a:ext uri="{FF2B5EF4-FFF2-40B4-BE49-F238E27FC236}">
-                <a16:creationId xmlns:a16="http://schemas.microsoft.com/office/drawing/2014/main" id="{6FA52589-14C2-4A82-886E-89B6ED1BE881}"/>
+                <a16:creationId xmlns:a16="http://schemas.microsoft.com/office/drawing/2014/main" id="{1E0684CA-DAE2-4DB9-9820-D1D2CA73BB93}"/>
               </a:ext>
             </a:extLst>
           </p:cNvPr>
@@ -9075,7 +9075,7 @@
           <p:cNvPr id="4" name="s8-intro">
             <a:extLst xmlns:a="http://schemas.openxmlformats.org/drawingml/2006/main">
               <a:ext uri="{FF2B5EF4-FFF2-40B4-BE49-F238E27FC236}">
-                <a16:creationId xmlns:a16="http://schemas.microsoft.com/office/drawing/2014/main" id="{3BB6CB81-5DAE-4C3E-A8F6-5C3D05204AC3}"/>
+                <a16:creationId xmlns:a16="http://schemas.microsoft.com/office/drawing/2014/main" id="{F502AC9D-35D3-40DB-90F7-3A2C8874DFFB}"/>
               </a:ext>
             </a:extLst>
           </p:cNvPr>
@@ -9131,7 +9131,7 @@
           <p:cNvPr id="5" name="s8-left-head">
             <a:extLst xmlns:a="http://schemas.openxmlformats.org/drawingml/2006/main">
               <a:ext uri="{FF2B5EF4-FFF2-40B4-BE49-F238E27FC236}">
-                <a16:creationId xmlns:a16="http://schemas.microsoft.com/office/drawing/2014/main" id="{0A157C61-A90F-4146-8D5F-FDACB396FD13}"/>
+                <a16:creationId xmlns:a16="http://schemas.microsoft.com/office/drawing/2014/main" id="{788DBCE4-DF28-4382-849D-C7FE21A9E8A2}"/>
               </a:ext>
             </a:extLst>
           </p:cNvPr>
@@ -9187,7 +9187,7 @@
           <p:cNvPr id="6" name="s8-right-head">
             <a:extLst xmlns:a="http://schemas.openxmlformats.org/drawingml/2006/main">
               <a:ext uri="{FF2B5EF4-FFF2-40B4-BE49-F238E27FC236}">
-                <a16:creationId xmlns:a16="http://schemas.microsoft.com/office/drawing/2014/main" id="{1A09494E-4ACD-42C1-9135-09014E670D86}"/>
+                <a16:creationId xmlns:a16="http://schemas.microsoft.com/office/drawing/2014/main" id="{3A86E507-7D0F-41EE-829F-227A4867FB40}"/>
               </a:ext>
             </a:extLst>
           </p:cNvPr>
@@ -10061,7 +10061,7 @@
           <p:cNvPr id="9" name="s8-bottom">
             <a:extLst xmlns:a="http://schemas.openxmlformats.org/drawingml/2006/main">
               <a:ext uri="{FF2B5EF4-FFF2-40B4-BE49-F238E27FC236}">
-                <a16:creationId xmlns:a16="http://schemas.microsoft.com/office/drawing/2014/main" id="{8980F26F-0384-4F25-AA5F-FD7CCDF7B97C}"/>
+                <a16:creationId xmlns:a16="http://schemas.microsoft.com/office/drawing/2014/main" id="{3B5F7A5F-3A8B-4BC1-996B-5D6834D181B0}"/>
               </a:ext>
             </a:extLst>
           </p:cNvPr>
@@ -10092,7 +10092,7 @@
           <p:cNvPr id="10" name="s8-bottom-text">
             <a:extLst xmlns:a="http://schemas.openxmlformats.org/drawingml/2006/main">
               <a:ext uri="{FF2B5EF4-FFF2-40B4-BE49-F238E27FC236}">
-                <a16:creationId xmlns:a16="http://schemas.microsoft.com/office/drawing/2014/main" id="{AEAEB15B-4388-4EC1-BB9B-C9CB9B63457E}"/>
+                <a16:creationId xmlns:a16="http://schemas.microsoft.com/office/drawing/2014/main" id="{3DE06FED-C4E8-4245-81C7-E7DC6B94685C}"/>
               </a:ext>
             </a:extLst>
           </p:cNvPr>
@@ -10146,7 +10146,7 @@
     </p:spTree>
     <p:extLst>
       <p:ext uri="{BB962C8B-B14F-4D97-AF65-F5344CB8AC3E}">
-        <p14:creationId xmlns:p14="http://schemas.microsoft.com/office/powerpoint/2010/main" val="493063959"/>
+        <p14:creationId xmlns:p14="http://schemas.microsoft.com/office/powerpoint/2010/main" val="1219076764"/>
       </p:ext>
     </p:extLst>
   </p:cSld>
@@ -10177,7 +10177,7 @@
           <p:cNvPr id="20" name="eyebrow-9">
             <a:extLst xmlns:a="http://schemas.openxmlformats.org/drawingml/2006/main">
               <a:ext uri="{FF2B5EF4-FFF2-40B4-BE49-F238E27FC236}">
-                <a16:creationId xmlns:a16="http://schemas.microsoft.com/office/drawing/2014/main" id="{2F37A0FB-EB69-4490-A556-65AA371FFA9B}"/>
+                <a16:creationId xmlns:a16="http://schemas.microsoft.com/office/drawing/2014/main" id="{DC8BD624-7794-417C-B98E-CD22E3042AF2}"/>
               </a:ext>
             </a:extLst>
           </p:cNvPr>
@@ -10233,7 +10233,7 @@
           <p:cNvPr id="2" name="title-9">
             <a:extLst xmlns:a="http://schemas.openxmlformats.org/drawingml/2006/main">
               <a:ext uri="{FF2B5EF4-FFF2-40B4-BE49-F238E27FC236}">
-                <a16:creationId xmlns:a16="http://schemas.microsoft.com/office/drawing/2014/main" id="{6E121127-3D04-44C2-B737-32169406659F}"/>
+                <a16:creationId xmlns:a16="http://schemas.microsoft.com/office/drawing/2014/main" id="{D16FC3D1-5C25-4FE4-84D5-253DA50E1576}"/>
               </a:ext>
             </a:extLst>
           </p:cNvPr>
@@ -10279,7 +10279,7 @@
                 <a:ea typeface="Arial"/>
                 <a:cs typeface="Arial"/>
               </a:rPr>
-              <a:t>One 90-day plan, two ways to operate the same model</a:t>
+              <a:t>The first 30 days are the same under either implementation option</a:t>
             </a:r>
           </a:p>
         </p:txBody>
@@ -10289,7 +10289,7 @@
           <p:cNvPr id="3" name="footer-9">
             <a:extLst xmlns:a="http://schemas.openxmlformats.org/drawingml/2006/main">
               <a:ext uri="{FF2B5EF4-FFF2-40B4-BE49-F238E27FC236}">
-                <a16:creationId xmlns:a16="http://schemas.microsoft.com/office/drawing/2014/main" id="{438EA34B-6A0D-4CA0-9F94-B4643E6C9EB8}"/>
+                <a16:creationId xmlns:a16="http://schemas.microsoft.com/office/drawing/2014/main" id="{9C8A06D4-078B-4938-AA3A-A8B8E3D97C76}"/>
               </a:ext>
             </a:extLst>
           </p:cNvPr>
@@ -10345,7 +10345,7 @@
           <p:cNvPr id="4" name="s9-intro">
             <a:extLst xmlns:a="http://schemas.openxmlformats.org/drawingml/2006/main">
               <a:ext uri="{FF2B5EF4-FFF2-40B4-BE49-F238E27FC236}">
-                <a16:creationId xmlns:a16="http://schemas.microsoft.com/office/drawing/2014/main" id="{CDDC9FFC-9959-4C11-ADF1-C6915F26F8E2}"/>
+                <a16:creationId xmlns:a16="http://schemas.microsoft.com/office/drawing/2014/main" id="{BF261152-594B-4C78-8158-5FB8B00BCF17}"/>
               </a:ext>
             </a:extLst>
           </p:cNvPr>
@@ -10401,7 +10401,7 @@
           <p:cNvPr id="5" name="s9-phase-0">
             <a:extLst xmlns:a="http://schemas.openxmlformats.org/drawingml/2006/main">
               <a:ext uri="{FF2B5EF4-FFF2-40B4-BE49-F238E27FC236}">
-                <a16:creationId xmlns:a16="http://schemas.microsoft.com/office/drawing/2014/main" id="{A2090CB9-CB63-4A74-95FF-6A9B4DC6769A}"/>
+                <a16:creationId xmlns:a16="http://schemas.microsoft.com/office/drawing/2014/main" id="{CE3E27E0-56FE-4EE7-9349-2D294A47CB53}"/>
               </a:ext>
             </a:extLst>
           </p:cNvPr>
@@ -10434,7 +10434,7 @@
           <p:cNvPr id="6" name="s9-time-0">
             <a:extLst xmlns:a="http://schemas.openxmlformats.org/drawingml/2006/main">
               <a:ext uri="{FF2B5EF4-FFF2-40B4-BE49-F238E27FC236}">
-                <a16:creationId xmlns:a16="http://schemas.microsoft.com/office/drawing/2014/main" id="{588E101F-58F1-46BE-8EBC-58D0B99A4BF2}"/>
+                <a16:creationId xmlns:a16="http://schemas.microsoft.com/office/drawing/2014/main" id="{89251D59-C064-4115-A681-EA9178510891}"/>
               </a:ext>
             </a:extLst>
           </p:cNvPr>
@@ -10490,7 +10490,7 @@
           <p:cNvPr id="7" name="s9-title-0">
             <a:extLst xmlns:a="http://schemas.openxmlformats.org/drawingml/2006/main">
               <a:ext uri="{FF2B5EF4-FFF2-40B4-BE49-F238E27FC236}">
-                <a16:creationId xmlns:a16="http://schemas.microsoft.com/office/drawing/2014/main" id="{B89D79DD-4D59-4C0D-A988-95136AB0C618}"/>
+                <a16:creationId xmlns:a16="http://schemas.microsoft.com/office/drawing/2014/main" id="{47203970-3F16-4C91-BFAD-D5685F59D204}"/>
               </a:ext>
             </a:extLst>
           </p:cNvPr>
@@ -10546,7 +10546,7 @@
           <p:cNvPr id="8" name="s9-body-0">
             <a:extLst xmlns:a="http://schemas.openxmlformats.org/drawingml/2006/main">
               <a:ext uri="{FF2B5EF4-FFF2-40B4-BE49-F238E27FC236}">
-                <a16:creationId xmlns:a16="http://schemas.microsoft.com/office/drawing/2014/main" id="{C7E01113-3868-40D1-B61B-0F9C2E834FD9}"/>
+                <a16:creationId xmlns:a16="http://schemas.microsoft.com/office/drawing/2014/main" id="{9078AAE1-98CF-4B22-9515-81968472EC43}"/>
               </a:ext>
             </a:extLst>
           </p:cNvPr>
@@ -10592,7 +10592,7 @@
                 <a:ea typeface="Arial"/>
                 <a:cs typeface="Arial"/>
               </a:rPr>
-              <a:t>Schema drift + raw replay</a:t>
+              <a:t>Schema changes + raw history</a:t>
             </a:r>
           </a:p>
           <a:p xmlns:a="http://schemas.openxmlformats.org/drawingml/2006/main">
@@ -10615,7 +10615,7 @@
                 <a:ea typeface="Arial"/>
                 <a:cs typeface="Arial"/>
               </a:rPr>
-              <a:t>Product/UOM/identity bridge</a:t>
+              <a:t>Product/UOM mappings</a:t>
             </a:r>
           </a:p>
           <a:p xmlns:a="http://schemas.openxmlformats.org/drawingml/2006/main">
@@ -10638,7 +10638,7 @@
                 <a:ea typeface="Arial"/>
                 <a:cs typeface="Arial"/>
               </a:rPr>
-              <a:t>Dedup + amount gates</a:t>
+              <a:t>Duplicate + amount checks</a:t>
             </a:r>
           </a:p>
         </p:txBody>
@@ -10648,7 +10648,7 @@
           <p:cNvPr id="9" name="s9-output-0">
             <a:extLst xmlns:a="http://schemas.openxmlformats.org/drawingml/2006/main">
               <a:ext uri="{FF2B5EF4-FFF2-40B4-BE49-F238E27FC236}">
-                <a16:creationId xmlns:a16="http://schemas.microsoft.com/office/drawing/2014/main" id="{0F6C6952-C226-4A0B-AC3E-1D6FE65DBFE3}"/>
+                <a16:creationId xmlns:a16="http://schemas.microsoft.com/office/drawing/2014/main" id="{7104A2FB-E594-4722-8702-D1AE65AA8C8A}"/>
               </a:ext>
             </a:extLst>
           </p:cNvPr>
@@ -10694,7 +10694,7 @@
                 <a:ea typeface="Arial"/>
                 <a:cs typeface="Arial"/>
               </a:rPr>
-              <a:t>Same medallion model</a:t>
+              <a:t>Same BigQuery tables</a:t>
             </a:r>
           </a:p>
           <a:p xmlns:a="http://schemas.openxmlformats.org/drawingml/2006/main">
@@ -10717,7 +10717,7 @@
                 <a:ea typeface="Arial"/>
                 <a:cs typeface="Arial"/>
               </a:rPr>
-              <a:t>Same finance controls</a:t>
+              <a:t>Same finance checks</a:t>
             </a:r>
           </a:p>
         </p:txBody>
@@ -10727,7 +10727,7 @@
           <p:cNvPr id="10" name="s9-phase-1">
             <a:extLst xmlns:a="http://schemas.openxmlformats.org/drawingml/2006/main">
               <a:ext uri="{FF2B5EF4-FFF2-40B4-BE49-F238E27FC236}">
-                <a16:creationId xmlns:a16="http://schemas.microsoft.com/office/drawing/2014/main" id="{FE86BBBF-0AE3-4AA4-994D-047DB5CE4658}"/>
+                <a16:creationId xmlns:a16="http://schemas.microsoft.com/office/drawing/2014/main" id="{51FF7542-1DAB-4984-9B96-322EF0832832}"/>
               </a:ext>
             </a:extLst>
           </p:cNvPr>
@@ -10760,7 +10760,7 @@
           <p:cNvPr id="11" name="s9-time-1">
             <a:extLst xmlns:a="http://schemas.openxmlformats.org/drawingml/2006/main">
               <a:ext uri="{FF2B5EF4-FFF2-40B4-BE49-F238E27FC236}">
-                <a16:creationId xmlns:a16="http://schemas.microsoft.com/office/drawing/2014/main" id="{E1636103-AC98-4680-8037-C2C67A3DA43A}"/>
+                <a16:creationId xmlns:a16="http://schemas.microsoft.com/office/drawing/2014/main" id="{6CBCFABB-8664-4D98-9E1C-7B433A1A283A}"/>
               </a:ext>
             </a:extLst>
           </p:cNvPr>
@@ -10816,7 +10816,7 @@
           <p:cNvPr id="12" name="s9-title-1">
             <a:extLst xmlns:a="http://schemas.openxmlformats.org/drawingml/2006/main">
               <a:ext uri="{FF2B5EF4-FFF2-40B4-BE49-F238E27FC236}">
-                <a16:creationId xmlns:a16="http://schemas.microsoft.com/office/drawing/2014/main" id="{C8245F19-C2BC-4073-9B87-4186778705E7}"/>
+                <a16:creationId xmlns:a16="http://schemas.microsoft.com/office/drawing/2014/main" id="{D63137E0-E898-4463-A382-E4D002D5599A}"/>
               </a:ext>
             </a:extLst>
           </p:cNvPr>
@@ -10872,7 +10872,7 @@
           <p:cNvPr id="13" name="s9-body-1">
             <a:extLst xmlns:a="http://schemas.openxmlformats.org/drawingml/2006/main">
               <a:ext uri="{FF2B5EF4-FFF2-40B4-BE49-F238E27FC236}">
-                <a16:creationId xmlns:a16="http://schemas.microsoft.com/office/drawing/2014/main" id="{A27FC6F6-6A48-4506-A9BB-08B27BA0CBD1}"/>
+                <a16:creationId xmlns:a16="http://schemas.microsoft.com/office/drawing/2014/main" id="{8BE77F9A-D3A9-4869-ABEB-A40D34F0631A}"/>
               </a:ext>
             </a:extLst>
           </p:cNvPr>
@@ -10974,7 +10974,7 @@
           <p:cNvPr id="14" name="s9-output-1">
             <a:extLst xmlns:a="http://schemas.openxmlformats.org/drawingml/2006/main">
               <a:ext uri="{FF2B5EF4-FFF2-40B4-BE49-F238E27FC236}">
-                <a16:creationId xmlns:a16="http://schemas.microsoft.com/office/drawing/2014/main" id="{6C287174-ACD8-4F5F-9FB9-EF93F609115A}"/>
+                <a16:creationId xmlns:a16="http://schemas.microsoft.com/office/drawing/2014/main" id="{4F9CC90D-93BF-453A-BE1A-072CA6773683}"/>
               </a:ext>
             </a:extLst>
           </p:cNvPr>
@@ -11053,7 +11053,7 @@
           <p:cNvPr id="15" name="s9-phase-2">
             <a:extLst xmlns:a="http://schemas.openxmlformats.org/drawingml/2006/main">
               <a:ext uri="{FF2B5EF4-FFF2-40B4-BE49-F238E27FC236}">
-                <a16:creationId xmlns:a16="http://schemas.microsoft.com/office/drawing/2014/main" id="{CF7F9EB3-9015-4303-855F-DD3764FCCAEC}"/>
+                <a16:creationId xmlns:a16="http://schemas.microsoft.com/office/drawing/2014/main" id="{D5979142-3EF6-4343-A411-E7150CA4B0BD}"/>
               </a:ext>
             </a:extLst>
           </p:cNvPr>
@@ -11086,7 +11086,7 @@
           <p:cNvPr id="16" name="s9-time-2">
             <a:extLst xmlns:a="http://schemas.openxmlformats.org/drawingml/2006/main">
               <a:ext uri="{FF2B5EF4-FFF2-40B4-BE49-F238E27FC236}">
-                <a16:creationId xmlns:a16="http://schemas.microsoft.com/office/drawing/2014/main" id="{2BEAB6B7-88BA-4246-846F-DE1516DE1C86}"/>
+                <a16:creationId xmlns:a16="http://schemas.microsoft.com/office/drawing/2014/main" id="{B3C74935-201E-4D1D-83DD-D0C17C30A02B}"/>
               </a:ext>
             </a:extLst>
           </p:cNvPr>
@@ -11142,7 +11142,7 @@
           <p:cNvPr id="17" name="s9-title-2">
             <a:extLst xmlns:a="http://schemas.openxmlformats.org/drawingml/2006/main">
               <a:ext uri="{FF2B5EF4-FFF2-40B4-BE49-F238E27FC236}">
-                <a16:creationId xmlns:a16="http://schemas.microsoft.com/office/drawing/2014/main" id="{52D0951D-6F30-4A11-973C-B40BCE66AD78}"/>
+                <a16:creationId xmlns:a16="http://schemas.microsoft.com/office/drawing/2014/main" id="{9AD7605A-2BB7-42C8-869A-CEF94B3B453E}"/>
               </a:ext>
             </a:extLst>
           </p:cNvPr>
@@ -11198,7 +11198,7 @@
           <p:cNvPr id="18" name="s9-body-2">
             <a:extLst xmlns:a="http://schemas.openxmlformats.org/drawingml/2006/main">
               <a:ext uri="{FF2B5EF4-FFF2-40B4-BE49-F238E27FC236}">
-                <a16:creationId xmlns:a16="http://schemas.microsoft.com/office/drawing/2014/main" id="{35B0A708-5CAF-4FA7-A7F9-C9DB6326566F}"/>
+                <a16:creationId xmlns:a16="http://schemas.microsoft.com/office/drawing/2014/main" id="{D9027F52-C41A-4A9B-AA01-5BE72D67BD3E}"/>
               </a:ext>
             </a:extLst>
           </p:cNvPr>
@@ -11300,7 +11300,7 @@
           <p:cNvPr id="19" name="s9-output-2">
             <a:extLst xmlns:a="http://schemas.openxmlformats.org/drawingml/2006/main">
               <a:ext uri="{FF2B5EF4-FFF2-40B4-BE49-F238E27FC236}">
-                <a16:creationId xmlns:a16="http://schemas.microsoft.com/office/drawing/2014/main" id="{30AE05A9-EB76-4729-9E4B-21A5D4D9E01D}"/>
+                <a16:creationId xmlns:a16="http://schemas.microsoft.com/office/drawing/2014/main" id="{321D1C1E-F325-457C-9618-49E9D43A68EC}"/>
               </a:ext>
             </a:extLst>
           </p:cNvPr>
@@ -11377,7 +11377,7 @@
     </p:spTree>
     <p:extLst>
       <p:ext uri="{BB962C8B-B14F-4D97-AF65-F5344CB8AC3E}">
-        <p14:creationId xmlns:p14="http://schemas.microsoft.com/office/powerpoint/2010/main" val="1393451286"/>
+        <p14:creationId xmlns:p14="http://schemas.microsoft.com/office/powerpoint/2010/main" val="1552308798"/>
       </p:ext>
     </p:extLst>
   </p:cSld>

</xml_diff>

<commit_message>
Add refund risk analysis and profitability erosion after costs
</commit_message>
<xml_diff>
--- a/deliverables/Amazon_Q2_2026_Leadership_Presentation.pptx
+++ b/deliverables/Amazon_Q2_2026_Leadership_Presentation.pptx
@@ -2,21 +2,21 @@
 <file path=ppt/presentation.xml><?xml version="1.0" encoding="utf-8"?>
 <p:presentation xmlns:p="http://schemas.openxmlformats.org/presentationml/2006/main">
   <p:sldMasterIdLst>
-    <p:sldMasterId xmlns:r="http://schemas.openxmlformats.org/officeDocument/2006/relationships" id="2147483648" r:id="Re00efff5510d4205"/>
+    <p:sldMasterId xmlns:r="http://schemas.openxmlformats.org/officeDocument/2006/relationships" id="2147483648" r:id="R09d86f083ce54df1"/>
   </p:sldMasterIdLst>
   <p:notesMasterIdLst>
-    <p:notesMasterId xmlns:r="http://schemas.openxmlformats.org/officeDocument/2006/relationships" r:id="Rc38f0dcf9fdd4aa0"/>
+    <p:notesMasterId xmlns:r="http://schemas.openxmlformats.org/officeDocument/2006/relationships" r:id="R6fb32dfa88e84fb7"/>
   </p:notesMasterIdLst>
   <p:sldIdLst>
-    <p:sldId xmlns:r="http://schemas.openxmlformats.org/officeDocument/2006/relationships" id="256" r:id="R8290dd06559b4059"/>
-    <p:sldId xmlns:r="http://schemas.openxmlformats.org/officeDocument/2006/relationships" id="257" r:id="Rf1f767bf92444173"/>
-    <p:sldId xmlns:r="http://schemas.openxmlformats.org/officeDocument/2006/relationships" id="258" r:id="Rdb46c87053134317"/>
-    <p:sldId xmlns:r="http://schemas.openxmlformats.org/officeDocument/2006/relationships" id="259" r:id="R4f6c017f60634891"/>
-    <p:sldId xmlns:r="http://schemas.openxmlformats.org/officeDocument/2006/relationships" id="260" r:id="R56f6cb48b58e48f8"/>
-    <p:sldId xmlns:r="http://schemas.openxmlformats.org/officeDocument/2006/relationships" id="261" r:id="R33367083eb6b44b4"/>
-    <p:sldId xmlns:r="http://schemas.openxmlformats.org/officeDocument/2006/relationships" id="262" r:id="Re2bc031d5efa4346"/>
-    <p:sldId xmlns:r="http://schemas.openxmlformats.org/officeDocument/2006/relationships" id="263" r:id="R261a30e1ccb94eb4"/>
-    <p:sldId xmlns:r="http://schemas.openxmlformats.org/officeDocument/2006/relationships" id="264" r:id="Rd312b308c8f74bb1"/>
+    <p:sldId xmlns:r="http://schemas.openxmlformats.org/officeDocument/2006/relationships" id="256" r:id="R7da852f158f04797"/>
+    <p:sldId xmlns:r="http://schemas.openxmlformats.org/officeDocument/2006/relationships" id="257" r:id="Rfdeb1b7e618141e7"/>
+    <p:sldId xmlns:r="http://schemas.openxmlformats.org/officeDocument/2006/relationships" id="258" r:id="Rf875dae898e2426b"/>
+    <p:sldId xmlns:r="http://schemas.openxmlformats.org/officeDocument/2006/relationships" id="259" r:id="Re7223934b7df43f5"/>
+    <p:sldId xmlns:r="http://schemas.openxmlformats.org/officeDocument/2006/relationships" id="260" r:id="R6966beec870245ef"/>
+    <p:sldId xmlns:r="http://schemas.openxmlformats.org/officeDocument/2006/relationships" id="261" r:id="R265e24bc1c524944"/>
+    <p:sldId xmlns:r="http://schemas.openxmlformats.org/officeDocument/2006/relationships" id="262" r:id="Rd6857bbb793748df"/>
+    <p:sldId xmlns:r="http://schemas.openxmlformats.org/officeDocument/2006/relationships" id="263" r:id="Re91f480c43524aa9"/>
+    <p:sldId xmlns:r="http://schemas.openxmlformats.org/officeDocument/2006/relationships" id="264" r:id="R7919b45a16794ba7"/>
   </p:sldIdLst>
   <p:sldSz cx="12192000" cy="6858000"/>
   <p:notesSz cx="6858000" cy="9144000"/>
@@ -1042,7 +1042,7 @@
   </p:cSld>
   <p:clrMap bg1="lt1" tx1="dk1" bg2="lt2" tx2="dk2" accent1="accent1" accent2="accent2" accent3="accent3" accent4="accent4" accent5="accent5" accent6="accent6" hlink="hlink" folHlink="folHlink"/>
   <p:sldLayoutIdLst>
-    <p:sldLayoutId xmlns:r="http://schemas.openxmlformats.org/officeDocument/2006/relationships" id="2147483649" r:id="Rc111e6252ac04058"/>
+    <p:sldLayoutId xmlns:r="http://schemas.openxmlformats.org/officeDocument/2006/relationships" id="2147483649" r:id="R5f419bff2c9d45ff"/>
   </p:sldLayoutIdLst>
   <p:txStyles>
     <p:titleStyle>
@@ -1878,6 +1878,151 @@
 </c:chartSpace>
 </file>
 
+<file path=ppt/slides/charts/chart3.xml><?xml version="1.0" encoding="utf-8"?>
+<c:chartSpace xmlns:c="http://schemas.openxmlformats.org/drawingml/2006/chart">
+  <c:lang val="en-US"/>
+  <c:chart>
+    <c:plotArea>
+      <c:barChart>
+        <c:barDir val="col"/>
+        <c:varyColors val="0"/>
+        <c:ser>
+          <c:idx val="0"/>
+          <c:order val="0"/>
+          <c:tx>
+            <c:v>Unit refund rate (%)</c:v>
+          </c:tx>
+          <c:spPr>
+            <a:solidFill xmlns:a="http://schemas.openxmlformats.org/drawingml/2006/main">
+              <a:srgbClr val="2E74B5"/>
+            </a:solidFill>
+          </c:spPr>
+          <c:cat>
+            <c:strLit>
+              <c:ptCount val="3"/>
+              <c:pt idx="0">
+                <c:v>GlowTheory</c:v>
+              </c:pt>
+              <c:pt idx="1">
+                <c:v>Peak Fuel</c:v>
+              </c:pt>
+              <c:pt idx="2">
+                <c:v>PawHaus</c:v>
+              </c:pt>
+            </c:strLit>
+          </c:cat>
+          <c:val>
+            <c:numLit>
+              <c:formatCode>General</c:formatCode>
+              <c:ptCount val="3"/>
+              <c:pt idx="0">
+                <c:v>4.9</c:v>
+              </c:pt>
+              <c:pt idx="1">
+                <c:v>2.8</c:v>
+              </c:pt>
+              <c:pt idx="2">
+                <c:v>2.7</c:v>
+              </c:pt>
+            </c:numLit>
+          </c:val>
+        </c:ser>
+        <c:dLbls>
+          <c:dLblPos val="outEnd"/>
+          <c:showLegendKey val="0"/>
+          <c:showVal val="1"/>
+          <c:showCatName val="0"/>
+          <c:showSerName val="0"/>
+          <c:showPercent val="0"/>
+          <c:showBubbleSize val="0"/>
+          <c:showLeaderLines val="0"/>
+        </c:dLbls>
+        <c:axId val="48650112"/>
+        <c:axId val="48672768"/>
+      </c:barChart>
+      <c:catAx>
+        <c:axId val="48650112"/>
+        <c:scaling>
+          <c:orientation val="minMax"/>
+        </c:scaling>
+        <c:delete val="0"/>
+        <c:axPos val="b"/>
+        <c:numFmt formatCode="General"/>
+        <c:majorTickMark val="none"/>
+        <c:minorTickMark val="none"/>
+        <c:spPr>
+          <a:ln xmlns:a="http://schemas.openxmlformats.org/drawingml/2006/main" w="9525">
+            <a:solidFill>
+              <a:srgbClr val="D4D4D4"/>
+            </a:solidFill>
+            <a:prstDash val="solid"/>
+          </a:ln>
+        </c:spPr>
+        <c:txPr>
+          <a:bodyPr xmlns:a="http://schemas.openxmlformats.org/drawingml/2006/main" anchorCtr="1"/>
+          <a:lstStyle xmlns:a="http://schemas.openxmlformats.org/drawingml/2006/main"/>
+          <a:p xmlns:a="http://schemas.openxmlformats.org/drawingml/2006/main">
+            <a:pPr>
+              <a:defRPr>
+                <a:solidFill>
+                  <a:srgbClr val="666666"/>
+                </a:solidFill>
+              </a:defRPr>
+            </a:pPr>
+          </a:p>
+        </c:txPr>
+        <c:crossAx val="48672768"/>
+      </c:catAx>
+      <c:valAx>
+        <c:axId val="48672768"/>
+        <c:scaling>
+          <c:orientation val="minMax"/>
+        </c:scaling>
+        <c:delete val="0"/>
+        <c:axPos val="l"/>
+        <c:majorGridlines>
+          <c:spPr>
+            <a:ln xmlns:a="http://schemas.openxmlformats.org/drawingml/2006/main" w="9525">
+              <a:solidFill>
+                <a:srgbClr val="D0D5DD"/>
+              </a:solidFill>
+              <a:prstDash val="solid"/>
+            </a:ln>
+          </c:spPr>
+        </c:majorGridlines>
+        <c:numFmt formatCode="General"/>
+        <c:majorTickMark val="none"/>
+        <c:minorTickMark val="none"/>
+        <c:spPr>
+          <a:ln xmlns:a="http://schemas.openxmlformats.org/drawingml/2006/main" w="9525">
+            <a:solidFill>
+              <a:srgbClr val="D4D4D4"/>
+            </a:solidFill>
+            <a:prstDash val="solid"/>
+          </a:ln>
+        </c:spPr>
+        <c:txPr>
+          <a:bodyPr xmlns:a="http://schemas.openxmlformats.org/drawingml/2006/main" anchorCtr="1"/>
+          <a:lstStyle xmlns:a="http://schemas.openxmlformats.org/drawingml/2006/main"/>
+          <a:p xmlns:a="http://schemas.openxmlformats.org/drawingml/2006/main">
+            <a:pPr>
+              <a:defRPr>
+                <a:solidFill>
+                  <a:srgbClr val="666666"/>
+                </a:solidFill>
+              </a:defRPr>
+            </a:pPr>
+          </a:p>
+        </c:txPr>
+        <c:crossAx val="48650112"/>
+        <c:crossBetween val="between"/>
+      </c:valAx>
+    </c:plotArea>
+    <c:plotVisOnly val="1"/>
+  </c:chart>
+</c:chartSpace>
+</file>
+
 <file path=ppt/slides/slide1.xml><?xml version="1.0" encoding="utf-8"?>
 <p:sld xmlns:p="http://schemas.openxmlformats.org/presentationml/2006/main">
   <p:cSld>
@@ -1902,7 +2047,7 @@
           <p:cNvPr id="9" name="">
             <a:extLst xmlns:a="http://schemas.openxmlformats.org/drawingml/2006/main">
               <a:ext uri="{FF2B5EF4-FFF2-40B4-BE49-F238E27FC236}">
-                <a16:creationId xmlns:a16="http://schemas.microsoft.com/office/drawing/2014/main" id="{555964F2-9CA6-4036-B2EC-810401ABCD17}"/>
+                <a16:creationId xmlns:a16="http://schemas.microsoft.com/office/drawing/2014/main" id="{097D7118-CC53-4F31-8790-8E3BA1B0BAD3}"/>
               </a:ext>
             </a:extLst>
           </p:cNvPr>
@@ -1952,7 +2097,7 @@
           <p:cNvPr id="2" name="">
             <a:extLst xmlns:a="http://schemas.openxmlformats.org/drawingml/2006/main">
               <a:ext uri="{FF2B5EF4-FFF2-40B4-BE49-F238E27FC236}">
-                <a16:creationId xmlns:a16="http://schemas.microsoft.com/office/drawing/2014/main" id="{4F250FE2-396E-4DC3-B400-C140EFF1BE2A}"/>
+                <a16:creationId xmlns:a16="http://schemas.microsoft.com/office/drawing/2014/main" id="{AB3F779B-47D5-4A65-9239-51DD5EAB17C1}"/>
               </a:ext>
             </a:extLst>
           </p:cNvPr>
@@ -2002,7 +2147,7 @@
           <p:cNvPr id="3" name="">
             <a:extLst xmlns:a="http://schemas.openxmlformats.org/drawingml/2006/main">
               <a:ext uri="{FF2B5EF4-FFF2-40B4-BE49-F238E27FC236}">
-                <a16:creationId xmlns:a16="http://schemas.microsoft.com/office/drawing/2014/main" id="{503ABA40-795E-4376-8212-DAB6756235A3}"/>
+                <a16:creationId xmlns:a16="http://schemas.microsoft.com/office/drawing/2014/main" id="{1AE8EDB3-790A-451D-BB92-A2D5A8C67468}"/>
               </a:ext>
             </a:extLst>
           </p:cNvPr>
@@ -2052,7 +2197,7 @@
           <p:cNvPr id="4" name="">
             <a:extLst xmlns:a="http://schemas.openxmlformats.org/drawingml/2006/main">
               <a:ext uri="{FF2B5EF4-FFF2-40B4-BE49-F238E27FC236}">
-                <a16:creationId xmlns:a16="http://schemas.microsoft.com/office/drawing/2014/main" id="{7C207497-FA61-41DB-8ED0-CABBA7CD4DF5}"/>
+                <a16:creationId xmlns:a16="http://schemas.microsoft.com/office/drawing/2014/main" id="{5710C897-0DF9-48B0-B590-8489A2D2467B}"/>
               </a:ext>
             </a:extLst>
           </p:cNvPr>
@@ -2085,7 +2230,7 @@
           <p:cNvPr id="5" name="">
             <a:extLst xmlns:a="http://schemas.openxmlformats.org/drawingml/2006/main">
               <a:ext uri="{FF2B5EF4-FFF2-40B4-BE49-F238E27FC236}">
-                <a16:creationId xmlns:a16="http://schemas.microsoft.com/office/drawing/2014/main" id="{9960B853-0BAD-46B8-BF02-A5400E0D1BCE}"/>
+                <a16:creationId xmlns:a16="http://schemas.microsoft.com/office/drawing/2014/main" id="{EC532627-ED0A-4A58-9EC0-0E4DCEA014B6}"/>
               </a:ext>
             </a:extLst>
           </p:cNvPr>
@@ -2135,7 +2280,7 @@
           <p:cNvPr id="6" name="">
             <a:extLst xmlns:a="http://schemas.openxmlformats.org/drawingml/2006/main">
               <a:ext uri="{FF2B5EF4-FFF2-40B4-BE49-F238E27FC236}">
-                <a16:creationId xmlns:a16="http://schemas.microsoft.com/office/drawing/2014/main" id="{E9ADD007-2CC3-4F41-A373-C34440011AD4}"/>
+                <a16:creationId xmlns:a16="http://schemas.microsoft.com/office/drawing/2014/main" id="{1FF68DA8-A500-4197-9422-2EB0BE8052DF}"/>
               </a:ext>
             </a:extLst>
           </p:cNvPr>
@@ -2185,7 +2330,7 @@
           <p:cNvPr id="7" name="">
             <a:extLst xmlns:a="http://schemas.openxmlformats.org/drawingml/2006/main">
               <a:ext uri="{FF2B5EF4-FFF2-40B4-BE49-F238E27FC236}">
-                <a16:creationId xmlns:a16="http://schemas.microsoft.com/office/drawing/2014/main" id="{FCA8358C-99B0-41E8-A726-2EC84486BB30}"/>
+                <a16:creationId xmlns:a16="http://schemas.microsoft.com/office/drawing/2014/main" id="{F414EE9A-3197-448A-88CF-5B642A1072DC}"/>
               </a:ext>
             </a:extLst>
           </p:cNvPr>
@@ -2252,7 +2397,7 @@
           <p:cNvPr id="8" name="">
             <a:extLst xmlns:a="http://schemas.openxmlformats.org/drawingml/2006/main">
               <a:ext uri="{FF2B5EF4-FFF2-40B4-BE49-F238E27FC236}">
-                <a16:creationId xmlns:a16="http://schemas.microsoft.com/office/drawing/2014/main" id="{DD55A5BD-B92F-4219-B945-8AE3612E0BB7}"/>
+                <a16:creationId xmlns:a16="http://schemas.microsoft.com/office/drawing/2014/main" id="{2008072E-84BD-4628-8376-4F94FBD55467}"/>
               </a:ext>
             </a:extLst>
           </p:cNvPr>
@@ -2300,7 +2445,7 @@
     </p:spTree>
     <p:extLst>
       <p:ext uri="{BB962C8B-B14F-4D97-AF65-F5344CB8AC3E}">
-        <p14:creationId xmlns:p14="http://schemas.microsoft.com/office/powerpoint/2010/main" val="236831668"/>
+        <p14:creationId xmlns:p14="http://schemas.microsoft.com/office/powerpoint/2010/main" val="1190807397"/>
       </p:ext>
     </p:extLst>
   </p:cSld>
@@ -2331,7 +2476,7 @@
           <p:cNvPr id="17" name="">
             <a:extLst xmlns:a="http://schemas.openxmlformats.org/drawingml/2006/main">
               <a:ext uri="{FF2B5EF4-FFF2-40B4-BE49-F238E27FC236}">
-                <a16:creationId xmlns:a16="http://schemas.microsoft.com/office/drawing/2014/main" id="{D2DD0838-89DA-47D4-B1A7-6D595125C2E2}"/>
+                <a16:creationId xmlns:a16="http://schemas.microsoft.com/office/drawing/2014/main" id="{3561813A-D438-45B6-B287-039C1A7B480A}"/>
               </a:ext>
             </a:extLst>
           </p:cNvPr>
@@ -2381,7 +2526,7 @@
           <p:cNvPr id="2" name="">
             <a:extLst xmlns:a="http://schemas.openxmlformats.org/drawingml/2006/main">
               <a:ext uri="{FF2B5EF4-FFF2-40B4-BE49-F238E27FC236}">
-                <a16:creationId xmlns:a16="http://schemas.microsoft.com/office/drawing/2014/main" id="{09542D89-B4FB-4186-A85F-77A80B823D02}"/>
+                <a16:creationId xmlns:a16="http://schemas.microsoft.com/office/drawing/2014/main" id="{94FDDEC3-FE41-4135-B6A7-38EB6597FBCB}"/>
               </a:ext>
             </a:extLst>
           </p:cNvPr>
@@ -2431,7 +2576,7 @@
           <p:cNvPr id="3" name="">
             <a:extLst xmlns:a="http://schemas.openxmlformats.org/drawingml/2006/main">
               <a:ext uri="{FF2B5EF4-FFF2-40B4-BE49-F238E27FC236}">
-                <a16:creationId xmlns:a16="http://schemas.microsoft.com/office/drawing/2014/main" id="{393315E7-2616-4D7B-A4FB-DCBC6FC522A1}"/>
+                <a16:creationId xmlns:a16="http://schemas.microsoft.com/office/drawing/2014/main" id="{3AF824E7-2D9B-4F3A-A49F-16FFA2CDB343}"/>
               </a:ext>
             </a:extLst>
           </p:cNvPr>
@@ -2481,7 +2626,7 @@
           <p:cNvPr id="4" name="">
             <a:extLst xmlns:a="http://schemas.openxmlformats.org/drawingml/2006/main">
               <a:ext uri="{FF2B5EF4-FFF2-40B4-BE49-F238E27FC236}">
-                <a16:creationId xmlns:a16="http://schemas.microsoft.com/office/drawing/2014/main" id="{2520796F-A19C-4145-9AA6-9514219790A8}"/>
+                <a16:creationId xmlns:a16="http://schemas.microsoft.com/office/drawing/2014/main" id="{9EC9A4CE-1B8D-4255-A70B-7DCBF61D3DDF}"/>
               </a:ext>
             </a:extLst>
           </p:cNvPr>
@@ -2531,7 +2676,7 @@
           <p:cNvPr id="5" name="">
             <a:extLst xmlns:a="http://schemas.openxmlformats.org/drawingml/2006/main">
               <a:ext uri="{FF2B5EF4-FFF2-40B4-BE49-F238E27FC236}">
-                <a16:creationId xmlns:a16="http://schemas.microsoft.com/office/drawing/2014/main" id="{39302F71-4BBE-4DD3-923C-E03C63897FB0}"/>
+                <a16:creationId xmlns:a16="http://schemas.microsoft.com/office/drawing/2014/main" id="{E3D168F4-EC4C-4A8B-996D-1C55CE2F1384}"/>
               </a:ext>
             </a:extLst>
           </p:cNvPr>
@@ -2581,7 +2726,7 @@
           <p:cNvPr id="6" name="">
             <a:extLst xmlns:a="http://schemas.openxmlformats.org/drawingml/2006/main">
               <a:ext uri="{FF2B5EF4-FFF2-40B4-BE49-F238E27FC236}">
-                <a16:creationId xmlns:a16="http://schemas.microsoft.com/office/drawing/2014/main" id="{811B0D3D-E16F-4193-AC7F-13518EF1CA46}"/>
+                <a16:creationId xmlns:a16="http://schemas.microsoft.com/office/drawing/2014/main" id="{5DFB0540-621B-4C3B-B5D1-ED95E169AD2C}"/>
               </a:ext>
             </a:extLst>
           </p:cNvPr>
@@ -2631,7 +2776,7 @@
           <p:cNvPr id="7" name="">
             <a:extLst xmlns:a="http://schemas.openxmlformats.org/drawingml/2006/main">
               <a:ext uri="{FF2B5EF4-FFF2-40B4-BE49-F238E27FC236}">
-                <a16:creationId xmlns:a16="http://schemas.microsoft.com/office/drawing/2014/main" id="{6FE3B08E-3082-4FEB-8A81-59035B77C642}"/>
+                <a16:creationId xmlns:a16="http://schemas.microsoft.com/office/drawing/2014/main" id="{B20BCDD5-95B9-4EA9-BC59-809849D5A77B}"/>
               </a:ext>
             </a:extLst>
           </p:cNvPr>
@@ -2681,7 +2826,7 @@
           <p:cNvPr id="8" name="">
             <a:extLst xmlns:a="http://schemas.openxmlformats.org/drawingml/2006/main">
               <a:ext uri="{FF2B5EF4-FFF2-40B4-BE49-F238E27FC236}">
-                <a16:creationId xmlns:a16="http://schemas.microsoft.com/office/drawing/2014/main" id="{78BAF3EA-1659-4D18-8B0F-EAB3FF6FEC05}"/>
+                <a16:creationId xmlns:a16="http://schemas.microsoft.com/office/drawing/2014/main" id="{2B90C123-8E94-46DA-A8EA-A75CCD115502}"/>
               </a:ext>
             </a:extLst>
           </p:cNvPr>
@@ -2731,7 +2876,7 @@
           <p:cNvPr id="9" name="">
             <a:extLst xmlns:a="http://schemas.openxmlformats.org/drawingml/2006/main">
               <a:ext uri="{FF2B5EF4-FFF2-40B4-BE49-F238E27FC236}">
-                <a16:creationId xmlns:a16="http://schemas.microsoft.com/office/drawing/2014/main" id="{4A3FAF25-D7C3-4A4B-94FA-AD1926AAAEF7}"/>
+                <a16:creationId xmlns:a16="http://schemas.microsoft.com/office/drawing/2014/main" id="{E3EF4B3A-78F0-4FD7-BD42-AED8D47A8A4B}"/>
               </a:ext>
             </a:extLst>
           </p:cNvPr>
@@ -2781,7 +2926,7 @@
           <p:cNvPr id="10" name="">
             <a:extLst xmlns:a="http://schemas.openxmlformats.org/drawingml/2006/main">
               <a:ext uri="{FF2B5EF4-FFF2-40B4-BE49-F238E27FC236}">
-                <a16:creationId xmlns:a16="http://schemas.microsoft.com/office/drawing/2014/main" id="{646D3F45-B84C-435B-AAB7-C93C56EE44ED}"/>
+                <a16:creationId xmlns:a16="http://schemas.microsoft.com/office/drawing/2014/main" id="{D06888D3-9EB7-4B9B-A75C-5EF6D9C73EF3}"/>
               </a:ext>
             </a:extLst>
           </p:cNvPr>
@@ -2831,7 +2976,7 @@
           <p:cNvPr id="11" name="">
             <a:extLst xmlns:a="http://schemas.openxmlformats.org/drawingml/2006/main">
               <a:ext uri="{FF2B5EF4-FFF2-40B4-BE49-F238E27FC236}">
-                <a16:creationId xmlns:a16="http://schemas.microsoft.com/office/drawing/2014/main" id="{275B22C6-F33C-4329-846F-FF1F01E37112}"/>
+                <a16:creationId xmlns:a16="http://schemas.microsoft.com/office/drawing/2014/main" id="{7AE32CDF-4830-438C-BF17-50F164FAC626}"/>
               </a:ext>
             </a:extLst>
           </p:cNvPr>
@@ -2881,7 +3026,7 @@
           <p:cNvPr id="12" name="">
             <a:extLst xmlns:a="http://schemas.openxmlformats.org/drawingml/2006/main">
               <a:ext uri="{FF2B5EF4-FFF2-40B4-BE49-F238E27FC236}">
-                <a16:creationId xmlns:a16="http://schemas.microsoft.com/office/drawing/2014/main" id="{A684772D-82A9-450B-957A-BB427398F065}"/>
+                <a16:creationId xmlns:a16="http://schemas.microsoft.com/office/drawing/2014/main" id="{B6AABA6B-5624-4B98-A172-A37BCF890553}"/>
               </a:ext>
             </a:extLst>
           </p:cNvPr>
@@ -2914,7 +3059,7 @@
           <p:cNvPr id="13" name="">
             <a:extLst xmlns:a="http://schemas.openxmlformats.org/drawingml/2006/main">
               <a:ext uri="{FF2B5EF4-FFF2-40B4-BE49-F238E27FC236}">
-                <a16:creationId xmlns:a16="http://schemas.microsoft.com/office/drawing/2014/main" id="{66989923-FCA1-4710-A2E2-47C524E110AD}"/>
+                <a16:creationId xmlns:a16="http://schemas.microsoft.com/office/drawing/2014/main" id="{0C31EB65-8983-412E-A006-53BA7BE8E38B}"/>
               </a:ext>
             </a:extLst>
           </p:cNvPr>
@@ -2964,7 +3109,7 @@
           <p:cNvPr id="14" name="">
             <a:extLst xmlns:a="http://schemas.openxmlformats.org/drawingml/2006/main">
               <a:ext uri="{FF2B5EF4-FFF2-40B4-BE49-F238E27FC236}">
-                <a16:creationId xmlns:a16="http://schemas.microsoft.com/office/drawing/2014/main" id="{284F7F18-E1C0-402E-ABB4-6AF4B148FFC7}"/>
+                <a16:creationId xmlns:a16="http://schemas.microsoft.com/office/drawing/2014/main" id="{7CAAE5BC-8851-42E5-B5AC-888C7941B32F}"/>
               </a:ext>
             </a:extLst>
           </p:cNvPr>
@@ -3048,7 +3193,7 @@
           <p:cNvPr id="15" name="">
             <a:extLst xmlns:a="http://schemas.openxmlformats.org/drawingml/2006/main">
               <a:ext uri="{FF2B5EF4-FFF2-40B4-BE49-F238E27FC236}">
-                <a16:creationId xmlns:a16="http://schemas.microsoft.com/office/drawing/2014/main" id="{858C04F2-0624-4308-BCAE-AA0185697C8E}"/>
+                <a16:creationId xmlns:a16="http://schemas.microsoft.com/office/drawing/2014/main" id="{38F10759-A653-4058-92A7-A54301FD2826}"/>
               </a:ext>
             </a:extLst>
           </p:cNvPr>
@@ -3098,7 +3243,7 @@
           <p:cNvPr id="16" name="">
             <a:extLst xmlns:a="http://schemas.openxmlformats.org/drawingml/2006/main">
               <a:ext uri="{FF2B5EF4-FFF2-40B4-BE49-F238E27FC236}">
-                <a16:creationId xmlns:a16="http://schemas.microsoft.com/office/drawing/2014/main" id="{BBB6E46E-04F8-4093-887A-F3942EEB0D12}"/>
+                <a16:creationId xmlns:a16="http://schemas.microsoft.com/office/drawing/2014/main" id="{9A67BA15-29B7-44A6-A94E-A57525104616}"/>
               </a:ext>
             </a:extLst>
           </p:cNvPr>
@@ -3146,7 +3291,7 @@
     </p:spTree>
     <p:extLst>
       <p:ext uri="{BB962C8B-B14F-4D97-AF65-F5344CB8AC3E}">
-        <p14:creationId xmlns:p14="http://schemas.microsoft.com/office/powerpoint/2010/main" val="1166766298"/>
+        <p14:creationId xmlns:p14="http://schemas.microsoft.com/office/powerpoint/2010/main" val="21053111"/>
       </p:ext>
     </p:extLst>
   </p:cSld>
@@ -3177,7 +3322,7 @@
           <p:cNvPr id="27" name="">
             <a:extLst xmlns:a="http://schemas.openxmlformats.org/drawingml/2006/main">
               <a:ext uri="{FF2B5EF4-FFF2-40B4-BE49-F238E27FC236}">
-                <a16:creationId xmlns:a16="http://schemas.microsoft.com/office/drawing/2014/main" id="{7A36051A-C40E-4FB3-A067-A294244C2980}"/>
+                <a16:creationId xmlns:a16="http://schemas.microsoft.com/office/drawing/2014/main" id="{730202F6-C784-4654-9EF6-6F14B2C391E8}"/>
               </a:ext>
             </a:extLst>
           </p:cNvPr>
@@ -3227,7 +3372,7 @@
           <p:cNvPr id="2" name="">
             <a:extLst xmlns:a="http://schemas.openxmlformats.org/drawingml/2006/main">
               <a:ext uri="{FF2B5EF4-FFF2-40B4-BE49-F238E27FC236}">
-                <a16:creationId xmlns:a16="http://schemas.microsoft.com/office/drawing/2014/main" id="{0A66D6C2-155D-4C11-81D5-D22B372B3077}"/>
+                <a16:creationId xmlns:a16="http://schemas.microsoft.com/office/drawing/2014/main" id="{27E2A1F5-6BF2-4495-A382-851D4BC5B754}"/>
               </a:ext>
             </a:extLst>
           </p:cNvPr>
@@ -3277,7 +3422,7 @@
           <p:cNvPr id="3" name="">
             <a:extLst xmlns:a="http://schemas.openxmlformats.org/drawingml/2006/main">
               <a:ext uri="{FF2B5EF4-FFF2-40B4-BE49-F238E27FC236}">
-                <a16:creationId xmlns:a16="http://schemas.microsoft.com/office/drawing/2014/main" id="{D56BBC3D-169E-411A-8DFC-D56ABB8D253A}"/>
+                <a16:creationId xmlns:a16="http://schemas.microsoft.com/office/drawing/2014/main" id="{C6CF593C-7BDD-44F8-9232-975E3430F31F}"/>
               </a:ext>
             </a:extLst>
           </p:cNvPr>
@@ -3327,7 +3472,7 @@
           <p:cNvPr id="4" name="">
             <a:extLst xmlns:a="http://schemas.openxmlformats.org/drawingml/2006/main">
               <a:ext uri="{FF2B5EF4-FFF2-40B4-BE49-F238E27FC236}">
-                <a16:creationId xmlns:a16="http://schemas.microsoft.com/office/drawing/2014/main" id="{B0753B3B-A7FF-48D9-9E76-B41FAFC09A00}"/>
+                <a16:creationId xmlns:a16="http://schemas.microsoft.com/office/drawing/2014/main" id="{EF6BD1B1-8A52-48ED-A047-DB4A915564C8}"/>
               </a:ext>
             </a:extLst>
           </p:cNvPr>
@@ -3362,7 +3507,7 @@
           <p:cNvPr id="5" name="">
             <a:extLst xmlns:a="http://schemas.openxmlformats.org/drawingml/2006/main">
               <a:ext uri="{FF2B5EF4-FFF2-40B4-BE49-F238E27FC236}">
-                <a16:creationId xmlns:a16="http://schemas.microsoft.com/office/drawing/2014/main" id="{D742BC3D-7ED9-402E-9261-C92239732B95}"/>
+                <a16:creationId xmlns:a16="http://schemas.microsoft.com/office/drawing/2014/main" id="{F9F6D08C-2172-49F5-B302-B287BFD07FC2}"/>
               </a:ext>
             </a:extLst>
           </p:cNvPr>
@@ -3412,7 +3557,7 @@
           <p:cNvPr id="6" name="">
             <a:extLst xmlns:a="http://schemas.openxmlformats.org/drawingml/2006/main">
               <a:ext uri="{FF2B5EF4-FFF2-40B4-BE49-F238E27FC236}">
-                <a16:creationId xmlns:a16="http://schemas.microsoft.com/office/drawing/2014/main" id="{0B3E7847-855A-4479-A85B-5EFC20336F9C}"/>
+                <a16:creationId xmlns:a16="http://schemas.microsoft.com/office/drawing/2014/main" id="{15A373EE-5859-4382-9D3C-40CD460B7AD4}"/>
               </a:ext>
             </a:extLst>
           </p:cNvPr>
@@ -3513,7 +3658,7 @@
           <p:cNvPr id="7" name="">
             <a:extLst xmlns:a="http://schemas.openxmlformats.org/drawingml/2006/main">
               <a:ext uri="{FF2B5EF4-FFF2-40B4-BE49-F238E27FC236}">
-                <a16:creationId xmlns:a16="http://schemas.microsoft.com/office/drawing/2014/main" id="{C8BD13AB-FB76-4DFE-8D5D-E9FCA0CCB6B2}"/>
+                <a16:creationId xmlns:a16="http://schemas.microsoft.com/office/drawing/2014/main" id="{F5CD2EAB-5009-4790-B369-39C918A6AA45}"/>
               </a:ext>
             </a:extLst>
           </p:cNvPr>
@@ -3546,7 +3691,7 @@
           <p:cNvPr id="8" name="">
             <a:extLst xmlns:a="http://schemas.openxmlformats.org/drawingml/2006/main">
               <a:ext uri="{FF2B5EF4-FFF2-40B4-BE49-F238E27FC236}">
-                <a16:creationId xmlns:a16="http://schemas.microsoft.com/office/drawing/2014/main" id="{9837180D-62B4-4328-AA03-DFA16D614BB1}"/>
+                <a16:creationId xmlns:a16="http://schemas.microsoft.com/office/drawing/2014/main" id="{A0FFF98E-752C-4D28-99C7-C6E3AC6FF774}"/>
               </a:ext>
             </a:extLst>
           </p:cNvPr>
@@ -3581,7 +3726,7 @@
           <p:cNvPr id="9" name="">
             <a:extLst xmlns:a="http://schemas.openxmlformats.org/drawingml/2006/main">
               <a:ext uri="{FF2B5EF4-FFF2-40B4-BE49-F238E27FC236}">
-                <a16:creationId xmlns:a16="http://schemas.microsoft.com/office/drawing/2014/main" id="{7D61A28E-E389-4C81-8D57-88A2F10B1BE7}"/>
+                <a16:creationId xmlns:a16="http://schemas.microsoft.com/office/drawing/2014/main" id="{6200B421-1337-4221-8809-9FF82DD5896F}"/>
               </a:ext>
             </a:extLst>
           </p:cNvPr>
@@ -3631,7 +3776,7 @@
           <p:cNvPr id="10" name="">
             <a:extLst xmlns:a="http://schemas.openxmlformats.org/drawingml/2006/main">
               <a:ext uri="{FF2B5EF4-FFF2-40B4-BE49-F238E27FC236}">
-                <a16:creationId xmlns:a16="http://schemas.microsoft.com/office/drawing/2014/main" id="{59A7687C-6822-4783-A8A7-A4B96236BF3E}"/>
+                <a16:creationId xmlns:a16="http://schemas.microsoft.com/office/drawing/2014/main" id="{2D7D4164-6C78-449F-9029-44414506EA06}"/>
               </a:ext>
             </a:extLst>
           </p:cNvPr>
@@ -3698,7 +3843,7 @@
           <p:cNvPr id="11" name="">
             <a:extLst xmlns:a="http://schemas.openxmlformats.org/drawingml/2006/main">
               <a:ext uri="{FF2B5EF4-FFF2-40B4-BE49-F238E27FC236}">
-                <a16:creationId xmlns:a16="http://schemas.microsoft.com/office/drawing/2014/main" id="{FB394FA4-A784-41FC-ADBD-2BE154268219}"/>
+                <a16:creationId xmlns:a16="http://schemas.microsoft.com/office/drawing/2014/main" id="{EDCC609C-C63B-492D-9444-587ECB4CF415}"/>
               </a:ext>
             </a:extLst>
           </p:cNvPr>
@@ -3731,7 +3876,7 @@
           <p:cNvPr id="12" name="">
             <a:extLst xmlns:a="http://schemas.openxmlformats.org/drawingml/2006/main">
               <a:ext uri="{FF2B5EF4-FFF2-40B4-BE49-F238E27FC236}">
-                <a16:creationId xmlns:a16="http://schemas.microsoft.com/office/drawing/2014/main" id="{4C561B87-5407-4770-A1C3-0DCD9FEAF916}"/>
+                <a16:creationId xmlns:a16="http://schemas.microsoft.com/office/drawing/2014/main" id="{DC21BEA1-4B8F-4F75-A3F4-B1FF550B5E83}"/>
               </a:ext>
             </a:extLst>
           </p:cNvPr>
@@ -3766,7 +3911,7 @@
           <p:cNvPr id="13" name="">
             <a:extLst xmlns:a="http://schemas.openxmlformats.org/drawingml/2006/main">
               <a:ext uri="{FF2B5EF4-FFF2-40B4-BE49-F238E27FC236}">
-                <a16:creationId xmlns:a16="http://schemas.microsoft.com/office/drawing/2014/main" id="{2F765650-7066-46CA-B71C-18E021C60A7C}"/>
+                <a16:creationId xmlns:a16="http://schemas.microsoft.com/office/drawing/2014/main" id="{09363AC0-F887-441D-876A-0B828DEF3AC5}"/>
               </a:ext>
             </a:extLst>
           </p:cNvPr>
@@ -3816,7 +3961,7 @@
           <p:cNvPr id="14" name="">
             <a:extLst xmlns:a="http://schemas.openxmlformats.org/drawingml/2006/main">
               <a:ext uri="{FF2B5EF4-FFF2-40B4-BE49-F238E27FC236}">
-                <a16:creationId xmlns:a16="http://schemas.microsoft.com/office/drawing/2014/main" id="{5264F454-4714-4A56-86AD-243691467BA1}"/>
+                <a16:creationId xmlns:a16="http://schemas.microsoft.com/office/drawing/2014/main" id="{E843BA0B-E5D8-42EF-9853-1CEDA17D19CF}"/>
               </a:ext>
             </a:extLst>
           </p:cNvPr>
@@ -3883,7 +4028,7 @@
           <p:cNvPr id="15" name="">
             <a:extLst xmlns:a="http://schemas.openxmlformats.org/drawingml/2006/main">
               <a:ext uri="{FF2B5EF4-FFF2-40B4-BE49-F238E27FC236}">
-                <a16:creationId xmlns:a16="http://schemas.microsoft.com/office/drawing/2014/main" id="{279D006C-F3C0-4A7C-9FC2-36C08BC982B9}"/>
+                <a16:creationId xmlns:a16="http://schemas.microsoft.com/office/drawing/2014/main" id="{4418D574-E6BF-40EA-9354-17C14FEBBB35}"/>
               </a:ext>
             </a:extLst>
           </p:cNvPr>
@@ -3916,7 +4061,7 @@
           <p:cNvPr id="16" name="">
             <a:extLst xmlns:a="http://schemas.openxmlformats.org/drawingml/2006/main">
               <a:ext uri="{FF2B5EF4-FFF2-40B4-BE49-F238E27FC236}">
-                <a16:creationId xmlns:a16="http://schemas.microsoft.com/office/drawing/2014/main" id="{BD52077A-47ED-46BA-8708-F5F761848055}"/>
+                <a16:creationId xmlns:a16="http://schemas.microsoft.com/office/drawing/2014/main" id="{9D594159-1B0A-4B2C-92EF-E16478D06C22}"/>
               </a:ext>
             </a:extLst>
           </p:cNvPr>
@@ -3951,7 +4096,7 @@
           <p:cNvPr id="17" name="">
             <a:extLst xmlns:a="http://schemas.openxmlformats.org/drawingml/2006/main">
               <a:ext uri="{FF2B5EF4-FFF2-40B4-BE49-F238E27FC236}">
-                <a16:creationId xmlns:a16="http://schemas.microsoft.com/office/drawing/2014/main" id="{3DA0F54F-2500-4EAB-BC81-5B5EACD5534A}"/>
+                <a16:creationId xmlns:a16="http://schemas.microsoft.com/office/drawing/2014/main" id="{32418750-0534-4818-A397-E28A43D52B82}"/>
               </a:ext>
             </a:extLst>
           </p:cNvPr>
@@ -4001,7 +4146,7 @@
           <p:cNvPr id="18" name="">
             <a:extLst xmlns:a="http://schemas.openxmlformats.org/drawingml/2006/main">
               <a:ext uri="{FF2B5EF4-FFF2-40B4-BE49-F238E27FC236}">
-                <a16:creationId xmlns:a16="http://schemas.microsoft.com/office/drawing/2014/main" id="{7F28C90C-3B14-4E8F-A753-B7A0302B6212}"/>
+                <a16:creationId xmlns:a16="http://schemas.microsoft.com/office/drawing/2014/main" id="{D90E7E50-0C5F-4502-942E-E2A2D9620B11}"/>
               </a:ext>
             </a:extLst>
           </p:cNvPr>
@@ -4068,7 +4213,7 @@
           <p:cNvPr id="19" name="">
             <a:extLst xmlns:a="http://schemas.openxmlformats.org/drawingml/2006/main">
               <a:ext uri="{FF2B5EF4-FFF2-40B4-BE49-F238E27FC236}">
-                <a16:creationId xmlns:a16="http://schemas.microsoft.com/office/drawing/2014/main" id="{D46F2BF3-C0CE-4F04-B5D7-776E99EF53B9}"/>
+                <a16:creationId xmlns:a16="http://schemas.microsoft.com/office/drawing/2014/main" id="{A8EB7E53-E4D5-4EAF-BF8A-DA0735D59B91}"/>
               </a:ext>
             </a:extLst>
           </p:cNvPr>
@@ -4101,7 +4246,7 @@
           <p:cNvPr id="20" name="">
             <a:extLst xmlns:a="http://schemas.openxmlformats.org/drawingml/2006/main">
               <a:ext uri="{FF2B5EF4-FFF2-40B4-BE49-F238E27FC236}">
-                <a16:creationId xmlns:a16="http://schemas.microsoft.com/office/drawing/2014/main" id="{4216BD43-BF2B-4781-8F03-CD0995AA6001}"/>
+                <a16:creationId xmlns:a16="http://schemas.microsoft.com/office/drawing/2014/main" id="{67558620-1457-404B-8508-4EC5495CBDC3}"/>
               </a:ext>
             </a:extLst>
           </p:cNvPr>
@@ -4136,7 +4281,7 @@
           <p:cNvPr id="21" name="">
             <a:extLst xmlns:a="http://schemas.openxmlformats.org/drawingml/2006/main">
               <a:ext uri="{FF2B5EF4-FFF2-40B4-BE49-F238E27FC236}">
-                <a16:creationId xmlns:a16="http://schemas.microsoft.com/office/drawing/2014/main" id="{DFE38C13-5CC2-48D3-BB68-02FF81C32E0E}"/>
+                <a16:creationId xmlns:a16="http://schemas.microsoft.com/office/drawing/2014/main" id="{B8751973-FA19-433C-863C-0390F9DDEBC6}"/>
               </a:ext>
             </a:extLst>
           </p:cNvPr>
@@ -4186,7 +4331,7 @@
           <p:cNvPr id="22" name="">
             <a:extLst xmlns:a="http://schemas.openxmlformats.org/drawingml/2006/main">
               <a:ext uri="{FF2B5EF4-FFF2-40B4-BE49-F238E27FC236}">
-                <a16:creationId xmlns:a16="http://schemas.microsoft.com/office/drawing/2014/main" id="{66D0EC6B-B4CC-491B-A034-886B9019CCDF}"/>
+                <a16:creationId xmlns:a16="http://schemas.microsoft.com/office/drawing/2014/main" id="{FE527246-70F6-493D-9BA8-544922BC00E4}"/>
               </a:ext>
             </a:extLst>
           </p:cNvPr>
@@ -4253,7 +4398,7 @@
           <p:cNvPr id="23" name="">
             <a:extLst xmlns:a="http://schemas.openxmlformats.org/drawingml/2006/main">
               <a:ext uri="{FF2B5EF4-FFF2-40B4-BE49-F238E27FC236}">
-                <a16:creationId xmlns:a16="http://schemas.microsoft.com/office/drawing/2014/main" id="{F364288A-E9CC-42AF-9BF1-FD8A35DB8403}"/>
+                <a16:creationId xmlns:a16="http://schemas.microsoft.com/office/drawing/2014/main" id="{4DD5908B-67A3-4C4F-AE6B-6C39D85A347A}"/>
               </a:ext>
             </a:extLst>
           </p:cNvPr>
@@ -4303,7 +4448,7 @@
           <p:cNvPr id="24" name="">
             <a:extLst xmlns:a="http://schemas.openxmlformats.org/drawingml/2006/main">
               <a:ext uri="{FF2B5EF4-FFF2-40B4-BE49-F238E27FC236}">
-                <a16:creationId xmlns:a16="http://schemas.microsoft.com/office/drawing/2014/main" id="{96E85384-2201-4F9D-89D5-AB3C3D37567D}"/>
+                <a16:creationId xmlns:a16="http://schemas.microsoft.com/office/drawing/2014/main" id="{A81BB86A-A2B4-4445-A529-D0C0E4B89E80}"/>
               </a:ext>
             </a:extLst>
           </p:cNvPr>
@@ -4353,7 +4498,7 @@
           <p:cNvPr id="25" name="">
             <a:extLst xmlns:a="http://schemas.openxmlformats.org/drawingml/2006/main">
               <a:ext uri="{FF2B5EF4-FFF2-40B4-BE49-F238E27FC236}">
-                <a16:creationId xmlns:a16="http://schemas.microsoft.com/office/drawing/2014/main" id="{FF447C1F-C997-487F-AABB-3FDE79312383}"/>
+                <a16:creationId xmlns:a16="http://schemas.microsoft.com/office/drawing/2014/main" id="{39520C36-79E5-4249-83CB-73E61CE77164}"/>
               </a:ext>
             </a:extLst>
           </p:cNvPr>
@@ -4403,7 +4548,7 @@
           <p:cNvPr id="26" name="">
             <a:extLst xmlns:a="http://schemas.openxmlformats.org/drawingml/2006/main">
               <a:ext uri="{FF2B5EF4-FFF2-40B4-BE49-F238E27FC236}">
-                <a16:creationId xmlns:a16="http://schemas.microsoft.com/office/drawing/2014/main" id="{B074AD67-ABD6-4BFF-AF96-6AFA9E0345BB}"/>
+                <a16:creationId xmlns:a16="http://schemas.microsoft.com/office/drawing/2014/main" id="{7F88596C-83B7-46AB-8D4C-9EEDD806010B}"/>
               </a:ext>
             </a:extLst>
           </p:cNvPr>
@@ -4451,7 +4596,7 @@
     </p:spTree>
     <p:extLst>
       <p:ext uri="{BB962C8B-B14F-4D97-AF65-F5344CB8AC3E}">
-        <p14:creationId xmlns:p14="http://schemas.microsoft.com/office/powerpoint/2010/main" val="791245769"/>
+        <p14:creationId xmlns:p14="http://schemas.microsoft.com/office/powerpoint/2010/main" val="991381496"/>
       </p:ext>
     </p:extLst>
   </p:cSld>
@@ -4482,7 +4627,7 @@
           <p:cNvPr id="27" name="">
             <a:extLst xmlns:a="http://schemas.openxmlformats.org/drawingml/2006/main">
               <a:ext uri="{FF2B5EF4-FFF2-40B4-BE49-F238E27FC236}">
-                <a16:creationId xmlns:a16="http://schemas.microsoft.com/office/drawing/2014/main" id="{A50B851C-A26F-467F-A9E7-AB6EDAB92717}"/>
+                <a16:creationId xmlns:a16="http://schemas.microsoft.com/office/drawing/2014/main" id="{1B282F03-AC43-4521-8783-0CA69F9A944D}"/>
               </a:ext>
             </a:extLst>
           </p:cNvPr>
@@ -4532,7 +4677,7 @@
           <p:cNvPr id="2" name="">
             <a:extLst xmlns:a="http://schemas.openxmlformats.org/drawingml/2006/main">
               <a:ext uri="{FF2B5EF4-FFF2-40B4-BE49-F238E27FC236}">
-                <a16:creationId xmlns:a16="http://schemas.microsoft.com/office/drawing/2014/main" id="{128C9F0D-D2F3-4721-831C-A70C2AD58291}"/>
+                <a16:creationId xmlns:a16="http://schemas.microsoft.com/office/drawing/2014/main" id="{585FA7E0-50F7-4F25-B29D-DF84A9B4C8B2}"/>
               </a:ext>
             </a:extLst>
           </p:cNvPr>
@@ -4582,7 +4727,7 @@
           <p:cNvPr id="3" name="">
             <a:extLst xmlns:a="http://schemas.openxmlformats.org/drawingml/2006/main">
               <a:ext uri="{FF2B5EF4-FFF2-40B4-BE49-F238E27FC236}">
-                <a16:creationId xmlns:a16="http://schemas.microsoft.com/office/drawing/2014/main" id="{D3FFD13E-8E14-40F8-8A66-7C1D5BCE45C1}"/>
+                <a16:creationId xmlns:a16="http://schemas.microsoft.com/office/drawing/2014/main" id="{674FD731-8D59-4884-B1D1-A69546F0B566}"/>
               </a:ext>
             </a:extLst>
           </p:cNvPr>
@@ -4632,7 +4777,7 @@
           <p:cNvPr id="4" name="">
             <a:extLst xmlns:a="http://schemas.openxmlformats.org/drawingml/2006/main">
               <a:ext uri="{FF2B5EF4-FFF2-40B4-BE49-F238E27FC236}">
-                <a16:creationId xmlns:a16="http://schemas.microsoft.com/office/drawing/2014/main" id="{E0035B3D-D180-48A6-A674-7B2459DC1D7B}"/>
+                <a16:creationId xmlns:a16="http://schemas.microsoft.com/office/drawing/2014/main" id="{6A1F4322-6F97-4A20-9E7F-40D6BF8C3286}"/>
               </a:ext>
             </a:extLst>
           </p:cNvPr>
@@ -4682,7 +4827,7 @@
           <p:cNvPr id="5" name="">
             <a:extLst xmlns:a="http://schemas.openxmlformats.org/drawingml/2006/main">
               <a:ext uri="{FF2B5EF4-FFF2-40B4-BE49-F238E27FC236}">
-                <a16:creationId xmlns:a16="http://schemas.microsoft.com/office/drawing/2014/main" id="{260FD816-A0ED-4BB9-BA57-4C4FA30D33CF}"/>
+                <a16:creationId xmlns:a16="http://schemas.microsoft.com/office/drawing/2014/main" id="{2950E603-A767-48A2-A116-19706F36B3E9}"/>
               </a:ext>
             </a:extLst>
           </p:cNvPr>
@@ -4715,7 +4860,7 @@
           <p:cNvPr id="6" name="">
             <a:extLst xmlns:a="http://schemas.openxmlformats.org/drawingml/2006/main">
               <a:ext uri="{FF2B5EF4-FFF2-40B4-BE49-F238E27FC236}">
-                <a16:creationId xmlns:a16="http://schemas.microsoft.com/office/drawing/2014/main" id="{D1028B5D-2E17-4E78-896A-05E401D0239F}"/>
+                <a16:creationId xmlns:a16="http://schemas.microsoft.com/office/drawing/2014/main" id="{6BF082DD-6FA0-4496-A0DA-8C765669008F}"/>
               </a:ext>
             </a:extLst>
           </p:cNvPr>
@@ -4765,7 +4910,7 @@
           <p:cNvPr id="7" name="">
             <a:extLst xmlns:a="http://schemas.openxmlformats.org/drawingml/2006/main">
               <a:ext uri="{FF2B5EF4-FFF2-40B4-BE49-F238E27FC236}">
-                <a16:creationId xmlns:a16="http://schemas.microsoft.com/office/drawing/2014/main" id="{CA349B82-2496-4DB0-ADAC-E6FB3D7847FB}"/>
+                <a16:creationId xmlns:a16="http://schemas.microsoft.com/office/drawing/2014/main" id="{AFA79FCE-0D70-4020-B8FB-380E0EE1AC47}"/>
               </a:ext>
             </a:extLst>
           </p:cNvPr>
@@ -4815,7 +4960,7 @@
           <p:cNvPr id="8" name="">
             <a:extLst xmlns:a="http://schemas.openxmlformats.org/drawingml/2006/main">
               <a:ext uri="{FF2B5EF4-FFF2-40B4-BE49-F238E27FC236}">
-                <a16:creationId xmlns:a16="http://schemas.microsoft.com/office/drawing/2014/main" id="{3B5BF4C6-1AE0-4E9C-820E-4685D3D97BC5}"/>
+                <a16:creationId xmlns:a16="http://schemas.microsoft.com/office/drawing/2014/main" id="{874A56A5-99F5-434F-B976-413FA8A6AE30}"/>
               </a:ext>
             </a:extLst>
           </p:cNvPr>
@@ -4865,7 +5010,7 @@
           <p:cNvPr id="9" name="">
             <a:extLst xmlns:a="http://schemas.openxmlformats.org/drawingml/2006/main">
               <a:ext uri="{FF2B5EF4-FFF2-40B4-BE49-F238E27FC236}">
-                <a16:creationId xmlns:a16="http://schemas.microsoft.com/office/drawing/2014/main" id="{619C8FE5-09BC-490D-A377-C31C7803DF35}"/>
+                <a16:creationId xmlns:a16="http://schemas.microsoft.com/office/drawing/2014/main" id="{8999B51D-FBA1-4CB6-984D-781574E2BB2C}"/>
               </a:ext>
             </a:extLst>
           </p:cNvPr>
@@ -4898,7 +5043,7 @@
           <p:cNvPr id="10" name="">
             <a:extLst xmlns:a="http://schemas.openxmlformats.org/drawingml/2006/main">
               <a:ext uri="{FF2B5EF4-FFF2-40B4-BE49-F238E27FC236}">
-                <a16:creationId xmlns:a16="http://schemas.microsoft.com/office/drawing/2014/main" id="{58025006-12A0-4405-A617-21E67ED3A1D4}"/>
+                <a16:creationId xmlns:a16="http://schemas.microsoft.com/office/drawing/2014/main" id="{8BA833D9-DB1B-4921-87ED-C72AB6FFD895}"/>
               </a:ext>
             </a:extLst>
           </p:cNvPr>
@@ -4948,7 +5093,7 @@
           <p:cNvPr id="11" name="">
             <a:extLst xmlns:a="http://schemas.openxmlformats.org/drawingml/2006/main">
               <a:ext uri="{FF2B5EF4-FFF2-40B4-BE49-F238E27FC236}">
-                <a16:creationId xmlns:a16="http://schemas.microsoft.com/office/drawing/2014/main" id="{76F151BD-0508-45E1-B518-244F60AAD759}"/>
+                <a16:creationId xmlns:a16="http://schemas.microsoft.com/office/drawing/2014/main" id="{FE4297C9-EA29-49B6-9158-E737B371239E}"/>
               </a:ext>
             </a:extLst>
           </p:cNvPr>
@@ -4998,7 +5143,7 @@
           <p:cNvPr id="12" name="">
             <a:extLst xmlns:a="http://schemas.openxmlformats.org/drawingml/2006/main">
               <a:ext uri="{FF2B5EF4-FFF2-40B4-BE49-F238E27FC236}">
-                <a16:creationId xmlns:a16="http://schemas.microsoft.com/office/drawing/2014/main" id="{16FD97AF-9CD6-4251-B781-F063FCED2042}"/>
+                <a16:creationId xmlns:a16="http://schemas.microsoft.com/office/drawing/2014/main" id="{BBCBE1FC-4D8D-4394-9681-C600486D642A}"/>
               </a:ext>
             </a:extLst>
           </p:cNvPr>
@@ -5048,7 +5193,7 @@
           <p:cNvPr id="13" name="">
             <a:extLst xmlns:a="http://schemas.openxmlformats.org/drawingml/2006/main">
               <a:ext uri="{FF2B5EF4-FFF2-40B4-BE49-F238E27FC236}">
-                <a16:creationId xmlns:a16="http://schemas.microsoft.com/office/drawing/2014/main" id="{D4242388-EFA5-46EC-8F4A-D04611A0C0DD}"/>
+                <a16:creationId xmlns:a16="http://schemas.microsoft.com/office/drawing/2014/main" id="{D9496F3E-14C7-488B-97F7-8A6BCD304BDB}"/>
               </a:ext>
             </a:extLst>
           </p:cNvPr>
@@ -5081,7 +5226,7 @@
           <p:cNvPr id="14" name="">
             <a:extLst xmlns:a="http://schemas.openxmlformats.org/drawingml/2006/main">
               <a:ext uri="{FF2B5EF4-FFF2-40B4-BE49-F238E27FC236}">
-                <a16:creationId xmlns:a16="http://schemas.microsoft.com/office/drawing/2014/main" id="{2EDDDD62-7A59-400B-8B8A-AFEE9AA0E273}"/>
+                <a16:creationId xmlns:a16="http://schemas.microsoft.com/office/drawing/2014/main" id="{42EDE369-9088-4D0E-84EF-A33E230552F3}"/>
               </a:ext>
             </a:extLst>
           </p:cNvPr>
@@ -5131,7 +5276,7 @@
           <p:cNvPr id="15" name="">
             <a:extLst xmlns:a="http://schemas.openxmlformats.org/drawingml/2006/main">
               <a:ext uri="{FF2B5EF4-FFF2-40B4-BE49-F238E27FC236}">
-                <a16:creationId xmlns:a16="http://schemas.microsoft.com/office/drawing/2014/main" id="{D9C6A2BD-8DA0-4137-A98F-4DF9B86F0A58}"/>
+                <a16:creationId xmlns:a16="http://schemas.microsoft.com/office/drawing/2014/main" id="{B72C3A13-5943-442A-9F79-083B631692F0}"/>
               </a:ext>
             </a:extLst>
           </p:cNvPr>
@@ -5181,7 +5326,7 @@
           <p:cNvPr id="16" name="">
             <a:extLst xmlns:a="http://schemas.openxmlformats.org/drawingml/2006/main">
               <a:ext uri="{FF2B5EF4-FFF2-40B4-BE49-F238E27FC236}">
-                <a16:creationId xmlns:a16="http://schemas.microsoft.com/office/drawing/2014/main" id="{41B005A5-335D-4F7D-AF6E-D956FEEAB0C1}"/>
+                <a16:creationId xmlns:a16="http://schemas.microsoft.com/office/drawing/2014/main" id="{8F807759-B2E1-438C-B0F1-C42B33B23B92}"/>
               </a:ext>
             </a:extLst>
           </p:cNvPr>
@@ -5231,7 +5376,7 @@
           <p:cNvPr id="17" name="">
             <a:extLst xmlns:a="http://schemas.openxmlformats.org/drawingml/2006/main">
               <a:ext uri="{FF2B5EF4-FFF2-40B4-BE49-F238E27FC236}">
-                <a16:creationId xmlns:a16="http://schemas.microsoft.com/office/drawing/2014/main" id="{17396B18-84F4-4701-BCBD-8F7D2641FFD1}"/>
+                <a16:creationId xmlns:a16="http://schemas.microsoft.com/office/drawing/2014/main" id="{924FA4DC-3CFB-4214-91AD-1E0CB411D91C}"/>
               </a:ext>
             </a:extLst>
           </p:cNvPr>
@@ -5264,7 +5409,7 @@
           <p:cNvPr id="18" name="">
             <a:extLst xmlns:a="http://schemas.openxmlformats.org/drawingml/2006/main">
               <a:ext uri="{FF2B5EF4-FFF2-40B4-BE49-F238E27FC236}">
-                <a16:creationId xmlns:a16="http://schemas.microsoft.com/office/drawing/2014/main" id="{74EE27FD-F094-4328-9CE9-6A753B50FA35}"/>
+                <a16:creationId xmlns:a16="http://schemas.microsoft.com/office/drawing/2014/main" id="{169AA5C6-C595-45FE-B70D-9C6549C1C82D}"/>
               </a:ext>
             </a:extLst>
           </p:cNvPr>
@@ -5314,7 +5459,7 @@
           <p:cNvPr id="19" name="">
             <a:extLst xmlns:a="http://schemas.openxmlformats.org/drawingml/2006/main">
               <a:ext uri="{FF2B5EF4-FFF2-40B4-BE49-F238E27FC236}">
-                <a16:creationId xmlns:a16="http://schemas.microsoft.com/office/drawing/2014/main" id="{F6098A14-8E2C-4628-848B-A458D0FD4817}"/>
+                <a16:creationId xmlns:a16="http://schemas.microsoft.com/office/drawing/2014/main" id="{C3F3AB7E-A1EF-4581-8111-239C11BBA344}"/>
               </a:ext>
             </a:extLst>
           </p:cNvPr>
@@ -5364,7 +5509,7 @@
           <p:cNvPr id="20" name="">
             <a:extLst xmlns:a="http://schemas.openxmlformats.org/drawingml/2006/main">
               <a:ext uri="{FF2B5EF4-FFF2-40B4-BE49-F238E27FC236}">
-                <a16:creationId xmlns:a16="http://schemas.microsoft.com/office/drawing/2014/main" id="{185C9D96-4E17-49A0-87C0-DFA6E86CD551}"/>
+                <a16:creationId xmlns:a16="http://schemas.microsoft.com/office/drawing/2014/main" id="{12F5D63D-AC68-4707-AFF5-9BC3E53AB726}"/>
               </a:ext>
             </a:extLst>
           </p:cNvPr>
@@ -5414,7 +5559,7 @@
           <p:cNvPr id="21" name="">
             <a:extLst xmlns:a="http://schemas.openxmlformats.org/drawingml/2006/main">
               <a:ext uri="{FF2B5EF4-FFF2-40B4-BE49-F238E27FC236}">
-                <a16:creationId xmlns:a16="http://schemas.microsoft.com/office/drawing/2014/main" id="{522CF5D7-FEDA-4580-B9C1-B50AFCE361CE}"/>
+                <a16:creationId xmlns:a16="http://schemas.microsoft.com/office/drawing/2014/main" id="{086AD570-1176-42FD-8C14-72CA856ABA17}"/>
               </a:ext>
             </a:extLst>
           </p:cNvPr>
@@ -5447,7 +5592,7 @@
           <p:cNvPr id="22" name="">
             <a:extLst xmlns:a="http://schemas.openxmlformats.org/drawingml/2006/main">
               <a:ext uri="{FF2B5EF4-FFF2-40B4-BE49-F238E27FC236}">
-                <a16:creationId xmlns:a16="http://schemas.microsoft.com/office/drawing/2014/main" id="{97430918-6CD9-4013-86EC-E90A57CE3218}"/>
+                <a16:creationId xmlns:a16="http://schemas.microsoft.com/office/drawing/2014/main" id="{CF69A00C-22B9-4232-867C-8A09549A1CC4}"/>
               </a:ext>
             </a:extLst>
           </p:cNvPr>
@@ -5497,7 +5642,7 @@
           <p:cNvPr id="23" name="">
             <a:extLst xmlns:a="http://schemas.openxmlformats.org/drawingml/2006/main">
               <a:ext uri="{FF2B5EF4-FFF2-40B4-BE49-F238E27FC236}">
-                <a16:creationId xmlns:a16="http://schemas.microsoft.com/office/drawing/2014/main" id="{370BF211-B51F-4344-BFA3-C9C56434BC3C}"/>
+                <a16:creationId xmlns:a16="http://schemas.microsoft.com/office/drawing/2014/main" id="{707E6254-C1FD-442D-A44D-7B51EA500414}"/>
               </a:ext>
             </a:extLst>
           </p:cNvPr>
@@ -5547,7 +5692,7 @@
           <p:cNvPr id="24" name="">
             <a:extLst xmlns:a="http://schemas.openxmlformats.org/drawingml/2006/main">
               <a:ext uri="{FF2B5EF4-FFF2-40B4-BE49-F238E27FC236}">
-                <a16:creationId xmlns:a16="http://schemas.microsoft.com/office/drawing/2014/main" id="{DDF11783-F29C-4AE0-88A5-0CE24382FF55}"/>
+                <a16:creationId xmlns:a16="http://schemas.microsoft.com/office/drawing/2014/main" id="{34946DEE-F69B-4684-A56A-174386261D9F}"/>
               </a:ext>
             </a:extLst>
           </p:cNvPr>
@@ -5597,7 +5742,7 @@
           <p:cNvPr id="25" name="">
             <a:extLst xmlns:a="http://schemas.openxmlformats.org/drawingml/2006/main">
               <a:ext uri="{FF2B5EF4-FFF2-40B4-BE49-F238E27FC236}">
-                <a16:creationId xmlns:a16="http://schemas.microsoft.com/office/drawing/2014/main" id="{9C870239-1394-443E-9212-D6AFF0B44C03}"/>
+                <a16:creationId xmlns:a16="http://schemas.microsoft.com/office/drawing/2014/main" id="{DA5B6E97-6BE7-41F7-97F3-85199678D3A2}"/>
               </a:ext>
             </a:extLst>
           </p:cNvPr>
@@ -5647,7 +5792,7 @@
           <p:cNvPr id="26" name="">
             <a:extLst xmlns:a="http://schemas.openxmlformats.org/drawingml/2006/main">
               <a:ext uri="{FF2B5EF4-FFF2-40B4-BE49-F238E27FC236}">
-                <a16:creationId xmlns:a16="http://schemas.microsoft.com/office/drawing/2014/main" id="{1091C180-7B7C-4EBB-8AEA-D2F3CE9ABD43}"/>
+                <a16:creationId xmlns:a16="http://schemas.microsoft.com/office/drawing/2014/main" id="{3BC6A2DA-3CF9-4944-A3AC-73A5AF5A8B07}"/>
               </a:ext>
             </a:extLst>
           </p:cNvPr>
@@ -5695,7 +5840,7 @@
     </p:spTree>
     <p:extLst>
       <p:ext uri="{BB962C8B-B14F-4D97-AF65-F5344CB8AC3E}">
-        <p14:creationId xmlns:p14="http://schemas.microsoft.com/office/powerpoint/2010/main" val="1819066636"/>
+        <p14:creationId xmlns:p14="http://schemas.microsoft.com/office/powerpoint/2010/main" val="1017032973"/>
       </p:ext>
     </p:extLst>
   </p:cSld>
@@ -5726,7 +5871,7 @@
           <p:cNvPr id="26" name="">
             <a:extLst xmlns:a="http://schemas.openxmlformats.org/drawingml/2006/main">
               <a:ext uri="{FF2B5EF4-FFF2-40B4-BE49-F238E27FC236}">
-                <a16:creationId xmlns:a16="http://schemas.microsoft.com/office/drawing/2014/main" id="{36AA7165-18D9-4013-A59C-9602B108F952}"/>
+                <a16:creationId xmlns:a16="http://schemas.microsoft.com/office/drawing/2014/main" id="{C2908EC0-4A77-4D6D-8CEE-32335EE7CCDF}"/>
               </a:ext>
             </a:extLst>
           </p:cNvPr>
@@ -5776,7 +5921,7 @@
           <p:cNvPr id="2" name="">
             <a:extLst xmlns:a="http://schemas.openxmlformats.org/drawingml/2006/main">
               <a:ext uri="{FF2B5EF4-FFF2-40B4-BE49-F238E27FC236}">
-                <a16:creationId xmlns:a16="http://schemas.microsoft.com/office/drawing/2014/main" id="{D5955A85-AB71-4CC1-A545-226FEE0EBD84}"/>
+                <a16:creationId xmlns:a16="http://schemas.microsoft.com/office/drawing/2014/main" id="{28840109-E9EB-4B2A-85BE-F389F3D92EBA}"/>
               </a:ext>
             </a:extLst>
           </p:cNvPr>
@@ -5826,7 +5971,7 @@
           <p:cNvPr id="3" name="">
             <a:extLst xmlns:a="http://schemas.openxmlformats.org/drawingml/2006/main">
               <a:ext uri="{FF2B5EF4-FFF2-40B4-BE49-F238E27FC236}">
-                <a16:creationId xmlns:a16="http://schemas.microsoft.com/office/drawing/2014/main" id="{078D5620-8AF2-47C4-9A24-E15D10FC2E58}"/>
+                <a16:creationId xmlns:a16="http://schemas.microsoft.com/office/drawing/2014/main" id="{EE144D7B-862E-4E2F-B64A-F349D677686E}"/>
               </a:ext>
             </a:extLst>
           </p:cNvPr>
@@ -5876,7 +6021,7 @@
           <p:cNvPr id="4" name="">
             <a:extLst xmlns:a="http://schemas.openxmlformats.org/drawingml/2006/main">
               <a:ext uri="{FF2B5EF4-FFF2-40B4-BE49-F238E27FC236}">
-                <a16:creationId xmlns:a16="http://schemas.microsoft.com/office/drawing/2014/main" id="{CFCBC902-77FF-4E5C-8CC7-C9E000F28533}"/>
+                <a16:creationId xmlns:a16="http://schemas.microsoft.com/office/drawing/2014/main" id="{7D955BA6-8F0B-4A76-B6AC-B335E5F7E3F1}"/>
               </a:ext>
             </a:extLst>
           </p:cNvPr>
@@ -5926,7 +6071,7 @@
           <p:cNvPr id="5" name="">
             <a:extLst xmlns:a="http://schemas.openxmlformats.org/drawingml/2006/main">
               <a:ext uri="{FF2B5EF4-FFF2-40B4-BE49-F238E27FC236}">
-                <a16:creationId xmlns:a16="http://schemas.microsoft.com/office/drawing/2014/main" id="{FE225BAC-49E1-4AC9-9BE9-2CF3985BFD9B}"/>
+                <a16:creationId xmlns:a16="http://schemas.microsoft.com/office/drawing/2014/main" id="{1F008637-650F-46A2-A715-C592CE0AD3CD}"/>
               </a:ext>
             </a:extLst>
           </p:cNvPr>
@@ -5976,7 +6121,7 @@
           <p:cNvPr id="6" name="">
             <a:extLst xmlns:a="http://schemas.openxmlformats.org/drawingml/2006/main">
               <a:ext uri="{FF2B5EF4-FFF2-40B4-BE49-F238E27FC236}">
-                <a16:creationId xmlns:a16="http://schemas.microsoft.com/office/drawing/2014/main" id="{41DF5640-5DA3-4067-98E1-C861B2292441}"/>
+                <a16:creationId xmlns:a16="http://schemas.microsoft.com/office/drawing/2014/main" id="{FCAB2DE5-28DE-4865-AE0D-95FF26C8E89B}"/>
               </a:ext>
             </a:extLst>
           </p:cNvPr>
@@ -6026,7 +6171,7 @@
           <p:cNvPr id="7" name="">
             <a:extLst xmlns:a="http://schemas.openxmlformats.org/drawingml/2006/main">
               <a:ext uri="{FF2B5EF4-FFF2-40B4-BE49-F238E27FC236}">
-                <a16:creationId xmlns:a16="http://schemas.microsoft.com/office/drawing/2014/main" id="{3FFB29BC-95AB-4D9C-9497-4A26266BCF68}"/>
+                <a16:creationId xmlns:a16="http://schemas.microsoft.com/office/drawing/2014/main" id="{0A31901E-A06D-47C8-AA79-6F18D3B2D304}"/>
               </a:ext>
             </a:extLst>
           </p:cNvPr>
@@ -6076,7 +6221,7 @@
           <p:cNvPr id="8" name="">
             <a:extLst xmlns:a="http://schemas.openxmlformats.org/drawingml/2006/main">
               <a:ext uri="{FF2B5EF4-FFF2-40B4-BE49-F238E27FC236}">
-                <a16:creationId xmlns:a16="http://schemas.microsoft.com/office/drawing/2014/main" id="{90EF2A44-061C-4C7C-8503-5E887ACFECB5}"/>
+                <a16:creationId xmlns:a16="http://schemas.microsoft.com/office/drawing/2014/main" id="{FDF2B606-EF65-422E-820D-44204C6C4991}"/>
               </a:ext>
             </a:extLst>
           </p:cNvPr>
@@ -6109,7 +6254,7 @@
           <p:cNvPr id="9" name="">
             <a:extLst xmlns:a="http://schemas.openxmlformats.org/drawingml/2006/main">
               <a:ext uri="{FF2B5EF4-FFF2-40B4-BE49-F238E27FC236}">
-                <a16:creationId xmlns:a16="http://schemas.microsoft.com/office/drawing/2014/main" id="{23AF323B-BCE6-4D1E-AC2A-BD8C06D8CC1A}"/>
+                <a16:creationId xmlns:a16="http://schemas.microsoft.com/office/drawing/2014/main" id="{18641C8C-94B0-4185-90FE-694F91E680C3}"/>
               </a:ext>
             </a:extLst>
           </p:cNvPr>
@@ -6159,7 +6304,7 @@
           <p:cNvPr id="10" name="">
             <a:extLst xmlns:a="http://schemas.openxmlformats.org/drawingml/2006/main">
               <a:ext uri="{FF2B5EF4-FFF2-40B4-BE49-F238E27FC236}">
-                <a16:creationId xmlns:a16="http://schemas.microsoft.com/office/drawing/2014/main" id="{762261DB-49E9-4C12-AA1E-98F3B8249202}"/>
+                <a16:creationId xmlns:a16="http://schemas.microsoft.com/office/drawing/2014/main" id="{76CFD24E-17F8-4F6B-AC7B-11A56F1A3AF1}"/>
               </a:ext>
             </a:extLst>
           </p:cNvPr>
@@ -6209,7 +6354,7 @@
           <p:cNvPr id="11" name="">
             <a:extLst xmlns:a="http://schemas.openxmlformats.org/drawingml/2006/main">
               <a:ext uri="{FF2B5EF4-FFF2-40B4-BE49-F238E27FC236}">
-                <a16:creationId xmlns:a16="http://schemas.microsoft.com/office/drawing/2014/main" id="{2CF9EB23-3DC4-4445-AACD-D589D059BD61}"/>
+                <a16:creationId xmlns:a16="http://schemas.microsoft.com/office/drawing/2014/main" id="{3D6FCAAF-F3A9-4F81-A4A7-7C4DEFE14363}"/>
               </a:ext>
             </a:extLst>
           </p:cNvPr>
@@ -6259,7 +6404,7 @@
           <p:cNvPr id="12" name="">
             <a:extLst xmlns:a="http://schemas.openxmlformats.org/drawingml/2006/main">
               <a:ext uri="{FF2B5EF4-FFF2-40B4-BE49-F238E27FC236}">
-                <a16:creationId xmlns:a16="http://schemas.microsoft.com/office/drawing/2014/main" id="{18338B1A-128F-4ABD-978F-4782E222B54A}"/>
+                <a16:creationId xmlns:a16="http://schemas.microsoft.com/office/drawing/2014/main" id="{7B2B7DA0-96D3-4905-A99F-AB4B038DD8B1}"/>
               </a:ext>
             </a:extLst>
           </p:cNvPr>
@@ -6309,7 +6454,7 @@
           <p:cNvPr id="13" name="">
             <a:extLst xmlns:a="http://schemas.openxmlformats.org/drawingml/2006/main">
               <a:ext uri="{FF2B5EF4-FFF2-40B4-BE49-F238E27FC236}">
-                <a16:creationId xmlns:a16="http://schemas.microsoft.com/office/drawing/2014/main" id="{75A609DE-0413-4897-A09F-074907485EDB}"/>
+                <a16:creationId xmlns:a16="http://schemas.microsoft.com/office/drawing/2014/main" id="{D05E4685-741C-4BAD-B135-D9D104CB3152}"/>
               </a:ext>
             </a:extLst>
           </p:cNvPr>
@@ -6342,7 +6487,7 @@
           <p:cNvPr id="14" name="">
             <a:extLst xmlns:a="http://schemas.openxmlformats.org/drawingml/2006/main">
               <a:ext uri="{FF2B5EF4-FFF2-40B4-BE49-F238E27FC236}">
-                <a16:creationId xmlns:a16="http://schemas.microsoft.com/office/drawing/2014/main" id="{9E8C14E8-EFB4-4618-B101-1E587D66E215}"/>
+                <a16:creationId xmlns:a16="http://schemas.microsoft.com/office/drawing/2014/main" id="{F11971A1-7AC4-45F3-9D9D-FDB0AD912F8E}"/>
               </a:ext>
             </a:extLst>
           </p:cNvPr>
@@ -6392,7 +6537,7 @@
           <p:cNvPr id="15" name="">
             <a:extLst xmlns:a="http://schemas.openxmlformats.org/drawingml/2006/main">
               <a:ext uri="{FF2B5EF4-FFF2-40B4-BE49-F238E27FC236}">
-                <a16:creationId xmlns:a16="http://schemas.microsoft.com/office/drawing/2014/main" id="{624128E1-8C56-4548-9B2C-F0F801EB8756}"/>
+                <a16:creationId xmlns:a16="http://schemas.microsoft.com/office/drawing/2014/main" id="{31C7DA25-6812-4C8D-915E-E260F561ECF0}"/>
               </a:ext>
             </a:extLst>
           </p:cNvPr>
@@ -6442,7 +6587,7 @@
           <p:cNvPr id="16" name="">
             <a:extLst xmlns:a="http://schemas.openxmlformats.org/drawingml/2006/main">
               <a:ext uri="{FF2B5EF4-FFF2-40B4-BE49-F238E27FC236}">
-                <a16:creationId xmlns:a16="http://schemas.microsoft.com/office/drawing/2014/main" id="{7656EEB4-F969-4401-BB41-5853FEDDED64}"/>
+                <a16:creationId xmlns:a16="http://schemas.microsoft.com/office/drawing/2014/main" id="{79E81CF2-F568-4010-818A-A97CFA09EE49}"/>
               </a:ext>
             </a:extLst>
           </p:cNvPr>
@@ -6492,7 +6637,7 @@
           <p:cNvPr id="17" name="">
             <a:extLst xmlns:a="http://schemas.openxmlformats.org/drawingml/2006/main">
               <a:ext uri="{FF2B5EF4-FFF2-40B4-BE49-F238E27FC236}">
-                <a16:creationId xmlns:a16="http://schemas.microsoft.com/office/drawing/2014/main" id="{C5A6CF78-4A54-47DB-9F58-F807CF35448E}"/>
+                <a16:creationId xmlns:a16="http://schemas.microsoft.com/office/drawing/2014/main" id="{21D9F83E-739A-4645-A337-4C1D7464A8F6}"/>
               </a:ext>
             </a:extLst>
           </p:cNvPr>
@@ -6542,7 +6687,7 @@
           <p:cNvPr id="18" name="">
             <a:extLst xmlns:a="http://schemas.openxmlformats.org/drawingml/2006/main">
               <a:ext uri="{FF2B5EF4-FFF2-40B4-BE49-F238E27FC236}">
-                <a16:creationId xmlns:a16="http://schemas.microsoft.com/office/drawing/2014/main" id="{B25530C3-71FB-4953-BDF5-7AF8520A6B24}"/>
+                <a16:creationId xmlns:a16="http://schemas.microsoft.com/office/drawing/2014/main" id="{88DDDB57-BA42-4A68-9C61-1C9B078FE88C}"/>
               </a:ext>
             </a:extLst>
           </p:cNvPr>
@@ -6575,7 +6720,7 @@
           <p:cNvPr id="19" name="">
             <a:extLst xmlns:a="http://schemas.openxmlformats.org/drawingml/2006/main">
               <a:ext uri="{FF2B5EF4-FFF2-40B4-BE49-F238E27FC236}">
-                <a16:creationId xmlns:a16="http://schemas.microsoft.com/office/drawing/2014/main" id="{34364924-F977-4836-9D07-A79F446A97B6}"/>
+                <a16:creationId xmlns:a16="http://schemas.microsoft.com/office/drawing/2014/main" id="{8F545A75-AFFC-41BE-97FD-F297410D7E4C}"/>
               </a:ext>
             </a:extLst>
           </p:cNvPr>
@@ -6625,7 +6770,7 @@
           <p:cNvPr id="20" name="">
             <a:extLst xmlns:a="http://schemas.openxmlformats.org/drawingml/2006/main">
               <a:ext uri="{FF2B5EF4-FFF2-40B4-BE49-F238E27FC236}">
-                <a16:creationId xmlns:a16="http://schemas.microsoft.com/office/drawing/2014/main" id="{F1BC1EF7-A2EF-4D64-918A-5EB60B8B13C7}"/>
+                <a16:creationId xmlns:a16="http://schemas.microsoft.com/office/drawing/2014/main" id="{F6FFAB78-FE0F-4C38-A501-2A5C050BDF96}"/>
               </a:ext>
             </a:extLst>
           </p:cNvPr>
@@ -6675,7 +6820,7 @@
           <p:cNvPr id="21" name="">
             <a:extLst xmlns:a="http://schemas.openxmlformats.org/drawingml/2006/main">
               <a:ext uri="{FF2B5EF4-FFF2-40B4-BE49-F238E27FC236}">
-                <a16:creationId xmlns:a16="http://schemas.microsoft.com/office/drawing/2014/main" id="{DAE7F9F5-2095-473E-AA14-F146C39C301E}"/>
+                <a16:creationId xmlns:a16="http://schemas.microsoft.com/office/drawing/2014/main" id="{FEFACAE5-323A-4416-A3F3-E04C1F7252BD}"/>
               </a:ext>
             </a:extLst>
           </p:cNvPr>
@@ -6725,7 +6870,7 @@
           <p:cNvPr id="22" name="">
             <a:extLst xmlns:a="http://schemas.openxmlformats.org/drawingml/2006/main">
               <a:ext uri="{FF2B5EF4-FFF2-40B4-BE49-F238E27FC236}">
-                <a16:creationId xmlns:a16="http://schemas.microsoft.com/office/drawing/2014/main" id="{CDC36533-FDB3-485F-8F4D-BEBD065FEBE6}"/>
+                <a16:creationId xmlns:a16="http://schemas.microsoft.com/office/drawing/2014/main" id="{33327DEC-011B-4060-B702-BCC109AA947C}"/>
               </a:ext>
             </a:extLst>
           </p:cNvPr>
@@ -6775,7 +6920,7 @@
           <p:cNvPr id="23" name="">
             <a:extLst xmlns:a="http://schemas.openxmlformats.org/drawingml/2006/main">
               <a:ext uri="{FF2B5EF4-FFF2-40B4-BE49-F238E27FC236}">
-                <a16:creationId xmlns:a16="http://schemas.microsoft.com/office/drawing/2014/main" id="{E0BFE10F-96DA-4A24-96F4-1E80613BE952}"/>
+                <a16:creationId xmlns:a16="http://schemas.microsoft.com/office/drawing/2014/main" id="{BFF849E9-D63E-4898-B8BC-F56FBC6980CD}"/>
               </a:ext>
             </a:extLst>
           </p:cNvPr>
@@ -6825,7 +6970,7 @@
           <p:cNvPr id="24" name="">
             <a:extLst xmlns:a="http://schemas.openxmlformats.org/drawingml/2006/main">
               <a:ext uri="{FF2B5EF4-FFF2-40B4-BE49-F238E27FC236}">
-                <a16:creationId xmlns:a16="http://schemas.microsoft.com/office/drawing/2014/main" id="{57C919EB-3C82-4BB2-A2D7-F401011FB156}"/>
+                <a16:creationId xmlns:a16="http://schemas.microsoft.com/office/drawing/2014/main" id="{6AFFC7C6-BD68-4CD9-AF68-194F489AD0D9}"/>
               </a:ext>
             </a:extLst>
           </p:cNvPr>
@@ -6875,7 +7020,7 @@
           <p:cNvPr id="25" name="">
             <a:extLst xmlns:a="http://schemas.openxmlformats.org/drawingml/2006/main">
               <a:ext uri="{FF2B5EF4-FFF2-40B4-BE49-F238E27FC236}">
-                <a16:creationId xmlns:a16="http://schemas.microsoft.com/office/drawing/2014/main" id="{281D6BE8-FBDA-4B73-A07A-7E7306169751}"/>
+                <a16:creationId xmlns:a16="http://schemas.microsoft.com/office/drawing/2014/main" id="{18D2F999-37AE-4C44-80B8-9BE2D955F2A6}"/>
               </a:ext>
             </a:extLst>
           </p:cNvPr>
@@ -6923,7 +7068,7 @@
     </p:spTree>
     <p:extLst>
       <p:ext uri="{BB962C8B-B14F-4D97-AF65-F5344CB8AC3E}">
-        <p14:creationId xmlns:p14="http://schemas.microsoft.com/office/powerpoint/2010/main" val="1472316968"/>
+        <p14:creationId xmlns:p14="http://schemas.microsoft.com/office/powerpoint/2010/main" val="578757707"/>
       </p:ext>
     </p:extLst>
   </p:cSld>
@@ -6954,7 +7099,7 @@
           <p:cNvPr id="11" name="">
             <a:extLst xmlns:a="http://schemas.openxmlformats.org/drawingml/2006/main">
               <a:ext uri="{FF2B5EF4-FFF2-40B4-BE49-F238E27FC236}">
-                <a16:creationId xmlns:a16="http://schemas.microsoft.com/office/drawing/2014/main" id="{511522D3-C910-4E8B-9441-4C5318284D20}"/>
+                <a16:creationId xmlns:a16="http://schemas.microsoft.com/office/drawing/2014/main" id="{DD6596D9-9A2E-443F-9296-45E616F788FC}"/>
               </a:ext>
             </a:extLst>
           </p:cNvPr>
@@ -7004,7 +7149,7 @@
           <p:cNvPr id="2" name="">
             <a:extLst xmlns:a="http://schemas.openxmlformats.org/drawingml/2006/main">
               <a:ext uri="{FF2B5EF4-FFF2-40B4-BE49-F238E27FC236}">
-                <a16:creationId xmlns:a16="http://schemas.microsoft.com/office/drawing/2014/main" id="{10FE5844-FF83-43DA-9B72-667AA8B99F41}"/>
+                <a16:creationId xmlns:a16="http://schemas.microsoft.com/office/drawing/2014/main" id="{7BC08004-59CE-4018-A02F-B2E32AD85686}"/>
               </a:ext>
             </a:extLst>
           </p:cNvPr>
@@ -7054,7 +7199,7 @@
           <p:cNvPr id="3" name="">
             <a:extLst xmlns:a="http://schemas.openxmlformats.org/drawingml/2006/main">
               <a:ext uri="{FF2B5EF4-FFF2-40B4-BE49-F238E27FC236}">
-                <a16:creationId xmlns:a16="http://schemas.microsoft.com/office/drawing/2014/main" id="{F3940043-736D-40CF-9341-D44EFEBFEEC4}"/>
+                <a16:creationId xmlns:a16="http://schemas.microsoft.com/office/drawing/2014/main" id="{98BC731F-5E44-42AE-B521-C14C9E0BAA15}"/>
               </a:ext>
             </a:extLst>
           </p:cNvPr>
@@ -7111,7 +7256,7 @@
         </p:xfrm>
         <a:graphic xmlns:a="http://schemas.openxmlformats.org/drawingml/2006/main">
           <a:graphicData uri="http://schemas.openxmlformats.org/drawingml/2006/chart">
-            <c:chart xmlns:r="http://schemas.openxmlformats.org/officeDocument/2006/relationships" xmlns:c="http://schemas.openxmlformats.org/drawingml/2006/chart" r:id="Rf7e99af044124c4d"/>
+            <c:chart xmlns:r="http://schemas.openxmlformats.org/officeDocument/2006/relationships" xmlns:c="http://schemas.openxmlformats.org/drawingml/2006/chart" r:id="Rb7b7fb5439064a94"/>
           </a:graphicData>
         </a:graphic>
       </p:graphicFrame>
@@ -7120,7 +7265,7 @@
           <p:cNvPr id="5" name="">
             <a:extLst xmlns:a="http://schemas.openxmlformats.org/drawingml/2006/main">
               <a:ext uri="{FF2B5EF4-FFF2-40B4-BE49-F238E27FC236}">
-                <a16:creationId xmlns:a16="http://schemas.microsoft.com/office/drawing/2014/main" id="{54D19F00-1BEE-4A9F-AF5D-DC08A7F1682A}"/>
+                <a16:creationId xmlns:a16="http://schemas.microsoft.com/office/drawing/2014/main" id="{2BF0120E-FB99-4CD6-A1EE-A624F78A533F}"/>
               </a:ext>
             </a:extLst>
           </p:cNvPr>
@@ -7170,7 +7315,7 @@
           <p:cNvPr id="6" name="">
             <a:extLst xmlns:a="http://schemas.openxmlformats.org/drawingml/2006/main">
               <a:ext uri="{FF2B5EF4-FFF2-40B4-BE49-F238E27FC236}">
-                <a16:creationId xmlns:a16="http://schemas.microsoft.com/office/drawing/2014/main" id="{2AD419E9-6610-4E80-B3D5-367E973A96D7}"/>
+                <a16:creationId xmlns:a16="http://schemas.microsoft.com/office/drawing/2014/main" id="{2B5C1584-1751-4DB8-9AC2-A19E8D0DF7EF}"/>
               </a:ext>
             </a:extLst>
           </p:cNvPr>
@@ -7237,7 +7382,7 @@
           <p:cNvPr id="7" name="">
             <a:extLst xmlns:a="http://schemas.openxmlformats.org/drawingml/2006/main">
               <a:ext uri="{FF2B5EF4-FFF2-40B4-BE49-F238E27FC236}">
-                <a16:creationId xmlns:a16="http://schemas.microsoft.com/office/drawing/2014/main" id="{93635E3C-D962-4861-9EBE-D2BB7992B149}"/>
+                <a16:creationId xmlns:a16="http://schemas.microsoft.com/office/drawing/2014/main" id="{BB91D797-3809-4DC5-A82A-6A1B2CECDE60}"/>
               </a:ext>
             </a:extLst>
           </p:cNvPr>
@@ -7287,7 +7432,7 @@
           <p:cNvPr id="8" name="">
             <a:extLst xmlns:a="http://schemas.openxmlformats.org/drawingml/2006/main">
               <a:ext uri="{FF2B5EF4-FFF2-40B4-BE49-F238E27FC236}">
-                <a16:creationId xmlns:a16="http://schemas.microsoft.com/office/drawing/2014/main" id="{EA7EFC9B-A40E-43C0-84B6-E7C661AB79D2}"/>
+                <a16:creationId xmlns:a16="http://schemas.microsoft.com/office/drawing/2014/main" id="{604128FA-7DCF-4D0F-96C3-32AD412D5B3B}"/>
               </a:ext>
             </a:extLst>
           </p:cNvPr>
@@ -7354,7 +7499,7 @@
           <p:cNvPr id="9" name="">
             <a:extLst xmlns:a="http://schemas.openxmlformats.org/drawingml/2006/main">
               <a:ext uri="{FF2B5EF4-FFF2-40B4-BE49-F238E27FC236}">
-                <a16:creationId xmlns:a16="http://schemas.microsoft.com/office/drawing/2014/main" id="{1B5A81D0-8687-445E-80F9-C52E9EEDCE91}"/>
+                <a16:creationId xmlns:a16="http://schemas.microsoft.com/office/drawing/2014/main" id="{A925691B-EB02-4C4E-B8CA-17A2C0F59CE1}"/>
               </a:ext>
             </a:extLst>
           </p:cNvPr>
@@ -7404,7 +7549,7 @@
           <p:cNvPr id="10" name="">
             <a:extLst xmlns:a="http://schemas.openxmlformats.org/drawingml/2006/main">
               <a:ext uri="{FF2B5EF4-FFF2-40B4-BE49-F238E27FC236}">
-                <a16:creationId xmlns:a16="http://schemas.microsoft.com/office/drawing/2014/main" id="{5D8C94CE-6CEE-4228-9054-8F613E2FA576}"/>
+                <a16:creationId xmlns:a16="http://schemas.microsoft.com/office/drawing/2014/main" id="{A12BA7D5-1292-460B-ACE5-EC78C2BB4B3C}"/>
               </a:ext>
             </a:extLst>
           </p:cNvPr>
@@ -7452,7 +7597,7 @@
     </p:spTree>
     <p:extLst>
       <p:ext uri="{BB962C8B-B14F-4D97-AF65-F5344CB8AC3E}">
-        <p14:creationId xmlns:p14="http://schemas.microsoft.com/office/powerpoint/2010/main" val="1598265801"/>
+        <p14:creationId xmlns:p14="http://schemas.microsoft.com/office/powerpoint/2010/main" val="161985838"/>
       </p:ext>
     </p:extLst>
   </p:cSld>
@@ -7483,7 +7628,7 @@
           <p:cNvPr id="13" name="">
             <a:extLst xmlns:a="http://schemas.openxmlformats.org/drawingml/2006/main">
               <a:ext uri="{FF2B5EF4-FFF2-40B4-BE49-F238E27FC236}">
-                <a16:creationId xmlns:a16="http://schemas.microsoft.com/office/drawing/2014/main" id="{76F2182A-0B94-4B18-B764-4780A67D2877}"/>
+                <a16:creationId xmlns:a16="http://schemas.microsoft.com/office/drawing/2014/main" id="{69835FD8-780B-4DA1-9014-82F55EF4DCF4}"/>
               </a:ext>
             </a:extLst>
           </p:cNvPr>
@@ -7533,7 +7678,7 @@
           <p:cNvPr id="2" name="">
             <a:extLst xmlns:a="http://schemas.openxmlformats.org/drawingml/2006/main">
               <a:ext uri="{FF2B5EF4-FFF2-40B4-BE49-F238E27FC236}">
-                <a16:creationId xmlns:a16="http://schemas.microsoft.com/office/drawing/2014/main" id="{25607DFC-87D9-4C40-8A4B-0B28EFDB722B}"/>
+                <a16:creationId xmlns:a16="http://schemas.microsoft.com/office/drawing/2014/main" id="{8721AF97-02B7-4D50-B199-C1EB810EB9E9}"/>
               </a:ext>
             </a:extLst>
           </p:cNvPr>
@@ -7583,7 +7728,7 @@
           <p:cNvPr id="3" name="">
             <a:extLst xmlns:a="http://schemas.openxmlformats.org/drawingml/2006/main">
               <a:ext uri="{FF2B5EF4-FFF2-40B4-BE49-F238E27FC236}">
-                <a16:creationId xmlns:a16="http://schemas.microsoft.com/office/drawing/2014/main" id="{B338FA67-1495-4494-B4C0-63805E1267F5}"/>
+                <a16:creationId xmlns:a16="http://schemas.microsoft.com/office/drawing/2014/main" id="{B8A2E13C-EC88-465F-B531-373605ED25D1}"/>
               </a:ext>
             </a:extLst>
           </p:cNvPr>
@@ -7640,7 +7785,7 @@
         </p:xfrm>
         <a:graphic xmlns:a="http://schemas.openxmlformats.org/drawingml/2006/main">
           <a:graphicData uri="http://schemas.openxmlformats.org/drawingml/2006/chart">
-            <c:chart xmlns:r="http://schemas.openxmlformats.org/officeDocument/2006/relationships" xmlns:c="http://schemas.openxmlformats.org/drawingml/2006/chart" r:id="Rd03c0e0b61034803"/>
+            <c:chart xmlns:r="http://schemas.openxmlformats.org/officeDocument/2006/relationships" xmlns:c="http://schemas.openxmlformats.org/drawingml/2006/chart" r:id="Rcce14c1010aa460b"/>
           </a:graphicData>
         </a:graphic>
       </p:graphicFrame>
@@ -7649,7 +7794,7 @@
           <p:cNvPr id="5" name="">
             <a:extLst xmlns:a="http://schemas.openxmlformats.org/drawingml/2006/main">
               <a:ext uri="{FF2B5EF4-FFF2-40B4-BE49-F238E27FC236}">
-                <a16:creationId xmlns:a16="http://schemas.microsoft.com/office/drawing/2014/main" id="{767E887A-2D25-466F-BA0A-88EB8B3FA29A}"/>
+                <a16:creationId xmlns:a16="http://schemas.microsoft.com/office/drawing/2014/main" id="{EA32EC58-98FE-49BF-A6F9-CD760A19A008}"/>
               </a:ext>
             </a:extLst>
           </p:cNvPr>
@@ -7699,7 +7844,7 @@
           <p:cNvPr id="6" name="">
             <a:extLst xmlns:a="http://schemas.openxmlformats.org/drawingml/2006/main">
               <a:ext uri="{FF2B5EF4-FFF2-40B4-BE49-F238E27FC236}">
-                <a16:creationId xmlns:a16="http://schemas.microsoft.com/office/drawing/2014/main" id="{2A3B1075-58EF-4FFD-B12A-297CA05DFF7D}"/>
+                <a16:creationId xmlns:a16="http://schemas.microsoft.com/office/drawing/2014/main" id="{A9B99428-4818-418F-8721-9434CEE7362F}"/>
               </a:ext>
             </a:extLst>
           </p:cNvPr>
@@ -7749,7 +7894,7 @@
           <p:cNvPr id="7" name="">
             <a:extLst xmlns:a="http://schemas.openxmlformats.org/drawingml/2006/main">
               <a:ext uri="{FF2B5EF4-FFF2-40B4-BE49-F238E27FC236}">
-                <a16:creationId xmlns:a16="http://schemas.microsoft.com/office/drawing/2014/main" id="{724DD013-8309-41AD-862F-3C0B84EB40DC}"/>
+                <a16:creationId xmlns:a16="http://schemas.microsoft.com/office/drawing/2014/main" id="{2875168D-787B-49BF-BE3F-73260B5AE875}"/>
               </a:ext>
             </a:extLst>
           </p:cNvPr>
@@ -7799,7 +7944,7 @@
           <p:cNvPr id="8" name="">
             <a:extLst xmlns:a="http://schemas.openxmlformats.org/drawingml/2006/main">
               <a:ext uri="{FF2B5EF4-FFF2-40B4-BE49-F238E27FC236}">
-                <a16:creationId xmlns:a16="http://schemas.microsoft.com/office/drawing/2014/main" id="{93BBEFFF-54A1-4AD2-986D-A531DCFF5CFE}"/>
+                <a16:creationId xmlns:a16="http://schemas.microsoft.com/office/drawing/2014/main" id="{F508C29F-06CC-45E3-82CD-F8E42E320144}"/>
               </a:ext>
             </a:extLst>
           </p:cNvPr>
@@ -7849,7 +7994,7 @@
           <p:cNvPr id="9" name="">
             <a:extLst xmlns:a="http://schemas.openxmlformats.org/drawingml/2006/main">
               <a:ext uri="{FF2B5EF4-FFF2-40B4-BE49-F238E27FC236}">
-                <a16:creationId xmlns:a16="http://schemas.microsoft.com/office/drawing/2014/main" id="{3BE5FBC1-FAE4-4B52-ABC7-F220C430FF55}"/>
+                <a16:creationId xmlns:a16="http://schemas.microsoft.com/office/drawing/2014/main" id="{D4DA28C7-4611-436A-A3CD-A1768CC6C4AD}"/>
               </a:ext>
             </a:extLst>
           </p:cNvPr>
@@ -7899,7 +8044,7 @@
           <p:cNvPr id="10" name="">
             <a:extLst xmlns:a="http://schemas.openxmlformats.org/drawingml/2006/main">
               <a:ext uri="{FF2B5EF4-FFF2-40B4-BE49-F238E27FC236}">
-                <a16:creationId xmlns:a16="http://schemas.microsoft.com/office/drawing/2014/main" id="{60E08948-19A3-4A47-A805-37FF0617FF9F}"/>
+                <a16:creationId xmlns:a16="http://schemas.microsoft.com/office/drawing/2014/main" id="{07560319-832F-4D38-84A8-1AE899E97638}"/>
               </a:ext>
             </a:extLst>
           </p:cNvPr>
@@ -7949,7 +8094,7 @@
           <p:cNvPr id="11" name="">
             <a:extLst xmlns:a="http://schemas.openxmlformats.org/drawingml/2006/main">
               <a:ext uri="{FF2B5EF4-FFF2-40B4-BE49-F238E27FC236}">
-                <a16:creationId xmlns:a16="http://schemas.microsoft.com/office/drawing/2014/main" id="{B3314C98-1F08-44F6-BA6C-BC6A61915D19}"/>
+                <a16:creationId xmlns:a16="http://schemas.microsoft.com/office/drawing/2014/main" id="{F99FD2DB-F8E1-4AA9-B254-6EE458F21170}"/>
               </a:ext>
             </a:extLst>
           </p:cNvPr>
@@ -7999,7 +8144,7 @@
           <p:cNvPr id="12" name="">
             <a:extLst xmlns:a="http://schemas.openxmlformats.org/drawingml/2006/main">
               <a:ext uri="{FF2B5EF4-FFF2-40B4-BE49-F238E27FC236}">
-                <a16:creationId xmlns:a16="http://schemas.microsoft.com/office/drawing/2014/main" id="{C5200610-24FF-4713-B4B3-EDE12F7C8347}"/>
+                <a16:creationId xmlns:a16="http://schemas.microsoft.com/office/drawing/2014/main" id="{C03E1094-2520-4865-BC73-16536D7944D5}"/>
               </a:ext>
             </a:extLst>
           </p:cNvPr>
@@ -8047,7 +8192,7 @@
     </p:spTree>
     <p:extLst>
       <p:ext uri="{BB962C8B-B14F-4D97-AF65-F5344CB8AC3E}">
-        <p14:creationId xmlns:p14="http://schemas.microsoft.com/office/powerpoint/2010/main" val="924799870"/>
+        <p14:creationId xmlns:p14="http://schemas.microsoft.com/office/powerpoint/2010/main" val="1743924887"/>
       </p:ext>
     </p:extLst>
   </p:cSld>
@@ -8075,10 +8220,10 @@
       </p:grpSpPr>
       <p:sp>
         <p:nvSpPr>
-          <p:cNvPr id="16" name="">
-            <a:extLst xmlns:a="http://schemas.openxmlformats.org/drawingml/2006/main">
-              <a:ext uri="{FF2B5EF4-FFF2-40B4-BE49-F238E27FC236}">
-                <a16:creationId xmlns:a16="http://schemas.microsoft.com/office/drawing/2014/main" id="{DD15B4AF-22AE-4894-AC24-ECF91EFCF285}"/>
+          <p:cNvPr id="14" name="">
+            <a:extLst xmlns:a="http://schemas.openxmlformats.org/drawingml/2006/main">
+              <a:ext uri="{FF2B5EF4-FFF2-40B4-BE49-F238E27FC236}">
+                <a16:creationId xmlns:a16="http://schemas.microsoft.com/office/drawing/2014/main" id="{5B528ED6-F0F5-4BCF-9ACC-EF03E74D93E1}"/>
               </a:ext>
             </a:extLst>
           </p:cNvPr>
@@ -8128,7 +8273,7 @@
           <p:cNvPr id="2" name="">
             <a:extLst xmlns:a="http://schemas.openxmlformats.org/drawingml/2006/main">
               <a:ext uri="{FF2B5EF4-FFF2-40B4-BE49-F238E27FC236}">
-                <a16:creationId xmlns:a16="http://schemas.microsoft.com/office/drawing/2014/main" id="{0E2E247F-CF50-474E-A3E2-909DC56D999A}"/>
+                <a16:creationId xmlns:a16="http://schemas.microsoft.com/office/drawing/2014/main" id="{C462C104-A1C5-4067-9A9F-0FCBCE8FD5F6}"/>
               </a:ext>
             </a:extLst>
           </p:cNvPr>
@@ -8168,7 +8313,7 @@
                   <a:srgbClr val="0B2545"/>
                 </a:solidFill>
               </a:rPr>
-              <a:t>The findings point to three immediate decisions</a:t>
+              <a:t>Refunds expose concentrated product risk</a:t>
             </a:r>
           </a:p>
         </p:txBody>
@@ -8178,69 +8323,135 @@
           <p:cNvPr id="3" name="">
             <a:extLst xmlns:a="http://schemas.openxmlformats.org/drawingml/2006/main">
               <a:ext uri="{FF2B5EF4-FFF2-40B4-BE49-F238E27FC236}">
-                <a16:creationId xmlns:a16="http://schemas.microsoft.com/office/drawing/2014/main" id="{3E5F44C1-E818-4FE8-8765-064775D48D85}"/>
-              </a:ext>
-            </a:extLst>
-          </p:cNvPr>
-          <p:cNvSpPr>
-            <a:spLocks xmlns:a="http://schemas.openxmlformats.org/drawingml/2006/main" noGrp="1"/>
-          </p:cNvSpPr>
-          <p:nvPr/>
-        </p:nvSpPr>
-        <p:spPr>
-          <a:xfrm xmlns:a="http://schemas.openxmlformats.org/drawingml/2006/main">
-            <a:off x="762000" y="1952625"/>
-            <a:ext cx="571500" cy="523875"/>
-          </a:xfrm>
-          <a:prstGeom xmlns:a="http://schemas.openxmlformats.org/drawingml/2006/main" prst="rect">
-            <a:avLst/>
-          </a:prstGeom>
-          <a:noFill xmlns:a="http://schemas.openxmlformats.org/drawingml/2006/main"/>
-          <a:ln xmlns:a="http://schemas.openxmlformats.org/drawingml/2006/main" w="0">
-            <a:noFill/>
-            <a:prstDash val="solid"/>
-          </a:ln>
-        </p:spPr>
-        <p:txBody>
-          <a:bodyPr xmlns:a="http://schemas.openxmlformats.org/drawingml/2006/main"/>
-          <a:lstStyle xmlns:a="http://schemas.openxmlformats.org/drawingml/2006/main"/>
-          <a:p xmlns:a="http://schemas.openxmlformats.org/drawingml/2006/main">
-            <a:pPr algn="ctr">
-              <a:defRPr sz="2550" b="1">
+                <a16:creationId xmlns:a16="http://schemas.microsoft.com/office/drawing/2014/main" id="{E3BCE7AB-5288-4CE2-863B-7BC901209766}"/>
+              </a:ext>
+            </a:extLst>
+          </p:cNvPr>
+          <p:cNvSpPr>
+            <a:spLocks xmlns:a="http://schemas.openxmlformats.org/drawingml/2006/main" noGrp="1"/>
+          </p:cNvSpPr>
+          <p:nvPr/>
+        </p:nvSpPr>
+        <p:spPr>
+          <a:xfrm xmlns:a="http://schemas.openxmlformats.org/drawingml/2006/main">
+            <a:off x="685800" y="1257300"/>
+            <a:ext cx="10477500" cy="361950"/>
+          </a:xfrm>
+          <a:prstGeom xmlns:a="http://schemas.openxmlformats.org/drawingml/2006/main" prst="rect">
+            <a:avLst/>
+          </a:prstGeom>
+          <a:noFill xmlns:a="http://schemas.openxmlformats.org/drawingml/2006/main"/>
+          <a:ln xmlns:a="http://schemas.openxmlformats.org/drawingml/2006/main" w="0">
+            <a:noFill/>
+            <a:prstDash val="solid"/>
+          </a:ln>
+        </p:spPr>
+        <p:txBody>
+          <a:bodyPr xmlns:a="http://schemas.openxmlformats.org/drawingml/2006/main"/>
+          <a:lstStyle xmlns:a="http://schemas.openxmlformats.org/drawingml/2006/main"/>
+          <a:p xmlns:a="http://schemas.openxmlformats.org/drawingml/2006/main">
+            <a:pPr algn="l">
+              <a:defRPr sz="1425" b="0">
+                <a:solidFill>
+                  <a:srgbClr val="667085"/>
+                </a:solidFill>
+              </a:defRPr>
+            </a:pPr>
+            <a:r>
+              <a:rPr sz="1425" b="0">
+                <a:solidFill>
+                  <a:srgbClr val="667085"/>
+                </a:solidFill>
+              </a:rPr>
+              <a:t>GlowTheory has the highest brand rate; the PawHaus dog bed has the sharpest margin exposure.</a:t>
+            </a:r>
+          </a:p>
+        </p:txBody>
+      </p:sp>
+      <p:graphicFrame>
+        <p:nvGraphicFramePr>
+          <p:cNvPr id="17" name="Chart"/>
+          <p:cNvGraphicFramePr/>
+          <p:nvPr/>
+        </p:nvGraphicFramePr>
+        <p:xfrm>
+          <a:off xmlns:a="http://schemas.openxmlformats.org/drawingml/2006/main" x="723900" y="2047875"/>
+          <a:ext xmlns:a="http://schemas.openxmlformats.org/drawingml/2006/main" cx="6191250" cy="3476625"/>
+        </p:xfrm>
+        <a:graphic xmlns:a="http://schemas.openxmlformats.org/drawingml/2006/main">
+          <a:graphicData uri="http://schemas.openxmlformats.org/drawingml/2006/chart">
+            <c:chart xmlns:r="http://schemas.openxmlformats.org/officeDocument/2006/relationships" xmlns:c="http://schemas.openxmlformats.org/drawingml/2006/chart" r:id="Rdcd9de9ce95143ed"/>
+          </a:graphicData>
+        </a:graphic>
+      </p:graphicFrame>
+      <p:sp>
+        <p:nvSpPr>
+          <p:cNvPr id="5" name="">
+            <a:extLst xmlns:a="http://schemas.openxmlformats.org/drawingml/2006/main">
+              <a:ext uri="{FF2B5EF4-FFF2-40B4-BE49-F238E27FC236}">
+                <a16:creationId xmlns:a16="http://schemas.microsoft.com/office/drawing/2014/main" id="{106BFBED-E3DC-4311-90CE-5F0BF7558169}"/>
+              </a:ext>
+            </a:extLst>
+          </p:cNvPr>
+          <p:cNvSpPr>
+            <a:spLocks xmlns:a="http://schemas.openxmlformats.org/drawingml/2006/main" noGrp="1"/>
+          </p:cNvSpPr>
+          <p:nvPr/>
+        </p:nvSpPr>
+        <p:spPr>
+          <a:xfrm xmlns:a="http://schemas.openxmlformats.org/drawingml/2006/main">
+            <a:off x="7524750" y="2133600"/>
+            <a:ext cx="3714750" cy="304800"/>
+          </a:xfrm>
+          <a:prstGeom xmlns:a="http://schemas.openxmlformats.org/drawingml/2006/main" prst="rect">
+            <a:avLst/>
+          </a:prstGeom>
+          <a:noFill xmlns:a="http://schemas.openxmlformats.org/drawingml/2006/main"/>
+          <a:ln xmlns:a="http://schemas.openxmlformats.org/drawingml/2006/main" w="0">
+            <a:noFill/>
+            <a:prstDash val="solid"/>
+          </a:ln>
+        </p:spPr>
+        <p:txBody>
+          <a:bodyPr xmlns:a="http://schemas.openxmlformats.org/drawingml/2006/main"/>
+          <a:lstStyle xmlns:a="http://schemas.openxmlformats.org/drawingml/2006/main"/>
+          <a:p xmlns:a="http://schemas.openxmlformats.org/drawingml/2006/main">
+            <a:pPr algn="l">
+              <a:defRPr sz="1500" b="1">
                 <a:solidFill>
                   <a:srgbClr val="2E74B5"/>
                 </a:solidFill>
               </a:defRPr>
             </a:pPr>
             <a:r>
-              <a:rPr sz="2550" b="1">
+              <a:rPr sz="1500" b="1">
                 <a:solidFill>
                   <a:srgbClr val="2E74B5"/>
                 </a:solidFill>
               </a:rPr>
-              <a:t>1</a:t>
-            </a:r>
-          </a:p>
-        </p:txBody>
-      </p:sp>
-      <p:sp>
-        <p:nvSpPr>
-          <p:cNvPr id="4" name="">
-            <a:extLst xmlns:a="http://schemas.openxmlformats.org/drawingml/2006/main">
-              <a:ext uri="{FF2B5EF4-FFF2-40B4-BE49-F238E27FC236}">
-                <a16:creationId xmlns:a16="http://schemas.microsoft.com/office/drawing/2014/main" id="{1A54AFA1-30EB-485D-8236-512FC4DA090F}"/>
-              </a:ext>
-            </a:extLst>
-          </p:cNvPr>
-          <p:cNvSpPr>
-            <a:spLocks xmlns:a="http://schemas.openxmlformats.org/drawingml/2006/main" noGrp="1"/>
-          </p:cNvSpPr>
-          <p:nvPr/>
-        </p:nvSpPr>
-        <p:spPr>
-          <a:xfrm xmlns:a="http://schemas.openxmlformats.org/drawingml/2006/main">
-            <a:off x="1619250" y="1952625"/>
-            <a:ext cx="2333625" cy="381000"/>
+              <a:t>Products to investigate</a:t>
+            </a:r>
+          </a:p>
+        </p:txBody>
+      </p:sp>
+      <p:sp>
+        <p:nvSpPr>
+          <p:cNvPr id="6" name="">
+            <a:extLst xmlns:a="http://schemas.openxmlformats.org/drawingml/2006/main">
+              <a:ext uri="{FF2B5EF4-FFF2-40B4-BE49-F238E27FC236}">
+                <a16:creationId xmlns:a16="http://schemas.microsoft.com/office/drawing/2014/main" id="{09673B9B-854A-4854-8C2B-0A249FC49990}"/>
+              </a:ext>
+            </a:extLst>
+          </p:cNvPr>
+          <p:cNvSpPr>
+            <a:spLocks xmlns:a="http://schemas.openxmlformats.org/drawingml/2006/main" noGrp="1"/>
+          </p:cNvSpPr>
+          <p:nvPr/>
+        </p:nvSpPr>
+        <p:spPr>
+          <a:xfrm xmlns:a="http://schemas.openxmlformats.org/drawingml/2006/main">
+            <a:off x="7524750" y="2647950"/>
+            <a:ext cx="3714750" cy="381000"/>
           </a:xfrm>
           <a:prstGeom xmlns:a="http://schemas.openxmlformats.org/drawingml/2006/main" prst="rect">
             <a:avLst/>
@@ -8268,140 +8479,57 @@
                   <a:srgbClr val="0B2545"/>
                 </a:solidFill>
               </a:rPr>
-              <a:t>Advertising</a:t>
-            </a:r>
-          </a:p>
-        </p:txBody>
-      </p:sp>
-      <p:sp>
-        <p:nvSpPr>
-          <p:cNvPr id="5" name="">
-            <a:extLst xmlns:a="http://schemas.openxmlformats.org/drawingml/2006/main">
-              <a:ext uri="{FF2B5EF4-FFF2-40B4-BE49-F238E27FC236}">
-                <a16:creationId xmlns:a16="http://schemas.microsoft.com/office/drawing/2014/main" id="{77976C91-B0EE-49B0-88CB-DE4A61657D71}"/>
-              </a:ext>
-            </a:extLst>
-          </p:cNvPr>
-          <p:cNvSpPr>
-            <a:spLocks xmlns:a="http://schemas.openxmlformats.org/drawingml/2006/main" noGrp="1"/>
-          </p:cNvSpPr>
-          <p:nvPr/>
-        </p:nvSpPr>
-        <p:spPr>
-          <a:xfrm xmlns:a="http://schemas.openxmlformats.org/drawingml/2006/main">
-            <a:off x="4238625" y="1952625"/>
-            <a:ext cx="6667500" cy="619125"/>
-          </a:xfrm>
-          <a:prstGeom xmlns:a="http://schemas.openxmlformats.org/drawingml/2006/main" prst="rect">
-            <a:avLst/>
-          </a:prstGeom>
-          <a:noFill xmlns:a="http://schemas.openxmlformats.org/drawingml/2006/main"/>
-          <a:ln xmlns:a="http://schemas.openxmlformats.org/drawingml/2006/main" w="0">
-            <a:noFill/>
-            <a:prstDash val="solid"/>
-          </a:ln>
-        </p:spPr>
-        <p:txBody>
-          <a:bodyPr xmlns:a="http://schemas.openxmlformats.org/drawingml/2006/main"/>
-          <a:lstStyle xmlns:a="http://schemas.openxmlformats.org/drawingml/2006/main"/>
-          <a:p xmlns:a="http://schemas.openxmlformats.org/drawingml/2006/main">
-            <a:pPr algn="l">
-              <a:defRPr sz="1575" b="0">
-                <a:solidFill>
-                  <a:srgbClr val="172B4D"/>
-                </a:solidFill>
-              </a:defRPr>
-            </a:pPr>
-            <a:r>
-              <a:rPr sz="1575" b="0">
-                <a:solidFill>
-                  <a:srgbClr val="172B4D"/>
-                </a:solidFill>
-              </a:rPr>
-              <a:t>Add campaign/SKU attribution before reallocating or cutting spend.</a:t>
-            </a:r>
-          </a:p>
-        </p:txBody>
-      </p:sp>
-      <p:sp>
-        <p:nvSpPr>
-          <p:cNvPr id="6" name="">
-            <a:extLst xmlns:a="http://schemas.openxmlformats.org/drawingml/2006/main">
-              <a:ext uri="{FF2B5EF4-FFF2-40B4-BE49-F238E27FC236}">
-                <a16:creationId xmlns:a16="http://schemas.microsoft.com/office/drawing/2014/main" id="{0AFAEFA8-CDE2-495E-BCFC-DC97468EB63E}"/>
-              </a:ext>
-            </a:extLst>
-          </p:cNvPr>
-          <p:cNvSpPr>
-            <a:spLocks xmlns:a="http://schemas.openxmlformats.org/drawingml/2006/main" noGrp="1"/>
-          </p:cNvSpPr>
-          <p:nvPr/>
-        </p:nvSpPr>
-        <p:spPr>
-          <a:xfrm xmlns:a="http://schemas.openxmlformats.org/drawingml/2006/main">
-            <a:off x="1619250" y="2847975"/>
-            <a:ext cx="9286875" cy="9525"/>
-          </a:xfrm>
-          <a:prstGeom xmlns:a="http://schemas.openxmlformats.org/drawingml/2006/main" prst="rect">
-            <a:avLst/>
-          </a:prstGeom>
-          <a:solidFill xmlns:a="http://schemas.openxmlformats.org/drawingml/2006/main">
-            <a:srgbClr val="D0D5DD"/>
-          </a:solidFill>
-          <a:ln xmlns:a="http://schemas.openxmlformats.org/drawingml/2006/main" w="0">
-            <a:solidFill>
-              <a:srgbClr val="D0D5DD"/>
-            </a:solidFill>
-            <a:prstDash val="solid"/>
-          </a:ln>
-        </p:spPr>
+              <a:t>GT-MASK-CLAY  •  10.7%</a:t>
+            </a:r>
+          </a:p>
+        </p:txBody>
       </p:sp>
       <p:sp>
         <p:nvSpPr>
           <p:cNvPr id="7" name="">
             <a:extLst xmlns:a="http://schemas.openxmlformats.org/drawingml/2006/main">
               <a:ext uri="{FF2B5EF4-FFF2-40B4-BE49-F238E27FC236}">
-                <a16:creationId xmlns:a16="http://schemas.microsoft.com/office/drawing/2014/main" id="{D361EE08-7D6E-4C3E-AA6F-9C9E566DDD59}"/>
-              </a:ext>
-            </a:extLst>
-          </p:cNvPr>
-          <p:cNvSpPr>
-            <a:spLocks xmlns:a="http://schemas.openxmlformats.org/drawingml/2006/main" noGrp="1"/>
-          </p:cNvSpPr>
-          <p:nvPr/>
-        </p:nvSpPr>
-        <p:spPr>
-          <a:xfrm xmlns:a="http://schemas.openxmlformats.org/drawingml/2006/main">
-            <a:off x="762000" y="3190875"/>
-            <a:ext cx="571500" cy="523875"/>
-          </a:xfrm>
-          <a:prstGeom xmlns:a="http://schemas.openxmlformats.org/drawingml/2006/main" prst="rect">
-            <a:avLst/>
-          </a:prstGeom>
-          <a:noFill xmlns:a="http://schemas.openxmlformats.org/drawingml/2006/main"/>
-          <a:ln xmlns:a="http://schemas.openxmlformats.org/drawingml/2006/main" w="0">
-            <a:noFill/>
-            <a:prstDash val="solid"/>
-          </a:ln>
-        </p:spPr>
-        <p:txBody>
-          <a:bodyPr xmlns:a="http://schemas.openxmlformats.org/drawingml/2006/main"/>
-          <a:lstStyle xmlns:a="http://schemas.openxmlformats.org/drawingml/2006/main"/>
-          <a:p xmlns:a="http://schemas.openxmlformats.org/drawingml/2006/main">
-            <a:pPr algn="ctr">
-              <a:defRPr sz="2550" b="1">
-                <a:solidFill>
-                  <a:srgbClr val="2E74B5"/>
-                </a:solidFill>
-              </a:defRPr>
-            </a:pPr>
-            <a:r>
-              <a:rPr sz="2550" b="1">
-                <a:solidFill>
-                  <a:srgbClr val="2E74B5"/>
-                </a:solidFill>
-              </a:rPr>
-              <a:t>2</a:t>
+                <a16:creationId xmlns:a16="http://schemas.microsoft.com/office/drawing/2014/main" id="{B7065DA7-5758-4224-8025-19AA26F16D33}"/>
+              </a:ext>
+            </a:extLst>
+          </p:cNvPr>
+          <p:cNvSpPr>
+            <a:spLocks xmlns:a="http://schemas.openxmlformats.org/drawingml/2006/main" noGrp="1"/>
+          </p:cNvSpPr>
+          <p:nvPr/>
+        </p:nvSpPr>
+        <p:spPr>
+          <a:xfrm xmlns:a="http://schemas.openxmlformats.org/drawingml/2006/main">
+            <a:off x="7524750" y="3067050"/>
+            <a:ext cx="3714750" cy="457200"/>
+          </a:xfrm>
+          <a:prstGeom xmlns:a="http://schemas.openxmlformats.org/drawingml/2006/main" prst="rect">
+            <a:avLst/>
+          </a:prstGeom>
+          <a:noFill xmlns:a="http://schemas.openxmlformats.org/drawingml/2006/main"/>
+          <a:ln xmlns:a="http://schemas.openxmlformats.org/drawingml/2006/main" w="0">
+            <a:noFill/>
+            <a:prstDash val="solid"/>
+          </a:ln>
+        </p:spPr>
+        <p:txBody>
+          <a:bodyPr xmlns:a="http://schemas.openxmlformats.org/drawingml/2006/main"/>
+          <a:lstStyle xmlns:a="http://schemas.openxmlformats.org/drawingml/2006/main"/>
+          <a:p xmlns:a="http://schemas.openxmlformats.org/drawingml/2006/main">
+            <a:pPr algn="l">
+              <a:defRPr sz="1275" b="0">
+                <a:solidFill>
+                  <a:srgbClr val="667085"/>
+                </a:solidFill>
+              </a:defRPr>
+            </a:pPr>
+            <a:r>
+              <a:rPr sz="1275" b="0">
+                <a:solidFill>
+                  <a:srgbClr val="667085"/>
+                </a:solidFill>
+              </a:rPr>
+              <a:t>$143 contribution reversed</a:t>
             </a:r>
           </a:p>
         </p:txBody>
@@ -8411,19 +8539,19 @@
           <p:cNvPr id="8" name="">
             <a:extLst xmlns:a="http://schemas.openxmlformats.org/drawingml/2006/main">
               <a:ext uri="{FF2B5EF4-FFF2-40B4-BE49-F238E27FC236}">
-                <a16:creationId xmlns:a16="http://schemas.microsoft.com/office/drawing/2014/main" id="{3F553F55-D016-46CB-B082-27587B657118}"/>
-              </a:ext>
-            </a:extLst>
-          </p:cNvPr>
-          <p:cNvSpPr>
-            <a:spLocks xmlns:a="http://schemas.openxmlformats.org/drawingml/2006/main" noGrp="1"/>
-          </p:cNvSpPr>
-          <p:nvPr/>
-        </p:nvSpPr>
-        <p:spPr>
-          <a:xfrm xmlns:a="http://schemas.openxmlformats.org/drawingml/2006/main">
-            <a:off x="1619250" y="3190875"/>
-            <a:ext cx="2333625" cy="381000"/>
+                <a16:creationId xmlns:a16="http://schemas.microsoft.com/office/drawing/2014/main" id="{3DA825BD-4F84-4E26-AACB-B57CC0B7C239}"/>
+              </a:ext>
+            </a:extLst>
+          </p:cNvPr>
+          <p:cNvSpPr>
+            <a:spLocks xmlns:a="http://schemas.openxmlformats.org/drawingml/2006/main" noGrp="1"/>
+          </p:cNvSpPr>
+          <p:nvPr/>
+        </p:nvSpPr>
+        <p:spPr>
+          <a:xfrm xmlns:a="http://schemas.openxmlformats.org/drawingml/2006/main">
+            <a:off x="7524750" y="3695700"/>
+            <a:ext cx="3714750" cy="381000"/>
           </a:xfrm>
           <a:prstGeom xmlns:a="http://schemas.openxmlformats.org/drawingml/2006/main" prst="rect">
             <a:avLst/>
@@ -8451,7 +8579,7 @@
                   <a:srgbClr val="0B2545"/>
                 </a:solidFill>
               </a:rPr>
-              <a:t>Landed cost</a:t>
+              <a:t>PF-WHEY-CHOC  •  3.4%</a:t>
             </a:r>
           </a:p>
         </p:txBody>
@@ -8461,47 +8589,47 @@
           <p:cNvPr id="9" name="">
             <a:extLst xmlns:a="http://schemas.openxmlformats.org/drawingml/2006/main">
               <a:ext uri="{FF2B5EF4-FFF2-40B4-BE49-F238E27FC236}">
-                <a16:creationId xmlns:a16="http://schemas.microsoft.com/office/drawing/2014/main" id="{D1A56A95-08E1-41AA-AEAB-0011DABA1ECB}"/>
-              </a:ext>
-            </a:extLst>
-          </p:cNvPr>
-          <p:cNvSpPr>
-            <a:spLocks xmlns:a="http://schemas.openxmlformats.org/drawingml/2006/main" noGrp="1"/>
-          </p:cNvSpPr>
-          <p:nvPr/>
-        </p:nvSpPr>
-        <p:spPr>
-          <a:xfrm xmlns:a="http://schemas.openxmlformats.org/drawingml/2006/main">
-            <a:off x="4238625" y="3190875"/>
-            <a:ext cx="6667500" cy="619125"/>
-          </a:xfrm>
-          <a:prstGeom xmlns:a="http://schemas.openxmlformats.org/drawingml/2006/main" prst="rect">
-            <a:avLst/>
-          </a:prstGeom>
-          <a:noFill xmlns:a="http://schemas.openxmlformats.org/drawingml/2006/main"/>
-          <a:ln xmlns:a="http://schemas.openxmlformats.org/drawingml/2006/main" w="0">
-            <a:noFill/>
-            <a:prstDash val="solid"/>
-          </a:ln>
-        </p:spPr>
-        <p:txBody>
-          <a:bodyPr xmlns:a="http://schemas.openxmlformats.org/drawingml/2006/main"/>
-          <a:lstStyle xmlns:a="http://schemas.openxmlformats.org/drawingml/2006/main"/>
-          <a:p xmlns:a="http://schemas.openxmlformats.org/drawingml/2006/main">
-            <a:pPr algn="l">
-              <a:defRPr sz="1575" b="0">
-                <a:solidFill>
-                  <a:srgbClr val="172B4D"/>
-                </a:solidFill>
-              </a:defRPr>
-            </a:pPr>
-            <a:r>
-              <a:rPr sz="1575" b="0">
-                <a:solidFill>
-                  <a:srgbClr val="172B4D"/>
-                </a:solidFill>
-              </a:rPr>
-              <a:t>Validate two imputed SKUs representing 2.3% of gross sales.</a:t>
+                <a16:creationId xmlns:a16="http://schemas.microsoft.com/office/drawing/2014/main" id="{6B17EF6E-50E4-4588-837E-26431BB16312}"/>
+              </a:ext>
+            </a:extLst>
+          </p:cNvPr>
+          <p:cNvSpPr>
+            <a:spLocks xmlns:a="http://schemas.openxmlformats.org/drawingml/2006/main" noGrp="1"/>
+          </p:cNvSpPr>
+          <p:nvPr/>
+        </p:nvSpPr>
+        <p:spPr>
+          <a:xfrm xmlns:a="http://schemas.openxmlformats.org/drawingml/2006/main">
+            <a:off x="7524750" y="4114800"/>
+            <a:ext cx="3714750" cy="457200"/>
+          </a:xfrm>
+          <a:prstGeom xmlns:a="http://schemas.openxmlformats.org/drawingml/2006/main" prst="rect">
+            <a:avLst/>
+          </a:prstGeom>
+          <a:noFill xmlns:a="http://schemas.openxmlformats.org/drawingml/2006/main"/>
+          <a:ln xmlns:a="http://schemas.openxmlformats.org/drawingml/2006/main" w="0">
+            <a:noFill/>
+            <a:prstDash val="solid"/>
+          </a:ln>
+        </p:spPr>
+        <p:txBody>
+          <a:bodyPr xmlns:a="http://schemas.openxmlformats.org/drawingml/2006/main"/>
+          <a:lstStyle xmlns:a="http://schemas.openxmlformats.org/drawingml/2006/main"/>
+          <a:p xmlns:a="http://schemas.openxmlformats.org/drawingml/2006/main">
+            <a:pPr algn="l">
+              <a:defRPr sz="1275" b="0">
+                <a:solidFill>
+                  <a:srgbClr val="667085"/>
+                </a:solidFill>
+              </a:defRPr>
+            </a:pPr>
+            <a:r>
+              <a:rPr sz="1275" b="0">
+                <a:solidFill>
+                  <a:srgbClr val="667085"/>
+                </a:solidFill>
+              </a:rPr>
+              <a:t>$328 contribution reversed</a:t>
             </a:r>
           </a:p>
         </p:txBody>
@@ -8511,80 +8639,97 @@
           <p:cNvPr id="10" name="">
             <a:extLst xmlns:a="http://schemas.openxmlformats.org/drawingml/2006/main">
               <a:ext uri="{FF2B5EF4-FFF2-40B4-BE49-F238E27FC236}">
-                <a16:creationId xmlns:a16="http://schemas.microsoft.com/office/drawing/2014/main" id="{614025AC-C696-4C8C-896A-1A1B65D293C8}"/>
-              </a:ext>
-            </a:extLst>
-          </p:cNvPr>
-          <p:cNvSpPr>
-            <a:spLocks xmlns:a="http://schemas.openxmlformats.org/drawingml/2006/main" noGrp="1"/>
-          </p:cNvSpPr>
-          <p:nvPr/>
-        </p:nvSpPr>
-        <p:spPr>
-          <a:xfrm xmlns:a="http://schemas.openxmlformats.org/drawingml/2006/main">
-            <a:off x="1619250" y="4086225"/>
-            <a:ext cx="9286875" cy="9525"/>
-          </a:xfrm>
-          <a:prstGeom xmlns:a="http://schemas.openxmlformats.org/drawingml/2006/main" prst="rect">
-            <a:avLst/>
-          </a:prstGeom>
-          <a:solidFill xmlns:a="http://schemas.openxmlformats.org/drawingml/2006/main">
-            <a:srgbClr val="D0D5DD"/>
-          </a:solidFill>
-          <a:ln xmlns:a="http://schemas.openxmlformats.org/drawingml/2006/main" w="0">
-            <a:solidFill>
-              <a:srgbClr val="D0D5DD"/>
-            </a:solidFill>
-            <a:prstDash val="solid"/>
-          </a:ln>
-        </p:spPr>
+                <a16:creationId xmlns:a16="http://schemas.microsoft.com/office/drawing/2014/main" id="{C2095B90-64D4-47D7-8EBB-865EACC0A76C}"/>
+              </a:ext>
+            </a:extLst>
+          </p:cNvPr>
+          <p:cNvSpPr>
+            <a:spLocks xmlns:a="http://schemas.openxmlformats.org/drawingml/2006/main" noGrp="1"/>
+          </p:cNvSpPr>
+          <p:nvPr/>
+        </p:nvSpPr>
+        <p:spPr>
+          <a:xfrm xmlns:a="http://schemas.openxmlformats.org/drawingml/2006/main">
+            <a:off x="7524750" y="4743450"/>
+            <a:ext cx="3714750" cy="381000"/>
+          </a:xfrm>
+          <a:prstGeom xmlns:a="http://schemas.openxmlformats.org/drawingml/2006/main" prst="rect">
+            <a:avLst/>
+          </a:prstGeom>
+          <a:noFill xmlns:a="http://schemas.openxmlformats.org/drawingml/2006/main"/>
+          <a:ln xmlns:a="http://schemas.openxmlformats.org/drawingml/2006/main" w="0">
+            <a:noFill/>
+            <a:prstDash val="solid"/>
+          </a:ln>
+        </p:spPr>
+        <p:txBody>
+          <a:bodyPr xmlns:a="http://schemas.openxmlformats.org/drawingml/2006/main"/>
+          <a:lstStyle xmlns:a="http://schemas.openxmlformats.org/drawingml/2006/main"/>
+          <a:p xmlns:a="http://schemas.openxmlformats.org/drawingml/2006/main">
+            <a:pPr algn="l">
+              <a:defRPr sz="1800" b="1">
+                <a:solidFill>
+                  <a:srgbClr val="0B2545"/>
+                </a:solidFill>
+              </a:defRPr>
+            </a:pPr>
+            <a:r>
+              <a:rPr sz="1800" b="1">
+                <a:solidFill>
+                  <a:srgbClr val="0B2545"/>
+                </a:solidFill>
+              </a:rPr>
+              <a:t>PH-BED-MED-GRY  •  6.6%</a:t>
+            </a:r>
+          </a:p>
+        </p:txBody>
       </p:sp>
       <p:sp>
         <p:nvSpPr>
           <p:cNvPr id="11" name="">
             <a:extLst xmlns:a="http://schemas.openxmlformats.org/drawingml/2006/main">
               <a:ext uri="{FF2B5EF4-FFF2-40B4-BE49-F238E27FC236}">
-                <a16:creationId xmlns:a16="http://schemas.microsoft.com/office/drawing/2014/main" id="{50DDA70D-3048-430A-A0F8-8B40EC526FD6}"/>
-              </a:ext>
-            </a:extLst>
-          </p:cNvPr>
-          <p:cNvSpPr>
-            <a:spLocks xmlns:a="http://schemas.openxmlformats.org/drawingml/2006/main" noGrp="1"/>
-          </p:cNvSpPr>
-          <p:nvPr/>
-        </p:nvSpPr>
-        <p:spPr>
-          <a:xfrm xmlns:a="http://schemas.openxmlformats.org/drawingml/2006/main">
-            <a:off x="762000" y="4429125"/>
-            <a:ext cx="571500" cy="523875"/>
-          </a:xfrm>
-          <a:prstGeom xmlns:a="http://schemas.openxmlformats.org/drawingml/2006/main" prst="rect">
-            <a:avLst/>
-          </a:prstGeom>
-          <a:noFill xmlns:a="http://schemas.openxmlformats.org/drawingml/2006/main"/>
-          <a:ln xmlns:a="http://schemas.openxmlformats.org/drawingml/2006/main" w="0">
-            <a:noFill/>
-            <a:prstDash val="solid"/>
-          </a:ln>
-        </p:spPr>
-        <p:txBody>
-          <a:bodyPr xmlns:a="http://schemas.openxmlformats.org/drawingml/2006/main"/>
-          <a:lstStyle xmlns:a="http://schemas.openxmlformats.org/drawingml/2006/main"/>
-          <a:p xmlns:a="http://schemas.openxmlformats.org/drawingml/2006/main">
-            <a:pPr algn="ctr">
-              <a:defRPr sz="2550" b="1">
-                <a:solidFill>
-                  <a:srgbClr val="2E74B5"/>
-                </a:solidFill>
-              </a:defRPr>
-            </a:pPr>
-            <a:r>
-              <a:rPr sz="2550" b="1">
-                <a:solidFill>
-                  <a:srgbClr val="2E74B5"/>
-                </a:solidFill>
-              </a:rPr>
-              <a:t>3</a:t>
+                <a16:creationId xmlns:a16="http://schemas.microsoft.com/office/drawing/2014/main" id="{7C80B63C-E73B-4A50-9EE5-730F641DB958}"/>
+              </a:ext>
+            </a:extLst>
+          </p:cNvPr>
+          <p:cNvSpPr>
+            <a:spLocks xmlns:a="http://schemas.openxmlformats.org/drawingml/2006/main" noGrp="1"/>
+          </p:cNvSpPr>
+          <p:nvPr/>
+        </p:nvSpPr>
+        <p:spPr>
+          <a:xfrm xmlns:a="http://schemas.openxmlformats.org/drawingml/2006/main">
+            <a:off x="7524750" y="5162550"/>
+            <a:ext cx="3714750" cy="552450"/>
+          </a:xfrm>
+          <a:prstGeom xmlns:a="http://schemas.openxmlformats.org/drawingml/2006/main" prst="rect">
+            <a:avLst/>
+          </a:prstGeom>
+          <a:noFill xmlns:a="http://schemas.openxmlformats.org/drawingml/2006/main"/>
+          <a:ln xmlns:a="http://schemas.openxmlformats.org/drawingml/2006/main" w="0">
+            <a:noFill/>
+            <a:prstDash val="solid"/>
+          </a:ln>
+        </p:spPr>
+        <p:txBody>
+          <a:bodyPr xmlns:a="http://schemas.openxmlformats.org/drawingml/2006/main"/>
+          <a:lstStyle xmlns:a="http://schemas.openxmlformats.org/drawingml/2006/main"/>
+          <a:p xmlns:a="http://schemas.openxmlformats.org/drawingml/2006/main">
+            <a:pPr algn="l">
+              <a:defRPr sz="1275" b="1">
+                <a:solidFill>
+                  <a:srgbClr val="B42318"/>
+                </a:solidFill>
+              </a:defRPr>
+            </a:pPr>
+            <a:r>
+              <a:rPr sz="1275" b="1">
+                <a:solidFill>
+                  <a:srgbClr val="B42318"/>
+                </a:solidFill>
+              </a:rPr>
+              <a:t>Refund impact equals 47% of remaining CM</a:t>
             </a:r>
           </a:p>
         </p:txBody>
@@ -8594,107 +8739,7 @@
           <p:cNvPr id="12" name="">
             <a:extLst xmlns:a="http://schemas.openxmlformats.org/drawingml/2006/main">
               <a:ext uri="{FF2B5EF4-FFF2-40B4-BE49-F238E27FC236}">
-                <a16:creationId xmlns:a16="http://schemas.microsoft.com/office/drawing/2014/main" id="{92F28F2D-7094-4A8A-8644-AD2B8BCCDF33}"/>
-              </a:ext>
-            </a:extLst>
-          </p:cNvPr>
-          <p:cNvSpPr>
-            <a:spLocks xmlns:a="http://schemas.openxmlformats.org/drawingml/2006/main" noGrp="1"/>
-          </p:cNvSpPr>
-          <p:nvPr/>
-        </p:nvSpPr>
-        <p:spPr>
-          <a:xfrm xmlns:a="http://schemas.openxmlformats.org/drawingml/2006/main">
-            <a:off x="1619250" y="4429125"/>
-            <a:ext cx="2333625" cy="381000"/>
-          </a:xfrm>
-          <a:prstGeom xmlns:a="http://schemas.openxmlformats.org/drawingml/2006/main" prst="rect">
-            <a:avLst/>
-          </a:prstGeom>
-          <a:noFill xmlns:a="http://schemas.openxmlformats.org/drawingml/2006/main"/>
-          <a:ln xmlns:a="http://schemas.openxmlformats.org/drawingml/2006/main" w="0">
-            <a:noFill/>
-            <a:prstDash val="solid"/>
-          </a:ln>
-        </p:spPr>
-        <p:txBody>
-          <a:bodyPr xmlns:a="http://schemas.openxmlformats.org/drawingml/2006/main"/>
-          <a:lstStyle xmlns:a="http://schemas.openxmlformats.org/drawingml/2006/main"/>
-          <a:p xmlns:a="http://schemas.openxmlformats.org/drawingml/2006/main">
-            <a:pPr algn="l">
-              <a:defRPr sz="1800" b="1">
-                <a:solidFill>
-                  <a:srgbClr val="0B2545"/>
-                </a:solidFill>
-              </a:defRPr>
-            </a:pPr>
-            <a:r>
-              <a:rPr sz="1800" b="1">
-                <a:solidFill>
-                  <a:srgbClr val="0B2545"/>
-                </a:solidFill>
-              </a:rPr>
-              <a:t>Inventory</a:t>
-            </a:r>
-          </a:p>
-        </p:txBody>
-      </p:sp>
-      <p:sp>
-        <p:nvSpPr>
-          <p:cNvPr id="13" name="">
-            <a:extLst xmlns:a="http://schemas.openxmlformats.org/drawingml/2006/main">
-              <a:ext uri="{FF2B5EF4-FFF2-40B4-BE49-F238E27FC236}">
-                <a16:creationId xmlns:a16="http://schemas.microsoft.com/office/drawing/2014/main" id="{51991A91-4A4F-42EA-AF0E-C64D5E555940}"/>
-              </a:ext>
-            </a:extLst>
-          </p:cNvPr>
-          <p:cNvSpPr>
-            <a:spLocks xmlns:a="http://schemas.openxmlformats.org/drawingml/2006/main" noGrp="1"/>
-          </p:cNvSpPr>
-          <p:nvPr/>
-        </p:nvSpPr>
-        <p:spPr>
-          <a:xfrm xmlns:a="http://schemas.openxmlformats.org/drawingml/2006/main">
-            <a:off x="4238625" y="4429125"/>
-            <a:ext cx="6667500" cy="619125"/>
-          </a:xfrm>
-          <a:prstGeom xmlns:a="http://schemas.openxmlformats.org/drawingml/2006/main" prst="rect">
-            <a:avLst/>
-          </a:prstGeom>
-          <a:noFill xmlns:a="http://schemas.openxmlformats.org/drawingml/2006/main"/>
-          <a:ln xmlns:a="http://schemas.openxmlformats.org/drawingml/2006/main" w="0">
-            <a:noFill/>
-            <a:prstDash val="solid"/>
-          </a:ln>
-        </p:spPr>
-        <p:txBody>
-          <a:bodyPr xmlns:a="http://schemas.openxmlformats.org/drawingml/2006/main"/>
-          <a:lstStyle xmlns:a="http://schemas.openxmlformats.org/drawingml/2006/main"/>
-          <a:p xmlns:a="http://schemas.openxmlformats.org/drawingml/2006/main">
-            <a:pPr algn="l">
-              <a:defRPr sz="1575" b="0">
-                <a:solidFill>
-                  <a:srgbClr val="172B4D"/>
-                </a:solidFill>
-              </a:defRPr>
-            </a:pPr>
-            <a:r>
-              <a:rPr sz="1575" b="0">
-                <a:solidFill>
-                  <a:srgbClr val="172B4D"/>
-                </a:solidFill>
-              </a:rPr>
-              <a:t>Review two low-cover SKUs and slow movers with more than a year of stock.</a:t>
-            </a:r>
-          </a:p>
-        </p:txBody>
-      </p:sp>
-      <p:sp>
-        <p:nvSpPr>
-          <p:cNvPr id="14" name="">
-            <a:extLst xmlns:a="http://schemas.openxmlformats.org/drawingml/2006/main">
-              <a:ext uri="{FF2B5EF4-FFF2-40B4-BE49-F238E27FC236}">
-                <a16:creationId xmlns:a16="http://schemas.microsoft.com/office/drawing/2014/main" id="{3A104D18-C30A-4E72-AF8B-CD473AF52099}"/>
+                <a16:creationId xmlns:a16="http://schemas.microsoft.com/office/drawing/2014/main" id="{CC63A40F-74DE-44F6-859C-0BB1F743D7CC}"/>
               </a:ext>
             </a:extLst>
           </p:cNvPr>
@@ -8741,10 +8786,10 @@
       </p:sp>
       <p:sp>
         <p:nvSpPr>
-          <p:cNvPr id="15" name="">
-            <a:extLst xmlns:a="http://schemas.openxmlformats.org/drawingml/2006/main">
-              <a:ext uri="{FF2B5EF4-FFF2-40B4-BE49-F238E27FC236}">
-                <a16:creationId xmlns:a16="http://schemas.microsoft.com/office/drawing/2014/main" id="{4C5DF2B6-D3C0-4DA1-8ED9-2164F4802E5B}"/>
+          <p:cNvPr id="13" name="">
+            <a:extLst xmlns:a="http://schemas.openxmlformats.org/drawingml/2006/main">
+              <a:ext uri="{FF2B5EF4-FFF2-40B4-BE49-F238E27FC236}">
+                <a16:creationId xmlns:a16="http://schemas.microsoft.com/office/drawing/2014/main" id="{97AA699A-BB52-49B6-AF52-75D7F68A7C4B}"/>
               </a:ext>
             </a:extLst>
           </p:cNvPr>
@@ -8792,7 +8837,7 @@
     </p:spTree>
     <p:extLst>
       <p:ext uri="{BB962C8B-B14F-4D97-AF65-F5344CB8AC3E}">
-        <p14:creationId xmlns:p14="http://schemas.microsoft.com/office/powerpoint/2010/main" val="1298291273"/>
+        <p14:creationId xmlns:p14="http://schemas.microsoft.com/office/powerpoint/2010/main" val="2056236328"/>
       </p:ext>
     </p:extLst>
   </p:cSld>
@@ -8823,7 +8868,7 @@
           <p:cNvPr id="19" name="">
             <a:extLst xmlns:a="http://schemas.openxmlformats.org/drawingml/2006/main">
               <a:ext uri="{FF2B5EF4-FFF2-40B4-BE49-F238E27FC236}">
-                <a16:creationId xmlns:a16="http://schemas.microsoft.com/office/drawing/2014/main" id="{27FF76F1-5BF4-47BE-863C-3D3EDD2095EF}"/>
+                <a16:creationId xmlns:a16="http://schemas.microsoft.com/office/drawing/2014/main" id="{0694EBBF-AA7D-41B5-A9A4-D42E88E5DF10}"/>
               </a:ext>
             </a:extLst>
           </p:cNvPr>
@@ -8873,7 +8918,7 @@
           <p:cNvPr id="2" name="">
             <a:extLst xmlns:a="http://schemas.openxmlformats.org/drawingml/2006/main">
               <a:ext uri="{FF2B5EF4-FFF2-40B4-BE49-F238E27FC236}">
-                <a16:creationId xmlns:a16="http://schemas.microsoft.com/office/drawing/2014/main" id="{DE205AF1-295E-4C01-8061-A50D238CFAF5}"/>
+                <a16:creationId xmlns:a16="http://schemas.microsoft.com/office/drawing/2014/main" id="{2EEF3176-503C-4F01-9A58-857E16035016}"/>
               </a:ext>
             </a:extLst>
           </p:cNvPr>
@@ -8923,7 +8968,7 @@
           <p:cNvPr id="3" name="">
             <a:extLst xmlns:a="http://schemas.openxmlformats.org/drawingml/2006/main">
               <a:ext uri="{FF2B5EF4-FFF2-40B4-BE49-F238E27FC236}">
-                <a16:creationId xmlns:a16="http://schemas.microsoft.com/office/drawing/2014/main" id="{D706483E-99D1-4714-BAD1-09FFDBCDBF37}"/>
+                <a16:creationId xmlns:a16="http://schemas.microsoft.com/office/drawing/2014/main" id="{86FE3E53-AF43-4366-9BE9-4102ADC35375}"/>
               </a:ext>
             </a:extLst>
           </p:cNvPr>
@@ -8973,7 +9018,7 @@
           <p:cNvPr id="4" name="">
             <a:extLst xmlns:a="http://schemas.openxmlformats.org/drawingml/2006/main">
               <a:ext uri="{FF2B5EF4-FFF2-40B4-BE49-F238E27FC236}">
-                <a16:creationId xmlns:a16="http://schemas.microsoft.com/office/drawing/2014/main" id="{51B83817-AD0A-45B5-83D5-3F82E6B17E9A}"/>
+                <a16:creationId xmlns:a16="http://schemas.microsoft.com/office/drawing/2014/main" id="{A0B48C04-A101-496C-AC82-EDA9D3997ECF}"/>
               </a:ext>
             </a:extLst>
           </p:cNvPr>
@@ -9023,7 +9068,7 @@
           <p:cNvPr id="5" name="">
             <a:extLst xmlns:a="http://schemas.openxmlformats.org/drawingml/2006/main">
               <a:ext uri="{FF2B5EF4-FFF2-40B4-BE49-F238E27FC236}">
-                <a16:creationId xmlns:a16="http://schemas.microsoft.com/office/drawing/2014/main" id="{068099A1-3DAD-46EC-ABB8-9FC7ABE6B2C3}"/>
+                <a16:creationId xmlns:a16="http://schemas.microsoft.com/office/drawing/2014/main" id="{52869C2F-3929-4843-AA7A-5D08F25756AB}"/>
               </a:ext>
             </a:extLst>
           </p:cNvPr>
@@ -9056,7 +9101,7 @@
           <p:cNvPr id="6" name="">
             <a:extLst xmlns:a="http://schemas.openxmlformats.org/drawingml/2006/main">
               <a:ext uri="{FF2B5EF4-FFF2-40B4-BE49-F238E27FC236}">
-                <a16:creationId xmlns:a16="http://schemas.microsoft.com/office/drawing/2014/main" id="{7E912DD7-41B2-49F8-A11F-F63E8CA8E361}"/>
+                <a16:creationId xmlns:a16="http://schemas.microsoft.com/office/drawing/2014/main" id="{119F3C96-ABEC-4EDB-BFA2-44EA515DBE1B}"/>
               </a:ext>
             </a:extLst>
           </p:cNvPr>
@@ -9106,7 +9151,7 @@
           <p:cNvPr id="7" name="">
             <a:extLst xmlns:a="http://schemas.openxmlformats.org/drawingml/2006/main">
               <a:ext uri="{FF2B5EF4-FFF2-40B4-BE49-F238E27FC236}">
-                <a16:creationId xmlns:a16="http://schemas.microsoft.com/office/drawing/2014/main" id="{1DC29A4C-D8E5-4086-BDA2-80C27ABC5618}"/>
+                <a16:creationId xmlns:a16="http://schemas.microsoft.com/office/drawing/2014/main" id="{EE32C6CB-4F76-4B90-B37D-B76D6ECA5490}"/>
               </a:ext>
             </a:extLst>
           </p:cNvPr>
@@ -9190,7 +9235,7 @@
           <p:cNvPr id="8" name="">
             <a:extLst xmlns:a="http://schemas.openxmlformats.org/drawingml/2006/main">
               <a:ext uri="{FF2B5EF4-FFF2-40B4-BE49-F238E27FC236}">
-                <a16:creationId xmlns:a16="http://schemas.microsoft.com/office/drawing/2014/main" id="{D6D51A4E-DE27-48ED-B271-F58CAE82742D}"/>
+                <a16:creationId xmlns:a16="http://schemas.microsoft.com/office/drawing/2014/main" id="{B82E8955-2A7B-44BC-A484-935AAB40CDE2}"/>
               </a:ext>
             </a:extLst>
           </p:cNvPr>
@@ -9240,7 +9285,7 @@
           <p:cNvPr id="9" name="">
             <a:extLst xmlns:a="http://schemas.openxmlformats.org/drawingml/2006/main">
               <a:ext uri="{FF2B5EF4-FFF2-40B4-BE49-F238E27FC236}">
-                <a16:creationId xmlns:a16="http://schemas.microsoft.com/office/drawing/2014/main" id="{959E0AFC-7EED-490C-B04F-24941B0C6298}"/>
+                <a16:creationId xmlns:a16="http://schemas.microsoft.com/office/drawing/2014/main" id="{8CF11B98-DAA4-4C22-B2A2-FA5AD4DBB5DD}"/>
               </a:ext>
             </a:extLst>
           </p:cNvPr>
@@ -9273,7 +9318,7 @@
           <p:cNvPr id="10" name="">
             <a:extLst xmlns:a="http://schemas.openxmlformats.org/drawingml/2006/main">
               <a:ext uri="{FF2B5EF4-FFF2-40B4-BE49-F238E27FC236}">
-                <a16:creationId xmlns:a16="http://schemas.microsoft.com/office/drawing/2014/main" id="{02F701FF-091B-4009-A9A1-1B96BEE63C04}"/>
+                <a16:creationId xmlns:a16="http://schemas.microsoft.com/office/drawing/2014/main" id="{302222E5-86BE-4DDC-90ED-6CC52E34638E}"/>
               </a:ext>
             </a:extLst>
           </p:cNvPr>
@@ -9323,7 +9368,7 @@
           <p:cNvPr id="11" name="">
             <a:extLst xmlns:a="http://schemas.openxmlformats.org/drawingml/2006/main">
               <a:ext uri="{FF2B5EF4-FFF2-40B4-BE49-F238E27FC236}">
-                <a16:creationId xmlns:a16="http://schemas.microsoft.com/office/drawing/2014/main" id="{891F2A3D-0DC6-46CD-89BE-16C36E5F886A}"/>
+                <a16:creationId xmlns:a16="http://schemas.microsoft.com/office/drawing/2014/main" id="{3C4625CA-392B-4D57-883E-4F06B4273ED8}"/>
               </a:ext>
             </a:extLst>
           </p:cNvPr>
@@ -9407,7 +9452,7 @@
           <p:cNvPr id="12" name="">
             <a:extLst xmlns:a="http://schemas.openxmlformats.org/drawingml/2006/main">
               <a:ext uri="{FF2B5EF4-FFF2-40B4-BE49-F238E27FC236}">
-                <a16:creationId xmlns:a16="http://schemas.microsoft.com/office/drawing/2014/main" id="{AC3CD57B-0D4E-4013-B438-D575304CAFE6}"/>
+                <a16:creationId xmlns:a16="http://schemas.microsoft.com/office/drawing/2014/main" id="{ADB424E9-018F-4025-9163-E9C007255262}"/>
               </a:ext>
             </a:extLst>
           </p:cNvPr>
@@ -9457,7 +9502,7 @@
           <p:cNvPr id="13" name="">
             <a:extLst xmlns:a="http://schemas.openxmlformats.org/drawingml/2006/main">
               <a:ext uri="{FF2B5EF4-FFF2-40B4-BE49-F238E27FC236}">
-                <a16:creationId xmlns:a16="http://schemas.microsoft.com/office/drawing/2014/main" id="{1976C6EE-288D-4FA7-B3C6-901BEA4948A1}"/>
+                <a16:creationId xmlns:a16="http://schemas.microsoft.com/office/drawing/2014/main" id="{F990B189-168E-463B-A316-F4A315A8FDDC}"/>
               </a:ext>
             </a:extLst>
           </p:cNvPr>
@@ -9490,7 +9535,7 @@
           <p:cNvPr id="14" name="">
             <a:extLst xmlns:a="http://schemas.openxmlformats.org/drawingml/2006/main">
               <a:ext uri="{FF2B5EF4-FFF2-40B4-BE49-F238E27FC236}">
-                <a16:creationId xmlns:a16="http://schemas.microsoft.com/office/drawing/2014/main" id="{B49057E1-4B27-48CA-8141-43711CB17C68}"/>
+                <a16:creationId xmlns:a16="http://schemas.microsoft.com/office/drawing/2014/main" id="{A75A8ABB-2842-4FA6-9946-2EAD63197CFB}"/>
               </a:ext>
             </a:extLst>
           </p:cNvPr>
@@ -9540,7 +9585,7 @@
           <p:cNvPr id="15" name="">
             <a:extLst xmlns:a="http://schemas.openxmlformats.org/drawingml/2006/main">
               <a:ext uri="{FF2B5EF4-FFF2-40B4-BE49-F238E27FC236}">
-                <a16:creationId xmlns:a16="http://schemas.microsoft.com/office/drawing/2014/main" id="{68FE9767-6A8E-4F15-9257-24FDD5F79B4D}"/>
+                <a16:creationId xmlns:a16="http://schemas.microsoft.com/office/drawing/2014/main" id="{AD89EA5D-82E6-42C2-9871-5D428044758F}"/>
               </a:ext>
             </a:extLst>
           </p:cNvPr>
@@ -9624,7 +9669,7 @@
           <p:cNvPr id="16" name="">
             <a:extLst xmlns:a="http://schemas.openxmlformats.org/drawingml/2006/main">
               <a:ext uri="{FF2B5EF4-FFF2-40B4-BE49-F238E27FC236}">
-                <a16:creationId xmlns:a16="http://schemas.microsoft.com/office/drawing/2014/main" id="{B6A83AE5-1AA2-4E68-A193-7F4F41D6D5F6}"/>
+                <a16:creationId xmlns:a16="http://schemas.microsoft.com/office/drawing/2014/main" id="{50BFDC33-0597-4325-8E5E-1B65C747CBCA}"/>
               </a:ext>
             </a:extLst>
           </p:cNvPr>
@@ -9674,7 +9719,7 @@
           <p:cNvPr id="17" name="">
             <a:extLst xmlns:a="http://schemas.openxmlformats.org/drawingml/2006/main">
               <a:ext uri="{FF2B5EF4-FFF2-40B4-BE49-F238E27FC236}">
-                <a16:creationId xmlns:a16="http://schemas.microsoft.com/office/drawing/2014/main" id="{8D964990-33E0-404B-8C68-F61624CD664E}"/>
+                <a16:creationId xmlns:a16="http://schemas.microsoft.com/office/drawing/2014/main" id="{741FD7B3-F195-45C4-A23F-2B4837414549}"/>
               </a:ext>
             </a:extLst>
           </p:cNvPr>
@@ -9724,7 +9769,7 @@
           <p:cNvPr id="18" name="">
             <a:extLst xmlns:a="http://schemas.openxmlformats.org/drawingml/2006/main">
               <a:ext uri="{FF2B5EF4-FFF2-40B4-BE49-F238E27FC236}">
-                <a16:creationId xmlns:a16="http://schemas.microsoft.com/office/drawing/2014/main" id="{BACA1A55-0E13-4DB5-831C-75C780E17799}"/>
+                <a16:creationId xmlns:a16="http://schemas.microsoft.com/office/drawing/2014/main" id="{1DE52240-90FD-40CF-9150-6ACBFF55D5EF}"/>
               </a:ext>
             </a:extLst>
           </p:cNvPr>
@@ -9772,7 +9817,7 @@
     </p:spTree>
     <p:extLst>
       <p:ext uri="{BB962C8B-B14F-4D97-AF65-F5344CB8AC3E}">
-        <p14:creationId xmlns:p14="http://schemas.microsoft.com/office/powerpoint/2010/main" val="1228436837"/>
+        <p14:creationId xmlns:p14="http://schemas.microsoft.com/office/powerpoint/2010/main" val="672020330"/>
       </p:ext>
     </p:extLst>
   </p:cSld>

</xml_diff>

<commit_message>
Add traceable product profitability example
</commit_message>
<xml_diff>
--- a/deliverables/Amazon_Q2_2026_Leadership_Presentation.pptx
+++ b/deliverables/Amazon_Q2_2026_Leadership_Presentation.pptx
@@ -2,21 +2,22 @@
 <file path=ppt/presentation.xml><?xml version="1.0" encoding="utf-8"?>
 <p:presentation xmlns:p="http://schemas.openxmlformats.org/presentationml/2006/main">
   <p:sldMasterIdLst>
-    <p:sldMasterId xmlns:r="http://schemas.openxmlformats.org/officeDocument/2006/relationships" id="2147483648" r:id="R09d86f083ce54df1"/>
+    <p:sldMasterId xmlns:r="http://schemas.openxmlformats.org/officeDocument/2006/relationships" id="2147483648" r:id="R52727c6199f3482a"/>
   </p:sldMasterIdLst>
   <p:notesMasterIdLst>
-    <p:notesMasterId xmlns:r="http://schemas.openxmlformats.org/officeDocument/2006/relationships" r:id="R6fb32dfa88e84fb7"/>
+    <p:notesMasterId xmlns:r="http://schemas.openxmlformats.org/officeDocument/2006/relationships" r:id="Rdcf78678e40247c8"/>
   </p:notesMasterIdLst>
   <p:sldIdLst>
-    <p:sldId xmlns:r="http://schemas.openxmlformats.org/officeDocument/2006/relationships" id="256" r:id="R7da852f158f04797"/>
-    <p:sldId xmlns:r="http://schemas.openxmlformats.org/officeDocument/2006/relationships" id="257" r:id="Rfdeb1b7e618141e7"/>
-    <p:sldId xmlns:r="http://schemas.openxmlformats.org/officeDocument/2006/relationships" id="258" r:id="Rf875dae898e2426b"/>
-    <p:sldId xmlns:r="http://schemas.openxmlformats.org/officeDocument/2006/relationships" id="259" r:id="Re7223934b7df43f5"/>
-    <p:sldId xmlns:r="http://schemas.openxmlformats.org/officeDocument/2006/relationships" id="260" r:id="R6966beec870245ef"/>
-    <p:sldId xmlns:r="http://schemas.openxmlformats.org/officeDocument/2006/relationships" id="261" r:id="R265e24bc1c524944"/>
-    <p:sldId xmlns:r="http://schemas.openxmlformats.org/officeDocument/2006/relationships" id="262" r:id="Rd6857bbb793748df"/>
-    <p:sldId xmlns:r="http://schemas.openxmlformats.org/officeDocument/2006/relationships" id="263" r:id="Re91f480c43524aa9"/>
-    <p:sldId xmlns:r="http://schemas.openxmlformats.org/officeDocument/2006/relationships" id="264" r:id="R7919b45a16794ba7"/>
+    <p:sldId xmlns:r="http://schemas.openxmlformats.org/officeDocument/2006/relationships" id="256" r:id="R5ad9c15d25e04f4b"/>
+    <p:sldId xmlns:r="http://schemas.openxmlformats.org/officeDocument/2006/relationships" id="257" r:id="Rd8c8e9a5dec445a4"/>
+    <p:sldId xmlns:r="http://schemas.openxmlformats.org/officeDocument/2006/relationships" id="258" r:id="Re61b8eb862e945aa"/>
+    <p:sldId xmlns:r="http://schemas.openxmlformats.org/officeDocument/2006/relationships" id="259" r:id="Ra29cd66d27034f45"/>
+    <p:sldId xmlns:r="http://schemas.openxmlformats.org/officeDocument/2006/relationships" id="260" r:id="R96796ecdb8d848e6"/>
+    <p:sldId xmlns:r="http://schemas.openxmlformats.org/officeDocument/2006/relationships" id="261" r:id="R8d99683a33954cbf"/>
+    <p:sldId xmlns:r="http://schemas.openxmlformats.org/officeDocument/2006/relationships" id="262" r:id="Rc6707baf73d24cb8"/>
+    <p:sldId xmlns:r="http://schemas.openxmlformats.org/officeDocument/2006/relationships" id="263" r:id="R11e34cc21bab4023"/>
+    <p:sldId xmlns:r="http://schemas.openxmlformats.org/officeDocument/2006/relationships" id="264" r:id="Raba5306df4b9484c"/>
+    <p:sldId xmlns:r="http://schemas.openxmlformats.org/officeDocument/2006/relationships" id="265" r:id="Raabbd13a3b16458c"/>
   </p:sldIdLst>
   <p:sldSz cx="12192000" cy="6858000"/>
   <p:notesSz cx="6858000" cy="9144000"/>
@@ -476,6 +477,72 @@
 </p:notes>
 </file>
 
+<file path=ppt/notesSlides/notesSlide10.xml><?xml version="1.0" encoding="utf-8"?>
+<p:notes xmlns:p="http://schemas.openxmlformats.org/presentationml/2006/main">
+  <p:cSld>
+    <p:spTree>
+      <p:nvGrpSpPr>
+        <p:cNvPr id="1" name=""/>
+        <p:cNvGrpSpPr/>
+        <p:nvPr/>
+      </p:nvGrpSpPr>
+      <p:grpSpPr>
+        <a:xfrm xmlns:a="http://schemas.openxmlformats.org/drawingml/2006/main"/>
+      </p:grpSpPr>
+      <p:sp>
+        <p:nvSpPr>
+          <p:cNvPr id="2" name="Slide Image Placeholder 1"/>
+          <p:cNvSpPr>
+            <a:spLocks xmlns:a="http://schemas.openxmlformats.org/drawingml/2006/main" noGrp="1"/>
+          </p:cNvSpPr>
+          <p:nvPr>
+            <p:ph type="sldImg" idx="0"/>
+          </p:nvPr>
+        </p:nvSpPr>
+        <p:spPr/>
+      </p:sp>
+      <p:sp>
+        <p:nvSpPr>
+          <p:cNvPr id="3" name="Notes Placeholder 2"/>
+          <p:cNvSpPr>
+            <a:spLocks xmlns:a="http://schemas.openxmlformats.org/drawingml/2006/main" noGrp="1"/>
+          </p:cNvSpPr>
+          <p:nvPr>
+            <p:ph type="body" idx="1"/>
+          </p:nvPr>
+        </p:nvSpPr>
+        <p:spPr/>
+        <p:txBody>
+          <a:bodyPr xmlns:a="http://schemas.openxmlformats.org/drawingml/2006/main"/>
+          <a:lstStyle xmlns:a="http://schemas.openxmlformats.org/drawingml/2006/main"/>
+          <a:p xmlns:a="http://schemas.openxmlformats.org/drawingml/2006/main"/>
+        </p:txBody>
+      </p:sp>
+      <p:sp>
+        <p:nvSpPr>
+          <p:cNvPr id="4" name="Slide Number Placeholder 3"/>
+          <p:cNvSpPr>
+            <a:spLocks xmlns:a="http://schemas.openxmlformats.org/drawingml/2006/main" noGrp="1"/>
+          </p:cNvSpPr>
+          <p:nvPr>
+            <p:ph type="sldNum" idx="5"/>
+          </p:nvPr>
+        </p:nvSpPr>
+        <p:spPr/>
+        <p:txBody>
+          <a:bodyPr xmlns:a="http://schemas.openxmlformats.org/drawingml/2006/main"/>
+          <a:lstStyle xmlns:a="http://schemas.openxmlformats.org/drawingml/2006/main"/>
+          <a:p xmlns:a="http://schemas.openxmlformats.org/drawingml/2006/main"/>
+        </p:txBody>
+      </p:sp>
+    </p:spTree>
+  </p:cSld>
+  <p:clrMapOvr>
+    <a:masterClrMapping xmlns:a="http://schemas.openxmlformats.org/drawingml/2006/main"/>
+  </p:clrMapOvr>
+</p:notes>
+</file>
+
 <file path=ppt/notesSlides/notesSlide2.xml><?xml version="1.0" encoding="utf-8"?>
 <p:notes xmlns:p="http://schemas.openxmlformats.org/presentationml/2006/main">
   <p:cSld>
@@ -1042,7 +1109,7 @@
   </p:cSld>
   <p:clrMap bg1="lt1" tx1="dk1" bg2="lt2" tx2="dk2" accent1="accent1" accent2="accent2" accent3="accent3" accent4="accent4" accent5="accent5" accent6="accent6" hlink="hlink" folHlink="folHlink"/>
   <p:sldLayoutIdLst>
-    <p:sldLayoutId xmlns:r="http://schemas.openxmlformats.org/officeDocument/2006/relationships" id="2147483649" r:id="R5f419bff2c9d45ff"/>
+    <p:sldLayoutId xmlns:r="http://schemas.openxmlformats.org/officeDocument/2006/relationships" id="2147483649" r:id="Ra495b2f049364bff"/>
   </p:sldLayoutIdLst>
   <p:txStyles>
     <p:titleStyle>
@@ -2047,7 +2114,7 @@
           <p:cNvPr id="9" name="">
             <a:extLst xmlns:a="http://schemas.openxmlformats.org/drawingml/2006/main">
               <a:ext uri="{FF2B5EF4-FFF2-40B4-BE49-F238E27FC236}">
-                <a16:creationId xmlns:a16="http://schemas.microsoft.com/office/drawing/2014/main" id="{097D7118-CC53-4F31-8790-8E3BA1B0BAD3}"/>
+                <a16:creationId xmlns:a16="http://schemas.microsoft.com/office/drawing/2014/main" id="{BEC4B584-E6BF-4874-B747-13FD200E1D63}"/>
               </a:ext>
             </a:extLst>
           </p:cNvPr>
@@ -2097,7 +2164,7 @@
           <p:cNvPr id="2" name="">
             <a:extLst xmlns:a="http://schemas.openxmlformats.org/drawingml/2006/main">
               <a:ext uri="{FF2B5EF4-FFF2-40B4-BE49-F238E27FC236}">
-                <a16:creationId xmlns:a16="http://schemas.microsoft.com/office/drawing/2014/main" id="{AB3F779B-47D5-4A65-9239-51DD5EAB17C1}"/>
+                <a16:creationId xmlns:a16="http://schemas.microsoft.com/office/drawing/2014/main" id="{D1ED93F6-E71B-493A-90B2-C671C6D43F4B}"/>
               </a:ext>
             </a:extLst>
           </p:cNvPr>
@@ -2147,7 +2214,7 @@
           <p:cNvPr id="3" name="">
             <a:extLst xmlns:a="http://schemas.openxmlformats.org/drawingml/2006/main">
               <a:ext uri="{FF2B5EF4-FFF2-40B4-BE49-F238E27FC236}">
-                <a16:creationId xmlns:a16="http://schemas.microsoft.com/office/drawing/2014/main" id="{1AE8EDB3-790A-451D-BB92-A2D5A8C67468}"/>
+                <a16:creationId xmlns:a16="http://schemas.microsoft.com/office/drawing/2014/main" id="{2483E41B-782E-4C15-BB86-EB946FC0A23F}"/>
               </a:ext>
             </a:extLst>
           </p:cNvPr>
@@ -2197,7 +2264,7 @@
           <p:cNvPr id="4" name="">
             <a:extLst xmlns:a="http://schemas.openxmlformats.org/drawingml/2006/main">
               <a:ext uri="{FF2B5EF4-FFF2-40B4-BE49-F238E27FC236}">
-                <a16:creationId xmlns:a16="http://schemas.microsoft.com/office/drawing/2014/main" id="{5710C897-0DF9-48B0-B590-8489A2D2467B}"/>
+                <a16:creationId xmlns:a16="http://schemas.microsoft.com/office/drawing/2014/main" id="{DB4D964A-1C4F-4B4B-9827-AD228994E8A1}"/>
               </a:ext>
             </a:extLst>
           </p:cNvPr>
@@ -2230,7 +2297,7 @@
           <p:cNvPr id="5" name="">
             <a:extLst xmlns:a="http://schemas.openxmlformats.org/drawingml/2006/main">
               <a:ext uri="{FF2B5EF4-FFF2-40B4-BE49-F238E27FC236}">
-                <a16:creationId xmlns:a16="http://schemas.microsoft.com/office/drawing/2014/main" id="{EC532627-ED0A-4A58-9EC0-0E4DCEA014B6}"/>
+                <a16:creationId xmlns:a16="http://schemas.microsoft.com/office/drawing/2014/main" id="{06925C25-F466-406E-A2FB-392D30DE2D53}"/>
               </a:ext>
             </a:extLst>
           </p:cNvPr>
@@ -2280,7 +2347,7 @@
           <p:cNvPr id="6" name="">
             <a:extLst xmlns:a="http://schemas.openxmlformats.org/drawingml/2006/main">
               <a:ext uri="{FF2B5EF4-FFF2-40B4-BE49-F238E27FC236}">
-                <a16:creationId xmlns:a16="http://schemas.microsoft.com/office/drawing/2014/main" id="{1FF68DA8-A500-4197-9422-2EB0BE8052DF}"/>
+                <a16:creationId xmlns:a16="http://schemas.microsoft.com/office/drawing/2014/main" id="{E2D023E8-2EE3-4557-B9B4-AFFC8992A86D}"/>
               </a:ext>
             </a:extLst>
           </p:cNvPr>
@@ -2330,7 +2397,7 @@
           <p:cNvPr id="7" name="">
             <a:extLst xmlns:a="http://schemas.openxmlformats.org/drawingml/2006/main">
               <a:ext uri="{FF2B5EF4-FFF2-40B4-BE49-F238E27FC236}">
-                <a16:creationId xmlns:a16="http://schemas.microsoft.com/office/drawing/2014/main" id="{F414EE9A-3197-448A-88CF-5B642A1072DC}"/>
+                <a16:creationId xmlns:a16="http://schemas.microsoft.com/office/drawing/2014/main" id="{CD77009D-369C-43E9-964E-1E918242E80A}"/>
               </a:ext>
             </a:extLst>
           </p:cNvPr>
@@ -2397,7 +2464,7 @@
           <p:cNvPr id="8" name="">
             <a:extLst xmlns:a="http://schemas.openxmlformats.org/drawingml/2006/main">
               <a:ext uri="{FF2B5EF4-FFF2-40B4-BE49-F238E27FC236}">
-                <a16:creationId xmlns:a16="http://schemas.microsoft.com/office/drawing/2014/main" id="{2008072E-84BD-4628-8376-4F94FBD55467}"/>
+                <a16:creationId xmlns:a16="http://schemas.microsoft.com/office/drawing/2014/main" id="{4DB610F4-C591-400B-B8AC-9AC369A205CC}"/>
               </a:ext>
             </a:extLst>
           </p:cNvPr>
@@ -2445,7 +2512,987 @@
     </p:spTree>
     <p:extLst>
       <p:ext uri="{BB962C8B-B14F-4D97-AF65-F5344CB8AC3E}">
-        <p14:creationId xmlns:p14="http://schemas.microsoft.com/office/powerpoint/2010/main" val="1190807397"/>
+        <p14:creationId xmlns:p14="http://schemas.microsoft.com/office/powerpoint/2010/main" val="664749380"/>
+      </p:ext>
+    </p:extLst>
+  </p:cSld>
+</p:sld>
+</file>
+
+<file path=ppt/slides/slide10.xml><?xml version="1.0" encoding="utf-8"?>
+<p:sld xmlns:p="http://schemas.openxmlformats.org/presentationml/2006/main">
+  <p:cSld>
+    <p:bg>
+      <p:bgPr>
+        <a:solidFill xmlns:a="http://schemas.openxmlformats.org/drawingml/2006/main">
+          <a:srgbClr val="FFFFFF"/>
+        </a:solidFill>
+      </p:bgPr>
+    </p:bg>
+    <p:spTree>
+      <p:nvGrpSpPr>
+        <p:cNvPr id="1" name=""/>
+        <p:cNvGrpSpPr/>
+        <p:nvPr/>
+      </p:nvGrpSpPr>
+      <p:grpSpPr>
+        <a:xfrm xmlns:a="http://schemas.openxmlformats.org/drawingml/2006/main"/>
+      </p:grpSpPr>
+      <p:sp>
+        <p:nvSpPr>
+          <p:cNvPr id="19" name="">
+            <a:extLst xmlns:a="http://schemas.openxmlformats.org/drawingml/2006/main">
+              <a:ext uri="{FF2B5EF4-FFF2-40B4-BE49-F238E27FC236}">
+                <a16:creationId xmlns:a16="http://schemas.microsoft.com/office/drawing/2014/main" id="{01227F48-301C-4283-96AC-390E1FB7A8AE}"/>
+              </a:ext>
+            </a:extLst>
+          </p:cNvPr>
+          <p:cNvSpPr>
+            <a:spLocks xmlns:a="http://schemas.openxmlformats.org/drawingml/2006/main" noGrp="1"/>
+          </p:cNvSpPr>
+          <p:nvPr/>
+        </p:nvSpPr>
+        <p:spPr>
+          <a:xfrm xmlns:a="http://schemas.openxmlformats.org/drawingml/2006/main">
+            <a:off x="685800" y="361950"/>
+            <a:ext cx="6667500" cy="228600"/>
+          </a:xfrm>
+          <a:prstGeom xmlns:a="http://schemas.openxmlformats.org/drawingml/2006/main" prst="rect">
+            <a:avLst/>
+          </a:prstGeom>
+          <a:noFill xmlns:a="http://schemas.openxmlformats.org/drawingml/2006/main"/>
+          <a:ln xmlns:a="http://schemas.openxmlformats.org/drawingml/2006/main" w="0">
+            <a:noFill/>
+            <a:prstDash val="solid"/>
+          </a:ln>
+        </p:spPr>
+        <p:txBody>
+          <a:bodyPr xmlns:a="http://schemas.openxmlformats.org/drawingml/2006/main"/>
+          <a:lstStyle xmlns:a="http://schemas.openxmlformats.org/drawingml/2006/main"/>
+          <a:p xmlns:a="http://schemas.openxmlformats.org/drawingml/2006/main">
+            <a:pPr algn="l">
+              <a:defRPr sz="975" b="1">
+                <a:solidFill>
+                  <a:srgbClr val="2E74B5"/>
+                </a:solidFill>
+              </a:defRPr>
+            </a:pPr>
+            <a:r>
+              <a:rPr sz="975" b="1">
+                <a:solidFill>
+                  <a:srgbClr val="2E74B5"/>
+                </a:solidFill>
+              </a:rPr>
+              <a:t>DELIVERABLE 3</a:t>
+            </a:r>
+          </a:p>
+        </p:txBody>
+      </p:sp>
+      <p:sp>
+        <p:nvSpPr>
+          <p:cNvPr id="2" name="">
+            <a:extLst xmlns:a="http://schemas.openxmlformats.org/drawingml/2006/main">
+              <a:ext uri="{FF2B5EF4-FFF2-40B4-BE49-F238E27FC236}">
+                <a16:creationId xmlns:a16="http://schemas.microsoft.com/office/drawing/2014/main" id="{FD6A4705-B1D1-4E96-AB20-7C4A8FDED90A}"/>
+              </a:ext>
+            </a:extLst>
+          </p:cNvPr>
+          <p:cNvSpPr>
+            <a:spLocks xmlns:a="http://schemas.openxmlformats.org/drawingml/2006/main" noGrp="1"/>
+          </p:cNvSpPr>
+          <p:nvPr/>
+        </p:nvSpPr>
+        <p:spPr>
+          <a:xfrm xmlns:a="http://schemas.openxmlformats.org/drawingml/2006/main">
+            <a:off x="685800" y="666750"/>
+            <a:ext cx="10820400" cy="552450"/>
+          </a:xfrm>
+          <a:prstGeom xmlns:a="http://schemas.openxmlformats.org/drawingml/2006/main" prst="rect">
+            <a:avLst/>
+          </a:prstGeom>
+          <a:noFill xmlns:a="http://schemas.openxmlformats.org/drawingml/2006/main"/>
+          <a:ln xmlns:a="http://schemas.openxmlformats.org/drawingml/2006/main" w="0">
+            <a:noFill/>
+            <a:prstDash val="solid"/>
+          </a:ln>
+        </p:spPr>
+        <p:txBody>
+          <a:bodyPr xmlns:a="http://schemas.openxmlformats.org/drawingml/2006/main"/>
+          <a:lstStyle xmlns:a="http://schemas.openxmlformats.org/drawingml/2006/main"/>
+          <a:p xmlns:a="http://schemas.openxmlformats.org/drawingml/2006/main">
+            <a:pPr algn="l">
+              <a:defRPr sz="2700" b="1">
+                <a:solidFill>
+                  <a:srgbClr val="0B2545"/>
+                </a:solidFill>
+              </a:defRPr>
+            </a:pPr>
+            <a:r>
+              <a:rPr sz="2700" b="1">
+                <a:solidFill>
+                  <a:srgbClr val="0B2545"/>
+                </a:solidFill>
+              </a:rPr>
+              <a:t>The first 90 days build trust before adding forecasting</a:t>
+            </a:r>
+          </a:p>
+        </p:txBody>
+      </p:sp>
+      <p:sp>
+        <p:nvSpPr>
+          <p:cNvPr id="3" name="">
+            <a:extLst xmlns:a="http://schemas.openxmlformats.org/drawingml/2006/main">
+              <a:ext uri="{FF2B5EF4-FFF2-40B4-BE49-F238E27FC236}">
+                <a16:creationId xmlns:a16="http://schemas.microsoft.com/office/drawing/2014/main" id="{036D4D32-0C90-444E-AF40-F56C5D3F5FC3}"/>
+              </a:ext>
+            </a:extLst>
+          </p:cNvPr>
+          <p:cNvSpPr>
+            <a:spLocks xmlns:a="http://schemas.openxmlformats.org/drawingml/2006/main" noGrp="1"/>
+          </p:cNvSpPr>
+          <p:nvPr/>
+        </p:nvSpPr>
+        <p:spPr>
+          <a:xfrm xmlns:a="http://schemas.openxmlformats.org/drawingml/2006/main">
+            <a:off x="685800" y="1257300"/>
+            <a:ext cx="10477500" cy="361950"/>
+          </a:xfrm>
+          <a:prstGeom xmlns:a="http://schemas.openxmlformats.org/drawingml/2006/main" prst="rect">
+            <a:avLst/>
+          </a:prstGeom>
+          <a:noFill xmlns:a="http://schemas.openxmlformats.org/drawingml/2006/main"/>
+          <a:ln xmlns:a="http://schemas.openxmlformats.org/drawingml/2006/main" w="0">
+            <a:noFill/>
+            <a:prstDash val="solid"/>
+          </a:ln>
+        </p:spPr>
+        <p:txBody>
+          <a:bodyPr xmlns:a="http://schemas.openxmlformats.org/drawingml/2006/main"/>
+          <a:lstStyle xmlns:a="http://schemas.openxmlformats.org/drawingml/2006/main"/>
+          <a:p xmlns:a="http://schemas.openxmlformats.org/drawingml/2006/main">
+            <a:pPr algn="l">
+              <a:defRPr sz="1425" b="0">
+                <a:solidFill>
+                  <a:srgbClr val="667085"/>
+                </a:solidFill>
+              </a:defRPr>
+            </a:pPr>
+            <a:r>
+              <a:rPr sz="1425" b="0">
+                <a:solidFill>
+                  <a:srgbClr val="667085"/>
+                </a:solidFill>
+              </a:rPr>
+              <a:t>Automate controls and reconciliation first; expand decisions only after the underlying history is dependable.</a:t>
+            </a:r>
+          </a:p>
+        </p:txBody>
+      </p:sp>
+      <p:sp>
+        <p:nvSpPr>
+          <p:cNvPr id="4" name="">
+            <a:extLst xmlns:a="http://schemas.openxmlformats.org/drawingml/2006/main">
+              <a:ext uri="{FF2B5EF4-FFF2-40B4-BE49-F238E27FC236}">
+                <a16:creationId xmlns:a16="http://schemas.microsoft.com/office/drawing/2014/main" id="{851F534E-C504-4CC9-A21E-4A4F1C940127}"/>
+              </a:ext>
+            </a:extLst>
+          </p:cNvPr>
+          <p:cNvSpPr>
+            <a:spLocks xmlns:a="http://schemas.openxmlformats.org/drawingml/2006/main" noGrp="1"/>
+          </p:cNvSpPr>
+          <p:nvPr/>
+        </p:nvSpPr>
+        <p:spPr>
+          <a:xfrm xmlns:a="http://schemas.openxmlformats.org/drawingml/2006/main">
+            <a:off x="685800" y="2047875"/>
+            <a:ext cx="3143250" cy="285750"/>
+          </a:xfrm>
+          <a:prstGeom xmlns:a="http://schemas.openxmlformats.org/drawingml/2006/main" prst="rect">
+            <a:avLst/>
+          </a:prstGeom>
+          <a:noFill xmlns:a="http://schemas.openxmlformats.org/drawingml/2006/main"/>
+          <a:ln xmlns:a="http://schemas.openxmlformats.org/drawingml/2006/main" w="0">
+            <a:noFill/>
+            <a:prstDash val="solid"/>
+          </a:ln>
+        </p:spPr>
+        <p:txBody>
+          <a:bodyPr xmlns:a="http://schemas.openxmlformats.org/drawingml/2006/main"/>
+          <a:lstStyle xmlns:a="http://schemas.openxmlformats.org/drawingml/2006/main"/>
+          <a:p xmlns:a="http://schemas.openxmlformats.org/drawingml/2006/main">
+            <a:pPr algn="l">
+              <a:defRPr sz="1350" b="1">
+                <a:solidFill>
+                  <a:srgbClr val="2E74B5"/>
+                </a:solidFill>
+              </a:defRPr>
+            </a:pPr>
+            <a:r>
+              <a:rPr sz="1350" b="1">
+                <a:solidFill>
+                  <a:srgbClr val="2E74B5"/>
+                </a:solidFill>
+              </a:rPr>
+              <a:t>Days 1–30</a:t>
+            </a:r>
+          </a:p>
+        </p:txBody>
+      </p:sp>
+      <p:sp>
+        <p:nvSpPr>
+          <p:cNvPr id="5" name="">
+            <a:extLst xmlns:a="http://schemas.openxmlformats.org/drawingml/2006/main">
+              <a:ext uri="{FF2B5EF4-FFF2-40B4-BE49-F238E27FC236}">
+                <a16:creationId xmlns:a16="http://schemas.microsoft.com/office/drawing/2014/main" id="{FA00CCF7-195C-4BBF-929B-EE08465D1AC9}"/>
+              </a:ext>
+            </a:extLst>
+          </p:cNvPr>
+          <p:cNvSpPr>
+            <a:spLocks xmlns:a="http://schemas.openxmlformats.org/drawingml/2006/main" noGrp="1"/>
+          </p:cNvSpPr>
+          <p:nvPr/>
+        </p:nvSpPr>
+        <p:spPr>
+          <a:xfrm xmlns:a="http://schemas.openxmlformats.org/drawingml/2006/main">
+            <a:off x="685800" y="2457450"/>
+            <a:ext cx="3143250" cy="57150"/>
+          </a:xfrm>
+          <a:prstGeom xmlns:a="http://schemas.openxmlformats.org/drawingml/2006/main" prst="rect">
+            <a:avLst/>
+          </a:prstGeom>
+          <a:solidFill xmlns:a="http://schemas.openxmlformats.org/drawingml/2006/main">
+            <a:srgbClr val="0B7A53"/>
+          </a:solidFill>
+          <a:ln xmlns:a="http://schemas.openxmlformats.org/drawingml/2006/main" w="0">
+            <a:solidFill>
+              <a:srgbClr val="0B7A53"/>
+            </a:solidFill>
+            <a:prstDash val="solid"/>
+          </a:ln>
+        </p:spPr>
+      </p:sp>
+      <p:sp>
+        <p:nvSpPr>
+          <p:cNvPr id="6" name="">
+            <a:extLst xmlns:a="http://schemas.openxmlformats.org/drawingml/2006/main">
+              <a:ext uri="{FF2B5EF4-FFF2-40B4-BE49-F238E27FC236}">
+                <a16:creationId xmlns:a16="http://schemas.microsoft.com/office/drawing/2014/main" id="{5CC1A022-1037-4AFB-A14A-BE52C4EFF48E}"/>
+              </a:ext>
+            </a:extLst>
+          </p:cNvPr>
+          <p:cNvSpPr>
+            <a:spLocks xmlns:a="http://schemas.openxmlformats.org/drawingml/2006/main" noGrp="1"/>
+          </p:cNvSpPr>
+          <p:nvPr/>
+        </p:nvSpPr>
+        <p:spPr>
+          <a:xfrm xmlns:a="http://schemas.openxmlformats.org/drawingml/2006/main">
+            <a:off x="685800" y="2781300"/>
+            <a:ext cx="3143250" cy="361950"/>
+          </a:xfrm>
+          <a:prstGeom xmlns:a="http://schemas.openxmlformats.org/drawingml/2006/main" prst="rect">
+            <a:avLst/>
+          </a:prstGeom>
+          <a:noFill xmlns:a="http://schemas.openxmlformats.org/drawingml/2006/main"/>
+          <a:ln xmlns:a="http://schemas.openxmlformats.org/drawingml/2006/main" w="0">
+            <a:noFill/>
+            <a:prstDash val="solid"/>
+          </a:ln>
+        </p:spPr>
+        <p:txBody>
+          <a:bodyPr xmlns:a="http://schemas.openxmlformats.org/drawingml/2006/main"/>
+          <a:lstStyle xmlns:a="http://schemas.openxmlformats.org/drawingml/2006/main"/>
+          <a:p xmlns:a="http://schemas.openxmlformats.org/drawingml/2006/main">
+            <a:pPr algn="l">
+              <a:defRPr sz="1875" b="1">
+                <a:solidFill>
+                  <a:srgbClr val="0B2545"/>
+                </a:solidFill>
+              </a:defRPr>
+            </a:pPr>
+            <a:r>
+              <a:rPr sz="1875" b="1">
+                <a:solidFill>
+                  <a:srgbClr val="0B2545"/>
+                </a:solidFill>
+              </a:rPr>
+              <a:t>Reliable ingestion</a:t>
+            </a:r>
+          </a:p>
+        </p:txBody>
+      </p:sp>
+      <p:sp>
+        <p:nvSpPr>
+          <p:cNvPr id="7" name="">
+            <a:extLst xmlns:a="http://schemas.openxmlformats.org/drawingml/2006/main">
+              <a:ext uri="{FF2B5EF4-FFF2-40B4-BE49-F238E27FC236}">
+                <a16:creationId xmlns:a16="http://schemas.microsoft.com/office/drawing/2014/main" id="{3D88B46E-1F7C-40E3-90C6-84083E49AD9B}"/>
+              </a:ext>
+            </a:extLst>
+          </p:cNvPr>
+          <p:cNvSpPr>
+            <a:spLocks xmlns:a="http://schemas.openxmlformats.org/drawingml/2006/main" noGrp="1"/>
+          </p:cNvSpPr>
+          <p:nvPr/>
+        </p:nvSpPr>
+        <p:spPr>
+          <a:xfrm xmlns:a="http://schemas.openxmlformats.org/drawingml/2006/main">
+            <a:off x="685800" y="3352800"/>
+            <a:ext cx="3143250" cy="1047750"/>
+          </a:xfrm>
+          <a:prstGeom xmlns:a="http://schemas.openxmlformats.org/drawingml/2006/main" prst="rect">
+            <a:avLst/>
+          </a:prstGeom>
+          <a:noFill xmlns:a="http://schemas.openxmlformats.org/drawingml/2006/main"/>
+          <a:ln xmlns:a="http://schemas.openxmlformats.org/drawingml/2006/main" w="0">
+            <a:noFill/>
+            <a:prstDash val="solid"/>
+          </a:ln>
+        </p:spPr>
+        <p:txBody>
+          <a:bodyPr xmlns:a="http://schemas.openxmlformats.org/drawingml/2006/main"/>
+          <a:lstStyle xmlns:a="http://schemas.openxmlformats.org/drawingml/2006/main"/>
+          <a:p xmlns:a="http://schemas.openxmlformats.org/drawingml/2006/main">
+            <a:pPr algn="l">
+              <a:defRPr sz="1425" b="0">
+                <a:solidFill>
+                  <a:srgbClr val="667085"/>
+                </a:solidFill>
+              </a:defRPr>
+            </a:pPr>
+            <a:r>
+              <a:rPr sz="1425" b="0">
+                <a:solidFill>
+                  <a:srgbClr val="667085"/>
+                </a:solidFill>
+              </a:rPr>
+              <a:t>Raw history • schema alerts</a:t>
+            </a:r>
+          </a:p>
+          <a:p xmlns:a="http://schemas.openxmlformats.org/drawingml/2006/main">
+            <a:pPr algn="l">
+              <a:defRPr sz="1425" b="0">
+                <a:solidFill>
+                  <a:srgbClr val="667085"/>
+                </a:solidFill>
+              </a:defRPr>
+            </a:pPr>
+            <a:r>
+              <a:rPr sz="1425" b="0">
+                <a:solidFill>
+                  <a:srgbClr val="667085"/>
+                </a:solidFill>
+              </a:rPr>
+              <a:t>identity/UOM mappings</a:t>
+            </a:r>
+          </a:p>
+          <a:p xmlns:a="http://schemas.openxmlformats.org/drawingml/2006/main">
+            <a:pPr algn="l">
+              <a:defRPr sz="1425" b="0">
+                <a:solidFill>
+                  <a:srgbClr val="667085"/>
+                </a:solidFill>
+              </a:defRPr>
+            </a:pPr>
+            <a:r>
+              <a:rPr sz="1425" b="0">
+                <a:solidFill>
+                  <a:srgbClr val="667085"/>
+                </a:solidFill>
+              </a:rPr>
+              <a:t>source tie-outs</a:t>
+            </a:r>
+          </a:p>
+        </p:txBody>
+      </p:sp>
+      <p:sp>
+        <p:nvSpPr>
+          <p:cNvPr id="8" name="">
+            <a:extLst xmlns:a="http://schemas.openxmlformats.org/drawingml/2006/main">
+              <a:ext uri="{FF2B5EF4-FFF2-40B4-BE49-F238E27FC236}">
+                <a16:creationId xmlns:a16="http://schemas.microsoft.com/office/drawing/2014/main" id="{C853917D-3543-4840-AEF2-10E3E1D591DC}"/>
+              </a:ext>
+            </a:extLst>
+          </p:cNvPr>
+          <p:cNvSpPr>
+            <a:spLocks xmlns:a="http://schemas.openxmlformats.org/drawingml/2006/main" noGrp="1"/>
+          </p:cNvSpPr>
+          <p:nvPr/>
+        </p:nvSpPr>
+        <p:spPr>
+          <a:xfrm xmlns:a="http://schemas.openxmlformats.org/drawingml/2006/main">
+            <a:off x="4286250" y="2047875"/>
+            <a:ext cx="3143250" cy="285750"/>
+          </a:xfrm>
+          <a:prstGeom xmlns:a="http://schemas.openxmlformats.org/drawingml/2006/main" prst="rect">
+            <a:avLst/>
+          </a:prstGeom>
+          <a:noFill xmlns:a="http://schemas.openxmlformats.org/drawingml/2006/main"/>
+          <a:ln xmlns:a="http://schemas.openxmlformats.org/drawingml/2006/main" w="0">
+            <a:noFill/>
+            <a:prstDash val="solid"/>
+          </a:ln>
+        </p:spPr>
+        <p:txBody>
+          <a:bodyPr xmlns:a="http://schemas.openxmlformats.org/drawingml/2006/main"/>
+          <a:lstStyle xmlns:a="http://schemas.openxmlformats.org/drawingml/2006/main"/>
+          <a:p xmlns:a="http://schemas.openxmlformats.org/drawingml/2006/main">
+            <a:pPr algn="l">
+              <a:defRPr sz="1350" b="1">
+                <a:solidFill>
+                  <a:srgbClr val="2E74B5"/>
+                </a:solidFill>
+              </a:defRPr>
+            </a:pPr>
+            <a:r>
+              <a:rPr sz="1350" b="1">
+                <a:solidFill>
+                  <a:srgbClr val="2E74B5"/>
+                </a:solidFill>
+              </a:rPr>
+              <a:t>Days 31–60</a:t>
+            </a:r>
+          </a:p>
+        </p:txBody>
+      </p:sp>
+      <p:sp>
+        <p:nvSpPr>
+          <p:cNvPr id="9" name="">
+            <a:extLst xmlns:a="http://schemas.openxmlformats.org/drawingml/2006/main">
+              <a:ext uri="{FF2B5EF4-FFF2-40B4-BE49-F238E27FC236}">
+                <a16:creationId xmlns:a16="http://schemas.microsoft.com/office/drawing/2014/main" id="{57014337-F8D8-4052-89AB-587066640D90}"/>
+              </a:ext>
+            </a:extLst>
+          </p:cNvPr>
+          <p:cNvSpPr>
+            <a:spLocks xmlns:a="http://schemas.openxmlformats.org/drawingml/2006/main" noGrp="1"/>
+          </p:cNvSpPr>
+          <p:nvPr/>
+        </p:nvSpPr>
+        <p:spPr>
+          <a:xfrm xmlns:a="http://schemas.openxmlformats.org/drawingml/2006/main">
+            <a:off x="4286250" y="2457450"/>
+            <a:ext cx="3143250" cy="57150"/>
+          </a:xfrm>
+          <a:prstGeom xmlns:a="http://schemas.openxmlformats.org/drawingml/2006/main" prst="rect">
+            <a:avLst/>
+          </a:prstGeom>
+          <a:solidFill xmlns:a="http://schemas.openxmlformats.org/drawingml/2006/main">
+            <a:srgbClr val="2E74B5"/>
+          </a:solidFill>
+          <a:ln xmlns:a="http://schemas.openxmlformats.org/drawingml/2006/main" w="0">
+            <a:solidFill>
+              <a:srgbClr val="2E74B5"/>
+            </a:solidFill>
+            <a:prstDash val="solid"/>
+          </a:ln>
+        </p:spPr>
+      </p:sp>
+      <p:sp>
+        <p:nvSpPr>
+          <p:cNvPr id="10" name="">
+            <a:extLst xmlns:a="http://schemas.openxmlformats.org/drawingml/2006/main">
+              <a:ext uri="{FF2B5EF4-FFF2-40B4-BE49-F238E27FC236}">
+                <a16:creationId xmlns:a16="http://schemas.microsoft.com/office/drawing/2014/main" id="{29803720-67FB-4EEB-AF85-0CA929666EDE}"/>
+              </a:ext>
+            </a:extLst>
+          </p:cNvPr>
+          <p:cNvSpPr>
+            <a:spLocks xmlns:a="http://schemas.openxmlformats.org/drawingml/2006/main" noGrp="1"/>
+          </p:cNvSpPr>
+          <p:nvPr/>
+        </p:nvSpPr>
+        <p:spPr>
+          <a:xfrm xmlns:a="http://schemas.openxmlformats.org/drawingml/2006/main">
+            <a:off x="4286250" y="2781300"/>
+            <a:ext cx="3143250" cy="361950"/>
+          </a:xfrm>
+          <a:prstGeom xmlns:a="http://schemas.openxmlformats.org/drawingml/2006/main" prst="rect">
+            <a:avLst/>
+          </a:prstGeom>
+          <a:noFill xmlns:a="http://schemas.openxmlformats.org/drawingml/2006/main"/>
+          <a:ln xmlns:a="http://schemas.openxmlformats.org/drawingml/2006/main" w="0">
+            <a:noFill/>
+            <a:prstDash val="solid"/>
+          </a:ln>
+        </p:spPr>
+        <p:txBody>
+          <a:bodyPr xmlns:a="http://schemas.openxmlformats.org/drawingml/2006/main"/>
+          <a:lstStyle xmlns:a="http://schemas.openxmlformats.org/drawingml/2006/main"/>
+          <a:p xmlns:a="http://schemas.openxmlformats.org/drawingml/2006/main">
+            <a:pPr algn="l">
+              <a:defRPr sz="1875" b="1">
+                <a:solidFill>
+                  <a:srgbClr val="0B2545"/>
+                </a:solidFill>
+              </a:defRPr>
+            </a:pPr>
+            <a:r>
+              <a:rPr sz="1875" b="1">
+                <a:solidFill>
+                  <a:srgbClr val="0B2545"/>
+                </a:solidFill>
+              </a:rPr>
+              <a:t>Repeatable finance</a:t>
+            </a:r>
+          </a:p>
+        </p:txBody>
+      </p:sp>
+      <p:sp>
+        <p:nvSpPr>
+          <p:cNvPr id="11" name="">
+            <a:extLst xmlns:a="http://schemas.openxmlformats.org/drawingml/2006/main">
+              <a:ext uri="{FF2B5EF4-FFF2-40B4-BE49-F238E27FC236}">
+                <a16:creationId xmlns:a16="http://schemas.microsoft.com/office/drawing/2014/main" id="{C4F5BCB4-B27A-4D52-8DA3-889D41A5C867}"/>
+              </a:ext>
+            </a:extLst>
+          </p:cNvPr>
+          <p:cNvSpPr>
+            <a:spLocks xmlns:a="http://schemas.openxmlformats.org/drawingml/2006/main" noGrp="1"/>
+          </p:cNvSpPr>
+          <p:nvPr/>
+        </p:nvSpPr>
+        <p:spPr>
+          <a:xfrm xmlns:a="http://schemas.openxmlformats.org/drawingml/2006/main">
+            <a:off x="4286250" y="3352800"/>
+            <a:ext cx="3143250" cy="1047750"/>
+          </a:xfrm>
+          <a:prstGeom xmlns:a="http://schemas.openxmlformats.org/drawingml/2006/main" prst="rect">
+            <a:avLst/>
+          </a:prstGeom>
+          <a:noFill xmlns:a="http://schemas.openxmlformats.org/drawingml/2006/main"/>
+          <a:ln xmlns:a="http://schemas.openxmlformats.org/drawingml/2006/main" w="0">
+            <a:noFill/>
+            <a:prstDash val="solid"/>
+          </a:ln>
+        </p:spPr>
+        <p:txBody>
+          <a:bodyPr xmlns:a="http://schemas.openxmlformats.org/drawingml/2006/main"/>
+          <a:lstStyle xmlns:a="http://schemas.openxmlformats.org/drawingml/2006/main"/>
+          <a:p xmlns:a="http://schemas.openxmlformats.org/drawingml/2006/main">
+            <a:pPr algn="l">
+              <a:defRPr sz="1425" b="0">
+                <a:solidFill>
+                  <a:srgbClr val="667085"/>
+                </a:solidFill>
+              </a:defRPr>
+            </a:pPr>
+            <a:r>
+              <a:rPr sz="1425" b="0">
+                <a:solidFill>
+                  <a:srgbClr val="667085"/>
+                </a:solidFill>
+              </a:rPr>
+              <a:t>Amazon management P&amp;L</a:t>
+            </a:r>
+          </a:p>
+          <a:p xmlns:a="http://schemas.openxmlformats.org/drawingml/2006/main">
+            <a:pPr algn="l">
+              <a:defRPr sz="1425" b="0">
+                <a:solidFill>
+                  <a:srgbClr val="667085"/>
+                </a:solidFill>
+              </a:defRPr>
+            </a:pPr>
+            <a:r>
+              <a:rPr sz="1425" b="0">
+                <a:solidFill>
+                  <a:srgbClr val="667085"/>
+                </a:solidFill>
+              </a:rPr>
+              <a:t>QuickBooks reconciliation</a:t>
+            </a:r>
+          </a:p>
+          <a:p xmlns:a="http://schemas.openxmlformats.org/drawingml/2006/main">
+            <a:pPr algn="l">
+              <a:defRPr sz="1425" b="0">
+                <a:solidFill>
+                  <a:srgbClr val="667085"/>
+                </a:solidFill>
+              </a:defRPr>
+            </a:pPr>
+            <a:r>
+              <a:rPr sz="1425" b="0">
+                <a:solidFill>
+                  <a:srgbClr val="667085"/>
+                </a:solidFill>
+              </a:rPr>
+              <a:t>source drill-through</a:t>
+            </a:r>
+          </a:p>
+        </p:txBody>
+      </p:sp>
+      <p:sp>
+        <p:nvSpPr>
+          <p:cNvPr id="12" name="">
+            <a:extLst xmlns:a="http://schemas.openxmlformats.org/drawingml/2006/main">
+              <a:ext uri="{FF2B5EF4-FFF2-40B4-BE49-F238E27FC236}">
+                <a16:creationId xmlns:a16="http://schemas.microsoft.com/office/drawing/2014/main" id="{0A63C395-6350-4A3D-88A7-311C2FC64A44}"/>
+              </a:ext>
+            </a:extLst>
+          </p:cNvPr>
+          <p:cNvSpPr>
+            <a:spLocks xmlns:a="http://schemas.openxmlformats.org/drawingml/2006/main" noGrp="1"/>
+          </p:cNvSpPr>
+          <p:nvPr/>
+        </p:nvSpPr>
+        <p:spPr>
+          <a:xfrm xmlns:a="http://schemas.openxmlformats.org/drawingml/2006/main">
+            <a:off x="7886700" y="2047875"/>
+            <a:ext cx="3143250" cy="285750"/>
+          </a:xfrm>
+          <a:prstGeom xmlns:a="http://schemas.openxmlformats.org/drawingml/2006/main" prst="rect">
+            <a:avLst/>
+          </a:prstGeom>
+          <a:noFill xmlns:a="http://schemas.openxmlformats.org/drawingml/2006/main"/>
+          <a:ln xmlns:a="http://schemas.openxmlformats.org/drawingml/2006/main" w="0">
+            <a:noFill/>
+            <a:prstDash val="solid"/>
+          </a:ln>
+        </p:spPr>
+        <p:txBody>
+          <a:bodyPr xmlns:a="http://schemas.openxmlformats.org/drawingml/2006/main"/>
+          <a:lstStyle xmlns:a="http://schemas.openxmlformats.org/drawingml/2006/main"/>
+          <a:p xmlns:a="http://schemas.openxmlformats.org/drawingml/2006/main">
+            <a:pPr algn="l">
+              <a:defRPr sz="1350" b="1">
+                <a:solidFill>
+                  <a:srgbClr val="2E74B5"/>
+                </a:solidFill>
+              </a:defRPr>
+            </a:pPr>
+            <a:r>
+              <a:rPr sz="1350" b="1">
+                <a:solidFill>
+                  <a:srgbClr val="2E74B5"/>
+                </a:solidFill>
+              </a:rPr>
+              <a:t>Days 61–90</a:t>
+            </a:r>
+          </a:p>
+        </p:txBody>
+      </p:sp>
+      <p:sp>
+        <p:nvSpPr>
+          <p:cNvPr id="13" name="">
+            <a:extLst xmlns:a="http://schemas.openxmlformats.org/drawingml/2006/main">
+              <a:ext uri="{FF2B5EF4-FFF2-40B4-BE49-F238E27FC236}">
+                <a16:creationId xmlns:a16="http://schemas.microsoft.com/office/drawing/2014/main" id="{F385729D-D6DF-43DA-A904-4CA614E20EAC}"/>
+              </a:ext>
+            </a:extLst>
+          </p:cNvPr>
+          <p:cNvSpPr>
+            <a:spLocks xmlns:a="http://schemas.openxmlformats.org/drawingml/2006/main" noGrp="1"/>
+          </p:cNvSpPr>
+          <p:nvPr/>
+        </p:nvSpPr>
+        <p:spPr>
+          <a:xfrm xmlns:a="http://schemas.openxmlformats.org/drawingml/2006/main">
+            <a:off x="7886700" y="2457450"/>
+            <a:ext cx="3143250" cy="57150"/>
+          </a:xfrm>
+          <a:prstGeom xmlns:a="http://schemas.openxmlformats.org/drawingml/2006/main" prst="rect">
+            <a:avLst/>
+          </a:prstGeom>
+          <a:solidFill xmlns:a="http://schemas.openxmlformats.org/drawingml/2006/main">
+            <a:srgbClr val="2E74B5"/>
+          </a:solidFill>
+          <a:ln xmlns:a="http://schemas.openxmlformats.org/drawingml/2006/main" w="0">
+            <a:solidFill>
+              <a:srgbClr val="2E74B5"/>
+            </a:solidFill>
+            <a:prstDash val="solid"/>
+          </a:ln>
+        </p:spPr>
+      </p:sp>
+      <p:sp>
+        <p:nvSpPr>
+          <p:cNvPr id="14" name="">
+            <a:extLst xmlns:a="http://schemas.openxmlformats.org/drawingml/2006/main">
+              <a:ext uri="{FF2B5EF4-FFF2-40B4-BE49-F238E27FC236}">
+                <a16:creationId xmlns:a16="http://schemas.microsoft.com/office/drawing/2014/main" id="{D9E4CEAC-66A1-4641-96E9-6BCE959B3515}"/>
+              </a:ext>
+            </a:extLst>
+          </p:cNvPr>
+          <p:cNvSpPr>
+            <a:spLocks xmlns:a="http://schemas.openxmlformats.org/drawingml/2006/main" noGrp="1"/>
+          </p:cNvSpPr>
+          <p:nvPr/>
+        </p:nvSpPr>
+        <p:spPr>
+          <a:xfrm xmlns:a="http://schemas.openxmlformats.org/drawingml/2006/main">
+            <a:off x="7886700" y="2781300"/>
+            <a:ext cx="3143250" cy="361950"/>
+          </a:xfrm>
+          <a:prstGeom xmlns:a="http://schemas.openxmlformats.org/drawingml/2006/main" prst="rect">
+            <a:avLst/>
+          </a:prstGeom>
+          <a:noFill xmlns:a="http://schemas.openxmlformats.org/drawingml/2006/main"/>
+          <a:ln xmlns:a="http://schemas.openxmlformats.org/drawingml/2006/main" w="0">
+            <a:noFill/>
+            <a:prstDash val="solid"/>
+          </a:ln>
+        </p:spPr>
+        <p:txBody>
+          <a:bodyPr xmlns:a="http://schemas.openxmlformats.org/drawingml/2006/main"/>
+          <a:lstStyle xmlns:a="http://schemas.openxmlformats.org/drawingml/2006/main"/>
+          <a:p xmlns:a="http://schemas.openxmlformats.org/drawingml/2006/main">
+            <a:pPr algn="l">
+              <a:defRPr sz="1875" b="1">
+                <a:solidFill>
+                  <a:srgbClr val="0B2545"/>
+                </a:solidFill>
+              </a:defRPr>
+            </a:pPr>
+            <a:r>
+              <a:rPr sz="1875" b="1">
+                <a:solidFill>
+                  <a:srgbClr val="0B2545"/>
+                </a:solidFill>
+              </a:rPr>
+              <a:t>Operational action</a:t>
+            </a:r>
+          </a:p>
+        </p:txBody>
+      </p:sp>
+      <p:sp>
+        <p:nvSpPr>
+          <p:cNvPr id="15" name="">
+            <a:extLst xmlns:a="http://schemas.openxmlformats.org/drawingml/2006/main">
+              <a:ext uri="{FF2B5EF4-FFF2-40B4-BE49-F238E27FC236}">
+                <a16:creationId xmlns:a16="http://schemas.microsoft.com/office/drawing/2014/main" id="{8A6EBE96-B426-41AF-B11E-A91AAF563EFA}"/>
+              </a:ext>
+            </a:extLst>
+          </p:cNvPr>
+          <p:cNvSpPr>
+            <a:spLocks xmlns:a="http://schemas.openxmlformats.org/drawingml/2006/main" noGrp="1"/>
+          </p:cNvSpPr>
+          <p:nvPr/>
+        </p:nvSpPr>
+        <p:spPr>
+          <a:xfrm xmlns:a="http://schemas.openxmlformats.org/drawingml/2006/main">
+            <a:off x="7886700" y="3352800"/>
+            <a:ext cx="3143250" cy="1047750"/>
+          </a:xfrm>
+          <a:prstGeom xmlns:a="http://schemas.openxmlformats.org/drawingml/2006/main" prst="rect">
+            <a:avLst/>
+          </a:prstGeom>
+          <a:noFill xmlns:a="http://schemas.openxmlformats.org/drawingml/2006/main"/>
+          <a:ln xmlns:a="http://schemas.openxmlformats.org/drawingml/2006/main" w="0">
+            <a:noFill/>
+            <a:prstDash val="solid"/>
+          </a:ln>
+        </p:spPr>
+        <p:txBody>
+          <a:bodyPr xmlns:a="http://schemas.openxmlformats.org/drawingml/2006/main"/>
+          <a:lstStyle xmlns:a="http://schemas.openxmlformats.org/drawingml/2006/main"/>
+          <a:p xmlns:a="http://schemas.openxmlformats.org/drawingml/2006/main">
+            <a:pPr algn="l">
+              <a:defRPr sz="1425" b="0">
+                <a:solidFill>
+                  <a:srgbClr val="667085"/>
+                </a:solidFill>
+              </a:defRPr>
+            </a:pPr>
+            <a:r>
+              <a:rPr sz="1425" b="0">
+                <a:solidFill>
+                  <a:srgbClr val="667085"/>
+                </a:solidFill>
+              </a:rPr>
+              <a:t>REACH PO/receipt history</a:t>
+            </a:r>
+          </a:p>
+          <a:p xmlns:a="http://schemas.openxmlformats.org/drawingml/2006/main">
+            <a:pPr algn="l">
+              <a:defRPr sz="1425" b="0">
+                <a:solidFill>
+                  <a:srgbClr val="667085"/>
+                </a:solidFill>
+              </a:defRPr>
+            </a:pPr>
+            <a:r>
+              <a:rPr sz="1425" b="0">
+                <a:solidFill>
+                  <a:srgbClr val="667085"/>
+                </a:solidFill>
+              </a:rPr>
+              <a:t>advertising attribution</a:t>
+            </a:r>
+          </a:p>
+          <a:p xmlns:a="http://schemas.openxmlformats.org/drawingml/2006/main">
+            <a:pPr algn="l">
+              <a:defRPr sz="1425" b="0">
+                <a:solidFill>
+                  <a:srgbClr val="667085"/>
+                </a:solidFill>
+              </a:defRPr>
+            </a:pPr>
+            <a:r>
+              <a:rPr sz="1425" b="0">
+                <a:solidFill>
+                  <a:srgbClr val="667085"/>
+                </a:solidFill>
+              </a:rPr>
+              <a:t>inventory + 13-week outlook</a:t>
+            </a:r>
+          </a:p>
+        </p:txBody>
+      </p:sp>
+      <p:sp>
+        <p:nvSpPr>
+          <p:cNvPr id="16" name="">
+            <a:extLst xmlns:a="http://schemas.openxmlformats.org/drawingml/2006/main">
+              <a:ext uri="{FF2B5EF4-FFF2-40B4-BE49-F238E27FC236}">
+                <a16:creationId xmlns:a16="http://schemas.microsoft.com/office/drawing/2014/main" id="{A7BA699F-BE38-44FE-9E08-B42C2E7A06F8}"/>
+              </a:ext>
+            </a:extLst>
+          </p:cNvPr>
+          <p:cNvSpPr>
+            <a:spLocks xmlns:a="http://schemas.openxmlformats.org/drawingml/2006/main" noGrp="1"/>
+          </p:cNvSpPr>
+          <p:nvPr/>
+        </p:nvSpPr>
+        <p:spPr>
+          <a:xfrm xmlns:a="http://schemas.openxmlformats.org/drawingml/2006/main">
+            <a:off x="685800" y="5143500"/>
+            <a:ext cx="10820400" cy="438150"/>
+          </a:xfrm>
+          <a:prstGeom xmlns:a="http://schemas.openxmlformats.org/drawingml/2006/main" prst="rect">
+            <a:avLst/>
+          </a:prstGeom>
+          <a:noFill xmlns:a="http://schemas.openxmlformats.org/drawingml/2006/main"/>
+          <a:ln xmlns:a="http://schemas.openxmlformats.org/drawingml/2006/main" w="0">
+            <a:noFill/>
+            <a:prstDash val="solid"/>
+          </a:ln>
+        </p:spPr>
+        <p:txBody>
+          <a:bodyPr xmlns:a="http://schemas.openxmlformats.org/drawingml/2006/main"/>
+          <a:lstStyle xmlns:a="http://schemas.openxmlformats.org/drawingml/2006/main"/>
+          <a:p xmlns:a="http://schemas.openxmlformats.org/drawingml/2006/main">
+            <a:pPr algn="ctr">
+              <a:defRPr sz="1575" b="1">
+                <a:solidFill>
+                  <a:srgbClr val="0B2545"/>
+                </a:solidFill>
+              </a:defRPr>
+            </a:pPr>
+            <a:r>
+              <a:rPr sz="1575" b="1">
+                <a:solidFill>
+                  <a:srgbClr val="0B2545"/>
+                </a:solidFill>
+              </a:rPr>
+              <a:t>Start cost-aware in GCP; buy managed connectors when reliability or implementation speed justifies the recurring cost.</a:t>
+            </a:r>
+          </a:p>
+        </p:txBody>
+      </p:sp>
+      <p:sp>
+        <p:nvSpPr>
+          <p:cNvPr id="17" name="">
+            <a:extLst xmlns:a="http://schemas.openxmlformats.org/drawingml/2006/main">
+              <a:ext uri="{FF2B5EF4-FFF2-40B4-BE49-F238E27FC236}">
+                <a16:creationId xmlns:a16="http://schemas.microsoft.com/office/drawing/2014/main" id="{6EA7D3D3-9988-45D5-94D5-DCDD7AEBBACE}"/>
+              </a:ext>
+            </a:extLst>
+          </p:cNvPr>
+          <p:cNvSpPr>
+            <a:spLocks xmlns:a="http://schemas.openxmlformats.org/drawingml/2006/main" noGrp="1"/>
+          </p:cNvSpPr>
+          <p:nvPr/>
+        </p:nvSpPr>
+        <p:spPr>
+          <a:xfrm xmlns:a="http://schemas.openxmlformats.org/drawingml/2006/main">
+            <a:off x="685800" y="6553200"/>
+            <a:ext cx="10287000" cy="171450"/>
+          </a:xfrm>
+          <a:prstGeom xmlns:a="http://schemas.openxmlformats.org/drawingml/2006/main" prst="rect">
+            <a:avLst/>
+          </a:prstGeom>
+          <a:noFill xmlns:a="http://schemas.openxmlformats.org/drawingml/2006/main"/>
+          <a:ln xmlns:a="http://schemas.openxmlformats.org/drawingml/2006/main" w="0">
+            <a:noFill/>
+            <a:prstDash val="solid"/>
+          </a:ln>
+        </p:spPr>
+        <p:txBody>
+          <a:bodyPr xmlns:a="http://schemas.openxmlformats.org/drawingml/2006/main"/>
+          <a:lstStyle xmlns:a="http://schemas.openxmlformats.org/drawingml/2006/main"/>
+          <a:p xmlns:a="http://schemas.openxmlformats.org/drawingml/2006/main">
+            <a:pPr algn="l">
+              <a:defRPr sz="825" b="0">
+                <a:solidFill>
+                  <a:srgbClr val="98A2B3"/>
+                </a:solidFill>
+              </a:defRPr>
+            </a:pPr>
+            <a:r>
+              <a:rPr sz="825" b="0">
+                <a:solidFill>
+                  <a:srgbClr val="98A2B3"/>
+                </a:solidFill>
+              </a:rPr>
+              <a:t>Q2 2026 Amazon profitability assessment</a:t>
+            </a:r>
+          </a:p>
+        </p:txBody>
+      </p:sp>
+      <p:sp>
+        <p:nvSpPr>
+          <p:cNvPr id="18" name="">
+            <a:extLst xmlns:a="http://schemas.openxmlformats.org/drawingml/2006/main">
+              <a:ext uri="{FF2B5EF4-FFF2-40B4-BE49-F238E27FC236}">
+                <a16:creationId xmlns:a16="http://schemas.microsoft.com/office/drawing/2014/main" id="{D81EDBDC-D221-4670-91EB-BADDB6A1801E}"/>
+              </a:ext>
+            </a:extLst>
+          </p:cNvPr>
+          <p:cNvSpPr>
+            <a:spLocks xmlns:a="http://schemas.openxmlformats.org/drawingml/2006/main" noGrp="1"/>
+          </p:cNvSpPr>
+          <p:nvPr/>
+        </p:nvSpPr>
+        <p:spPr>
+          <a:xfrm xmlns:a="http://schemas.openxmlformats.org/drawingml/2006/main">
+            <a:off x="11144250" y="6553200"/>
+            <a:ext cx="361950" cy="171450"/>
+          </a:xfrm>
+          <a:prstGeom xmlns:a="http://schemas.openxmlformats.org/drawingml/2006/main" prst="rect">
+            <a:avLst/>
+          </a:prstGeom>
+          <a:noFill xmlns:a="http://schemas.openxmlformats.org/drawingml/2006/main"/>
+          <a:ln xmlns:a="http://schemas.openxmlformats.org/drawingml/2006/main" w="0">
+            <a:noFill/>
+            <a:prstDash val="solid"/>
+          </a:ln>
+        </p:spPr>
+        <p:txBody>
+          <a:bodyPr xmlns:a="http://schemas.openxmlformats.org/drawingml/2006/main"/>
+          <a:lstStyle xmlns:a="http://schemas.openxmlformats.org/drawingml/2006/main"/>
+          <a:p xmlns:a="http://schemas.openxmlformats.org/drawingml/2006/main">
+            <a:pPr algn="r">
+              <a:defRPr sz="825" b="0">
+                <a:solidFill>
+                  <a:srgbClr val="98A2B3"/>
+                </a:solidFill>
+              </a:defRPr>
+            </a:pPr>
+            <a:r>
+              <a:rPr sz="825" b="0">
+                <a:solidFill>
+                  <a:srgbClr val="98A2B3"/>
+                </a:solidFill>
+              </a:rPr>
+              <a:t>10</a:t>
+            </a:r>
+          </a:p>
+        </p:txBody>
+      </p:sp>
+    </p:spTree>
+    <p:extLst>
+      <p:ext uri="{BB962C8B-B14F-4D97-AF65-F5344CB8AC3E}">
+        <p14:creationId xmlns:p14="http://schemas.microsoft.com/office/powerpoint/2010/main" val="639384877"/>
       </p:ext>
     </p:extLst>
   </p:cSld>
@@ -2476,7 +3523,7 @@
           <p:cNvPr id="17" name="">
             <a:extLst xmlns:a="http://schemas.openxmlformats.org/drawingml/2006/main">
               <a:ext uri="{FF2B5EF4-FFF2-40B4-BE49-F238E27FC236}">
-                <a16:creationId xmlns:a16="http://schemas.microsoft.com/office/drawing/2014/main" id="{3561813A-D438-45B6-B287-039C1A7B480A}"/>
+                <a16:creationId xmlns:a16="http://schemas.microsoft.com/office/drawing/2014/main" id="{0EA76627-C142-4956-BE28-DF8787DFFD2C}"/>
               </a:ext>
             </a:extLst>
           </p:cNvPr>
@@ -2526,7 +3573,7 @@
           <p:cNvPr id="2" name="">
             <a:extLst xmlns:a="http://schemas.openxmlformats.org/drawingml/2006/main">
               <a:ext uri="{FF2B5EF4-FFF2-40B4-BE49-F238E27FC236}">
-                <a16:creationId xmlns:a16="http://schemas.microsoft.com/office/drawing/2014/main" id="{94FDDEC3-FE41-4135-B6A7-38EB6597FBCB}"/>
+                <a16:creationId xmlns:a16="http://schemas.microsoft.com/office/drawing/2014/main" id="{2D32B75A-6C77-4F1B-941C-4FD006B721B6}"/>
               </a:ext>
             </a:extLst>
           </p:cNvPr>
@@ -2576,7 +3623,7 @@
           <p:cNvPr id="3" name="">
             <a:extLst xmlns:a="http://schemas.openxmlformats.org/drawingml/2006/main">
               <a:ext uri="{FF2B5EF4-FFF2-40B4-BE49-F238E27FC236}">
-                <a16:creationId xmlns:a16="http://schemas.microsoft.com/office/drawing/2014/main" id="{3AF824E7-2D9B-4F3A-A49F-16FFA2CDB343}"/>
+                <a16:creationId xmlns:a16="http://schemas.microsoft.com/office/drawing/2014/main" id="{13F72DA3-53DB-447C-A0FA-2FDD4B1D5A19}"/>
               </a:ext>
             </a:extLst>
           </p:cNvPr>
@@ -2626,7 +3673,7 @@
           <p:cNvPr id="4" name="">
             <a:extLst xmlns:a="http://schemas.openxmlformats.org/drawingml/2006/main">
               <a:ext uri="{FF2B5EF4-FFF2-40B4-BE49-F238E27FC236}">
-                <a16:creationId xmlns:a16="http://schemas.microsoft.com/office/drawing/2014/main" id="{9EC9A4CE-1B8D-4255-A70B-7DCBF61D3DDF}"/>
+                <a16:creationId xmlns:a16="http://schemas.microsoft.com/office/drawing/2014/main" id="{46AAB6BE-8E0E-41A5-92B1-832A22FB0B47}"/>
               </a:ext>
             </a:extLst>
           </p:cNvPr>
@@ -2676,7 +3723,7 @@
           <p:cNvPr id="5" name="">
             <a:extLst xmlns:a="http://schemas.openxmlformats.org/drawingml/2006/main">
               <a:ext uri="{FF2B5EF4-FFF2-40B4-BE49-F238E27FC236}">
-                <a16:creationId xmlns:a16="http://schemas.microsoft.com/office/drawing/2014/main" id="{E3D168F4-EC4C-4A8B-996D-1C55CE2F1384}"/>
+                <a16:creationId xmlns:a16="http://schemas.microsoft.com/office/drawing/2014/main" id="{403755B2-5572-4BCD-A3E0-60C06C5684E3}"/>
               </a:ext>
             </a:extLst>
           </p:cNvPr>
@@ -2726,7 +3773,7 @@
           <p:cNvPr id="6" name="">
             <a:extLst xmlns:a="http://schemas.openxmlformats.org/drawingml/2006/main">
               <a:ext uri="{FF2B5EF4-FFF2-40B4-BE49-F238E27FC236}">
-                <a16:creationId xmlns:a16="http://schemas.microsoft.com/office/drawing/2014/main" id="{5DFB0540-621B-4C3B-B5D1-ED95E169AD2C}"/>
+                <a16:creationId xmlns:a16="http://schemas.microsoft.com/office/drawing/2014/main" id="{5976F758-69C8-45DF-B84F-A2C368D2B849}"/>
               </a:ext>
             </a:extLst>
           </p:cNvPr>
@@ -2776,7 +3823,7 @@
           <p:cNvPr id="7" name="">
             <a:extLst xmlns:a="http://schemas.openxmlformats.org/drawingml/2006/main">
               <a:ext uri="{FF2B5EF4-FFF2-40B4-BE49-F238E27FC236}">
-                <a16:creationId xmlns:a16="http://schemas.microsoft.com/office/drawing/2014/main" id="{B20BCDD5-95B9-4EA9-BC59-809849D5A77B}"/>
+                <a16:creationId xmlns:a16="http://schemas.microsoft.com/office/drawing/2014/main" id="{DBAE5803-112C-461B-80F6-37763A35636C}"/>
               </a:ext>
             </a:extLst>
           </p:cNvPr>
@@ -2826,7 +3873,7 @@
           <p:cNvPr id="8" name="">
             <a:extLst xmlns:a="http://schemas.openxmlformats.org/drawingml/2006/main">
               <a:ext uri="{FF2B5EF4-FFF2-40B4-BE49-F238E27FC236}">
-                <a16:creationId xmlns:a16="http://schemas.microsoft.com/office/drawing/2014/main" id="{2B90C123-8E94-46DA-A8EA-A75CCD115502}"/>
+                <a16:creationId xmlns:a16="http://schemas.microsoft.com/office/drawing/2014/main" id="{5E2496E7-5086-4583-B6C6-3116EDD3636E}"/>
               </a:ext>
             </a:extLst>
           </p:cNvPr>
@@ -2876,7 +3923,7 @@
           <p:cNvPr id="9" name="">
             <a:extLst xmlns:a="http://schemas.openxmlformats.org/drawingml/2006/main">
               <a:ext uri="{FF2B5EF4-FFF2-40B4-BE49-F238E27FC236}">
-                <a16:creationId xmlns:a16="http://schemas.microsoft.com/office/drawing/2014/main" id="{E3EF4B3A-78F0-4FD7-BD42-AED8D47A8A4B}"/>
+                <a16:creationId xmlns:a16="http://schemas.microsoft.com/office/drawing/2014/main" id="{D40D653E-789D-4C54-B420-FF2EA02B4A21}"/>
               </a:ext>
             </a:extLst>
           </p:cNvPr>
@@ -2926,7 +3973,7 @@
           <p:cNvPr id="10" name="">
             <a:extLst xmlns:a="http://schemas.openxmlformats.org/drawingml/2006/main">
               <a:ext uri="{FF2B5EF4-FFF2-40B4-BE49-F238E27FC236}">
-                <a16:creationId xmlns:a16="http://schemas.microsoft.com/office/drawing/2014/main" id="{D06888D3-9EB7-4B9B-A75C-5EF6D9C73EF3}"/>
+                <a16:creationId xmlns:a16="http://schemas.microsoft.com/office/drawing/2014/main" id="{663D3385-D8F1-49A1-AAA3-F2E312323D8F}"/>
               </a:ext>
             </a:extLst>
           </p:cNvPr>
@@ -2976,7 +4023,7 @@
           <p:cNvPr id="11" name="">
             <a:extLst xmlns:a="http://schemas.openxmlformats.org/drawingml/2006/main">
               <a:ext uri="{FF2B5EF4-FFF2-40B4-BE49-F238E27FC236}">
-                <a16:creationId xmlns:a16="http://schemas.microsoft.com/office/drawing/2014/main" id="{7AE32CDF-4830-438C-BF17-50F164FAC626}"/>
+                <a16:creationId xmlns:a16="http://schemas.microsoft.com/office/drawing/2014/main" id="{96831794-E567-4FD0-B347-E1B7A5A5BE93}"/>
               </a:ext>
             </a:extLst>
           </p:cNvPr>
@@ -3026,7 +4073,7 @@
           <p:cNvPr id="12" name="">
             <a:extLst xmlns:a="http://schemas.openxmlformats.org/drawingml/2006/main">
               <a:ext uri="{FF2B5EF4-FFF2-40B4-BE49-F238E27FC236}">
-                <a16:creationId xmlns:a16="http://schemas.microsoft.com/office/drawing/2014/main" id="{B6AABA6B-5624-4B98-A172-A37BCF890553}"/>
+                <a16:creationId xmlns:a16="http://schemas.microsoft.com/office/drawing/2014/main" id="{87075BAF-660E-4FAF-BE78-E9575A52A184}"/>
               </a:ext>
             </a:extLst>
           </p:cNvPr>
@@ -3059,7 +4106,7 @@
           <p:cNvPr id="13" name="">
             <a:extLst xmlns:a="http://schemas.openxmlformats.org/drawingml/2006/main">
               <a:ext uri="{FF2B5EF4-FFF2-40B4-BE49-F238E27FC236}">
-                <a16:creationId xmlns:a16="http://schemas.microsoft.com/office/drawing/2014/main" id="{0C31EB65-8983-412E-A006-53BA7BE8E38B}"/>
+                <a16:creationId xmlns:a16="http://schemas.microsoft.com/office/drawing/2014/main" id="{7FD44C8A-273C-40D1-B934-3150806FD46D}"/>
               </a:ext>
             </a:extLst>
           </p:cNvPr>
@@ -3109,7 +4156,7 @@
           <p:cNvPr id="14" name="">
             <a:extLst xmlns:a="http://schemas.openxmlformats.org/drawingml/2006/main">
               <a:ext uri="{FF2B5EF4-FFF2-40B4-BE49-F238E27FC236}">
-                <a16:creationId xmlns:a16="http://schemas.microsoft.com/office/drawing/2014/main" id="{7CAAE5BC-8851-42E5-B5AC-888C7941B32F}"/>
+                <a16:creationId xmlns:a16="http://schemas.microsoft.com/office/drawing/2014/main" id="{D125DB65-5A94-4C82-A129-FC0F9773FA8D}"/>
               </a:ext>
             </a:extLst>
           </p:cNvPr>
@@ -3193,7 +4240,7 @@
           <p:cNvPr id="15" name="">
             <a:extLst xmlns:a="http://schemas.openxmlformats.org/drawingml/2006/main">
               <a:ext uri="{FF2B5EF4-FFF2-40B4-BE49-F238E27FC236}">
-                <a16:creationId xmlns:a16="http://schemas.microsoft.com/office/drawing/2014/main" id="{38F10759-A653-4058-92A7-A54301FD2826}"/>
+                <a16:creationId xmlns:a16="http://schemas.microsoft.com/office/drawing/2014/main" id="{D01842F8-1251-4D6E-9246-73A39A66AD52}"/>
               </a:ext>
             </a:extLst>
           </p:cNvPr>
@@ -3243,7 +4290,7 @@
           <p:cNvPr id="16" name="">
             <a:extLst xmlns:a="http://schemas.openxmlformats.org/drawingml/2006/main">
               <a:ext uri="{FF2B5EF4-FFF2-40B4-BE49-F238E27FC236}">
-                <a16:creationId xmlns:a16="http://schemas.microsoft.com/office/drawing/2014/main" id="{9A67BA15-29B7-44A6-A94E-A57525104616}"/>
+                <a16:creationId xmlns:a16="http://schemas.microsoft.com/office/drawing/2014/main" id="{2DAC7029-A977-4897-8CE9-5104A552DC39}"/>
               </a:ext>
             </a:extLst>
           </p:cNvPr>
@@ -3291,7 +4338,7 @@
     </p:spTree>
     <p:extLst>
       <p:ext uri="{BB962C8B-B14F-4D97-AF65-F5344CB8AC3E}">
-        <p14:creationId xmlns:p14="http://schemas.microsoft.com/office/powerpoint/2010/main" val="21053111"/>
+        <p14:creationId xmlns:p14="http://schemas.microsoft.com/office/powerpoint/2010/main" val="155100581"/>
       </p:ext>
     </p:extLst>
   </p:cSld>
@@ -3322,7 +4369,7 @@
           <p:cNvPr id="27" name="">
             <a:extLst xmlns:a="http://schemas.openxmlformats.org/drawingml/2006/main">
               <a:ext uri="{FF2B5EF4-FFF2-40B4-BE49-F238E27FC236}">
-                <a16:creationId xmlns:a16="http://schemas.microsoft.com/office/drawing/2014/main" id="{730202F6-C784-4654-9EF6-6F14B2C391E8}"/>
+                <a16:creationId xmlns:a16="http://schemas.microsoft.com/office/drawing/2014/main" id="{16E46B10-D33F-43D1-BD57-C2DAE490E848}"/>
               </a:ext>
             </a:extLst>
           </p:cNvPr>
@@ -3372,7 +4419,7 @@
           <p:cNvPr id="2" name="">
             <a:extLst xmlns:a="http://schemas.openxmlformats.org/drawingml/2006/main">
               <a:ext uri="{FF2B5EF4-FFF2-40B4-BE49-F238E27FC236}">
-                <a16:creationId xmlns:a16="http://schemas.microsoft.com/office/drawing/2014/main" id="{27E2A1F5-6BF2-4495-A382-851D4BC5B754}"/>
+                <a16:creationId xmlns:a16="http://schemas.microsoft.com/office/drawing/2014/main" id="{6DB04D3A-E04E-4A76-9F41-17BA89B204BD}"/>
               </a:ext>
             </a:extLst>
           </p:cNvPr>
@@ -3422,7 +4469,7 @@
           <p:cNvPr id="3" name="">
             <a:extLst xmlns:a="http://schemas.openxmlformats.org/drawingml/2006/main">
               <a:ext uri="{FF2B5EF4-FFF2-40B4-BE49-F238E27FC236}">
-                <a16:creationId xmlns:a16="http://schemas.microsoft.com/office/drawing/2014/main" id="{C6CF593C-7BDD-44F8-9232-975E3430F31F}"/>
+                <a16:creationId xmlns:a16="http://schemas.microsoft.com/office/drawing/2014/main" id="{28294042-1B88-42E7-AFBE-D4EB8F177222}"/>
               </a:ext>
             </a:extLst>
           </p:cNvPr>
@@ -3472,7 +4519,7 @@
           <p:cNvPr id="4" name="">
             <a:extLst xmlns:a="http://schemas.openxmlformats.org/drawingml/2006/main">
               <a:ext uri="{FF2B5EF4-FFF2-40B4-BE49-F238E27FC236}">
-                <a16:creationId xmlns:a16="http://schemas.microsoft.com/office/drawing/2014/main" id="{EF6BD1B1-8A52-48ED-A047-DB4A915564C8}"/>
+                <a16:creationId xmlns:a16="http://schemas.microsoft.com/office/drawing/2014/main" id="{A46C48B3-3494-4034-A2E9-61DD9812E2B2}"/>
               </a:ext>
             </a:extLst>
           </p:cNvPr>
@@ -3507,7 +4554,7 @@
           <p:cNvPr id="5" name="">
             <a:extLst xmlns:a="http://schemas.openxmlformats.org/drawingml/2006/main">
               <a:ext uri="{FF2B5EF4-FFF2-40B4-BE49-F238E27FC236}">
-                <a16:creationId xmlns:a16="http://schemas.microsoft.com/office/drawing/2014/main" id="{F9F6D08C-2172-49F5-B302-B287BFD07FC2}"/>
+                <a16:creationId xmlns:a16="http://schemas.microsoft.com/office/drawing/2014/main" id="{6E7A51FA-AC16-4A4C-B9F8-5182B9B6A9C1}"/>
               </a:ext>
             </a:extLst>
           </p:cNvPr>
@@ -3557,7 +4604,7 @@
           <p:cNvPr id="6" name="">
             <a:extLst xmlns:a="http://schemas.openxmlformats.org/drawingml/2006/main">
               <a:ext uri="{FF2B5EF4-FFF2-40B4-BE49-F238E27FC236}">
-                <a16:creationId xmlns:a16="http://schemas.microsoft.com/office/drawing/2014/main" id="{15A373EE-5859-4382-9D3C-40CD460B7AD4}"/>
+                <a16:creationId xmlns:a16="http://schemas.microsoft.com/office/drawing/2014/main" id="{9859ADC0-F2BE-47BF-B69D-E65D969F9471}"/>
               </a:ext>
             </a:extLst>
           </p:cNvPr>
@@ -3658,7 +4705,7 @@
           <p:cNvPr id="7" name="">
             <a:extLst xmlns:a="http://schemas.openxmlformats.org/drawingml/2006/main">
               <a:ext uri="{FF2B5EF4-FFF2-40B4-BE49-F238E27FC236}">
-                <a16:creationId xmlns:a16="http://schemas.microsoft.com/office/drawing/2014/main" id="{F5CD2EAB-5009-4790-B369-39C918A6AA45}"/>
+                <a16:creationId xmlns:a16="http://schemas.microsoft.com/office/drawing/2014/main" id="{3648C9E3-AD0F-475D-A686-63D53353E2B6}"/>
               </a:ext>
             </a:extLst>
           </p:cNvPr>
@@ -3691,7 +4738,7 @@
           <p:cNvPr id="8" name="">
             <a:extLst xmlns:a="http://schemas.openxmlformats.org/drawingml/2006/main">
               <a:ext uri="{FF2B5EF4-FFF2-40B4-BE49-F238E27FC236}">
-                <a16:creationId xmlns:a16="http://schemas.microsoft.com/office/drawing/2014/main" id="{A0FFF98E-752C-4D28-99C7-C6E3AC6FF774}"/>
+                <a16:creationId xmlns:a16="http://schemas.microsoft.com/office/drawing/2014/main" id="{CB939085-2959-4203-8930-3F25FE46CCCF}"/>
               </a:ext>
             </a:extLst>
           </p:cNvPr>
@@ -3726,7 +4773,7 @@
           <p:cNvPr id="9" name="">
             <a:extLst xmlns:a="http://schemas.openxmlformats.org/drawingml/2006/main">
               <a:ext uri="{FF2B5EF4-FFF2-40B4-BE49-F238E27FC236}">
-                <a16:creationId xmlns:a16="http://schemas.microsoft.com/office/drawing/2014/main" id="{6200B421-1337-4221-8809-9FF82DD5896F}"/>
+                <a16:creationId xmlns:a16="http://schemas.microsoft.com/office/drawing/2014/main" id="{CB4A6BF8-C26F-4FDD-B3E0-7105CD9A5FB3}"/>
               </a:ext>
             </a:extLst>
           </p:cNvPr>
@@ -3776,7 +4823,7 @@
           <p:cNvPr id="10" name="">
             <a:extLst xmlns:a="http://schemas.openxmlformats.org/drawingml/2006/main">
               <a:ext uri="{FF2B5EF4-FFF2-40B4-BE49-F238E27FC236}">
-                <a16:creationId xmlns:a16="http://schemas.microsoft.com/office/drawing/2014/main" id="{2D7D4164-6C78-449F-9029-44414506EA06}"/>
+                <a16:creationId xmlns:a16="http://schemas.microsoft.com/office/drawing/2014/main" id="{DF41E286-D7C2-4542-913D-B5511F768323}"/>
               </a:ext>
             </a:extLst>
           </p:cNvPr>
@@ -3843,7 +4890,7 @@
           <p:cNvPr id="11" name="">
             <a:extLst xmlns:a="http://schemas.openxmlformats.org/drawingml/2006/main">
               <a:ext uri="{FF2B5EF4-FFF2-40B4-BE49-F238E27FC236}">
-                <a16:creationId xmlns:a16="http://schemas.microsoft.com/office/drawing/2014/main" id="{EDCC609C-C63B-492D-9444-587ECB4CF415}"/>
+                <a16:creationId xmlns:a16="http://schemas.microsoft.com/office/drawing/2014/main" id="{E0E513CC-AE0F-4168-883D-51F05BC7E3EE}"/>
               </a:ext>
             </a:extLst>
           </p:cNvPr>
@@ -3876,7 +4923,7 @@
           <p:cNvPr id="12" name="">
             <a:extLst xmlns:a="http://schemas.openxmlformats.org/drawingml/2006/main">
               <a:ext uri="{FF2B5EF4-FFF2-40B4-BE49-F238E27FC236}">
-                <a16:creationId xmlns:a16="http://schemas.microsoft.com/office/drawing/2014/main" id="{DC21BEA1-4B8F-4F75-A3F4-B1FF550B5E83}"/>
+                <a16:creationId xmlns:a16="http://schemas.microsoft.com/office/drawing/2014/main" id="{9D84F337-BBA9-440F-8B6D-B3414293C337}"/>
               </a:ext>
             </a:extLst>
           </p:cNvPr>
@@ -3911,7 +4958,7 @@
           <p:cNvPr id="13" name="">
             <a:extLst xmlns:a="http://schemas.openxmlformats.org/drawingml/2006/main">
               <a:ext uri="{FF2B5EF4-FFF2-40B4-BE49-F238E27FC236}">
-                <a16:creationId xmlns:a16="http://schemas.microsoft.com/office/drawing/2014/main" id="{09363AC0-F887-441D-876A-0B828DEF3AC5}"/>
+                <a16:creationId xmlns:a16="http://schemas.microsoft.com/office/drawing/2014/main" id="{6BBBA504-E4C9-45A6-8DBE-03ADD2D90FB1}"/>
               </a:ext>
             </a:extLst>
           </p:cNvPr>
@@ -3961,7 +5008,7 @@
           <p:cNvPr id="14" name="">
             <a:extLst xmlns:a="http://schemas.openxmlformats.org/drawingml/2006/main">
               <a:ext uri="{FF2B5EF4-FFF2-40B4-BE49-F238E27FC236}">
-                <a16:creationId xmlns:a16="http://schemas.microsoft.com/office/drawing/2014/main" id="{E843BA0B-E5D8-42EF-9853-1CEDA17D19CF}"/>
+                <a16:creationId xmlns:a16="http://schemas.microsoft.com/office/drawing/2014/main" id="{B1223937-323D-4A21-9AB1-C82EE38C12D7}"/>
               </a:ext>
             </a:extLst>
           </p:cNvPr>
@@ -4028,7 +5075,7 @@
           <p:cNvPr id="15" name="">
             <a:extLst xmlns:a="http://schemas.openxmlformats.org/drawingml/2006/main">
               <a:ext uri="{FF2B5EF4-FFF2-40B4-BE49-F238E27FC236}">
-                <a16:creationId xmlns:a16="http://schemas.microsoft.com/office/drawing/2014/main" id="{4418D574-E6BF-40EA-9354-17C14FEBBB35}"/>
+                <a16:creationId xmlns:a16="http://schemas.microsoft.com/office/drawing/2014/main" id="{3B430F9C-4800-4812-ACAF-8B7E3F7C26FE}"/>
               </a:ext>
             </a:extLst>
           </p:cNvPr>
@@ -4061,7 +5108,7 @@
           <p:cNvPr id="16" name="">
             <a:extLst xmlns:a="http://schemas.openxmlformats.org/drawingml/2006/main">
               <a:ext uri="{FF2B5EF4-FFF2-40B4-BE49-F238E27FC236}">
-                <a16:creationId xmlns:a16="http://schemas.microsoft.com/office/drawing/2014/main" id="{9D594159-1B0A-4B2C-92EF-E16478D06C22}"/>
+                <a16:creationId xmlns:a16="http://schemas.microsoft.com/office/drawing/2014/main" id="{9C653EF5-1B94-4BC4-9C2F-D6D160655D02}"/>
               </a:ext>
             </a:extLst>
           </p:cNvPr>
@@ -4096,7 +5143,7 @@
           <p:cNvPr id="17" name="">
             <a:extLst xmlns:a="http://schemas.openxmlformats.org/drawingml/2006/main">
               <a:ext uri="{FF2B5EF4-FFF2-40B4-BE49-F238E27FC236}">
-                <a16:creationId xmlns:a16="http://schemas.microsoft.com/office/drawing/2014/main" id="{32418750-0534-4818-A397-E28A43D52B82}"/>
+                <a16:creationId xmlns:a16="http://schemas.microsoft.com/office/drawing/2014/main" id="{D2F27A72-7BDF-4B94-A3D0-FC868F3E637A}"/>
               </a:ext>
             </a:extLst>
           </p:cNvPr>
@@ -4146,7 +5193,7 @@
           <p:cNvPr id="18" name="">
             <a:extLst xmlns:a="http://schemas.openxmlformats.org/drawingml/2006/main">
               <a:ext uri="{FF2B5EF4-FFF2-40B4-BE49-F238E27FC236}">
-                <a16:creationId xmlns:a16="http://schemas.microsoft.com/office/drawing/2014/main" id="{D90E7E50-0C5F-4502-942E-E2A2D9620B11}"/>
+                <a16:creationId xmlns:a16="http://schemas.microsoft.com/office/drawing/2014/main" id="{3476EE8E-0D2C-48C1-AB26-2D768D1A89EC}"/>
               </a:ext>
             </a:extLst>
           </p:cNvPr>
@@ -4213,7 +5260,7 @@
           <p:cNvPr id="19" name="">
             <a:extLst xmlns:a="http://schemas.openxmlformats.org/drawingml/2006/main">
               <a:ext uri="{FF2B5EF4-FFF2-40B4-BE49-F238E27FC236}">
-                <a16:creationId xmlns:a16="http://schemas.microsoft.com/office/drawing/2014/main" id="{A8EB7E53-E4D5-4EAF-BF8A-DA0735D59B91}"/>
+                <a16:creationId xmlns:a16="http://schemas.microsoft.com/office/drawing/2014/main" id="{0972FDB9-8D4E-4448-8CBA-C0A8ACB23F8D}"/>
               </a:ext>
             </a:extLst>
           </p:cNvPr>
@@ -4246,7 +5293,7 @@
           <p:cNvPr id="20" name="">
             <a:extLst xmlns:a="http://schemas.openxmlformats.org/drawingml/2006/main">
               <a:ext uri="{FF2B5EF4-FFF2-40B4-BE49-F238E27FC236}">
-                <a16:creationId xmlns:a16="http://schemas.microsoft.com/office/drawing/2014/main" id="{67558620-1457-404B-8508-4EC5495CBDC3}"/>
+                <a16:creationId xmlns:a16="http://schemas.microsoft.com/office/drawing/2014/main" id="{B6E8C0EB-FFCC-466D-8602-54062BCF9327}"/>
               </a:ext>
             </a:extLst>
           </p:cNvPr>
@@ -4281,7 +5328,7 @@
           <p:cNvPr id="21" name="">
             <a:extLst xmlns:a="http://schemas.openxmlformats.org/drawingml/2006/main">
               <a:ext uri="{FF2B5EF4-FFF2-40B4-BE49-F238E27FC236}">
-                <a16:creationId xmlns:a16="http://schemas.microsoft.com/office/drawing/2014/main" id="{B8751973-FA19-433C-863C-0390F9DDEBC6}"/>
+                <a16:creationId xmlns:a16="http://schemas.microsoft.com/office/drawing/2014/main" id="{43631E4C-1C34-433B-BD18-A0FA5BCD6754}"/>
               </a:ext>
             </a:extLst>
           </p:cNvPr>
@@ -4331,7 +5378,7 @@
           <p:cNvPr id="22" name="">
             <a:extLst xmlns:a="http://schemas.openxmlformats.org/drawingml/2006/main">
               <a:ext uri="{FF2B5EF4-FFF2-40B4-BE49-F238E27FC236}">
-                <a16:creationId xmlns:a16="http://schemas.microsoft.com/office/drawing/2014/main" id="{FE527246-70F6-493D-9BA8-544922BC00E4}"/>
+                <a16:creationId xmlns:a16="http://schemas.microsoft.com/office/drawing/2014/main" id="{40C1DFBD-C12D-49B6-9B7F-755BF29F26AC}"/>
               </a:ext>
             </a:extLst>
           </p:cNvPr>
@@ -4398,7 +5445,7 @@
           <p:cNvPr id="23" name="">
             <a:extLst xmlns:a="http://schemas.openxmlformats.org/drawingml/2006/main">
               <a:ext uri="{FF2B5EF4-FFF2-40B4-BE49-F238E27FC236}">
-                <a16:creationId xmlns:a16="http://schemas.microsoft.com/office/drawing/2014/main" id="{4DD5908B-67A3-4C4F-AE6B-6C39D85A347A}"/>
+                <a16:creationId xmlns:a16="http://schemas.microsoft.com/office/drawing/2014/main" id="{0407FA01-DFF7-449F-ADA4-2FFA0006A3A6}"/>
               </a:ext>
             </a:extLst>
           </p:cNvPr>
@@ -4448,7 +5495,7 @@
           <p:cNvPr id="24" name="">
             <a:extLst xmlns:a="http://schemas.openxmlformats.org/drawingml/2006/main">
               <a:ext uri="{FF2B5EF4-FFF2-40B4-BE49-F238E27FC236}">
-                <a16:creationId xmlns:a16="http://schemas.microsoft.com/office/drawing/2014/main" id="{A81BB86A-A2B4-4445-A529-D0C0E4B89E80}"/>
+                <a16:creationId xmlns:a16="http://schemas.microsoft.com/office/drawing/2014/main" id="{8A06D3C4-5B7D-40E7-B14E-4031E42C536B}"/>
               </a:ext>
             </a:extLst>
           </p:cNvPr>
@@ -4498,7 +5545,7 @@
           <p:cNvPr id="25" name="">
             <a:extLst xmlns:a="http://schemas.openxmlformats.org/drawingml/2006/main">
               <a:ext uri="{FF2B5EF4-FFF2-40B4-BE49-F238E27FC236}">
-                <a16:creationId xmlns:a16="http://schemas.microsoft.com/office/drawing/2014/main" id="{39520C36-79E5-4249-83CB-73E61CE77164}"/>
+                <a16:creationId xmlns:a16="http://schemas.microsoft.com/office/drawing/2014/main" id="{11EED6E0-8A7B-4F6F-B235-1CD3FCFD6E32}"/>
               </a:ext>
             </a:extLst>
           </p:cNvPr>
@@ -4548,7 +5595,7 @@
           <p:cNvPr id="26" name="">
             <a:extLst xmlns:a="http://schemas.openxmlformats.org/drawingml/2006/main">
               <a:ext uri="{FF2B5EF4-FFF2-40B4-BE49-F238E27FC236}">
-                <a16:creationId xmlns:a16="http://schemas.microsoft.com/office/drawing/2014/main" id="{7F88596C-83B7-46AB-8D4C-9EEDD806010B}"/>
+                <a16:creationId xmlns:a16="http://schemas.microsoft.com/office/drawing/2014/main" id="{B74C2890-930C-41B6-A97D-A54EB021CA58}"/>
               </a:ext>
             </a:extLst>
           </p:cNvPr>
@@ -4596,7 +5643,7 @@
     </p:spTree>
     <p:extLst>
       <p:ext uri="{BB962C8B-B14F-4D97-AF65-F5344CB8AC3E}">
-        <p14:creationId xmlns:p14="http://schemas.microsoft.com/office/powerpoint/2010/main" val="991381496"/>
+        <p14:creationId xmlns:p14="http://schemas.microsoft.com/office/powerpoint/2010/main" val="1268650185"/>
       </p:ext>
     </p:extLst>
   </p:cSld>
@@ -4627,7 +5674,7 @@
           <p:cNvPr id="27" name="">
             <a:extLst xmlns:a="http://schemas.openxmlformats.org/drawingml/2006/main">
               <a:ext uri="{FF2B5EF4-FFF2-40B4-BE49-F238E27FC236}">
-                <a16:creationId xmlns:a16="http://schemas.microsoft.com/office/drawing/2014/main" id="{1B282F03-AC43-4521-8783-0CA69F9A944D}"/>
+                <a16:creationId xmlns:a16="http://schemas.microsoft.com/office/drawing/2014/main" id="{EEB7D650-0221-4CA1-8E68-B2EB816EEF9C}"/>
               </a:ext>
             </a:extLst>
           </p:cNvPr>
@@ -4677,7 +5724,7 @@
           <p:cNvPr id="2" name="">
             <a:extLst xmlns:a="http://schemas.openxmlformats.org/drawingml/2006/main">
               <a:ext uri="{FF2B5EF4-FFF2-40B4-BE49-F238E27FC236}">
-                <a16:creationId xmlns:a16="http://schemas.microsoft.com/office/drawing/2014/main" id="{585FA7E0-50F7-4F25-B29D-DF84A9B4C8B2}"/>
+                <a16:creationId xmlns:a16="http://schemas.microsoft.com/office/drawing/2014/main" id="{38A79E40-1715-4C4A-AA46-0728D8DAEC64}"/>
               </a:ext>
             </a:extLst>
           </p:cNvPr>
@@ -4727,7 +5774,7 @@
           <p:cNvPr id="3" name="">
             <a:extLst xmlns:a="http://schemas.openxmlformats.org/drawingml/2006/main">
               <a:ext uri="{FF2B5EF4-FFF2-40B4-BE49-F238E27FC236}">
-                <a16:creationId xmlns:a16="http://schemas.microsoft.com/office/drawing/2014/main" id="{674FD731-8D59-4884-B1D1-A69546F0B566}"/>
+                <a16:creationId xmlns:a16="http://schemas.microsoft.com/office/drawing/2014/main" id="{17C7C61A-D770-4CF0-84A0-EBF0D3E10E7E}"/>
               </a:ext>
             </a:extLst>
           </p:cNvPr>
@@ -4777,7 +5824,7 @@
           <p:cNvPr id="4" name="">
             <a:extLst xmlns:a="http://schemas.openxmlformats.org/drawingml/2006/main">
               <a:ext uri="{FF2B5EF4-FFF2-40B4-BE49-F238E27FC236}">
-                <a16:creationId xmlns:a16="http://schemas.microsoft.com/office/drawing/2014/main" id="{6A1F4322-6F97-4A20-9E7F-40D6BF8C3286}"/>
+                <a16:creationId xmlns:a16="http://schemas.microsoft.com/office/drawing/2014/main" id="{C4D63740-15C0-457B-9B61-886952E55479}"/>
               </a:ext>
             </a:extLst>
           </p:cNvPr>
@@ -4827,7 +5874,7 @@
           <p:cNvPr id="5" name="">
             <a:extLst xmlns:a="http://schemas.openxmlformats.org/drawingml/2006/main">
               <a:ext uri="{FF2B5EF4-FFF2-40B4-BE49-F238E27FC236}">
-                <a16:creationId xmlns:a16="http://schemas.microsoft.com/office/drawing/2014/main" id="{2950E603-A767-48A2-A116-19706F36B3E9}"/>
+                <a16:creationId xmlns:a16="http://schemas.microsoft.com/office/drawing/2014/main" id="{E4830841-943F-4FAF-9240-42D30A93359F}"/>
               </a:ext>
             </a:extLst>
           </p:cNvPr>
@@ -4860,7 +5907,7 @@
           <p:cNvPr id="6" name="">
             <a:extLst xmlns:a="http://schemas.openxmlformats.org/drawingml/2006/main">
               <a:ext uri="{FF2B5EF4-FFF2-40B4-BE49-F238E27FC236}">
-                <a16:creationId xmlns:a16="http://schemas.microsoft.com/office/drawing/2014/main" id="{6BF082DD-6FA0-4496-A0DA-8C765669008F}"/>
+                <a16:creationId xmlns:a16="http://schemas.microsoft.com/office/drawing/2014/main" id="{CB29ACF0-614C-41E2-8EA4-BB8A29CEE3E5}"/>
               </a:ext>
             </a:extLst>
           </p:cNvPr>
@@ -4910,7 +5957,7 @@
           <p:cNvPr id="7" name="">
             <a:extLst xmlns:a="http://schemas.openxmlformats.org/drawingml/2006/main">
               <a:ext uri="{FF2B5EF4-FFF2-40B4-BE49-F238E27FC236}">
-                <a16:creationId xmlns:a16="http://schemas.microsoft.com/office/drawing/2014/main" id="{AFA79FCE-0D70-4020-B8FB-380E0EE1AC47}"/>
+                <a16:creationId xmlns:a16="http://schemas.microsoft.com/office/drawing/2014/main" id="{E6931461-633B-4916-BA9B-D7BCABFEB631}"/>
               </a:ext>
             </a:extLst>
           </p:cNvPr>
@@ -4960,7 +6007,7 @@
           <p:cNvPr id="8" name="">
             <a:extLst xmlns:a="http://schemas.openxmlformats.org/drawingml/2006/main">
               <a:ext uri="{FF2B5EF4-FFF2-40B4-BE49-F238E27FC236}">
-                <a16:creationId xmlns:a16="http://schemas.microsoft.com/office/drawing/2014/main" id="{874A56A5-99F5-434F-B976-413FA8A6AE30}"/>
+                <a16:creationId xmlns:a16="http://schemas.microsoft.com/office/drawing/2014/main" id="{C7E114E3-01E0-4A9C-A36E-D148DBE25989}"/>
               </a:ext>
             </a:extLst>
           </p:cNvPr>
@@ -5010,7 +6057,7 @@
           <p:cNvPr id="9" name="">
             <a:extLst xmlns:a="http://schemas.openxmlformats.org/drawingml/2006/main">
               <a:ext uri="{FF2B5EF4-FFF2-40B4-BE49-F238E27FC236}">
-                <a16:creationId xmlns:a16="http://schemas.microsoft.com/office/drawing/2014/main" id="{8999B51D-FBA1-4CB6-984D-781574E2BB2C}"/>
+                <a16:creationId xmlns:a16="http://schemas.microsoft.com/office/drawing/2014/main" id="{79288303-4EC0-4EB3-BDF3-41A5A4E552E6}"/>
               </a:ext>
             </a:extLst>
           </p:cNvPr>
@@ -5043,7 +6090,7 @@
           <p:cNvPr id="10" name="">
             <a:extLst xmlns:a="http://schemas.openxmlformats.org/drawingml/2006/main">
               <a:ext uri="{FF2B5EF4-FFF2-40B4-BE49-F238E27FC236}">
-                <a16:creationId xmlns:a16="http://schemas.microsoft.com/office/drawing/2014/main" id="{8BA833D9-DB1B-4921-87ED-C72AB6FFD895}"/>
+                <a16:creationId xmlns:a16="http://schemas.microsoft.com/office/drawing/2014/main" id="{4F436307-A8CB-4004-A853-6366D0E166A6}"/>
               </a:ext>
             </a:extLst>
           </p:cNvPr>
@@ -5093,7 +6140,7 @@
           <p:cNvPr id="11" name="">
             <a:extLst xmlns:a="http://schemas.openxmlformats.org/drawingml/2006/main">
               <a:ext uri="{FF2B5EF4-FFF2-40B4-BE49-F238E27FC236}">
-                <a16:creationId xmlns:a16="http://schemas.microsoft.com/office/drawing/2014/main" id="{FE4297C9-EA29-49B6-9158-E737B371239E}"/>
+                <a16:creationId xmlns:a16="http://schemas.microsoft.com/office/drawing/2014/main" id="{AB392471-2A0A-46EC-B3A8-2DC8737F3737}"/>
               </a:ext>
             </a:extLst>
           </p:cNvPr>
@@ -5143,7 +6190,7 @@
           <p:cNvPr id="12" name="">
             <a:extLst xmlns:a="http://schemas.openxmlformats.org/drawingml/2006/main">
               <a:ext uri="{FF2B5EF4-FFF2-40B4-BE49-F238E27FC236}">
-                <a16:creationId xmlns:a16="http://schemas.microsoft.com/office/drawing/2014/main" id="{BBCBE1FC-4D8D-4394-9681-C600486D642A}"/>
+                <a16:creationId xmlns:a16="http://schemas.microsoft.com/office/drawing/2014/main" id="{1411FDF2-0445-4ECB-9A28-DE2369962C19}"/>
               </a:ext>
             </a:extLst>
           </p:cNvPr>
@@ -5193,7 +6240,7 @@
           <p:cNvPr id="13" name="">
             <a:extLst xmlns:a="http://schemas.openxmlformats.org/drawingml/2006/main">
               <a:ext uri="{FF2B5EF4-FFF2-40B4-BE49-F238E27FC236}">
-                <a16:creationId xmlns:a16="http://schemas.microsoft.com/office/drawing/2014/main" id="{D9496F3E-14C7-488B-97F7-8A6BCD304BDB}"/>
+                <a16:creationId xmlns:a16="http://schemas.microsoft.com/office/drawing/2014/main" id="{0684B5A7-A5DF-4D22-A341-D7BAEF2DD4E1}"/>
               </a:ext>
             </a:extLst>
           </p:cNvPr>
@@ -5226,7 +6273,7 @@
           <p:cNvPr id="14" name="">
             <a:extLst xmlns:a="http://schemas.openxmlformats.org/drawingml/2006/main">
               <a:ext uri="{FF2B5EF4-FFF2-40B4-BE49-F238E27FC236}">
-                <a16:creationId xmlns:a16="http://schemas.microsoft.com/office/drawing/2014/main" id="{42EDE369-9088-4D0E-84EF-A33E230552F3}"/>
+                <a16:creationId xmlns:a16="http://schemas.microsoft.com/office/drawing/2014/main" id="{32479696-9AFB-4EF4-913B-DF3B39E6AA64}"/>
               </a:ext>
             </a:extLst>
           </p:cNvPr>
@@ -5276,7 +6323,7 @@
           <p:cNvPr id="15" name="">
             <a:extLst xmlns:a="http://schemas.openxmlformats.org/drawingml/2006/main">
               <a:ext uri="{FF2B5EF4-FFF2-40B4-BE49-F238E27FC236}">
-                <a16:creationId xmlns:a16="http://schemas.microsoft.com/office/drawing/2014/main" id="{B72C3A13-5943-442A-9F79-083B631692F0}"/>
+                <a16:creationId xmlns:a16="http://schemas.microsoft.com/office/drawing/2014/main" id="{8368904D-E846-4870-A82A-E2193DE6EB2A}"/>
               </a:ext>
             </a:extLst>
           </p:cNvPr>
@@ -5326,7 +6373,7 @@
           <p:cNvPr id="16" name="">
             <a:extLst xmlns:a="http://schemas.openxmlformats.org/drawingml/2006/main">
               <a:ext uri="{FF2B5EF4-FFF2-40B4-BE49-F238E27FC236}">
-                <a16:creationId xmlns:a16="http://schemas.microsoft.com/office/drawing/2014/main" id="{8F807759-B2E1-438C-B0F1-C42B33B23B92}"/>
+                <a16:creationId xmlns:a16="http://schemas.microsoft.com/office/drawing/2014/main" id="{728FE9DD-2BE1-493A-A279-36AA76E262E4}"/>
               </a:ext>
             </a:extLst>
           </p:cNvPr>
@@ -5376,7 +6423,7 @@
           <p:cNvPr id="17" name="">
             <a:extLst xmlns:a="http://schemas.openxmlformats.org/drawingml/2006/main">
               <a:ext uri="{FF2B5EF4-FFF2-40B4-BE49-F238E27FC236}">
-                <a16:creationId xmlns:a16="http://schemas.microsoft.com/office/drawing/2014/main" id="{924FA4DC-3CFB-4214-91AD-1E0CB411D91C}"/>
+                <a16:creationId xmlns:a16="http://schemas.microsoft.com/office/drawing/2014/main" id="{FF3A0993-59E9-47D4-ACE0-8CC6EF70E9E3}"/>
               </a:ext>
             </a:extLst>
           </p:cNvPr>
@@ -5409,7 +6456,7 @@
           <p:cNvPr id="18" name="">
             <a:extLst xmlns:a="http://schemas.openxmlformats.org/drawingml/2006/main">
               <a:ext uri="{FF2B5EF4-FFF2-40B4-BE49-F238E27FC236}">
-                <a16:creationId xmlns:a16="http://schemas.microsoft.com/office/drawing/2014/main" id="{169AA5C6-C595-45FE-B70D-9C6549C1C82D}"/>
+                <a16:creationId xmlns:a16="http://schemas.microsoft.com/office/drawing/2014/main" id="{2AD0E577-DAB4-491C-BCD1-2982EA1A7AFC}"/>
               </a:ext>
             </a:extLst>
           </p:cNvPr>
@@ -5459,7 +6506,7 @@
           <p:cNvPr id="19" name="">
             <a:extLst xmlns:a="http://schemas.openxmlformats.org/drawingml/2006/main">
               <a:ext uri="{FF2B5EF4-FFF2-40B4-BE49-F238E27FC236}">
-                <a16:creationId xmlns:a16="http://schemas.microsoft.com/office/drawing/2014/main" id="{C3F3AB7E-A1EF-4581-8111-239C11BBA344}"/>
+                <a16:creationId xmlns:a16="http://schemas.microsoft.com/office/drawing/2014/main" id="{20BFA513-68A7-4CCC-8E8E-685CCD081F64}"/>
               </a:ext>
             </a:extLst>
           </p:cNvPr>
@@ -5509,7 +6556,7 @@
           <p:cNvPr id="20" name="">
             <a:extLst xmlns:a="http://schemas.openxmlformats.org/drawingml/2006/main">
               <a:ext uri="{FF2B5EF4-FFF2-40B4-BE49-F238E27FC236}">
-                <a16:creationId xmlns:a16="http://schemas.microsoft.com/office/drawing/2014/main" id="{12F5D63D-AC68-4707-AFF5-9BC3E53AB726}"/>
+                <a16:creationId xmlns:a16="http://schemas.microsoft.com/office/drawing/2014/main" id="{936597DA-B7D2-46AE-B82D-CD0590F13968}"/>
               </a:ext>
             </a:extLst>
           </p:cNvPr>
@@ -5559,7 +6606,7 @@
           <p:cNvPr id="21" name="">
             <a:extLst xmlns:a="http://schemas.openxmlformats.org/drawingml/2006/main">
               <a:ext uri="{FF2B5EF4-FFF2-40B4-BE49-F238E27FC236}">
-                <a16:creationId xmlns:a16="http://schemas.microsoft.com/office/drawing/2014/main" id="{086AD570-1176-42FD-8C14-72CA856ABA17}"/>
+                <a16:creationId xmlns:a16="http://schemas.microsoft.com/office/drawing/2014/main" id="{D9C61B31-2B3E-4456-AE2C-ABEAE8E8E4BA}"/>
               </a:ext>
             </a:extLst>
           </p:cNvPr>
@@ -5592,7 +6639,7 @@
           <p:cNvPr id="22" name="">
             <a:extLst xmlns:a="http://schemas.openxmlformats.org/drawingml/2006/main">
               <a:ext uri="{FF2B5EF4-FFF2-40B4-BE49-F238E27FC236}">
-                <a16:creationId xmlns:a16="http://schemas.microsoft.com/office/drawing/2014/main" id="{CF69A00C-22B9-4232-867C-8A09549A1CC4}"/>
+                <a16:creationId xmlns:a16="http://schemas.microsoft.com/office/drawing/2014/main" id="{E9D5A5A0-EDFD-4CB0-AA0E-FD960FA07BCF}"/>
               </a:ext>
             </a:extLst>
           </p:cNvPr>
@@ -5642,7 +6689,7 @@
           <p:cNvPr id="23" name="">
             <a:extLst xmlns:a="http://schemas.openxmlformats.org/drawingml/2006/main">
               <a:ext uri="{FF2B5EF4-FFF2-40B4-BE49-F238E27FC236}">
-                <a16:creationId xmlns:a16="http://schemas.microsoft.com/office/drawing/2014/main" id="{707E6254-C1FD-442D-A44D-7B51EA500414}"/>
+                <a16:creationId xmlns:a16="http://schemas.microsoft.com/office/drawing/2014/main" id="{DE505B61-2DF4-47D1-9D56-F390A642CFA6}"/>
               </a:ext>
             </a:extLst>
           </p:cNvPr>
@@ -5692,7 +6739,7 @@
           <p:cNvPr id="24" name="">
             <a:extLst xmlns:a="http://schemas.openxmlformats.org/drawingml/2006/main">
               <a:ext uri="{FF2B5EF4-FFF2-40B4-BE49-F238E27FC236}">
-                <a16:creationId xmlns:a16="http://schemas.microsoft.com/office/drawing/2014/main" id="{34946DEE-F69B-4684-A56A-174386261D9F}"/>
+                <a16:creationId xmlns:a16="http://schemas.microsoft.com/office/drawing/2014/main" id="{5D9E6EE3-E720-4F98-BCCB-6B2E88886652}"/>
               </a:ext>
             </a:extLst>
           </p:cNvPr>
@@ -5742,7 +6789,7 @@
           <p:cNvPr id="25" name="">
             <a:extLst xmlns:a="http://schemas.openxmlformats.org/drawingml/2006/main">
               <a:ext uri="{FF2B5EF4-FFF2-40B4-BE49-F238E27FC236}">
-                <a16:creationId xmlns:a16="http://schemas.microsoft.com/office/drawing/2014/main" id="{DA5B6E97-6BE7-41F7-97F3-85199678D3A2}"/>
+                <a16:creationId xmlns:a16="http://schemas.microsoft.com/office/drawing/2014/main" id="{3EFE3087-4D1C-463D-A244-EA0511D106A6}"/>
               </a:ext>
             </a:extLst>
           </p:cNvPr>
@@ -5792,7 +6839,7 @@
           <p:cNvPr id="26" name="">
             <a:extLst xmlns:a="http://schemas.openxmlformats.org/drawingml/2006/main">
               <a:ext uri="{FF2B5EF4-FFF2-40B4-BE49-F238E27FC236}">
-                <a16:creationId xmlns:a16="http://schemas.microsoft.com/office/drawing/2014/main" id="{3BC6A2DA-3CF9-4944-A3AC-73A5AF5A8B07}"/>
+                <a16:creationId xmlns:a16="http://schemas.microsoft.com/office/drawing/2014/main" id="{CABBEF56-7FD0-4AE0-812C-51731A94B04F}"/>
               </a:ext>
             </a:extLst>
           </p:cNvPr>
@@ -5840,7 +6887,7 @@
     </p:spTree>
     <p:extLst>
       <p:ext uri="{BB962C8B-B14F-4D97-AF65-F5344CB8AC3E}">
-        <p14:creationId xmlns:p14="http://schemas.microsoft.com/office/powerpoint/2010/main" val="1017032973"/>
+        <p14:creationId xmlns:p14="http://schemas.microsoft.com/office/powerpoint/2010/main" val="1372901926"/>
       </p:ext>
     </p:extLst>
   </p:cSld>
@@ -5871,7 +6918,7 @@
           <p:cNvPr id="26" name="">
             <a:extLst xmlns:a="http://schemas.openxmlformats.org/drawingml/2006/main">
               <a:ext uri="{FF2B5EF4-FFF2-40B4-BE49-F238E27FC236}">
-                <a16:creationId xmlns:a16="http://schemas.microsoft.com/office/drawing/2014/main" id="{C2908EC0-4A77-4D6D-8CEE-32335EE7CCDF}"/>
+                <a16:creationId xmlns:a16="http://schemas.microsoft.com/office/drawing/2014/main" id="{54776963-8C74-4F1A-89F2-423C2351C0A6}"/>
               </a:ext>
             </a:extLst>
           </p:cNvPr>
@@ -5921,7 +6968,7 @@
           <p:cNvPr id="2" name="">
             <a:extLst xmlns:a="http://schemas.openxmlformats.org/drawingml/2006/main">
               <a:ext uri="{FF2B5EF4-FFF2-40B4-BE49-F238E27FC236}">
-                <a16:creationId xmlns:a16="http://schemas.microsoft.com/office/drawing/2014/main" id="{28840109-E9EB-4B2A-85BE-F389F3D92EBA}"/>
+                <a16:creationId xmlns:a16="http://schemas.microsoft.com/office/drawing/2014/main" id="{1037B783-25E9-402C-8345-05DE4AE6D244}"/>
               </a:ext>
             </a:extLst>
           </p:cNvPr>
@@ -5971,7 +7018,7 @@
           <p:cNvPr id="3" name="">
             <a:extLst xmlns:a="http://schemas.openxmlformats.org/drawingml/2006/main">
               <a:ext uri="{FF2B5EF4-FFF2-40B4-BE49-F238E27FC236}">
-                <a16:creationId xmlns:a16="http://schemas.microsoft.com/office/drawing/2014/main" id="{EE144D7B-862E-4E2F-B64A-F349D677686E}"/>
+                <a16:creationId xmlns:a16="http://schemas.microsoft.com/office/drawing/2014/main" id="{2E14F433-0ABA-4604-873F-5B13D037BF08}"/>
               </a:ext>
             </a:extLst>
           </p:cNvPr>
@@ -6021,7 +7068,7 @@
           <p:cNvPr id="4" name="">
             <a:extLst xmlns:a="http://schemas.openxmlformats.org/drawingml/2006/main">
               <a:ext uri="{FF2B5EF4-FFF2-40B4-BE49-F238E27FC236}">
-                <a16:creationId xmlns:a16="http://schemas.microsoft.com/office/drawing/2014/main" id="{7D955BA6-8F0B-4A76-B6AC-B335E5F7E3F1}"/>
+                <a16:creationId xmlns:a16="http://schemas.microsoft.com/office/drawing/2014/main" id="{87E4EFFB-5C48-4B93-91B1-A4CED948774E}"/>
               </a:ext>
             </a:extLst>
           </p:cNvPr>
@@ -6071,7 +7118,7 @@
           <p:cNvPr id="5" name="">
             <a:extLst xmlns:a="http://schemas.openxmlformats.org/drawingml/2006/main">
               <a:ext uri="{FF2B5EF4-FFF2-40B4-BE49-F238E27FC236}">
-                <a16:creationId xmlns:a16="http://schemas.microsoft.com/office/drawing/2014/main" id="{1F008637-650F-46A2-A715-C592CE0AD3CD}"/>
+                <a16:creationId xmlns:a16="http://schemas.microsoft.com/office/drawing/2014/main" id="{97BD0834-433F-456E-80C3-B0BC54412914}"/>
               </a:ext>
             </a:extLst>
           </p:cNvPr>
@@ -6121,7 +7168,7 @@
           <p:cNvPr id="6" name="">
             <a:extLst xmlns:a="http://schemas.openxmlformats.org/drawingml/2006/main">
               <a:ext uri="{FF2B5EF4-FFF2-40B4-BE49-F238E27FC236}">
-                <a16:creationId xmlns:a16="http://schemas.microsoft.com/office/drawing/2014/main" id="{FCAB2DE5-28DE-4865-AE0D-95FF26C8E89B}"/>
+                <a16:creationId xmlns:a16="http://schemas.microsoft.com/office/drawing/2014/main" id="{FEC09A6A-10BF-4A39-B714-AFD608E77A6A}"/>
               </a:ext>
             </a:extLst>
           </p:cNvPr>
@@ -6171,7 +7218,7 @@
           <p:cNvPr id="7" name="">
             <a:extLst xmlns:a="http://schemas.openxmlformats.org/drawingml/2006/main">
               <a:ext uri="{FF2B5EF4-FFF2-40B4-BE49-F238E27FC236}">
-                <a16:creationId xmlns:a16="http://schemas.microsoft.com/office/drawing/2014/main" id="{0A31901E-A06D-47C8-AA79-6F18D3B2D304}"/>
+                <a16:creationId xmlns:a16="http://schemas.microsoft.com/office/drawing/2014/main" id="{94339CB2-01EA-4782-9462-61CE6288CAA8}"/>
               </a:ext>
             </a:extLst>
           </p:cNvPr>
@@ -6221,7 +7268,7 @@
           <p:cNvPr id="8" name="">
             <a:extLst xmlns:a="http://schemas.openxmlformats.org/drawingml/2006/main">
               <a:ext uri="{FF2B5EF4-FFF2-40B4-BE49-F238E27FC236}">
-                <a16:creationId xmlns:a16="http://schemas.microsoft.com/office/drawing/2014/main" id="{FDF2B606-EF65-422E-820D-44204C6C4991}"/>
+                <a16:creationId xmlns:a16="http://schemas.microsoft.com/office/drawing/2014/main" id="{2A36C732-7194-40F2-B85C-4DCF24A1DCD5}"/>
               </a:ext>
             </a:extLst>
           </p:cNvPr>
@@ -6254,7 +7301,7 @@
           <p:cNvPr id="9" name="">
             <a:extLst xmlns:a="http://schemas.openxmlformats.org/drawingml/2006/main">
               <a:ext uri="{FF2B5EF4-FFF2-40B4-BE49-F238E27FC236}">
-                <a16:creationId xmlns:a16="http://schemas.microsoft.com/office/drawing/2014/main" id="{18641C8C-94B0-4185-90FE-694F91E680C3}"/>
+                <a16:creationId xmlns:a16="http://schemas.microsoft.com/office/drawing/2014/main" id="{7EFBCF2D-5AA6-4D10-A8D7-945D986F831E}"/>
               </a:ext>
             </a:extLst>
           </p:cNvPr>
@@ -6304,7 +7351,7 @@
           <p:cNvPr id="10" name="">
             <a:extLst xmlns:a="http://schemas.openxmlformats.org/drawingml/2006/main">
               <a:ext uri="{FF2B5EF4-FFF2-40B4-BE49-F238E27FC236}">
-                <a16:creationId xmlns:a16="http://schemas.microsoft.com/office/drawing/2014/main" id="{76CFD24E-17F8-4F6B-AC7B-11A56F1A3AF1}"/>
+                <a16:creationId xmlns:a16="http://schemas.microsoft.com/office/drawing/2014/main" id="{D711533E-85C6-4ED7-9AEC-9BA37A78CDCB}"/>
               </a:ext>
             </a:extLst>
           </p:cNvPr>
@@ -6354,7 +7401,7 @@
           <p:cNvPr id="11" name="">
             <a:extLst xmlns:a="http://schemas.openxmlformats.org/drawingml/2006/main">
               <a:ext uri="{FF2B5EF4-FFF2-40B4-BE49-F238E27FC236}">
-                <a16:creationId xmlns:a16="http://schemas.microsoft.com/office/drawing/2014/main" id="{3D6FCAAF-F3A9-4F81-A4A7-7C4DEFE14363}"/>
+                <a16:creationId xmlns:a16="http://schemas.microsoft.com/office/drawing/2014/main" id="{6F801137-5EED-4C6D-95B7-079A959284E8}"/>
               </a:ext>
             </a:extLst>
           </p:cNvPr>
@@ -6404,7 +7451,7 @@
           <p:cNvPr id="12" name="">
             <a:extLst xmlns:a="http://schemas.openxmlformats.org/drawingml/2006/main">
               <a:ext uri="{FF2B5EF4-FFF2-40B4-BE49-F238E27FC236}">
-                <a16:creationId xmlns:a16="http://schemas.microsoft.com/office/drawing/2014/main" id="{7B2B7DA0-96D3-4905-A99F-AB4B038DD8B1}"/>
+                <a16:creationId xmlns:a16="http://schemas.microsoft.com/office/drawing/2014/main" id="{4B60336C-3CBE-4D81-A1A1-7040D126E04E}"/>
               </a:ext>
             </a:extLst>
           </p:cNvPr>
@@ -6454,7 +7501,7 @@
           <p:cNvPr id="13" name="">
             <a:extLst xmlns:a="http://schemas.openxmlformats.org/drawingml/2006/main">
               <a:ext uri="{FF2B5EF4-FFF2-40B4-BE49-F238E27FC236}">
-                <a16:creationId xmlns:a16="http://schemas.microsoft.com/office/drawing/2014/main" id="{D05E4685-741C-4BAD-B135-D9D104CB3152}"/>
+                <a16:creationId xmlns:a16="http://schemas.microsoft.com/office/drawing/2014/main" id="{317D9E87-6D12-4BBC-B562-528E2C2B2800}"/>
               </a:ext>
             </a:extLst>
           </p:cNvPr>
@@ -6487,7 +7534,7 @@
           <p:cNvPr id="14" name="">
             <a:extLst xmlns:a="http://schemas.openxmlformats.org/drawingml/2006/main">
               <a:ext uri="{FF2B5EF4-FFF2-40B4-BE49-F238E27FC236}">
-                <a16:creationId xmlns:a16="http://schemas.microsoft.com/office/drawing/2014/main" id="{F11971A1-7AC4-45F3-9D9D-FDB0AD912F8E}"/>
+                <a16:creationId xmlns:a16="http://schemas.microsoft.com/office/drawing/2014/main" id="{883C0609-F16B-4F21-A942-D322C42BCC81}"/>
               </a:ext>
             </a:extLst>
           </p:cNvPr>
@@ -6537,7 +7584,7 @@
           <p:cNvPr id="15" name="">
             <a:extLst xmlns:a="http://schemas.openxmlformats.org/drawingml/2006/main">
               <a:ext uri="{FF2B5EF4-FFF2-40B4-BE49-F238E27FC236}">
-                <a16:creationId xmlns:a16="http://schemas.microsoft.com/office/drawing/2014/main" id="{31C7DA25-6812-4C8D-915E-E260F561ECF0}"/>
+                <a16:creationId xmlns:a16="http://schemas.microsoft.com/office/drawing/2014/main" id="{AEB3A00D-4056-4A07-BAFD-BBA2006E588D}"/>
               </a:ext>
             </a:extLst>
           </p:cNvPr>
@@ -6587,7 +7634,7 @@
           <p:cNvPr id="16" name="">
             <a:extLst xmlns:a="http://schemas.openxmlformats.org/drawingml/2006/main">
               <a:ext uri="{FF2B5EF4-FFF2-40B4-BE49-F238E27FC236}">
-                <a16:creationId xmlns:a16="http://schemas.microsoft.com/office/drawing/2014/main" id="{79E81CF2-F568-4010-818A-A97CFA09EE49}"/>
+                <a16:creationId xmlns:a16="http://schemas.microsoft.com/office/drawing/2014/main" id="{31871F45-4B72-43E1-B1FE-202599F18F10}"/>
               </a:ext>
             </a:extLst>
           </p:cNvPr>
@@ -6637,7 +7684,7 @@
           <p:cNvPr id="17" name="">
             <a:extLst xmlns:a="http://schemas.openxmlformats.org/drawingml/2006/main">
               <a:ext uri="{FF2B5EF4-FFF2-40B4-BE49-F238E27FC236}">
-                <a16:creationId xmlns:a16="http://schemas.microsoft.com/office/drawing/2014/main" id="{21D9F83E-739A-4645-A337-4C1D7464A8F6}"/>
+                <a16:creationId xmlns:a16="http://schemas.microsoft.com/office/drawing/2014/main" id="{C09CDC53-F584-447B-BFAE-0B4CE85427C9}"/>
               </a:ext>
             </a:extLst>
           </p:cNvPr>
@@ -6687,7 +7734,7 @@
           <p:cNvPr id="18" name="">
             <a:extLst xmlns:a="http://schemas.openxmlformats.org/drawingml/2006/main">
               <a:ext uri="{FF2B5EF4-FFF2-40B4-BE49-F238E27FC236}">
-                <a16:creationId xmlns:a16="http://schemas.microsoft.com/office/drawing/2014/main" id="{88DDDB57-BA42-4A68-9C61-1C9B078FE88C}"/>
+                <a16:creationId xmlns:a16="http://schemas.microsoft.com/office/drawing/2014/main" id="{C4418388-A4C0-4E80-8D23-E1C7A28BCAB9}"/>
               </a:ext>
             </a:extLst>
           </p:cNvPr>
@@ -6720,7 +7767,7 @@
           <p:cNvPr id="19" name="">
             <a:extLst xmlns:a="http://schemas.openxmlformats.org/drawingml/2006/main">
               <a:ext uri="{FF2B5EF4-FFF2-40B4-BE49-F238E27FC236}">
-                <a16:creationId xmlns:a16="http://schemas.microsoft.com/office/drawing/2014/main" id="{8F545A75-AFFC-41BE-97FD-F297410D7E4C}"/>
+                <a16:creationId xmlns:a16="http://schemas.microsoft.com/office/drawing/2014/main" id="{6FCE2A9C-D889-4013-B4B9-F6804A42E659}"/>
               </a:ext>
             </a:extLst>
           </p:cNvPr>
@@ -6770,7 +7817,7 @@
           <p:cNvPr id="20" name="">
             <a:extLst xmlns:a="http://schemas.openxmlformats.org/drawingml/2006/main">
               <a:ext uri="{FF2B5EF4-FFF2-40B4-BE49-F238E27FC236}">
-                <a16:creationId xmlns:a16="http://schemas.microsoft.com/office/drawing/2014/main" id="{F6FFAB78-FE0F-4C38-A501-2A5C050BDF96}"/>
+                <a16:creationId xmlns:a16="http://schemas.microsoft.com/office/drawing/2014/main" id="{9545308D-4DE8-4AA8-8794-1CA0E1DFEE47}"/>
               </a:ext>
             </a:extLst>
           </p:cNvPr>
@@ -6820,7 +7867,7 @@
           <p:cNvPr id="21" name="">
             <a:extLst xmlns:a="http://schemas.openxmlformats.org/drawingml/2006/main">
               <a:ext uri="{FF2B5EF4-FFF2-40B4-BE49-F238E27FC236}">
-                <a16:creationId xmlns:a16="http://schemas.microsoft.com/office/drawing/2014/main" id="{FEFACAE5-323A-4416-A3F3-E04C1F7252BD}"/>
+                <a16:creationId xmlns:a16="http://schemas.microsoft.com/office/drawing/2014/main" id="{5B69BFE3-493B-47EE-970B-E67FF8B9475B}"/>
               </a:ext>
             </a:extLst>
           </p:cNvPr>
@@ -6870,7 +7917,7 @@
           <p:cNvPr id="22" name="">
             <a:extLst xmlns:a="http://schemas.openxmlformats.org/drawingml/2006/main">
               <a:ext uri="{FF2B5EF4-FFF2-40B4-BE49-F238E27FC236}">
-                <a16:creationId xmlns:a16="http://schemas.microsoft.com/office/drawing/2014/main" id="{33327DEC-011B-4060-B702-BCC109AA947C}"/>
+                <a16:creationId xmlns:a16="http://schemas.microsoft.com/office/drawing/2014/main" id="{7E000FFF-7D11-435A-A389-B6DB6D7955A2}"/>
               </a:ext>
             </a:extLst>
           </p:cNvPr>
@@ -6920,7 +7967,7 @@
           <p:cNvPr id="23" name="">
             <a:extLst xmlns:a="http://schemas.openxmlformats.org/drawingml/2006/main">
               <a:ext uri="{FF2B5EF4-FFF2-40B4-BE49-F238E27FC236}">
-                <a16:creationId xmlns:a16="http://schemas.microsoft.com/office/drawing/2014/main" id="{BFF849E9-D63E-4898-B8BC-F56FBC6980CD}"/>
+                <a16:creationId xmlns:a16="http://schemas.microsoft.com/office/drawing/2014/main" id="{04A6BDFD-7CE2-4362-BEF2-37123D5F18B3}"/>
               </a:ext>
             </a:extLst>
           </p:cNvPr>
@@ -6970,7 +8017,7 @@
           <p:cNvPr id="24" name="">
             <a:extLst xmlns:a="http://schemas.openxmlformats.org/drawingml/2006/main">
               <a:ext uri="{FF2B5EF4-FFF2-40B4-BE49-F238E27FC236}">
-                <a16:creationId xmlns:a16="http://schemas.microsoft.com/office/drawing/2014/main" id="{6AFFC7C6-BD68-4CD9-AF68-194F489AD0D9}"/>
+                <a16:creationId xmlns:a16="http://schemas.microsoft.com/office/drawing/2014/main" id="{4E0A641D-D974-463D-AD1F-5243792A83F5}"/>
               </a:ext>
             </a:extLst>
           </p:cNvPr>
@@ -7020,7 +8067,7 @@
           <p:cNvPr id="25" name="">
             <a:extLst xmlns:a="http://schemas.openxmlformats.org/drawingml/2006/main">
               <a:ext uri="{FF2B5EF4-FFF2-40B4-BE49-F238E27FC236}">
-                <a16:creationId xmlns:a16="http://schemas.microsoft.com/office/drawing/2014/main" id="{18D2F999-37AE-4C44-80B8-9BE2D955F2A6}"/>
+                <a16:creationId xmlns:a16="http://schemas.microsoft.com/office/drawing/2014/main" id="{EF6A7A9B-7BA3-4B32-B804-23E32BCFCC4B}"/>
               </a:ext>
             </a:extLst>
           </p:cNvPr>
@@ -7068,7 +8115,7 @@
     </p:spTree>
     <p:extLst>
       <p:ext uri="{BB962C8B-B14F-4D97-AF65-F5344CB8AC3E}">
-        <p14:creationId xmlns:p14="http://schemas.microsoft.com/office/powerpoint/2010/main" val="578757707"/>
+        <p14:creationId xmlns:p14="http://schemas.microsoft.com/office/powerpoint/2010/main" val="1594327945"/>
       </p:ext>
     </p:extLst>
   </p:cSld>
@@ -7099,7 +8146,7 @@
           <p:cNvPr id="11" name="">
             <a:extLst xmlns:a="http://schemas.openxmlformats.org/drawingml/2006/main">
               <a:ext uri="{FF2B5EF4-FFF2-40B4-BE49-F238E27FC236}">
-                <a16:creationId xmlns:a16="http://schemas.microsoft.com/office/drawing/2014/main" id="{DD6596D9-9A2E-443F-9296-45E616F788FC}"/>
+                <a16:creationId xmlns:a16="http://schemas.microsoft.com/office/drawing/2014/main" id="{8043D8C9-AA88-48EF-939C-8058C76DF6BC}"/>
               </a:ext>
             </a:extLst>
           </p:cNvPr>
@@ -7149,7 +8196,7 @@
           <p:cNvPr id="2" name="">
             <a:extLst xmlns:a="http://schemas.openxmlformats.org/drawingml/2006/main">
               <a:ext uri="{FF2B5EF4-FFF2-40B4-BE49-F238E27FC236}">
-                <a16:creationId xmlns:a16="http://schemas.microsoft.com/office/drawing/2014/main" id="{7BC08004-59CE-4018-A02F-B2E32AD85686}"/>
+                <a16:creationId xmlns:a16="http://schemas.microsoft.com/office/drawing/2014/main" id="{932858BE-B909-4778-9365-58759F74C4C2}"/>
               </a:ext>
             </a:extLst>
           </p:cNvPr>
@@ -7199,7 +8246,7 @@
           <p:cNvPr id="3" name="">
             <a:extLst xmlns:a="http://schemas.openxmlformats.org/drawingml/2006/main">
               <a:ext uri="{FF2B5EF4-FFF2-40B4-BE49-F238E27FC236}">
-                <a16:creationId xmlns:a16="http://schemas.microsoft.com/office/drawing/2014/main" id="{98BC731F-5E44-42AE-B521-C14C9E0BAA15}"/>
+                <a16:creationId xmlns:a16="http://schemas.microsoft.com/office/drawing/2014/main" id="{C28A950C-C963-483F-B46B-A0176BAFAFF1}"/>
               </a:ext>
             </a:extLst>
           </p:cNvPr>
@@ -7256,7 +8303,7 @@
         </p:xfrm>
         <a:graphic xmlns:a="http://schemas.openxmlformats.org/drawingml/2006/main">
           <a:graphicData uri="http://schemas.openxmlformats.org/drawingml/2006/chart">
-            <c:chart xmlns:r="http://schemas.openxmlformats.org/officeDocument/2006/relationships" xmlns:c="http://schemas.openxmlformats.org/drawingml/2006/chart" r:id="Rb7b7fb5439064a94"/>
+            <c:chart xmlns:r="http://schemas.openxmlformats.org/officeDocument/2006/relationships" xmlns:c="http://schemas.openxmlformats.org/drawingml/2006/chart" r:id="R81014b90d77f4c7c"/>
           </a:graphicData>
         </a:graphic>
       </p:graphicFrame>
@@ -7265,7 +8312,7 @@
           <p:cNvPr id="5" name="">
             <a:extLst xmlns:a="http://schemas.openxmlformats.org/drawingml/2006/main">
               <a:ext uri="{FF2B5EF4-FFF2-40B4-BE49-F238E27FC236}">
-                <a16:creationId xmlns:a16="http://schemas.microsoft.com/office/drawing/2014/main" id="{2BF0120E-FB99-4CD6-A1EE-A624F78A533F}"/>
+                <a16:creationId xmlns:a16="http://schemas.microsoft.com/office/drawing/2014/main" id="{23F49E04-A545-4AD8-9C56-B87F7CCF8747}"/>
               </a:ext>
             </a:extLst>
           </p:cNvPr>
@@ -7315,7 +8362,7 @@
           <p:cNvPr id="6" name="">
             <a:extLst xmlns:a="http://schemas.openxmlformats.org/drawingml/2006/main">
               <a:ext uri="{FF2B5EF4-FFF2-40B4-BE49-F238E27FC236}">
-                <a16:creationId xmlns:a16="http://schemas.microsoft.com/office/drawing/2014/main" id="{2B5C1584-1751-4DB8-9AC2-A19E8D0DF7EF}"/>
+                <a16:creationId xmlns:a16="http://schemas.microsoft.com/office/drawing/2014/main" id="{429DE698-52FE-4F3D-B93F-175B1560FF22}"/>
               </a:ext>
             </a:extLst>
           </p:cNvPr>
@@ -7382,7 +8429,7 @@
           <p:cNvPr id="7" name="">
             <a:extLst xmlns:a="http://schemas.openxmlformats.org/drawingml/2006/main">
               <a:ext uri="{FF2B5EF4-FFF2-40B4-BE49-F238E27FC236}">
-                <a16:creationId xmlns:a16="http://schemas.microsoft.com/office/drawing/2014/main" id="{BB91D797-3809-4DC5-A82A-6A1B2CECDE60}"/>
+                <a16:creationId xmlns:a16="http://schemas.microsoft.com/office/drawing/2014/main" id="{4D65F87A-1A5A-4135-861C-89B8A5A71651}"/>
               </a:ext>
             </a:extLst>
           </p:cNvPr>
@@ -7432,7 +8479,7 @@
           <p:cNvPr id="8" name="">
             <a:extLst xmlns:a="http://schemas.openxmlformats.org/drawingml/2006/main">
               <a:ext uri="{FF2B5EF4-FFF2-40B4-BE49-F238E27FC236}">
-                <a16:creationId xmlns:a16="http://schemas.microsoft.com/office/drawing/2014/main" id="{604128FA-7DCF-4D0F-96C3-32AD412D5B3B}"/>
+                <a16:creationId xmlns:a16="http://schemas.microsoft.com/office/drawing/2014/main" id="{D91D14CB-80A8-46F0-A9E0-D5D22787B4E5}"/>
               </a:ext>
             </a:extLst>
           </p:cNvPr>
@@ -7499,7 +8546,7 @@
           <p:cNvPr id="9" name="">
             <a:extLst xmlns:a="http://schemas.openxmlformats.org/drawingml/2006/main">
               <a:ext uri="{FF2B5EF4-FFF2-40B4-BE49-F238E27FC236}">
-                <a16:creationId xmlns:a16="http://schemas.microsoft.com/office/drawing/2014/main" id="{A925691B-EB02-4C4E-B8CA-17A2C0F59CE1}"/>
+                <a16:creationId xmlns:a16="http://schemas.microsoft.com/office/drawing/2014/main" id="{2104A59D-F887-440D-BE6F-CE76676BF2A8}"/>
               </a:ext>
             </a:extLst>
           </p:cNvPr>
@@ -7549,7 +8596,7 @@
           <p:cNvPr id="10" name="">
             <a:extLst xmlns:a="http://schemas.openxmlformats.org/drawingml/2006/main">
               <a:ext uri="{FF2B5EF4-FFF2-40B4-BE49-F238E27FC236}">
-                <a16:creationId xmlns:a16="http://schemas.microsoft.com/office/drawing/2014/main" id="{A12BA7D5-1292-460B-ACE5-EC78C2BB4B3C}"/>
+                <a16:creationId xmlns:a16="http://schemas.microsoft.com/office/drawing/2014/main" id="{C81E99A7-57C5-4004-984C-F8F55477E4EE}"/>
               </a:ext>
             </a:extLst>
           </p:cNvPr>
@@ -7597,7 +8644,7 @@
     </p:spTree>
     <p:extLst>
       <p:ext uri="{BB962C8B-B14F-4D97-AF65-F5344CB8AC3E}">
-        <p14:creationId xmlns:p14="http://schemas.microsoft.com/office/powerpoint/2010/main" val="161985838"/>
+        <p14:creationId xmlns:p14="http://schemas.microsoft.com/office/powerpoint/2010/main" val="841013369"/>
       </p:ext>
     </p:extLst>
   </p:cSld>
@@ -7628,7 +8675,7 @@
           <p:cNvPr id="13" name="">
             <a:extLst xmlns:a="http://schemas.openxmlformats.org/drawingml/2006/main">
               <a:ext uri="{FF2B5EF4-FFF2-40B4-BE49-F238E27FC236}">
-                <a16:creationId xmlns:a16="http://schemas.microsoft.com/office/drawing/2014/main" id="{69835FD8-780B-4DA1-9014-82F55EF4DCF4}"/>
+                <a16:creationId xmlns:a16="http://schemas.microsoft.com/office/drawing/2014/main" id="{F1C22F5F-1164-409C-810B-6F72CBD8C231}"/>
               </a:ext>
             </a:extLst>
           </p:cNvPr>
@@ -7678,7 +8725,7 @@
           <p:cNvPr id="2" name="">
             <a:extLst xmlns:a="http://schemas.openxmlformats.org/drawingml/2006/main">
               <a:ext uri="{FF2B5EF4-FFF2-40B4-BE49-F238E27FC236}">
-                <a16:creationId xmlns:a16="http://schemas.microsoft.com/office/drawing/2014/main" id="{8721AF97-02B7-4D50-B199-C1EB810EB9E9}"/>
+                <a16:creationId xmlns:a16="http://schemas.microsoft.com/office/drawing/2014/main" id="{E970BFE9-4B16-45E8-8592-ACD1F51730EB}"/>
               </a:ext>
             </a:extLst>
           </p:cNvPr>
@@ -7728,7 +8775,7 @@
           <p:cNvPr id="3" name="">
             <a:extLst xmlns:a="http://schemas.openxmlformats.org/drawingml/2006/main">
               <a:ext uri="{FF2B5EF4-FFF2-40B4-BE49-F238E27FC236}">
-                <a16:creationId xmlns:a16="http://schemas.microsoft.com/office/drawing/2014/main" id="{B8A2E13C-EC88-465F-B531-373605ED25D1}"/>
+                <a16:creationId xmlns:a16="http://schemas.microsoft.com/office/drawing/2014/main" id="{F2366B6B-1BBF-4F3D-95B0-1A3EFEC4342A}"/>
               </a:ext>
             </a:extLst>
           </p:cNvPr>
@@ -7785,7 +8832,7 @@
         </p:xfrm>
         <a:graphic xmlns:a="http://schemas.openxmlformats.org/drawingml/2006/main">
           <a:graphicData uri="http://schemas.openxmlformats.org/drawingml/2006/chart">
-            <c:chart xmlns:r="http://schemas.openxmlformats.org/officeDocument/2006/relationships" xmlns:c="http://schemas.openxmlformats.org/drawingml/2006/chart" r:id="Rcce14c1010aa460b"/>
+            <c:chart xmlns:r="http://schemas.openxmlformats.org/officeDocument/2006/relationships" xmlns:c="http://schemas.openxmlformats.org/drawingml/2006/chart" r:id="R55797d47c7cd433b"/>
           </a:graphicData>
         </a:graphic>
       </p:graphicFrame>
@@ -7794,7 +8841,7 @@
           <p:cNvPr id="5" name="">
             <a:extLst xmlns:a="http://schemas.openxmlformats.org/drawingml/2006/main">
               <a:ext uri="{FF2B5EF4-FFF2-40B4-BE49-F238E27FC236}">
-                <a16:creationId xmlns:a16="http://schemas.microsoft.com/office/drawing/2014/main" id="{EA32EC58-98FE-49BF-A6F9-CD760A19A008}"/>
+                <a16:creationId xmlns:a16="http://schemas.microsoft.com/office/drawing/2014/main" id="{9AABA86E-4A24-45BE-AAFF-33E8DD0CB0F3}"/>
               </a:ext>
             </a:extLst>
           </p:cNvPr>
@@ -7844,7 +8891,7 @@
           <p:cNvPr id="6" name="">
             <a:extLst xmlns:a="http://schemas.openxmlformats.org/drawingml/2006/main">
               <a:ext uri="{FF2B5EF4-FFF2-40B4-BE49-F238E27FC236}">
-                <a16:creationId xmlns:a16="http://schemas.microsoft.com/office/drawing/2014/main" id="{A9B99428-4818-418F-8721-9434CEE7362F}"/>
+                <a16:creationId xmlns:a16="http://schemas.microsoft.com/office/drawing/2014/main" id="{F7FA1C1A-1212-449B-B776-580A6D8FD2E2}"/>
               </a:ext>
             </a:extLst>
           </p:cNvPr>
@@ -7894,7 +8941,7 @@
           <p:cNvPr id="7" name="">
             <a:extLst xmlns:a="http://schemas.openxmlformats.org/drawingml/2006/main">
               <a:ext uri="{FF2B5EF4-FFF2-40B4-BE49-F238E27FC236}">
-                <a16:creationId xmlns:a16="http://schemas.microsoft.com/office/drawing/2014/main" id="{2875168D-787B-49BF-BE3F-73260B5AE875}"/>
+                <a16:creationId xmlns:a16="http://schemas.microsoft.com/office/drawing/2014/main" id="{A7DF3145-0009-4141-8535-8E7AEE0D7DFF}"/>
               </a:ext>
             </a:extLst>
           </p:cNvPr>
@@ -7944,7 +8991,7 @@
           <p:cNvPr id="8" name="">
             <a:extLst xmlns:a="http://schemas.openxmlformats.org/drawingml/2006/main">
               <a:ext uri="{FF2B5EF4-FFF2-40B4-BE49-F238E27FC236}">
-                <a16:creationId xmlns:a16="http://schemas.microsoft.com/office/drawing/2014/main" id="{F508C29F-06CC-45E3-82CD-F8E42E320144}"/>
+                <a16:creationId xmlns:a16="http://schemas.microsoft.com/office/drawing/2014/main" id="{E3F76BA0-2AAC-474D-B365-139851CF716A}"/>
               </a:ext>
             </a:extLst>
           </p:cNvPr>
@@ -7994,7 +9041,7 @@
           <p:cNvPr id="9" name="">
             <a:extLst xmlns:a="http://schemas.openxmlformats.org/drawingml/2006/main">
               <a:ext uri="{FF2B5EF4-FFF2-40B4-BE49-F238E27FC236}">
-                <a16:creationId xmlns:a16="http://schemas.microsoft.com/office/drawing/2014/main" id="{D4DA28C7-4611-436A-A3CD-A1768CC6C4AD}"/>
+                <a16:creationId xmlns:a16="http://schemas.microsoft.com/office/drawing/2014/main" id="{3EE4E1EA-8FF7-4C1F-A98E-C087CD794985}"/>
               </a:ext>
             </a:extLst>
           </p:cNvPr>
@@ -8044,7 +9091,7 @@
           <p:cNvPr id="10" name="">
             <a:extLst xmlns:a="http://schemas.openxmlformats.org/drawingml/2006/main">
               <a:ext uri="{FF2B5EF4-FFF2-40B4-BE49-F238E27FC236}">
-                <a16:creationId xmlns:a16="http://schemas.microsoft.com/office/drawing/2014/main" id="{07560319-832F-4D38-84A8-1AE899E97638}"/>
+                <a16:creationId xmlns:a16="http://schemas.microsoft.com/office/drawing/2014/main" id="{7D6A1983-1018-46C7-8DB0-7B2B3EF7BF72}"/>
               </a:ext>
             </a:extLst>
           </p:cNvPr>
@@ -8094,7 +9141,7 @@
           <p:cNvPr id="11" name="">
             <a:extLst xmlns:a="http://schemas.openxmlformats.org/drawingml/2006/main">
               <a:ext uri="{FF2B5EF4-FFF2-40B4-BE49-F238E27FC236}">
-                <a16:creationId xmlns:a16="http://schemas.microsoft.com/office/drawing/2014/main" id="{F99FD2DB-F8E1-4AA9-B254-6EE458F21170}"/>
+                <a16:creationId xmlns:a16="http://schemas.microsoft.com/office/drawing/2014/main" id="{CEF0CFE9-1BE5-46C7-AE83-95C99A9BA1D5}"/>
               </a:ext>
             </a:extLst>
           </p:cNvPr>
@@ -8144,7 +9191,7 @@
           <p:cNvPr id="12" name="">
             <a:extLst xmlns:a="http://schemas.openxmlformats.org/drawingml/2006/main">
               <a:ext uri="{FF2B5EF4-FFF2-40B4-BE49-F238E27FC236}">
-                <a16:creationId xmlns:a16="http://schemas.microsoft.com/office/drawing/2014/main" id="{C03E1094-2520-4865-BC73-16536D7944D5}"/>
+                <a16:creationId xmlns:a16="http://schemas.microsoft.com/office/drawing/2014/main" id="{A0DFC41D-80DE-4BE0-A95D-249C6A77E603}"/>
               </a:ext>
             </a:extLst>
           </p:cNvPr>
@@ -8192,7 +9239,7 @@
     </p:spTree>
     <p:extLst>
       <p:ext uri="{BB962C8B-B14F-4D97-AF65-F5344CB8AC3E}">
-        <p14:creationId xmlns:p14="http://schemas.microsoft.com/office/powerpoint/2010/main" val="1743924887"/>
+        <p14:creationId xmlns:p14="http://schemas.microsoft.com/office/powerpoint/2010/main" val="713584527"/>
       </p:ext>
     </p:extLst>
   </p:cSld>
@@ -8220,10 +9267,10 @@
       </p:grpSpPr>
       <p:sp>
         <p:nvSpPr>
-          <p:cNvPr id="14" name="">
-            <a:extLst xmlns:a="http://schemas.openxmlformats.org/drawingml/2006/main">
-              <a:ext uri="{FF2B5EF4-FFF2-40B4-BE49-F238E27FC236}">
-                <a16:creationId xmlns:a16="http://schemas.microsoft.com/office/drawing/2014/main" id="{5B528ED6-F0F5-4BCF-9ACC-EF03E74D93E1}"/>
+          <p:cNvPr id="26" name="">
+            <a:extLst xmlns:a="http://schemas.openxmlformats.org/drawingml/2006/main">
+              <a:ext uri="{FF2B5EF4-FFF2-40B4-BE49-F238E27FC236}">
+                <a16:creationId xmlns:a16="http://schemas.microsoft.com/office/drawing/2014/main" id="{CA969236-6071-44DF-8FF8-C4BBA724DD1A}"/>
               </a:ext>
             </a:extLst>
           </p:cNvPr>
@@ -8273,7 +9320,7 @@
           <p:cNvPr id="2" name="">
             <a:extLst xmlns:a="http://schemas.openxmlformats.org/drawingml/2006/main">
               <a:ext uri="{FF2B5EF4-FFF2-40B4-BE49-F238E27FC236}">
-                <a16:creationId xmlns:a16="http://schemas.microsoft.com/office/drawing/2014/main" id="{C462C104-A1C5-4067-9A9F-0FCBCE8FD5F6}"/>
+                <a16:creationId xmlns:a16="http://schemas.microsoft.com/office/drawing/2014/main" id="{25F251D4-4AE4-44D2-8F4C-519AFC6E6E9E}"/>
               </a:ext>
             </a:extLst>
           </p:cNvPr>
@@ -8313,7 +9360,7 @@
                   <a:srgbClr val="0B2545"/>
                 </a:solidFill>
               </a:rPr>
-              <a:t>Refunds expose concentrated product risk</a:t>
+              <a:t>One sale shows how quickly margin can disappear</a:t>
             </a:r>
           </a:p>
         </p:txBody>
@@ -8323,7 +9370,7 @@
           <p:cNvPr id="3" name="">
             <a:extLst xmlns:a="http://schemas.openxmlformats.org/drawingml/2006/main">
               <a:ext uri="{FF2B5EF4-FFF2-40B4-BE49-F238E27FC236}">
-                <a16:creationId xmlns:a16="http://schemas.microsoft.com/office/drawing/2014/main" id="{E3BCE7AB-5288-4CE2-863B-7BC901209766}"/>
+                <a16:creationId xmlns:a16="http://schemas.microsoft.com/office/drawing/2014/main" id="{A1848549-A437-4CCF-8E6D-476682A5DD7B}"/>
               </a:ext>
             </a:extLst>
           </p:cNvPr>
@@ -8363,60 +9410,809 @@
                   <a:srgbClr val="667085"/>
                 </a:solidFill>
               </a:rPr>
-              <a:t>GlowTheory has the highest brand rate; the PawHaus dog bed has the sharpest margin exposure.</a:t>
-            </a:r>
-          </a:p>
-        </p:txBody>
-      </p:sp>
-      <p:graphicFrame>
-        <p:nvGraphicFramePr>
-          <p:cNvPr id="17" name="Chart"/>
-          <p:cNvGraphicFramePr/>
-          <p:nvPr/>
-        </p:nvGraphicFramePr>
-        <p:xfrm>
-          <a:off xmlns:a="http://schemas.openxmlformats.org/drawingml/2006/main" x="723900" y="2047875"/>
-          <a:ext xmlns:a="http://schemas.openxmlformats.org/drawingml/2006/main" cx="6191250" cy="3476625"/>
-        </p:xfrm>
-        <a:graphic xmlns:a="http://schemas.openxmlformats.org/drawingml/2006/main">
-          <a:graphicData uri="http://schemas.openxmlformats.org/drawingml/2006/chart">
-            <c:chart xmlns:r="http://schemas.openxmlformats.org/officeDocument/2006/relationships" xmlns:c="http://schemas.openxmlformats.org/drawingml/2006/chart" r:id="Rdcd9de9ce95143ed"/>
-          </a:graphicData>
-        </a:graphic>
-      </p:graphicFrame>
+              <a:t>Every value traces to one settlement row or the SKU's PO weighted landed cost.</a:t>
+            </a:r>
+          </a:p>
+        </p:txBody>
+      </p:sp>
+      <p:sp>
+        <p:nvSpPr>
+          <p:cNvPr id="4" name="">
+            <a:extLst xmlns:a="http://schemas.openxmlformats.org/drawingml/2006/main">
+              <a:ext uri="{FF2B5EF4-FFF2-40B4-BE49-F238E27FC236}">
+                <a16:creationId xmlns:a16="http://schemas.microsoft.com/office/drawing/2014/main" id="{FD705CC0-D0B5-472A-8AAB-5A7AAC912819}"/>
+              </a:ext>
+            </a:extLst>
+          </p:cNvPr>
+          <p:cNvSpPr>
+            <a:spLocks xmlns:a="http://schemas.openxmlformats.org/drawingml/2006/main" noGrp="1"/>
+          </p:cNvSpPr>
+          <p:nvPr/>
+        </p:nvSpPr>
+        <p:spPr>
+          <a:xfrm xmlns:a="http://schemas.openxmlformats.org/drawingml/2006/main">
+            <a:off x="571500" y="2190750"/>
+            <a:ext cx="1666875" cy="247650"/>
+          </a:xfrm>
+          <a:prstGeom xmlns:a="http://schemas.openxmlformats.org/drawingml/2006/main" prst="rect">
+            <a:avLst/>
+          </a:prstGeom>
+          <a:noFill xmlns:a="http://schemas.openxmlformats.org/drawingml/2006/main"/>
+          <a:ln xmlns:a="http://schemas.openxmlformats.org/drawingml/2006/main" w="0">
+            <a:noFill/>
+            <a:prstDash val="solid"/>
+          </a:ln>
+        </p:spPr>
+        <p:txBody>
+          <a:bodyPr xmlns:a="http://schemas.openxmlformats.org/drawingml/2006/main"/>
+          <a:lstStyle xmlns:a="http://schemas.openxmlformats.org/drawingml/2006/main"/>
+          <a:p xmlns:a="http://schemas.openxmlformats.org/drawingml/2006/main">
+            <a:pPr algn="ctr">
+              <a:defRPr sz="1200" b="1">
+                <a:solidFill>
+                  <a:srgbClr val="667085"/>
+                </a:solidFill>
+              </a:defRPr>
+            </a:pPr>
+            <a:r>
+              <a:rPr sz="1200" b="1">
+                <a:solidFill>
+                  <a:srgbClr val="667085"/>
+                </a:solidFill>
+              </a:rPr>
+              <a:t>Product sale</a:t>
+            </a:r>
+          </a:p>
+        </p:txBody>
+      </p:sp>
       <p:sp>
         <p:nvSpPr>
           <p:cNvPr id="5" name="">
             <a:extLst xmlns:a="http://schemas.openxmlformats.org/drawingml/2006/main">
               <a:ext uri="{FF2B5EF4-FFF2-40B4-BE49-F238E27FC236}">
-                <a16:creationId xmlns:a16="http://schemas.microsoft.com/office/drawing/2014/main" id="{106BFBED-E3DC-4311-90CE-5F0BF7558169}"/>
-              </a:ext>
-            </a:extLst>
-          </p:cNvPr>
-          <p:cNvSpPr>
-            <a:spLocks xmlns:a="http://schemas.openxmlformats.org/drawingml/2006/main" noGrp="1"/>
-          </p:cNvSpPr>
-          <p:nvPr/>
-        </p:nvSpPr>
-        <p:spPr>
-          <a:xfrm xmlns:a="http://schemas.openxmlformats.org/drawingml/2006/main">
-            <a:off x="7524750" y="2133600"/>
-            <a:ext cx="3714750" cy="304800"/>
-          </a:xfrm>
-          <a:prstGeom xmlns:a="http://schemas.openxmlformats.org/drawingml/2006/main" prst="rect">
-            <a:avLst/>
-          </a:prstGeom>
-          <a:noFill xmlns:a="http://schemas.openxmlformats.org/drawingml/2006/main"/>
-          <a:ln xmlns:a="http://schemas.openxmlformats.org/drawingml/2006/main" w="0">
-            <a:noFill/>
-            <a:prstDash val="solid"/>
-          </a:ln>
-        </p:spPr>
-        <p:txBody>
-          <a:bodyPr xmlns:a="http://schemas.openxmlformats.org/drawingml/2006/main"/>
-          <a:lstStyle xmlns:a="http://schemas.openxmlformats.org/drawingml/2006/main"/>
-          <a:p xmlns:a="http://schemas.openxmlformats.org/drawingml/2006/main">
-            <a:pPr algn="l">
+                <a16:creationId xmlns:a16="http://schemas.microsoft.com/office/drawing/2014/main" id="{B8A659F8-4E9C-4369-80FB-A1D5971D91E7}"/>
+              </a:ext>
+            </a:extLst>
+          </p:cNvPr>
+          <p:cNvSpPr>
+            <a:spLocks xmlns:a="http://schemas.openxmlformats.org/drawingml/2006/main" noGrp="1"/>
+          </p:cNvSpPr>
+          <p:nvPr/>
+        </p:nvSpPr>
+        <p:spPr>
+          <a:xfrm xmlns:a="http://schemas.openxmlformats.org/drawingml/2006/main">
+            <a:off x="571500" y="2609850"/>
+            <a:ext cx="1666875" cy="400050"/>
+          </a:xfrm>
+          <a:prstGeom xmlns:a="http://schemas.openxmlformats.org/drawingml/2006/main" prst="rect">
+            <a:avLst/>
+          </a:prstGeom>
+          <a:noFill xmlns:a="http://schemas.openxmlformats.org/drawingml/2006/main"/>
+          <a:ln xmlns:a="http://schemas.openxmlformats.org/drawingml/2006/main" w="0">
+            <a:noFill/>
+            <a:prstDash val="solid"/>
+          </a:ln>
+        </p:spPr>
+        <p:txBody>
+          <a:bodyPr xmlns:a="http://schemas.openxmlformats.org/drawingml/2006/main"/>
+          <a:lstStyle xmlns:a="http://schemas.openxmlformats.org/drawingml/2006/main"/>
+          <a:p xmlns:a="http://schemas.openxmlformats.org/drawingml/2006/main">
+            <a:pPr algn="ctr">
+              <a:defRPr sz="2100" b="1">
+                <a:solidFill>
+                  <a:srgbClr val="0B2545"/>
+                </a:solidFill>
+              </a:defRPr>
+            </a:pPr>
+            <a:r>
+              <a:rPr sz="2100" b="1">
+                <a:solidFill>
+                  <a:srgbClr val="0B2545"/>
+                </a:solidFill>
+              </a:rPr>
+              <a:t>$42.99</a:t>
+            </a:r>
+          </a:p>
+        </p:txBody>
+      </p:sp>
+      <p:sp>
+        <p:nvSpPr>
+          <p:cNvPr id="6" name="">
+            <a:extLst xmlns:a="http://schemas.openxmlformats.org/drawingml/2006/main">
+              <a:ext uri="{FF2B5EF4-FFF2-40B4-BE49-F238E27FC236}">
+                <a16:creationId xmlns:a16="http://schemas.microsoft.com/office/drawing/2014/main" id="{946A6E07-BD38-4F17-9C7B-CBFACCCEE19E}"/>
+              </a:ext>
+            </a:extLst>
+          </p:cNvPr>
+          <p:cNvSpPr>
+            <a:spLocks xmlns:a="http://schemas.openxmlformats.org/drawingml/2006/main" noGrp="1"/>
+          </p:cNvSpPr>
+          <p:nvPr/>
+        </p:nvSpPr>
+        <p:spPr>
+          <a:xfrm xmlns:a="http://schemas.openxmlformats.org/drawingml/2006/main">
+            <a:off x="2266950" y="2667000"/>
+            <a:ext cx="266700" cy="190500"/>
+          </a:xfrm>
+          <a:prstGeom xmlns:a="http://schemas.openxmlformats.org/drawingml/2006/main" prst="rightArrow">
+            <a:avLst/>
+          </a:prstGeom>
+          <a:solidFill xmlns:a="http://schemas.openxmlformats.org/drawingml/2006/main">
+            <a:srgbClr val="2E74B5"/>
+          </a:solidFill>
+          <a:ln xmlns:a="http://schemas.openxmlformats.org/drawingml/2006/main" w="0">
+            <a:solidFill>
+              <a:srgbClr val="2E74B5"/>
+            </a:solidFill>
+            <a:prstDash val="solid"/>
+          </a:ln>
+        </p:spPr>
+      </p:sp>
+      <p:sp>
+        <p:nvSpPr>
+          <p:cNvPr id="7" name="">
+            <a:extLst xmlns:a="http://schemas.openxmlformats.org/drawingml/2006/main">
+              <a:ext uri="{FF2B5EF4-FFF2-40B4-BE49-F238E27FC236}">
+                <a16:creationId xmlns:a16="http://schemas.microsoft.com/office/drawing/2014/main" id="{A70612C4-8295-4680-BEB6-F622F66026A5}"/>
+              </a:ext>
+            </a:extLst>
+          </p:cNvPr>
+          <p:cNvSpPr>
+            <a:spLocks xmlns:a="http://schemas.openxmlformats.org/drawingml/2006/main" noGrp="1"/>
+          </p:cNvSpPr>
+          <p:nvPr/>
+        </p:nvSpPr>
+        <p:spPr>
+          <a:xfrm xmlns:a="http://schemas.openxmlformats.org/drawingml/2006/main">
+            <a:off x="2495550" y="2190750"/>
+            <a:ext cx="1666875" cy="247650"/>
+          </a:xfrm>
+          <a:prstGeom xmlns:a="http://schemas.openxmlformats.org/drawingml/2006/main" prst="rect">
+            <a:avLst/>
+          </a:prstGeom>
+          <a:noFill xmlns:a="http://schemas.openxmlformats.org/drawingml/2006/main"/>
+          <a:ln xmlns:a="http://schemas.openxmlformats.org/drawingml/2006/main" w="0">
+            <a:noFill/>
+            <a:prstDash val="solid"/>
+          </a:ln>
+        </p:spPr>
+        <p:txBody>
+          <a:bodyPr xmlns:a="http://schemas.openxmlformats.org/drawingml/2006/main"/>
+          <a:lstStyle xmlns:a="http://schemas.openxmlformats.org/drawingml/2006/main"/>
+          <a:p xmlns:a="http://schemas.openxmlformats.org/drawingml/2006/main">
+            <a:pPr algn="ctr">
+              <a:defRPr sz="1200" b="1">
+                <a:solidFill>
+                  <a:srgbClr val="667085"/>
+                </a:solidFill>
+              </a:defRPr>
+            </a:pPr>
+            <a:r>
+              <a:rPr sz="1200" b="1">
+                <a:solidFill>
+                  <a:srgbClr val="667085"/>
+                </a:solidFill>
+              </a:rPr>
+              <a:t>Promotion</a:t>
+            </a:r>
+          </a:p>
+        </p:txBody>
+      </p:sp>
+      <p:sp>
+        <p:nvSpPr>
+          <p:cNvPr id="8" name="">
+            <a:extLst xmlns:a="http://schemas.openxmlformats.org/drawingml/2006/main">
+              <a:ext uri="{FF2B5EF4-FFF2-40B4-BE49-F238E27FC236}">
+                <a16:creationId xmlns:a16="http://schemas.microsoft.com/office/drawing/2014/main" id="{47648A9F-5880-492E-B853-D8AD2D21F516}"/>
+              </a:ext>
+            </a:extLst>
+          </p:cNvPr>
+          <p:cNvSpPr>
+            <a:spLocks xmlns:a="http://schemas.openxmlformats.org/drawingml/2006/main" noGrp="1"/>
+          </p:cNvSpPr>
+          <p:nvPr/>
+        </p:nvSpPr>
+        <p:spPr>
+          <a:xfrm xmlns:a="http://schemas.openxmlformats.org/drawingml/2006/main">
+            <a:off x="2495550" y="2609850"/>
+            <a:ext cx="1666875" cy="400050"/>
+          </a:xfrm>
+          <a:prstGeom xmlns:a="http://schemas.openxmlformats.org/drawingml/2006/main" prst="rect">
+            <a:avLst/>
+          </a:prstGeom>
+          <a:noFill xmlns:a="http://schemas.openxmlformats.org/drawingml/2006/main"/>
+          <a:ln xmlns:a="http://schemas.openxmlformats.org/drawingml/2006/main" w="0">
+            <a:noFill/>
+            <a:prstDash val="solid"/>
+          </a:ln>
+        </p:spPr>
+        <p:txBody>
+          <a:bodyPr xmlns:a="http://schemas.openxmlformats.org/drawingml/2006/main"/>
+          <a:lstStyle xmlns:a="http://schemas.openxmlformats.org/drawingml/2006/main"/>
+          <a:p xmlns:a="http://schemas.openxmlformats.org/drawingml/2006/main">
+            <a:pPr algn="ctr">
+              <a:defRPr sz="2100" b="1">
+                <a:solidFill>
+                  <a:srgbClr val="B42318"/>
+                </a:solidFill>
+              </a:defRPr>
+            </a:pPr>
+            <a:r>
+              <a:rPr sz="2100" b="1">
+                <a:solidFill>
+                  <a:srgbClr val="B42318"/>
+                </a:solidFill>
+              </a:rPr>
+              <a:t>($4.30)</a:t>
+            </a:r>
+          </a:p>
+        </p:txBody>
+      </p:sp>
+      <p:sp>
+        <p:nvSpPr>
+          <p:cNvPr id="9" name="">
+            <a:extLst xmlns:a="http://schemas.openxmlformats.org/drawingml/2006/main">
+              <a:ext uri="{FF2B5EF4-FFF2-40B4-BE49-F238E27FC236}">
+                <a16:creationId xmlns:a16="http://schemas.microsoft.com/office/drawing/2014/main" id="{32E3F0C4-CDFF-4660-A9EC-6CB2CBDA49D0}"/>
+              </a:ext>
+            </a:extLst>
+          </p:cNvPr>
+          <p:cNvSpPr>
+            <a:spLocks xmlns:a="http://schemas.openxmlformats.org/drawingml/2006/main" noGrp="1"/>
+          </p:cNvSpPr>
+          <p:nvPr/>
+        </p:nvSpPr>
+        <p:spPr>
+          <a:xfrm xmlns:a="http://schemas.openxmlformats.org/drawingml/2006/main">
+            <a:off x="4191000" y="2667000"/>
+            <a:ext cx="266700" cy="190500"/>
+          </a:xfrm>
+          <a:prstGeom xmlns:a="http://schemas.openxmlformats.org/drawingml/2006/main" prst="rightArrow">
+            <a:avLst/>
+          </a:prstGeom>
+          <a:solidFill xmlns:a="http://schemas.openxmlformats.org/drawingml/2006/main">
+            <a:srgbClr val="2E74B5"/>
+          </a:solidFill>
+          <a:ln xmlns:a="http://schemas.openxmlformats.org/drawingml/2006/main" w="0">
+            <a:solidFill>
+              <a:srgbClr val="2E74B5"/>
+            </a:solidFill>
+            <a:prstDash val="solid"/>
+          </a:ln>
+        </p:spPr>
+      </p:sp>
+      <p:sp>
+        <p:nvSpPr>
+          <p:cNvPr id="10" name="">
+            <a:extLst xmlns:a="http://schemas.openxmlformats.org/drawingml/2006/main">
+              <a:ext uri="{FF2B5EF4-FFF2-40B4-BE49-F238E27FC236}">
+                <a16:creationId xmlns:a16="http://schemas.microsoft.com/office/drawing/2014/main" id="{5CFEB44C-91F5-4E9A-87DE-AF3FDD4252B9}"/>
+              </a:ext>
+            </a:extLst>
+          </p:cNvPr>
+          <p:cNvSpPr>
+            <a:spLocks xmlns:a="http://schemas.openxmlformats.org/drawingml/2006/main" noGrp="1"/>
+          </p:cNvSpPr>
+          <p:nvPr/>
+        </p:nvSpPr>
+        <p:spPr>
+          <a:xfrm xmlns:a="http://schemas.openxmlformats.org/drawingml/2006/main">
+            <a:off x="4419600" y="2190750"/>
+            <a:ext cx="1666875" cy="247650"/>
+          </a:xfrm>
+          <a:prstGeom xmlns:a="http://schemas.openxmlformats.org/drawingml/2006/main" prst="rect">
+            <a:avLst/>
+          </a:prstGeom>
+          <a:noFill xmlns:a="http://schemas.openxmlformats.org/drawingml/2006/main"/>
+          <a:ln xmlns:a="http://schemas.openxmlformats.org/drawingml/2006/main" w="0">
+            <a:noFill/>
+            <a:prstDash val="solid"/>
+          </a:ln>
+        </p:spPr>
+        <p:txBody>
+          <a:bodyPr xmlns:a="http://schemas.openxmlformats.org/drawingml/2006/main"/>
+          <a:lstStyle xmlns:a="http://schemas.openxmlformats.org/drawingml/2006/main"/>
+          <a:p xmlns:a="http://schemas.openxmlformats.org/drawingml/2006/main">
+            <a:pPr algn="ctr">
+              <a:defRPr sz="1200" b="1">
+                <a:solidFill>
+                  <a:srgbClr val="667085"/>
+                </a:solidFill>
+              </a:defRPr>
+            </a:pPr>
+            <a:r>
+              <a:rPr sz="1200" b="1">
+                <a:solidFill>
+                  <a:srgbClr val="667085"/>
+                </a:solidFill>
+              </a:rPr>
+              <a:t>Referral</a:t>
+            </a:r>
+          </a:p>
+        </p:txBody>
+      </p:sp>
+      <p:sp>
+        <p:nvSpPr>
+          <p:cNvPr id="11" name="">
+            <a:extLst xmlns:a="http://schemas.openxmlformats.org/drawingml/2006/main">
+              <a:ext uri="{FF2B5EF4-FFF2-40B4-BE49-F238E27FC236}">
+                <a16:creationId xmlns:a16="http://schemas.microsoft.com/office/drawing/2014/main" id="{21A6805F-A4F7-4FAC-B4FE-AD732BC36209}"/>
+              </a:ext>
+            </a:extLst>
+          </p:cNvPr>
+          <p:cNvSpPr>
+            <a:spLocks xmlns:a="http://schemas.openxmlformats.org/drawingml/2006/main" noGrp="1"/>
+          </p:cNvSpPr>
+          <p:nvPr/>
+        </p:nvSpPr>
+        <p:spPr>
+          <a:xfrm xmlns:a="http://schemas.openxmlformats.org/drawingml/2006/main">
+            <a:off x="4419600" y="2609850"/>
+            <a:ext cx="1666875" cy="400050"/>
+          </a:xfrm>
+          <a:prstGeom xmlns:a="http://schemas.openxmlformats.org/drawingml/2006/main" prst="rect">
+            <a:avLst/>
+          </a:prstGeom>
+          <a:noFill xmlns:a="http://schemas.openxmlformats.org/drawingml/2006/main"/>
+          <a:ln xmlns:a="http://schemas.openxmlformats.org/drawingml/2006/main" w="0">
+            <a:noFill/>
+            <a:prstDash val="solid"/>
+          </a:ln>
+        </p:spPr>
+        <p:txBody>
+          <a:bodyPr xmlns:a="http://schemas.openxmlformats.org/drawingml/2006/main"/>
+          <a:lstStyle xmlns:a="http://schemas.openxmlformats.org/drawingml/2006/main"/>
+          <a:p xmlns:a="http://schemas.openxmlformats.org/drawingml/2006/main">
+            <a:pPr algn="ctr">
+              <a:defRPr sz="2100" b="1">
+                <a:solidFill>
+                  <a:srgbClr val="B42318"/>
+                </a:solidFill>
+              </a:defRPr>
+            </a:pPr>
+            <a:r>
+              <a:rPr sz="2100" b="1">
+                <a:solidFill>
+                  <a:srgbClr val="B42318"/>
+                </a:solidFill>
+              </a:rPr>
+              <a:t>($5.80)</a:t>
+            </a:r>
+          </a:p>
+        </p:txBody>
+      </p:sp>
+      <p:sp>
+        <p:nvSpPr>
+          <p:cNvPr id="12" name="">
+            <a:extLst xmlns:a="http://schemas.openxmlformats.org/drawingml/2006/main">
+              <a:ext uri="{FF2B5EF4-FFF2-40B4-BE49-F238E27FC236}">
+                <a16:creationId xmlns:a16="http://schemas.microsoft.com/office/drawing/2014/main" id="{03F6DF96-BF20-4FCB-AEFC-032081216F50}"/>
+              </a:ext>
+            </a:extLst>
+          </p:cNvPr>
+          <p:cNvSpPr>
+            <a:spLocks xmlns:a="http://schemas.openxmlformats.org/drawingml/2006/main" noGrp="1"/>
+          </p:cNvSpPr>
+          <p:nvPr/>
+        </p:nvSpPr>
+        <p:spPr>
+          <a:xfrm xmlns:a="http://schemas.openxmlformats.org/drawingml/2006/main">
+            <a:off x="6115050" y="2667000"/>
+            <a:ext cx="266700" cy="190500"/>
+          </a:xfrm>
+          <a:prstGeom xmlns:a="http://schemas.openxmlformats.org/drawingml/2006/main" prst="rightArrow">
+            <a:avLst/>
+          </a:prstGeom>
+          <a:solidFill xmlns:a="http://schemas.openxmlformats.org/drawingml/2006/main">
+            <a:srgbClr val="2E74B5"/>
+          </a:solidFill>
+          <a:ln xmlns:a="http://schemas.openxmlformats.org/drawingml/2006/main" w="0">
+            <a:solidFill>
+              <a:srgbClr val="2E74B5"/>
+            </a:solidFill>
+            <a:prstDash val="solid"/>
+          </a:ln>
+        </p:spPr>
+      </p:sp>
+      <p:sp>
+        <p:nvSpPr>
+          <p:cNvPr id="13" name="">
+            <a:extLst xmlns:a="http://schemas.openxmlformats.org/drawingml/2006/main">
+              <a:ext uri="{FF2B5EF4-FFF2-40B4-BE49-F238E27FC236}">
+                <a16:creationId xmlns:a16="http://schemas.microsoft.com/office/drawing/2014/main" id="{B3F6AF7C-F07D-4900-BC41-124ADADF1A8F}"/>
+              </a:ext>
+            </a:extLst>
+          </p:cNvPr>
+          <p:cNvSpPr>
+            <a:spLocks xmlns:a="http://schemas.openxmlformats.org/drawingml/2006/main" noGrp="1"/>
+          </p:cNvSpPr>
+          <p:nvPr/>
+        </p:nvSpPr>
+        <p:spPr>
+          <a:xfrm xmlns:a="http://schemas.openxmlformats.org/drawingml/2006/main">
+            <a:off x="6343650" y="2190750"/>
+            <a:ext cx="1666875" cy="247650"/>
+          </a:xfrm>
+          <a:prstGeom xmlns:a="http://schemas.openxmlformats.org/drawingml/2006/main" prst="rect">
+            <a:avLst/>
+          </a:prstGeom>
+          <a:noFill xmlns:a="http://schemas.openxmlformats.org/drawingml/2006/main"/>
+          <a:ln xmlns:a="http://schemas.openxmlformats.org/drawingml/2006/main" w="0">
+            <a:noFill/>
+            <a:prstDash val="solid"/>
+          </a:ln>
+        </p:spPr>
+        <p:txBody>
+          <a:bodyPr xmlns:a="http://schemas.openxmlformats.org/drawingml/2006/main"/>
+          <a:lstStyle xmlns:a="http://schemas.openxmlformats.org/drawingml/2006/main"/>
+          <a:p xmlns:a="http://schemas.openxmlformats.org/drawingml/2006/main">
+            <a:pPr algn="ctr">
+              <a:defRPr sz="1200" b="1">
+                <a:solidFill>
+                  <a:srgbClr val="667085"/>
+                </a:solidFill>
+              </a:defRPr>
+            </a:pPr>
+            <a:r>
+              <a:rPr sz="1200" b="1">
+                <a:solidFill>
+                  <a:srgbClr val="667085"/>
+                </a:solidFill>
+              </a:rPr>
+              <a:t>FBA fulfill.</a:t>
+            </a:r>
+          </a:p>
+        </p:txBody>
+      </p:sp>
+      <p:sp>
+        <p:nvSpPr>
+          <p:cNvPr id="14" name="">
+            <a:extLst xmlns:a="http://schemas.openxmlformats.org/drawingml/2006/main">
+              <a:ext uri="{FF2B5EF4-FFF2-40B4-BE49-F238E27FC236}">
+                <a16:creationId xmlns:a16="http://schemas.microsoft.com/office/drawing/2014/main" id="{D11988EB-D41A-4A0E-B2C7-224C5E514C02}"/>
+              </a:ext>
+            </a:extLst>
+          </p:cNvPr>
+          <p:cNvSpPr>
+            <a:spLocks xmlns:a="http://schemas.openxmlformats.org/drawingml/2006/main" noGrp="1"/>
+          </p:cNvSpPr>
+          <p:nvPr/>
+        </p:nvSpPr>
+        <p:spPr>
+          <a:xfrm xmlns:a="http://schemas.openxmlformats.org/drawingml/2006/main">
+            <a:off x="6343650" y="2609850"/>
+            <a:ext cx="1666875" cy="400050"/>
+          </a:xfrm>
+          <a:prstGeom xmlns:a="http://schemas.openxmlformats.org/drawingml/2006/main" prst="rect">
+            <a:avLst/>
+          </a:prstGeom>
+          <a:noFill xmlns:a="http://schemas.openxmlformats.org/drawingml/2006/main"/>
+          <a:ln xmlns:a="http://schemas.openxmlformats.org/drawingml/2006/main" w="0">
+            <a:noFill/>
+            <a:prstDash val="solid"/>
+          </a:ln>
+        </p:spPr>
+        <p:txBody>
+          <a:bodyPr xmlns:a="http://schemas.openxmlformats.org/drawingml/2006/main"/>
+          <a:lstStyle xmlns:a="http://schemas.openxmlformats.org/drawingml/2006/main"/>
+          <a:p xmlns:a="http://schemas.openxmlformats.org/drawingml/2006/main">
+            <a:pPr algn="ctr">
+              <a:defRPr sz="2100" b="1">
+                <a:solidFill>
+                  <a:srgbClr val="B42318"/>
+                </a:solidFill>
+              </a:defRPr>
+            </a:pPr>
+            <a:r>
+              <a:rPr sz="2100" b="1">
+                <a:solidFill>
+                  <a:srgbClr val="B42318"/>
+                </a:solidFill>
+              </a:rPr>
+              <a:t>($12.40)</a:t>
+            </a:r>
+          </a:p>
+        </p:txBody>
+      </p:sp>
+      <p:sp>
+        <p:nvSpPr>
+          <p:cNvPr id="15" name="">
+            <a:extLst xmlns:a="http://schemas.openxmlformats.org/drawingml/2006/main">
+              <a:ext uri="{FF2B5EF4-FFF2-40B4-BE49-F238E27FC236}">
+                <a16:creationId xmlns:a16="http://schemas.microsoft.com/office/drawing/2014/main" id="{6AD9E4B5-3314-4A1A-B72C-A9C1BCDC0F2B}"/>
+              </a:ext>
+            </a:extLst>
+          </p:cNvPr>
+          <p:cNvSpPr>
+            <a:spLocks xmlns:a="http://schemas.openxmlformats.org/drawingml/2006/main" noGrp="1"/>
+          </p:cNvSpPr>
+          <p:nvPr/>
+        </p:nvSpPr>
+        <p:spPr>
+          <a:xfrm xmlns:a="http://schemas.openxmlformats.org/drawingml/2006/main">
+            <a:off x="8039100" y="2667000"/>
+            <a:ext cx="266700" cy="190500"/>
+          </a:xfrm>
+          <a:prstGeom xmlns:a="http://schemas.openxmlformats.org/drawingml/2006/main" prst="rightArrow">
+            <a:avLst/>
+          </a:prstGeom>
+          <a:solidFill xmlns:a="http://schemas.openxmlformats.org/drawingml/2006/main">
+            <a:srgbClr val="2E74B5"/>
+          </a:solidFill>
+          <a:ln xmlns:a="http://schemas.openxmlformats.org/drawingml/2006/main" w="0">
+            <a:solidFill>
+              <a:srgbClr val="2E74B5"/>
+            </a:solidFill>
+            <a:prstDash val="solid"/>
+          </a:ln>
+        </p:spPr>
+      </p:sp>
+      <p:sp>
+        <p:nvSpPr>
+          <p:cNvPr id="16" name="">
+            <a:extLst xmlns:a="http://schemas.openxmlformats.org/drawingml/2006/main">
+              <a:ext uri="{FF2B5EF4-FFF2-40B4-BE49-F238E27FC236}">
+                <a16:creationId xmlns:a16="http://schemas.microsoft.com/office/drawing/2014/main" id="{260E404A-CCD2-4DA2-A846-D67FB1333452}"/>
+              </a:ext>
+            </a:extLst>
+          </p:cNvPr>
+          <p:cNvSpPr>
+            <a:spLocks xmlns:a="http://schemas.openxmlformats.org/drawingml/2006/main" noGrp="1"/>
+          </p:cNvSpPr>
+          <p:nvPr/>
+        </p:nvSpPr>
+        <p:spPr>
+          <a:xfrm xmlns:a="http://schemas.openxmlformats.org/drawingml/2006/main">
+            <a:off x="8267700" y="2190750"/>
+            <a:ext cx="1666875" cy="247650"/>
+          </a:xfrm>
+          <a:prstGeom xmlns:a="http://schemas.openxmlformats.org/drawingml/2006/main" prst="rect">
+            <a:avLst/>
+          </a:prstGeom>
+          <a:noFill xmlns:a="http://schemas.openxmlformats.org/drawingml/2006/main"/>
+          <a:ln xmlns:a="http://schemas.openxmlformats.org/drawingml/2006/main" w="0">
+            <a:noFill/>
+            <a:prstDash val="solid"/>
+          </a:ln>
+        </p:spPr>
+        <p:txBody>
+          <a:bodyPr xmlns:a="http://schemas.openxmlformats.org/drawingml/2006/main"/>
+          <a:lstStyle xmlns:a="http://schemas.openxmlformats.org/drawingml/2006/main"/>
+          <a:p xmlns:a="http://schemas.openxmlformats.org/drawingml/2006/main">
+            <a:pPr algn="ctr">
+              <a:defRPr sz="1200" b="1">
+                <a:solidFill>
+                  <a:srgbClr val="667085"/>
+                </a:solidFill>
+              </a:defRPr>
+            </a:pPr>
+            <a:r>
+              <a:rPr sz="1200" b="1">
+                <a:solidFill>
+                  <a:srgbClr val="667085"/>
+                </a:solidFill>
+              </a:rPr>
+              <a:t>Landed COGS</a:t>
+            </a:r>
+          </a:p>
+        </p:txBody>
+      </p:sp>
+      <p:sp>
+        <p:nvSpPr>
+          <p:cNvPr id="17" name="">
+            <a:extLst xmlns:a="http://schemas.openxmlformats.org/drawingml/2006/main">
+              <a:ext uri="{FF2B5EF4-FFF2-40B4-BE49-F238E27FC236}">
+                <a16:creationId xmlns:a16="http://schemas.microsoft.com/office/drawing/2014/main" id="{3F75848E-AAB9-49E2-B6F0-AE9BA4ABC5D6}"/>
+              </a:ext>
+            </a:extLst>
+          </p:cNvPr>
+          <p:cNvSpPr>
+            <a:spLocks xmlns:a="http://schemas.openxmlformats.org/drawingml/2006/main" noGrp="1"/>
+          </p:cNvSpPr>
+          <p:nvPr/>
+        </p:nvSpPr>
+        <p:spPr>
+          <a:xfrm xmlns:a="http://schemas.openxmlformats.org/drawingml/2006/main">
+            <a:off x="8267700" y="2609850"/>
+            <a:ext cx="1666875" cy="400050"/>
+          </a:xfrm>
+          <a:prstGeom xmlns:a="http://schemas.openxmlformats.org/drawingml/2006/main" prst="rect">
+            <a:avLst/>
+          </a:prstGeom>
+          <a:noFill xmlns:a="http://schemas.openxmlformats.org/drawingml/2006/main"/>
+          <a:ln xmlns:a="http://schemas.openxmlformats.org/drawingml/2006/main" w="0">
+            <a:noFill/>
+            <a:prstDash val="solid"/>
+          </a:ln>
+        </p:spPr>
+        <p:txBody>
+          <a:bodyPr xmlns:a="http://schemas.openxmlformats.org/drawingml/2006/main"/>
+          <a:lstStyle xmlns:a="http://schemas.openxmlformats.org/drawingml/2006/main"/>
+          <a:p xmlns:a="http://schemas.openxmlformats.org/drawingml/2006/main">
+            <a:pPr algn="ctr">
+              <a:defRPr sz="2100" b="1">
+                <a:solidFill>
+                  <a:srgbClr val="B42318"/>
+                </a:solidFill>
+              </a:defRPr>
+            </a:pPr>
+            <a:r>
+              <a:rPr sz="2100" b="1">
+                <a:solidFill>
+                  <a:srgbClr val="B42318"/>
+                </a:solidFill>
+              </a:rPr>
+              <a:t>($19.70)</a:t>
+            </a:r>
+          </a:p>
+        </p:txBody>
+      </p:sp>
+      <p:sp>
+        <p:nvSpPr>
+          <p:cNvPr id="18" name="">
+            <a:extLst xmlns:a="http://schemas.openxmlformats.org/drawingml/2006/main">
+              <a:ext uri="{FF2B5EF4-FFF2-40B4-BE49-F238E27FC236}">
+                <a16:creationId xmlns:a16="http://schemas.microsoft.com/office/drawing/2014/main" id="{7769B10A-D073-4BFC-B751-225882B8DD2E}"/>
+              </a:ext>
+            </a:extLst>
+          </p:cNvPr>
+          <p:cNvSpPr>
+            <a:spLocks xmlns:a="http://schemas.openxmlformats.org/drawingml/2006/main" noGrp="1"/>
+          </p:cNvSpPr>
+          <p:nvPr/>
+        </p:nvSpPr>
+        <p:spPr>
+          <a:xfrm xmlns:a="http://schemas.openxmlformats.org/drawingml/2006/main">
+            <a:off x="9963150" y="2667000"/>
+            <a:ext cx="266700" cy="190500"/>
+          </a:xfrm>
+          <a:prstGeom xmlns:a="http://schemas.openxmlformats.org/drawingml/2006/main" prst="rightArrow">
+            <a:avLst/>
+          </a:prstGeom>
+          <a:solidFill xmlns:a="http://schemas.openxmlformats.org/drawingml/2006/main">
+            <a:srgbClr val="2E74B5"/>
+          </a:solidFill>
+          <a:ln xmlns:a="http://schemas.openxmlformats.org/drawingml/2006/main" w="0">
+            <a:solidFill>
+              <a:srgbClr val="2E74B5"/>
+            </a:solidFill>
+            <a:prstDash val="solid"/>
+          </a:ln>
+        </p:spPr>
+      </p:sp>
+      <p:sp>
+        <p:nvSpPr>
+          <p:cNvPr id="19" name="">
+            <a:extLst xmlns:a="http://schemas.openxmlformats.org/drawingml/2006/main">
+              <a:ext uri="{FF2B5EF4-FFF2-40B4-BE49-F238E27FC236}">
+                <a16:creationId xmlns:a16="http://schemas.microsoft.com/office/drawing/2014/main" id="{DDC9C512-72FC-43B1-8B2D-BAC651D5C9B9}"/>
+              </a:ext>
+            </a:extLst>
+          </p:cNvPr>
+          <p:cNvSpPr>
+            <a:spLocks xmlns:a="http://schemas.openxmlformats.org/drawingml/2006/main" noGrp="1"/>
+          </p:cNvSpPr>
+          <p:nvPr/>
+        </p:nvSpPr>
+        <p:spPr>
+          <a:xfrm xmlns:a="http://schemas.openxmlformats.org/drawingml/2006/main">
+            <a:off x="10191750" y="2190750"/>
+            <a:ext cx="1666875" cy="247650"/>
+          </a:xfrm>
+          <a:prstGeom xmlns:a="http://schemas.openxmlformats.org/drawingml/2006/main" prst="rect">
+            <a:avLst/>
+          </a:prstGeom>
+          <a:noFill xmlns:a="http://schemas.openxmlformats.org/drawingml/2006/main"/>
+          <a:ln xmlns:a="http://schemas.openxmlformats.org/drawingml/2006/main" w="0">
+            <a:noFill/>
+            <a:prstDash val="solid"/>
+          </a:ln>
+        </p:spPr>
+        <p:txBody>
+          <a:bodyPr xmlns:a="http://schemas.openxmlformats.org/drawingml/2006/main"/>
+          <a:lstStyle xmlns:a="http://schemas.openxmlformats.org/drawingml/2006/main"/>
+          <a:p xmlns:a="http://schemas.openxmlformats.org/drawingml/2006/main">
+            <a:pPr algn="ctr">
+              <a:defRPr sz="1200" b="1">
+                <a:solidFill>
+                  <a:srgbClr val="667085"/>
+                </a:solidFill>
+              </a:defRPr>
+            </a:pPr>
+            <a:r>
+              <a:rPr sz="1200" b="1">
+                <a:solidFill>
+                  <a:srgbClr val="667085"/>
+                </a:solidFill>
+              </a:rPr>
+              <a:t>CM</a:t>
+            </a:r>
+          </a:p>
+        </p:txBody>
+      </p:sp>
+      <p:sp>
+        <p:nvSpPr>
+          <p:cNvPr id="20" name="">
+            <a:extLst xmlns:a="http://schemas.openxmlformats.org/drawingml/2006/main">
+              <a:ext uri="{FF2B5EF4-FFF2-40B4-BE49-F238E27FC236}">
+                <a16:creationId xmlns:a16="http://schemas.microsoft.com/office/drawing/2014/main" id="{5D61E13A-176C-478F-B91F-499F6F3D5069}"/>
+              </a:ext>
+            </a:extLst>
+          </p:cNvPr>
+          <p:cNvSpPr>
+            <a:spLocks xmlns:a="http://schemas.openxmlformats.org/drawingml/2006/main" noGrp="1"/>
+          </p:cNvSpPr>
+          <p:nvPr/>
+        </p:nvSpPr>
+        <p:spPr>
+          <a:xfrm xmlns:a="http://schemas.openxmlformats.org/drawingml/2006/main">
+            <a:off x="10191750" y="2609850"/>
+            <a:ext cx="1666875" cy="400050"/>
+          </a:xfrm>
+          <a:prstGeom xmlns:a="http://schemas.openxmlformats.org/drawingml/2006/main" prst="rect">
+            <a:avLst/>
+          </a:prstGeom>
+          <a:noFill xmlns:a="http://schemas.openxmlformats.org/drawingml/2006/main"/>
+          <a:ln xmlns:a="http://schemas.openxmlformats.org/drawingml/2006/main" w="0">
+            <a:noFill/>
+            <a:prstDash val="solid"/>
+          </a:ln>
+        </p:spPr>
+        <p:txBody>
+          <a:bodyPr xmlns:a="http://schemas.openxmlformats.org/drawingml/2006/main"/>
+          <a:lstStyle xmlns:a="http://schemas.openxmlformats.org/drawingml/2006/main"/>
+          <a:p xmlns:a="http://schemas.openxmlformats.org/drawingml/2006/main">
+            <a:pPr algn="ctr">
+              <a:defRPr sz="2100" b="1">
+                <a:solidFill>
+                  <a:srgbClr val="0B7A53"/>
+                </a:solidFill>
+              </a:defRPr>
+            </a:pPr>
+            <a:r>
+              <a:rPr sz="2100" b="1">
+                <a:solidFill>
+                  <a:srgbClr val="0B7A53"/>
+                </a:solidFill>
+              </a:rPr>
+              <a:t>$0.79</a:t>
+            </a:r>
+          </a:p>
+        </p:txBody>
+      </p:sp>
+      <p:sp>
+        <p:nvSpPr>
+          <p:cNvPr id="21" name="">
+            <a:extLst xmlns:a="http://schemas.openxmlformats.org/drawingml/2006/main">
+              <a:ext uri="{FF2B5EF4-FFF2-40B4-BE49-F238E27FC236}">
+                <a16:creationId xmlns:a16="http://schemas.microsoft.com/office/drawing/2014/main" id="{0B44F6C2-07E4-49A9-B662-8BD778C29EE3}"/>
+              </a:ext>
+            </a:extLst>
+          </p:cNvPr>
+          <p:cNvSpPr>
+            <a:spLocks xmlns:a="http://schemas.openxmlformats.org/drawingml/2006/main" noGrp="1"/>
+          </p:cNvSpPr>
+          <p:nvPr/>
+        </p:nvSpPr>
+        <p:spPr>
+          <a:xfrm xmlns:a="http://schemas.openxmlformats.org/drawingml/2006/main">
+            <a:off x="685800" y="3714750"/>
+            <a:ext cx="10820400" cy="304800"/>
+          </a:xfrm>
+          <a:prstGeom xmlns:a="http://schemas.openxmlformats.org/drawingml/2006/main" prst="rect">
+            <a:avLst/>
+          </a:prstGeom>
+          <a:noFill xmlns:a="http://schemas.openxmlformats.org/drawingml/2006/main"/>
+          <a:ln xmlns:a="http://schemas.openxmlformats.org/drawingml/2006/main" w="0">
+            <a:noFill/>
+            <a:prstDash val="solid"/>
+          </a:ln>
+        </p:spPr>
+        <p:txBody>
+          <a:bodyPr xmlns:a="http://schemas.openxmlformats.org/drawingml/2006/main"/>
+          <a:lstStyle xmlns:a="http://schemas.openxmlformats.org/drawingml/2006/main"/>
+          <a:p xmlns:a="http://schemas.openxmlformats.org/drawingml/2006/main">
+            <a:pPr algn="ctr">
               <a:defRPr sz="1500" b="1">
                 <a:solidFill>
                   <a:srgbClr val="2E74B5"/>
@@ -8429,317 +10225,134 @@
                   <a:srgbClr val="2E74B5"/>
                 </a:solidFill>
               </a:rPr>
-              <a:t>Products to investigate</a:t>
-            </a:r>
-          </a:p>
-        </p:txBody>
-      </p:sp>
-      <p:sp>
-        <p:nvSpPr>
-          <p:cNvPr id="6" name="">
-            <a:extLst xmlns:a="http://schemas.openxmlformats.org/drawingml/2006/main">
-              <a:ext uri="{FF2B5EF4-FFF2-40B4-BE49-F238E27FC236}">
-                <a16:creationId xmlns:a16="http://schemas.microsoft.com/office/drawing/2014/main" id="{09673B9B-854A-4854-8C2B-0A249FC49990}"/>
-              </a:ext>
-            </a:extLst>
-          </p:cNvPr>
-          <p:cNvSpPr>
-            <a:spLocks xmlns:a="http://schemas.openxmlformats.org/drawingml/2006/main" noGrp="1"/>
-          </p:cNvSpPr>
-          <p:nvPr/>
-        </p:nvSpPr>
-        <p:spPr>
-          <a:xfrm xmlns:a="http://schemas.openxmlformats.org/drawingml/2006/main">
-            <a:off x="7524750" y="2647950"/>
-            <a:ext cx="3714750" cy="381000"/>
-          </a:xfrm>
-          <a:prstGeom xmlns:a="http://schemas.openxmlformats.org/drawingml/2006/main" prst="rect">
-            <a:avLst/>
-          </a:prstGeom>
-          <a:noFill xmlns:a="http://schemas.openxmlformats.org/drawingml/2006/main"/>
-          <a:ln xmlns:a="http://schemas.openxmlformats.org/drawingml/2006/main" w="0">
-            <a:noFill/>
-            <a:prstDash val="solid"/>
-          </a:ln>
-        </p:spPr>
-        <p:txBody>
-          <a:bodyPr xmlns:a="http://schemas.openxmlformats.org/drawingml/2006/main"/>
-          <a:lstStyle xmlns:a="http://schemas.openxmlformats.org/drawingml/2006/main"/>
-          <a:p xmlns:a="http://schemas.openxmlformats.org/drawingml/2006/main">
-            <a:pPr algn="l">
-              <a:defRPr sz="1800" b="1">
+              <a:t>PawHaus Orthopedic Dog Bed • Order 114-1003986-4269335</a:t>
+            </a:r>
+          </a:p>
+        </p:txBody>
+      </p:sp>
+      <p:sp>
+        <p:nvSpPr>
+          <p:cNvPr id="22" name="">
+            <a:extLst xmlns:a="http://schemas.openxmlformats.org/drawingml/2006/main">
+              <a:ext uri="{FF2B5EF4-FFF2-40B4-BE49-F238E27FC236}">
+                <a16:creationId xmlns:a16="http://schemas.microsoft.com/office/drawing/2014/main" id="{38076F68-0EA2-4E71-B253-2DE78A158E5D}"/>
+              </a:ext>
+            </a:extLst>
+          </p:cNvPr>
+          <p:cNvSpPr>
+            <a:spLocks xmlns:a="http://schemas.openxmlformats.org/drawingml/2006/main" noGrp="1"/>
+          </p:cNvSpPr>
+          <p:nvPr/>
+        </p:nvSpPr>
+        <p:spPr>
+          <a:xfrm xmlns:a="http://schemas.openxmlformats.org/drawingml/2006/main">
+            <a:off x="1524000" y="4305300"/>
+            <a:ext cx="9144000" cy="590550"/>
+          </a:xfrm>
+          <a:prstGeom xmlns:a="http://schemas.openxmlformats.org/drawingml/2006/main" prst="rect">
+            <a:avLst/>
+          </a:prstGeom>
+          <a:noFill xmlns:a="http://schemas.openxmlformats.org/drawingml/2006/main"/>
+          <a:ln xmlns:a="http://schemas.openxmlformats.org/drawingml/2006/main" w="0">
+            <a:noFill/>
+            <a:prstDash val="solid"/>
+          </a:ln>
+        </p:spPr>
+        <p:txBody>
+          <a:bodyPr xmlns:a="http://schemas.openxmlformats.org/drawingml/2006/main"/>
+          <a:lstStyle xmlns:a="http://schemas.openxmlformats.org/drawingml/2006/main"/>
+          <a:p xmlns:a="http://schemas.openxmlformats.org/drawingml/2006/main">
+            <a:pPr algn="ctr">
+              <a:defRPr sz="1650" b="1">
                 <a:solidFill>
                   <a:srgbClr val="0B2545"/>
                 </a:solidFill>
               </a:defRPr>
             </a:pPr>
             <a:r>
-              <a:rPr sz="1800" b="1">
+              <a:rPr sz="1650" b="1">
                 <a:solidFill>
                   <a:srgbClr val="0B2545"/>
                 </a:solidFill>
               </a:rPr>
-              <a:t>GT-MASK-CLAY  •  10.7%</a:t>
-            </a:r>
-          </a:p>
-        </p:txBody>
-      </p:sp>
-      <p:sp>
-        <p:nvSpPr>
-          <p:cNvPr id="7" name="">
-            <a:extLst xmlns:a="http://schemas.openxmlformats.org/drawingml/2006/main">
-              <a:ext uri="{FF2B5EF4-FFF2-40B4-BE49-F238E27FC236}">
-                <a16:creationId xmlns:a16="http://schemas.microsoft.com/office/drawing/2014/main" id="{B7065DA7-5758-4224-8025-19AA26F16D33}"/>
-              </a:ext>
-            </a:extLst>
-          </p:cNvPr>
-          <p:cNvSpPr>
-            <a:spLocks xmlns:a="http://schemas.openxmlformats.org/drawingml/2006/main" noGrp="1"/>
-          </p:cNvSpPr>
-          <p:nvPr/>
-        </p:nvSpPr>
-        <p:spPr>
-          <a:xfrm xmlns:a="http://schemas.openxmlformats.org/drawingml/2006/main">
-            <a:off x="7524750" y="3067050"/>
-            <a:ext cx="3714750" cy="457200"/>
-          </a:xfrm>
-          <a:prstGeom xmlns:a="http://schemas.openxmlformats.org/drawingml/2006/main" prst="rect">
-            <a:avLst/>
-          </a:prstGeom>
-          <a:noFill xmlns:a="http://schemas.openxmlformats.org/drawingml/2006/main"/>
-          <a:ln xmlns:a="http://schemas.openxmlformats.org/drawingml/2006/main" w="0">
-            <a:noFill/>
-            <a:prstDash val="solid"/>
-          </a:ln>
-        </p:spPr>
-        <p:txBody>
-          <a:bodyPr xmlns:a="http://schemas.openxmlformats.org/drawingml/2006/main"/>
-          <a:lstStyle xmlns:a="http://schemas.openxmlformats.org/drawingml/2006/main"/>
-          <a:p xmlns:a="http://schemas.openxmlformats.org/drawingml/2006/main">
-            <a:pPr algn="l">
-              <a:defRPr sz="1275" b="0">
-                <a:solidFill>
-                  <a:srgbClr val="667085"/>
-                </a:solidFill>
-              </a:defRPr>
-            </a:pPr>
-            <a:r>
-              <a:rPr sz="1275" b="0">
-                <a:solidFill>
-                  <a:srgbClr val="667085"/>
-                </a:solidFill>
-              </a:rPr>
-              <a:t>$143 contribution reversed</a:t>
-            </a:r>
-          </a:p>
-        </p:txBody>
-      </p:sp>
-      <p:sp>
-        <p:nvSpPr>
-          <p:cNvPr id="8" name="">
-            <a:extLst xmlns:a="http://schemas.openxmlformats.org/drawingml/2006/main">
-              <a:ext uri="{FF2B5EF4-FFF2-40B4-BE49-F238E27FC236}">
-                <a16:creationId xmlns:a16="http://schemas.microsoft.com/office/drawing/2014/main" id="{3DA825BD-4F84-4E26-AACB-B57CC0B7C239}"/>
-              </a:ext>
-            </a:extLst>
-          </p:cNvPr>
-          <p:cNvSpPr>
-            <a:spLocks xmlns:a="http://schemas.openxmlformats.org/drawingml/2006/main" noGrp="1"/>
-          </p:cNvSpPr>
-          <p:nvPr/>
-        </p:nvSpPr>
-        <p:spPr>
-          <a:xfrm xmlns:a="http://schemas.openxmlformats.org/drawingml/2006/main">
-            <a:off x="7524750" y="3695700"/>
-            <a:ext cx="3714750" cy="381000"/>
-          </a:xfrm>
-          <a:prstGeom xmlns:a="http://schemas.openxmlformats.org/drawingml/2006/main" prst="rect">
-            <a:avLst/>
-          </a:prstGeom>
-          <a:noFill xmlns:a="http://schemas.openxmlformats.org/drawingml/2006/main"/>
-          <a:ln xmlns:a="http://schemas.openxmlformats.org/drawingml/2006/main" w="0">
-            <a:noFill/>
-            <a:prstDash val="solid"/>
-          </a:ln>
-        </p:spPr>
-        <p:txBody>
-          <a:bodyPr xmlns:a="http://schemas.openxmlformats.org/drawingml/2006/main"/>
-          <a:lstStyle xmlns:a="http://schemas.openxmlformats.org/drawingml/2006/main"/>
-          <a:p xmlns:a="http://schemas.openxmlformats.org/drawingml/2006/main">
-            <a:pPr algn="l">
-              <a:defRPr sz="1800" b="1">
+              <a:t>Three PO lines: $23,556 product + $2,048.80 freight/duty</a:t>
+            </a:r>
+          </a:p>
+          <a:p xmlns:a="http://schemas.openxmlformats.org/drawingml/2006/main">
+            <a:pPr algn="ctr">
+              <a:defRPr sz="1650" b="1">
                 <a:solidFill>
                   <a:srgbClr val="0B2545"/>
                 </a:solidFill>
               </a:defRPr>
             </a:pPr>
             <a:r>
-              <a:rPr sz="1800" b="1">
+              <a:rPr sz="1650" b="1">
                 <a:solidFill>
                   <a:srgbClr val="0B2545"/>
                 </a:solidFill>
               </a:rPr>
-              <a:t>PF-WHEY-CHOC  •  3.4%</a:t>
-            </a:r>
-          </a:p>
-        </p:txBody>
-      </p:sp>
-      <p:sp>
-        <p:nvSpPr>
-          <p:cNvPr id="9" name="">
-            <a:extLst xmlns:a="http://schemas.openxmlformats.org/drawingml/2006/main">
-              <a:ext uri="{FF2B5EF4-FFF2-40B4-BE49-F238E27FC236}">
-                <a16:creationId xmlns:a16="http://schemas.microsoft.com/office/drawing/2014/main" id="{6B17EF6E-50E4-4588-837E-26431BB16312}"/>
-              </a:ext>
-            </a:extLst>
-          </p:cNvPr>
-          <p:cNvSpPr>
-            <a:spLocks xmlns:a="http://schemas.openxmlformats.org/drawingml/2006/main" noGrp="1"/>
-          </p:cNvSpPr>
-          <p:nvPr/>
-        </p:nvSpPr>
-        <p:spPr>
-          <a:xfrm xmlns:a="http://schemas.openxmlformats.org/drawingml/2006/main">
-            <a:off x="7524750" y="4114800"/>
-            <a:ext cx="3714750" cy="457200"/>
-          </a:xfrm>
-          <a:prstGeom xmlns:a="http://schemas.openxmlformats.org/drawingml/2006/main" prst="rect">
-            <a:avLst/>
-          </a:prstGeom>
-          <a:noFill xmlns:a="http://schemas.openxmlformats.org/drawingml/2006/main"/>
-          <a:ln xmlns:a="http://schemas.openxmlformats.org/drawingml/2006/main" w="0">
-            <a:noFill/>
-            <a:prstDash val="solid"/>
-          </a:ln>
-        </p:spPr>
-        <p:txBody>
-          <a:bodyPr xmlns:a="http://schemas.openxmlformats.org/drawingml/2006/main"/>
-          <a:lstStyle xmlns:a="http://schemas.openxmlformats.org/drawingml/2006/main"/>
-          <a:p xmlns:a="http://schemas.openxmlformats.org/drawingml/2006/main">
-            <a:pPr algn="l">
-              <a:defRPr sz="1275" b="0">
-                <a:solidFill>
-                  <a:srgbClr val="667085"/>
-                </a:solidFill>
-              </a:defRPr>
-            </a:pPr>
-            <a:r>
-              <a:rPr sz="1275" b="0">
-                <a:solidFill>
-                  <a:srgbClr val="667085"/>
-                </a:solidFill>
-              </a:rPr>
-              <a:t>$328 contribution reversed</a:t>
-            </a:r>
-          </a:p>
-        </p:txBody>
-      </p:sp>
-      <p:sp>
-        <p:nvSpPr>
-          <p:cNvPr id="10" name="">
-            <a:extLst xmlns:a="http://schemas.openxmlformats.org/drawingml/2006/main">
-              <a:ext uri="{FF2B5EF4-FFF2-40B4-BE49-F238E27FC236}">
-                <a16:creationId xmlns:a16="http://schemas.microsoft.com/office/drawing/2014/main" id="{C2095B90-64D4-47D7-8EBB-865EACC0A76C}"/>
-              </a:ext>
-            </a:extLst>
-          </p:cNvPr>
-          <p:cNvSpPr>
-            <a:spLocks xmlns:a="http://schemas.openxmlformats.org/drawingml/2006/main" noGrp="1"/>
-          </p:cNvSpPr>
-          <p:nvPr/>
-        </p:nvSpPr>
-        <p:spPr>
-          <a:xfrm xmlns:a="http://schemas.openxmlformats.org/drawingml/2006/main">
-            <a:off x="7524750" y="4743450"/>
-            <a:ext cx="3714750" cy="381000"/>
-          </a:xfrm>
-          <a:prstGeom xmlns:a="http://schemas.openxmlformats.org/drawingml/2006/main" prst="rect">
-            <a:avLst/>
-          </a:prstGeom>
-          <a:noFill xmlns:a="http://schemas.openxmlformats.org/drawingml/2006/main"/>
-          <a:ln xmlns:a="http://schemas.openxmlformats.org/drawingml/2006/main" w="0">
-            <a:noFill/>
-            <a:prstDash val="solid"/>
-          </a:ln>
-        </p:spPr>
-        <p:txBody>
-          <a:bodyPr xmlns:a="http://schemas.openxmlformats.org/drawingml/2006/main"/>
-          <a:lstStyle xmlns:a="http://schemas.openxmlformats.org/drawingml/2006/main"/>
-          <a:p xmlns:a="http://schemas.openxmlformats.org/drawingml/2006/main">
-            <a:pPr algn="l">
-              <a:defRPr sz="1800" b="1">
-                <a:solidFill>
-                  <a:srgbClr val="0B2545"/>
-                </a:solidFill>
-              </a:defRPr>
-            </a:pPr>
-            <a:r>
-              <a:rPr sz="1800" b="1">
-                <a:solidFill>
-                  <a:srgbClr val="0B2545"/>
-                </a:solidFill>
-              </a:rPr>
-              <a:t>PH-BED-MED-GRY  •  6.6%</a:t>
-            </a:r>
-          </a:p>
-        </p:txBody>
-      </p:sp>
-      <p:sp>
-        <p:nvSpPr>
-          <p:cNvPr id="11" name="">
-            <a:extLst xmlns:a="http://schemas.openxmlformats.org/drawingml/2006/main">
-              <a:ext uri="{FF2B5EF4-FFF2-40B4-BE49-F238E27FC236}">
-                <a16:creationId xmlns:a16="http://schemas.microsoft.com/office/drawing/2014/main" id="{7C80B63C-E73B-4A50-9EE5-730F641DB958}"/>
-              </a:ext>
-            </a:extLst>
-          </p:cNvPr>
-          <p:cNvSpPr>
-            <a:spLocks xmlns:a="http://schemas.openxmlformats.org/drawingml/2006/main" noGrp="1"/>
-          </p:cNvSpPr>
-          <p:nvPr/>
-        </p:nvSpPr>
-        <p:spPr>
-          <a:xfrm xmlns:a="http://schemas.openxmlformats.org/drawingml/2006/main">
-            <a:off x="7524750" y="5162550"/>
-            <a:ext cx="3714750" cy="552450"/>
-          </a:xfrm>
-          <a:prstGeom xmlns:a="http://schemas.openxmlformats.org/drawingml/2006/main" prst="rect">
-            <a:avLst/>
-          </a:prstGeom>
-          <a:noFill xmlns:a="http://schemas.openxmlformats.org/drawingml/2006/main"/>
-          <a:ln xmlns:a="http://schemas.openxmlformats.org/drawingml/2006/main" w="0">
-            <a:noFill/>
-            <a:prstDash val="solid"/>
-          </a:ln>
-        </p:spPr>
-        <p:txBody>
-          <a:bodyPr xmlns:a="http://schemas.openxmlformats.org/drawingml/2006/main"/>
-          <a:lstStyle xmlns:a="http://schemas.openxmlformats.org/drawingml/2006/main"/>
-          <a:p xmlns:a="http://schemas.openxmlformats.org/drawingml/2006/main">
-            <a:pPr algn="l">
-              <a:defRPr sz="1275" b="1">
+              <a:t>÷ 1,300 units = $19.696 landed cost per unit</a:t>
+            </a:r>
+          </a:p>
+        </p:txBody>
+      </p:sp>
+      <p:sp>
+        <p:nvSpPr>
+          <p:cNvPr id="23" name="">
+            <a:extLst xmlns:a="http://schemas.openxmlformats.org/drawingml/2006/main">
+              <a:ext uri="{FF2B5EF4-FFF2-40B4-BE49-F238E27FC236}">
+                <a16:creationId xmlns:a16="http://schemas.microsoft.com/office/drawing/2014/main" id="{112A81F8-951E-456D-8596-652B8A8D4C20}"/>
+              </a:ext>
+            </a:extLst>
+          </p:cNvPr>
+          <p:cNvSpPr>
+            <a:spLocks xmlns:a="http://schemas.openxmlformats.org/drawingml/2006/main" noGrp="1"/>
+          </p:cNvSpPr>
+          <p:nvPr/>
+        </p:nvSpPr>
+        <p:spPr>
+          <a:xfrm xmlns:a="http://schemas.openxmlformats.org/drawingml/2006/main">
+            <a:off x="1428750" y="5381625"/>
+            <a:ext cx="9334500" cy="476250"/>
+          </a:xfrm>
+          <a:prstGeom xmlns:a="http://schemas.openxmlformats.org/drawingml/2006/main" prst="rect">
+            <a:avLst/>
+          </a:prstGeom>
+          <a:noFill xmlns:a="http://schemas.openxmlformats.org/drawingml/2006/main"/>
+          <a:ln xmlns:a="http://schemas.openxmlformats.org/drawingml/2006/main" w="0">
+            <a:noFill/>
+            <a:prstDash val="solid"/>
+          </a:ln>
+        </p:spPr>
+        <p:txBody>
+          <a:bodyPr xmlns:a="http://schemas.openxmlformats.org/drawingml/2006/main"/>
+          <a:lstStyle xmlns:a="http://schemas.openxmlformats.org/drawingml/2006/main"/>
+          <a:p xmlns:a="http://schemas.openxmlformats.org/drawingml/2006/main">
+            <a:pPr algn="ctr">
+              <a:defRPr sz="1425" b="1">
                 <a:solidFill>
                   <a:srgbClr val="B42318"/>
                 </a:solidFill>
               </a:defRPr>
             </a:pPr>
             <a:r>
-              <a:rPr sz="1275" b="1">
+              <a:rPr sz="1425" b="1">
                 <a:solidFill>
                   <a:srgbClr val="B42318"/>
                 </a:solidFill>
               </a:rPr>
-              <a:t>Refund impact equals 47% of remaining CM</a:t>
-            </a:r>
-          </a:p>
-        </p:txBody>
-      </p:sp>
-      <p:sp>
-        <p:nvSpPr>
-          <p:cNvPr id="12" name="">
-            <a:extLst xmlns:a="http://schemas.openxmlformats.org/drawingml/2006/main">
-              <a:ext uri="{FF2B5EF4-FFF2-40B4-BE49-F238E27FC236}">
-                <a16:creationId xmlns:a16="http://schemas.microsoft.com/office/drawing/2014/main" id="{CC63A40F-74DE-44F6-859C-0BB1F743D7CC}"/>
+              <a:t>Advertising and storage have no SKU key. We can prove the $0.79 break-even cushion—not assign those shared costs to this order.</a:t>
+            </a:r>
+          </a:p>
+        </p:txBody>
+      </p:sp>
+      <p:sp>
+        <p:nvSpPr>
+          <p:cNvPr id="24" name="">
+            <a:extLst xmlns:a="http://schemas.openxmlformats.org/drawingml/2006/main">
+              <a:ext uri="{FF2B5EF4-FFF2-40B4-BE49-F238E27FC236}">
+                <a16:creationId xmlns:a16="http://schemas.microsoft.com/office/drawing/2014/main" id="{DFDD8D4E-C8E5-4CF1-9424-60480C226C93}"/>
               </a:ext>
             </a:extLst>
           </p:cNvPr>
@@ -8786,10 +10399,10 @@
       </p:sp>
       <p:sp>
         <p:nvSpPr>
-          <p:cNvPr id="13" name="">
-            <a:extLst xmlns:a="http://schemas.openxmlformats.org/drawingml/2006/main">
-              <a:ext uri="{FF2B5EF4-FFF2-40B4-BE49-F238E27FC236}">
-                <a16:creationId xmlns:a16="http://schemas.microsoft.com/office/drawing/2014/main" id="{97AA699A-BB52-49B6-AF52-75D7F68A7C4B}"/>
+          <p:cNvPr id="25" name="">
+            <a:extLst xmlns:a="http://schemas.openxmlformats.org/drawingml/2006/main">
+              <a:ext uri="{FF2B5EF4-FFF2-40B4-BE49-F238E27FC236}">
+                <a16:creationId xmlns:a16="http://schemas.microsoft.com/office/drawing/2014/main" id="{E8070909-612A-45BA-B6C3-420CAA22C2FB}"/>
               </a:ext>
             </a:extLst>
           </p:cNvPr>
@@ -8837,7 +10450,7 @@
     </p:spTree>
     <p:extLst>
       <p:ext uri="{BB962C8B-B14F-4D97-AF65-F5344CB8AC3E}">
-        <p14:creationId xmlns:p14="http://schemas.microsoft.com/office/powerpoint/2010/main" val="2056236328"/>
+        <p14:creationId xmlns:p14="http://schemas.microsoft.com/office/powerpoint/2010/main" val="416649216"/>
       </p:ext>
     </p:extLst>
   </p:cSld>
@@ -8865,10 +10478,10 @@
       </p:grpSpPr>
       <p:sp>
         <p:nvSpPr>
-          <p:cNvPr id="19" name="">
-            <a:extLst xmlns:a="http://schemas.openxmlformats.org/drawingml/2006/main">
-              <a:ext uri="{FF2B5EF4-FFF2-40B4-BE49-F238E27FC236}">
-                <a16:creationId xmlns:a16="http://schemas.microsoft.com/office/drawing/2014/main" id="{0694EBBF-AA7D-41B5-A9A4-D42E88E5DF10}"/>
+          <p:cNvPr id="14" name="">
+            <a:extLst xmlns:a="http://schemas.openxmlformats.org/drawingml/2006/main">
+              <a:ext uri="{FF2B5EF4-FFF2-40B4-BE49-F238E27FC236}">
+                <a16:creationId xmlns:a16="http://schemas.microsoft.com/office/drawing/2014/main" id="{587F382A-E9A8-4CAC-AA01-D8D236034732}"/>
               </a:ext>
             </a:extLst>
           </p:cNvPr>
@@ -8908,7 +10521,7 @@
                   <a:srgbClr val="2E74B5"/>
                 </a:solidFill>
               </a:rPr>
-              <a:t>DELIVERABLE 3</a:t>
+              <a:t>DELIVERABLE 2</a:t>
             </a:r>
           </a:p>
         </p:txBody>
@@ -8918,7 +10531,7 @@
           <p:cNvPr id="2" name="">
             <a:extLst xmlns:a="http://schemas.openxmlformats.org/drawingml/2006/main">
               <a:ext uri="{FF2B5EF4-FFF2-40B4-BE49-F238E27FC236}">
-                <a16:creationId xmlns:a16="http://schemas.microsoft.com/office/drawing/2014/main" id="{2EEF3176-503C-4F01-9A58-857E16035016}"/>
+                <a16:creationId xmlns:a16="http://schemas.microsoft.com/office/drawing/2014/main" id="{91618359-8EFD-45AC-8689-631DCEAFC690}"/>
               </a:ext>
             </a:extLst>
           </p:cNvPr>
@@ -8958,7 +10571,7 @@
                   <a:srgbClr val="0B2545"/>
                 </a:solidFill>
               </a:rPr>
-              <a:t>The first 90 days build trust before adding forecasting</a:t>
+              <a:t>Refunds expose concentrated product risk</a:t>
             </a:r>
           </a:p>
         </p:txBody>
@@ -8968,7 +10581,7 @@
           <p:cNvPr id="3" name="">
             <a:extLst xmlns:a="http://schemas.openxmlformats.org/drawingml/2006/main">
               <a:ext uri="{FF2B5EF4-FFF2-40B4-BE49-F238E27FC236}">
-                <a16:creationId xmlns:a16="http://schemas.microsoft.com/office/drawing/2014/main" id="{86FE3E53-AF43-4366-9BE9-4102ADC35375}"/>
+                <a16:creationId xmlns:a16="http://schemas.microsoft.com/office/drawing/2014/main" id="{DFD35400-B365-4491-AE57-392C733AAD44}"/>
               </a:ext>
             </a:extLst>
           </p:cNvPr>
@@ -9008,29 +10621,45 @@
                   <a:srgbClr val="667085"/>
                 </a:solidFill>
               </a:rPr>
-              <a:t>Automate controls and reconciliation first; expand decisions only after the underlying history is dependable.</a:t>
-            </a:r>
-          </a:p>
-        </p:txBody>
-      </p:sp>
-      <p:sp>
-        <p:nvSpPr>
-          <p:cNvPr id="4" name="">
-            <a:extLst xmlns:a="http://schemas.openxmlformats.org/drawingml/2006/main">
-              <a:ext uri="{FF2B5EF4-FFF2-40B4-BE49-F238E27FC236}">
-                <a16:creationId xmlns:a16="http://schemas.microsoft.com/office/drawing/2014/main" id="{A0B48C04-A101-496C-AC82-EDA9D3997ECF}"/>
-              </a:ext>
-            </a:extLst>
-          </p:cNvPr>
-          <p:cNvSpPr>
-            <a:spLocks xmlns:a="http://schemas.openxmlformats.org/drawingml/2006/main" noGrp="1"/>
-          </p:cNvSpPr>
-          <p:nvPr/>
-        </p:nvSpPr>
-        <p:spPr>
-          <a:xfrm xmlns:a="http://schemas.openxmlformats.org/drawingml/2006/main">
-            <a:off x="685800" y="2047875"/>
-            <a:ext cx="3143250" cy="285750"/>
+              <a:t>GlowTheory has the highest brand rate; the PawHaus dog bed has the sharpest margin exposure.</a:t>
+            </a:r>
+          </a:p>
+        </p:txBody>
+      </p:sp>
+      <p:graphicFrame>
+        <p:nvGraphicFramePr>
+          <p:cNvPr id="17" name="Chart"/>
+          <p:cNvGraphicFramePr/>
+          <p:nvPr/>
+        </p:nvGraphicFramePr>
+        <p:xfrm>
+          <a:off xmlns:a="http://schemas.openxmlformats.org/drawingml/2006/main" x="723900" y="2047875"/>
+          <a:ext xmlns:a="http://schemas.openxmlformats.org/drawingml/2006/main" cx="6191250" cy="3476625"/>
+        </p:xfrm>
+        <a:graphic xmlns:a="http://schemas.openxmlformats.org/drawingml/2006/main">
+          <a:graphicData uri="http://schemas.openxmlformats.org/drawingml/2006/chart">
+            <c:chart xmlns:r="http://schemas.openxmlformats.org/officeDocument/2006/relationships" xmlns:c="http://schemas.openxmlformats.org/drawingml/2006/chart" r:id="R8035087f1f054676"/>
+          </a:graphicData>
+        </a:graphic>
+      </p:graphicFrame>
+      <p:sp>
+        <p:nvSpPr>
+          <p:cNvPr id="5" name="">
+            <a:extLst xmlns:a="http://schemas.openxmlformats.org/drawingml/2006/main">
+              <a:ext uri="{FF2B5EF4-FFF2-40B4-BE49-F238E27FC236}">
+                <a16:creationId xmlns:a16="http://schemas.microsoft.com/office/drawing/2014/main" id="{6E8586BA-065C-4FC8-9659-982325728F4B}"/>
+              </a:ext>
+            </a:extLst>
+          </p:cNvPr>
+          <p:cNvSpPr>
+            <a:spLocks xmlns:a="http://schemas.openxmlformats.org/drawingml/2006/main" noGrp="1"/>
+          </p:cNvSpPr>
+          <p:nvPr/>
+        </p:nvSpPr>
+        <p:spPr>
+          <a:xfrm xmlns:a="http://schemas.openxmlformats.org/drawingml/2006/main">
+            <a:off x="7524750" y="2133600"/>
+            <a:ext cx="3714750" cy="304800"/>
           </a:xfrm>
           <a:prstGeom xmlns:a="http://schemas.openxmlformats.org/drawingml/2006/main" prst="rect">
             <a:avLst/>
@@ -9046,74 +10675,41 @@
           <a:lstStyle xmlns:a="http://schemas.openxmlformats.org/drawingml/2006/main"/>
           <a:p xmlns:a="http://schemas.openxmlformats.org/drawingml/2006/main">
             <a:pPr algn="l">
-              <a:defRPr sz="1350" b="1">
+              <a:defRPr sz="1500" b="1">
                 <a:solidFill>
                   <a:srgbClr val="2E74B5"/>
                 </a:solidFill>
               </a:defRPr>
             </a:pPr>
             <a:r>
-              <a:rPr sz="1350" b="1">
+              <a:rPr sz="1500" b="1">
                 <a:solidFill>
                   <a:srgbClr val="2E74B5"/>
                 </a:solidFill>
               </a:rPr>
-              <a:t>Days 1–30</a:t>
-            </a:r>
-          </a:p>
-        </p:txBody>
-      </p:sp>
-      <p:sp>
-        <p:nvSpPr>
-          <p:cNvPr id="5" name="">
-            <a:extLst xmlns:a="http://schemas.openxmlformats.org/drawingml/2006/main">
-              <a:ext uri="{FF2B5EF4-FFF2-40B4-BE49-F238E27FC236}">
-                <a16:creationId xmlns:a16="http://schemas.microsoft.com/office/drawing/2014/main" id="{52869C2F-3929-4843-AA7A-5D08F25756AB}"/>
-              </a:ext>
-            </a:extLst>
-          </p:cNvPr>
-          <p:cNvSpPr>
-            <a:spLocks xmlns:a="http://schemas.openxmlformats.org/drawingml/2006/main" noGrp="1"/>
-          </p:cNvSpPr>
-          <p:nvPr/>
-        </p:nvSpPr>
-        <p:spPr>
-          <a:xfrm xmlns:a="http://schemas.openxmlformats.org/drawingml/2006/main">
-            <a:off x="685800" y="2457450"/>
-            <a:ext cx="3143250" cy="57150"/>
-          </a:xfrm>
-          <a:prstGeom xmlns:a="http://schemas.openxmlformats.org/drawingml/2006/main" prst="rect">
-            <a:avLst/>
-          </a:prstGeom>
-          <a:solidFill xmlns:a="http://schemas.openxmlformats.org/drawingml/2006/main">
-            <a:srgbClr val="0B7A53"/>
-          </a:solidFill>
-          <a:ln xmlns:a="http://schemas.openxmlformats.org/drawingml/2006/main" w="0">
-            <a:solidFill>
-              <a:srgbClr val="0B7A53"/>
-            </a:solidFill>
-            <a:prstDash val="solid"/>
-          </a:ln>
-        </p:spPr>
+              <a:t>Products to investigate</a:t>
+            </a:r>
+          </a:p>
+        </p:txBody>
       </p:sp>
       <p:sp>
         <p:nvSpPr>
           <p:cNvPr id="6" name="">
             <a:extLst xmlns:a="http://schemas.openxmlformats.org/drawingml/2006/main">
               <a:ext uri="{FF2B5EF4-FFF2-40B4-BE49-F238E27FC236}">
-                <a16:creationId xmlns:a16="http://schemas.microsoft.com/office/drawing/2014/main" id="{119F3C96-ABEC-4EDB-BFA2-44EA515DBE1B}"/>
-              </a:ext>
-            </a:extLst>
-          </p:cNvPr>
-          <p:cNvSpPr>
-            <a:spLocks xmlns:a="http://schemas.openxmlformats.org/drawingml/2006/main" noGrp="1"/>
-          </p:cNvSpPr>
-          <p:nvPr/>
-        </p:nvSpPr>
-        <p:spPr>
-          <a:xfrm xmlns:a="http://schemas.openxmlformats.org/drawingml/2006/main">
-            <a:off x="685800" y="2781300"/>
-            <a:ext cx="3143250" cy="361950"/>
+                <a16:creationId xmlns:a16="http://schemas.microsoft.com/office/drawing/2014/main" id="{5546AE0B-0687-4AF6-AB0A-F719266FFD31}"/>
+              </a:ext>
+            </a:extLst>
+          </p:cNvPr>
+          <p:cNvSpPr>
+            <a:spLocks xmlns:a="http://schemas.openxmlformats.org/drawingml/2006/main" noGrp="1"/>
+          </p:cNvSpPr>
+          <p:nvPr/>
+        </p:nvSpPr>
+        <p:spPr>
+          <a:xfrm xmlns:a="http://schemas.openxmlformats.org/drawingml/2006/main">
+            <a:off x="7524750" y="2647950"/>
+            <a:ext cx="3714750" cy="381000"/>
           </a:xfrm>
           <a:prstGeom xmlns:a="http://schemas.openxmlformats.org/drawingml/2006/main" prst="rect">
             <a:avLst/>
@@ -9129,19 +10725,19 @@
           <a:lstStyle xmlns:a="http://schemas.openxmlformats.org/drawingml/2006/main"/>
           <a:p xmlns:a="http://schemas.openxmlformats.org/drawingml/2006/main">
             <a:pPr algn="l">
-              <a:defRPr sz="1875" b="1">
+              <a:defRPr sz="1800" b="1">
                 <a:solidFill>
                   <a:srgbClr val="0B2545"/>
                 </a:solidFill>
               </a:defRPr>
             </a:pPr>
             <a:r>
-              <a:rPr sz="1875" b="1">
+              <a:rPr sz="1800" b="1">
                 <a:solidFill>
                   <a:srgbClr val="0B2545"/>
                 </a:solidFill>
               </a:rPr>
-              <a:t>Reliable ingestion</a:t>
+              <a:t>GT-MASK-CLAY  •  10.7%</a:t>
             </a:r>
           </a:p>
         </p:txBody>
@@ -9151,19 +10747,19 @@
           <p:cNvPr id="7" name="">
             <a:extLst xmlns:a="http://schemas.openxmlformats.org/drawingml/2006/main">
               <a:ext uri="{FF2B5EF4-FFF2-40B4-BE49-F238E27FC236}">
-                <a16:creationId xmlns:a16="http://schemas.microsoft.com/office/drawing/2014/main" id="{EE32C6CB-4F76-4B90-B37D-B76D6ECA5490}"/>
-              </a:ext>
-            </a:extLst>
-          </p:cNvPr>
-          <p:cNvSpPr>
-            <a:spLocks xmlns:a="http://schemas.openxmlformats.org/drawingml/2006/main" noGrp="1"/>
-          </p:cNvSpPr>
-          <p:nvPr/>
-        </p:nvSpPr>
-        <p:spPr>
-          <a:xfrm xmlns:a="http://schemas.openxmlformats.org/drawingml/2006/main">
-            <a:off x="685800" y="3352800"/>
-            <a:ext cx="3143250" cy="1047750"/>
+                <a16:creationId xmlns:a16="http://schemas.microsoft.com/office/drawing/2014/main" id="{C01A4274-E8E9-4FAB-B2BD-90F7B68C2ED1}"/>
+              </a:ext>
+            </a:extLst>
+          </p:cNvPr>
+          <p:cNvSpPr>
+            <a:spLocks xmlns:a="http://schemas.openxmlformats.org/drawingml/2006/main" noGrp="1"/>
+          </p:cNvSpPr>
+          <p:nvPr/>
+        </p:nvSpPr>
+        <p:spPr>
+          <a:xfrm xmlns:a="http://schemas.openxmlformats.org/drawingml/2006/main">
+            <a:off x="7524750" y="3067050"/>
+            <a:ext cx="3714750" cy="457200"/>
           </a:xfrm>
           <a:prstGeom xmlns:a="http://schemas.openxmlformats.org/drawingml/2006/main" prst="rect">
             <a:avLst/>
@@ -9179,75 +10775,191 @@
           <a:lstStyle xmlns:a="http://schemas.openxmlformats.org/drawingml/2006/main"/>
           <a:p xmlns:a="http://schemas.openxmlformats.org/drawingml/2006/main">
             <a:pPr algn="l">
-              <a:defRPr sz="1425" b="0">
+              <a:defRPr sz="1275" b="0">
                 <a:solidFill>
                   <a:srgbClr val="667085"/>
                 </a:solidFill>
               </a:defRPr>
             </a:pPr>
             <a:r>
-              <a:rPr sz="1425" b="0">
+              <a:rPr sz="1275" b="0">
                 <a:solidFill>
                   <a:srgbClr val="667085"/>
                 </a:solidFill>
               </a:rPr>
-              <a:t>Raw history • schema alerts</a:t>
-            </a:r>
-          </a:p>
+              <a:t>$143 contribution reversed</a:t>
+            </a:r>
+          </a:p>
+        </p:txBody>
+      </p:sp>
+      <p:sp>
+        <p:nvSpPr>
+          <p:cNvPr id="8" name="">
+            <a:extLst xmlns:a="http://schemas.openxmlformats.org/drawingml/2006/main">
+              <a:ext uri="{FF2B5EF4-FFF2-40B4-BE49-F238E27FC236}">
+                <a16:creationId xmlns:a16="http://schemas.microsoft.com/office/drawing/2014/main" id="{87966443-3564-4D6B-BE50-0373B42D83C4}"/>
+              </a:ext>
+            </a:extLst>
+          </p:cNvPr>
+          <p:cNvSpPr>
+            <a:spLocks xmlns:a="http://schemas.openxmlformats.org/drawingml/2006/main" noGrp="1"/>
+          </p:cNvSpPr>
+          <p:nvPr/>
+        </p:nvSpPr>
+        <p:spPr>
+          <a:xfrm xmlns:a="http://schemas.openxmlformats.org/drawingml/2006/main">
+            <a:off x="7524750" y="3695700"/>
+            <a:ext cx="3714750" cy="381000"/>
+          </a:xfrm>
+          <a:prstGeom xmlns:a="http://schemas.openxmlformats.org/drawingml/2006/main" prst="rect">
+            <a:avLst/>
+          </a:prstGeom>
+          <a:noFill xmlns:a="http://schemas.openxmlformats.org/drawingml/2006/main"/>
+          <a:ln xmlns:a="http://schemas.openxmlformats.org/drawingml/2006/main" w="0">
+            <a:noFill/>
+            <a:prstDash val="solid"/>
+          </a:ln>
+        </p:spPr>
+        <p:txBody>
+          <a:bodyPr xmlns:a="http://schemas.openxmlformats.org/drawingml/2006/main"/>
+          <a:lstStyle xmlns:a="http://schemas.openxmlformats.org/drawingml/2006/main"/>
           <a:p xmlns:a="http://schemas.openxmlformats.org/drawingml/2006/main">
             <a:pPr algn="l">
-              <a:defRPr sz="1425" b="0">
+              <a:defRPr sz="1800" b="1">
+                <a:solidFill>
+                  <a:srgbClr val="0B2545"/>
+                </a:solidFill>
+              </a:defRPr>
+            </a:pPr>
+            <a:r>
+              <a:rPr sz="1800" b="1">
+                <a:solidFill>
+                  <a:srgbClr val="0B2545"/>
+                </a:solidFill>
+              </a:rPr>
+              <a:t>PF-WHEY-CHOC  •  3.4%</a:t>
+            </a:r>
+          </a:p>
+        </p:txBody>
+      </p:sp>
+      <p:sp>
+        <p:nvSpPr>
+          <p:cNvPr id="9" name="">
+            <a:extLst xmlns:a="http://schemas.openxmlformats.org/drawingml/2006/main">
+              <a:ext uri="{FF2B5EF4-FFF2-40B4-BE49-F238E27FC236}">
+                <a16:creationId xmlns:a16="http://schemas.microsoft.com/office/drawing/2014/main" id="{AF4E452B-BD0E-4C1E-8CF5-528FD76B463F}"/>
+              </a:ext>
+            </a:extLst>
+          </p:cNvPr>
+          <p:cNvSpPr>
+            <a:spLocks xmlns:a="http://schemas.openxmlformats.org/drawingml/2006/main" noGrp="1"/>
+          </p:cNvSpPr>
+          <p:nvPr/>
+        </p:nvSpPr>
+        <p:spPr>
+          <a:xfrm xmlns:a="http://schemas.openxmlformats.org/drawingml/2006/main">
+            <a:off x="7524750" y="4114800"/>
+            <a:ext cx="3714750" cy="457200"/>
+          </a:xfrm>
+          <a:prstGeom xmlns:a="http://schemas.openxmlformats.org/drawingml/2006/main" prst="rect">
+            <a:avLst/>
+          </a:prstGeom>
+          <a:noFill xmlns:a="http://schemas.openxmlformats.org/drawingml/2006/main"/>
+          <a:ln xmlns:a="http://schemas.openxmlformats.org/drawingml/2006/main" w="0">
+            <a:noFill/>
+            <a:prstDash val="solid"/>
+          </a:ln>
+        </p:spPr>
+        <p:txBody>
+          <a:bodyPr xmlns:a="http://schemas.openxmlformats.org/drawingml/2006/main"/>
+          <a:lstStyle xmlns:a="http://schemas.openxmlformats.org/drawingml/2006/main"/>
+          <a:p xmlns:a="http://schemas.openxmlformats.org/drawingml/2006/main">
+            <a:pPr algn="l">
+              <a:defRPr sz="1275" b="0">
                 <a:solidFill>
                   <a:srgbClr val="667085"/>
                 </a:solidFill>
               </a:defRPr>
             </a:pPr>
             <a:r>
-              <a:rPr sz="1425" b="0">
+              <a:rPr sz="1275" b="0">
                 <a:solidFill>
                   <a:srgbClr val="667085"/>
                 </a:solidFill>
               </a:rPr>
-              <a:t>identity/UOM mappings</a:t>
-            </a:r>
-          </a:p>
+              <a:t>$328 contribution reversed</a:t>
+            </a:r>
+          </a:p>
+        </p:txBody>
+      </p:sp>
+      <p:sp>
+        <p:nvSpPr>
+          <p:cNvPr id="10" name="">
+            <a:extLst xmlns:a="http://schemas.openxmlformats.org/drawingml/2006/main">
+              <a:ext uri="{FF2B5EF4-FFF2-40B4-BE49-F238E27FC236}">
+                <a16:creationId xmlns:a16="http://schemas.microsoft.com/office/drawing/2014/main" id="{68246DAF-C1ED-4AF4-A4B3-F1660CF1391B}"/>
+              </a:ext>
+            </a:extLst>
+          </p:cNvPr>
+          <p:cNvSpPr>
+            <a:spLocks xmlns:a="http://schemas.openxmlformats.org/drawingml/2006/main" noGrp="1"/>
+          </p:cNvSpPr>
+          <p:nvPr/>
+        </p:nvSpPr>
+        <p:spPr>
+          <a:xfrm xmlns:a="http://schemas.openxmlformats.org/drawingml/2006/main">
+            <a:off x="7524750" y="4743450"/>
+            <a:ext cx="3714750" cy="381000"/>
+          </a:xfrm>
+          <a:prstGeom xmlns:a="http://schemas.openxmlformats.org/drawingml/2006/main" prst="rect">
+            <a:avLst/>
+          </a:prstGeom>
+          <a:noFill xmlns:a="http://schemas.openxmlformats.org/drawingml/2006/main"/>
+          <a:ln xmlns:a="http://schemas.openxmlformats.org/drawingml/2006/main" w="0">
+            <a:noFill/>
+            <a:prstDash val="solid"/>
+          </a:ln>
+        </p:spPr>
+        <p:txBody>
+          <a:bodyPr xmlns:a="http://schemas.openxmlformats.org/drawingml/2006/main"/>
+          <a:lstStyle xmlns:a="http://schemas.openxmlformats.org/drawingml/2006/main"/>
           <a:p xmlns:a="http://schemas.openxmlformats.org/drawingml/2006/main">
             <a:pPr algn="l">
-              <a:defRPr sz="1425" b="0">
-                <a:solidFill>
-                  <a:srgbClr val="667085"/>
-                </a:solidFill>
-              </a:defRPr>
-            </a:pPr>
-            <a:r>
-              <a:rPr sz="1425" b="0">
-                <a:solidFill>
-                  <a:srgbClr val="667085"/>
-                </a:solidFill>
-              </a:rPr>
-              <a:t>source tie-outs</a:t>
-            </a:r>
-          </a:p>
-        </p:txBody>
-      </p:sp>
-      <p:sp>
-        <p:nvSpPr>
-          <p:cNvPr id="8" name="">
-            <a:extLst xmlns:a="http://schemas.openxmlformats.org/drawingml/2006/main">
-              <a:ext uri="{FF2B5EF4-FFF2-40B4-BE49-F238E27FC236}">
-                <a16:creationId xmlns:a16="http://schemas.microsoft.com/office/drawing/2014/main" id="{B82E8955-2A7B-44BC-A484-935AAB40CDE2}"/>
-              </a:ext>
-            </a:extLst>
-          </p:cNvPr>
-          <p:cNvSpPr>
-            <a:spLocks xmlns:a="http://schemas.openxmlformats.org/drawingml/2006/main" noGrp="1"/>
-          </p:cNvSpPr>
-          <p:nvPr/>
-        </p:nvSpPr>
-        <p:spPr>
-          <a:xfrm xmlns:a="http://schemas.openxmlformats.org/drawingml/2006/main">
-            <a:off x="4286250" y="2047875"/>
-            <a:ext cx="3143250" cy="285750"/>
+              <a:defRPr sz="1800" b="1">
+                <a:solidFill>
+                  <a:srgbClr val="0B2545"/>
+                </a:solidFill>
+              </a:defRPr>
+            </a:pPr>
+            <a:r>
+              <a:rPr sz="1800" b="1">
+                <a:solidFill>
+                  <a:srgbClr val="0B2545"/>
+                </a:solidFill>
+              </a:rPr>
+              <a:t>PH-BED-MED-GRY  •  6.6%</a:t>
+            </a:r>
+          </a:p>
+        </p:txBody>
+      </p:sp>
+      <p:sp>
+        <p:nvSpPr>
+          <p:cNvPr id="11" name="">
+            <a:extLst xmlns:a="http://schemas.openxmlformats.org/drawingml/2006/main">
+              <a:ext uri="{FF2B5EF4-FFF2-40B4-BE49-F238E27FC236}">
+                <a16:creationId xmlns:a16="http://schemas.microsoft.com/office/drawing/2014/main" id="{7C4BD639-95A5-4E41-BCC7-5A27D6EFB46F}"/>
+              </a:ext>
+            </a:extLst>
+          </p:cNvPr>
+          <p:cNvSpPr>
+            <a:spLocks xmlns:a="http://schemas.openxmlformats.org/drawingml/2006/main" noGrp="1"/>
+          </p:cNvSpPr>
+          <p:nvPr/>
+        </p:nvSpPr>
+        <p:spPr>
+          <a:xfrm xmlns:a="http://schemas.openxmlformats.org/drawingml/2006/main">
+            <a:off x="7524750" y="5162550"/>
+            <a:ext cx="3714750" cy="552450"/>
           </a:xfrm>
           <a:prstGeom xmlns:a="http://schemas.openxmlformats.org/drawingml/2006/main" prst="rect">
             <a:avLst/>
@@ -9263,186 +10975,19 @@
           <a:lstStyle xmlns:a="http://schemas.openxmlformats.org/drawingml/2006/main"/>
           <a:p xmlns:a="http://schemas.openxmlformats.org/drawingml/2006/main">
             <a:pPr algn="l">
-              <a:defRPr sz="1350" b="1">
-                <a:solidFill>
-                  <a:srgbClr val="2E74B5"/>
-                </a:solidFill>
-              </a:defRPr>
-            </a:pPr>
-            <a:r>
-              <a:rPr sz="1350" b="1">
-                <a:solidFill>
-                  <a:srgbClr val="2E74B5"/>
-                </a:solidFill>
-              </a:rPr>
-              <a:t>Days 31–60</a:t>
-            </a:r>
-          </a:p>
-        </p:txBody>
-      </p:sp>
-      <p:sp>
-        <p:nvSpPr>
-          <p:cNvPr id="9" name="">
-            <a:extLst xmlns:a="http://schemas.openxmlformats.org/drawingml/2006/main">
-              <a:ext uri="{FF2B5EF4-FFF2-40B4-BE49-F238E27FC236}">
-                <a16:creationId xmlns:a16="http://schemas.microsoft.com/office/drawing/2014/main" id="{8CF11B98-DAA4-4C22-B2A2-FA5AD4DBB5DD}"/>
-              </a:ext>
-            </a:extLst>
-          </p:cNvPr>
-          <p:cNvSpPr>
-            <a:spLocks xmlns:a="http://schemas.openxmlformats.org/drawingml/2006/main" noGrp="1"/>
-          </p:cNvSpPr>
-          <p:nvPr/>
-        </p:nvSpPr>
-        <p:spPr>
-          <a:xfrm xmlns:a="http://schemas.openxmlformats.org/drawingml/2006/main">
-            <a:off x="4286250" y="2457450"/>
-            <a:ext cx="3143250" cy="57150"/>
-          </a:xfrm>
-          <a:prstGeom xmlns:a="http://schemas.openxmlformats.org/drawingml/2006/main" prst="rect">
-            <a:avLst/>
-          </a:prstGeom>
-          <a:solidFill xmlns:a="http://schemas.openxmlformats.org/drawingml/2006/main">
-            <a:srgbClr val="2E74B5"/>
-          </a:solidFill>
-          <a:ln xmlns:a="http://schemas.openxmlformats.org/drawingml/2006/main" w="0">
-            <a:solidFill>
-              <a:srgbClr val="2E74B5"/>
-            </a:solidFill>
-            <a:prstDash val="solid"/>
-          </a:ln>
-        </p:spPr>
-      </p:sp>
-      <p:sp>
-        <p:nvSpPr>
-          <p:cNvPr id="10" name="">
-            <a:extLst xmlns:a="http://schemas.openxmlformats.org/drawingml/2006/main">
-              <a:ext uri="{FF2B5EF4-FFF2-40B4-BE49-F238E27FC236}">
-                <a16:creationId xmlns:a16="http://schemas.microsoft.com/office/drawing/2014/main" id="{302222E5-86BE-4DDC-90ED-6CC52E34638E}"/>
-              </a:ext>
-            </a:extLst>
-          </p:cNvPr>
-          <p:cNvSpPr>
-            <a:spLocks xmlns:a="http://schemas.openxmlformats.org/drawingml/2006/main" noGrp="1"/>
-          </p:cNvSpPr>
-          <p:nvPr/>
-        </p:nvSpPr>
-        <p:spPr>
-          <a:xfrm xmlns:a="http://schemas.openxmlformats.org/drawingml/2006/main">
-            <a:off x="4286250" y="2781300"/>
-            <a:ext cx="3143250" cy="361950"/>
-          </a:xfrm>
-          <a:prstGeom xmlns:a="http://schemas.openxmlformats.org/drawingml/2006/main" prst="rect">
-            <a:avLst/>
-          </a:prstGeom>
-          <a:noFill xmlns:a="http://schemas.openxmlformats.org/drawingml/2006/main"/>
-          <a:ln xmlns:a="http://schemas.openxmlformats.org/drawingml/2006/main" w="0">
-            <a:noFill/>
-            <a:prstDash val="solid"/>
-          </a:ln>
-        </p:spPr>
-        <p:txBody>
-          <a:bodyPr xmlns:a="http://schemas.openxmlformats.org/drawingml/2006/main"/>
-          <a:lstStyle xmlns:a="http://schemas.openxmlformats.org/drawingml/2006/main"/>
-          <a:p xmlns:a="http://schemas.openxmlformats.org/drawingml/2006/main">
-            <a:pPr algn="l">
-              <a:defRPr sz="1875" b="1">
-                <a:solidFill>
-                  <a:srgbClr val="0B2545"/>
-                </a:solidFill>
-              </a:defRPr>
-            </a:pPr>
-            <a:r>
-              <a:rPr sz="1875" b="1">
-                <a:solidFill>
-                  <a:srgbClr val="0B2545"/>
-                </a:solidFill>
-              </a:rPr>
-              <a:t>Repeatable finance</a:t>
-            </a:r>
-          </a:p>
-        </p:txBody>
-      </p:sp>
-      <p:sp>
-        <p:nvSpPr>
-          <p:cNvPr id="11" name="">
-            <a:extLst xmlns:a="http://schemas.openxmlformats.org/drawingml/2006/main">
-              <a:ext uri="{FF2B5EF4-FFF2-40B4-BE49-F238E27FC236}">
-                <a16:creationId xmlns:a16="http://schemas.microsoft.com/office/drawing/2014/main" id="{3C4625CA-392B-4D57-883E-4F06B4273ED8}"/>
-              </a:ext>
-            </a:extLst>
-          </p:cNvPr>
-          <p:cNvSpPr>
-            <a:spLocks xmlns:a="http://schemas.openxmlformats.org/drawingml/2006/main" noGrp="1"/>
-          </p:cNvSpPr>
-          <p:nvPr/>
-        </p:nvSpPr>
-        <p:spPr>
-          <a:xfrm xmlns:a="http://schemas.openxmlformats.org/drawingml/2006/main">
-            <a:off x="4286250" y="3352800"/>
-            <a:ext cx="3143250" cy="1047750"/>
-          </a:xfrm>
-          <a:prstGeom xmlns:a="http://schemas.openxmlformats.org/drawingml/2006/main" prst="rect">
-            <a:avLst/>
-          </a:prstGeom>
-          <a:noFill xmlns:a="http://schemas.openxmlformats.org/drawingml/2006/main"/>
-          <a:ln xmlns:a="http://schemas.openxmlformats.org/drawingml/2006/main" w="0">
-            <a:noFill/>
-            <a:prstDash val="solid"/>
-          </a:ln>
-        </p:spPr>
-        <p:txBody>
-          <a:bodyPr xmlns:a="http://schemas.openxmlformats.org/drawingml/2006/main"/>
-          <a:lstStyle xmlns:a="http://schemas.openxmlformats.org/drawingml/2006/main"/>
-          <a:p xmlns:a="http://schemas.openxmlformats.org/drawingml/2006/main">
-            <a:pPr algn="l">
-              <a:defRPr sz="1425" b="0">
-                <a:solidFill>
-                  <a:srgbClr val="667085"/>
-                </a:solidFill>
-              </a:defRPr>
-            </a:pPr>
-            <a:r>
-              <a:rPr sz="1425" b="0">
-                <a:solidFill>
-                  <a:srgbClr val="667085"/>
-                </a:solidFill>
-              </a:rPr>
-              <a:t>Amazon management P&amp;L</a:t>
-            </a:r>
-          </a:p>
-          <a:p xmlns:a="http://schemas.openxmlformats.org/drawingml/2006/main">
-            <a:pPr algn="l">
-              <a:defRPr sz="1425" b="0">
-                <a:solidFill>
-                  <a:srgbClr val="667085"/>
-                </a:solidFill>
-              </a:defRPr>
-            </a:pPr>
-            <a:r>
-              <a:rPr sz="1425" b="0">
-                <a:solidFill>
-                  <a:srgbClr val="667085"/>
-                </a:solidFill>
-              </a:rPr>
-              <a:t>QuickBooks reconciliation</a:t>
-            </a:r>
-          </a:p>
-          <a:p xmlns:a="http://schemas.openxmlformats.org/drawingml/2006/main">
-            <a:pPr algn="l">
-              <a:defRPr sz="1425" b="0">
-                <a:solidFill>
-                  <a:srgbClr val="667085"/>
-                </a:solidFill>
-              </a:defRPr>
-            </a:pPr>
-            <a:r>
-              <a:rPr sz="1425" b="0">
-                <a:solidFill>
-                  <a:srgbClr val="667085"/>
-                </a:solidFill>
-              </a:rPr>
-              <a:t>source drill-through</a:t>
+              <a:defRPr sz="1275" b="1">
+                <a:solidFill>
+                  <a:srgbClr val="B42318"/>
+                </a:solidFill>
+              </a:defRPr>
+            </a:pPr>
+            <a:r>
+              <a:rPr sz="1275" b="1">
+                <a:solidFill>
+                  <a:srgbClr val="B42318"/>
+                </a:solidFill>
+              </a:rPr>
+              <a:t>Refund impact equals 47% of remaining CM</a:t>
             </a:r>
           </a:p>
         </p:txBody>
@@ -9452,274 +10997,7 @@
           <p:cNvPr id="12" name="">
             <a:extLst xmlns:a="http://schemas.openxmlformats.org/drawingml/2006/main">
               <a:ext uri="{FF2B5EF4-FFF2-40B4-BE49-F238E27FC236}">
-                <a16:creationId xmlns:a16="http://schemas.microsoft.com/office/drawing/2014/main" id="{ADB424E9-018F-4025-9163-E9C007255262}"/>
-              </a:ext>
-            </a:extLst>
-          </p:cNvPr>
-          <p:cNvSpPr>
-            <a:spLocks xmlns:a="http://schemas.openxmlformats.org/drawingml/2006/main" noGrp="1"/>
-          </p:cNvSpPr>
-          <p:nvPr/>
-        </p:nvSpPr>
-        <p:spPr>
-          <a:xfrm xmlns:a="http://schemas.openxmlformats.org/drawingml/2006/main">
-            <a:off x="7886700" y="2047875"/>
-            <a:ext cx="3143250" cy="285750"/>
-          </a:xfrm>
-          <a:prstGeom xmlns:a="http://schemas.openxmlformats.org/drawingml/2006/main" prst="rect">
-            <a:avLst/>
-          </a:prstGeom>
-          <a:noFill xmlns:a="http://schemas.openxmlformats.org/drawingml/2006/main"/>
-          <a:ln xmlns:a="http://schemas.openxmlformats.org/drawingml/2006/main" w="0">
-            <a:noFill/>
-            <a:prstDash val="solid"/>
-          </a:ln>
-        </p:spPr>
-        <p:txBody>
-          <a:bodyPr xmlns:a="http://schemas.openxmlformats.org/drawingml/2006/main"/>
-          <a:lstStyle xmlns:a="http://schemas.openxmlformats.org/drawingml/2006/main"/>
-          <a:p xmlns:a="http://schemas.openxmlformats.org/drawingml/2006/main">
-            <a:pPr algn="l">
-              <a:defRPr sz="1350" b="1">
-                <a:solidFill>
-                  <a:srgbClr val="2E74B5"/>
-                </a:solidFill>
-              </a:defRPr>
-            </a:pPr>
-            <a:r>
-              <a:rPr sz="1350" b="1">
-                <a:solidFill>
-                  <a:srgbClr val="2E74B5"/>
-                </a:solidFill>
-              </a:rPr>
-              <a:t>Days 61–90</a:t>
-            </a:r>
-          </a:p>
-        </p:txBody>
-      </p:sp>
-      <p:sp>
-        <p:nvSpPr>
-          <p:cNvPr id="13" name="">
-            <a:extLst xmlns:a="http://schemas.openxmlformats.org/drawingml/2006/main">
-              <a:ext uri="{FF2B5EF4-FFF2-40B4-BE49-F238E27FC236}">
-                <a16:creationId xmlns:a16="http://schemas.microsoft.com/office/drawing/2014/main" id="{F990B189-168E-463B-A316-F4A315A8FDDC}"/>
-              </a:ext>
-            </a:extLst>
-          </p:cNvPr>
-          <p:cNvSpPr>
-            <a:spLocks xmlns:a="http://schemas.openxmlformats.org/drawingml/2006/main" noGrp="1"/>
-          </p:cNvSpPr>
-          <p:nvPr/>
-        </p:nvSpPr>
-        <p:spPr>
-          <a:xfrm xmlns:a="http://schemas.openxmlformats.org/drawingml/2006/main">
-            <a:off x="7886700" y="2457450"/>
-            <a:ext cx="3143250" cy="57150"/>
-          </a:xfrm>
-          <a:prstGeom xmlns:a="http://schemas.openxmlformats.org/drawingml/2006/main" prst="rect">
-            <a:avLst/>
-          </a:prstGeom>
-          <a:solidFill xmlns:a="http://schemas.openxmlformats.org/drawingml/2006/main">
-            <a:srgbClr val="2E74B5"/>
-          </a:solidFill>
-          <a:ln xmlns:a="http://schemas.openxmlformats.org/drawingml/2006/main" w="0">
-            <a:solidFill>
-              <a:srgbClr val="2E74B5"/>
-            </a:solidFill>
-            <a:prstDash val="solid"/>
-          </a:ln>
-        </p:spPr>
-      </p:sp>
-      <p:sp>
-        <p:nvSpPr>
-          <p:cNvPr id="14" name="">
-            <a:extLst xmlns:a="http://schemas.openxmlformats.org/drawingml/2006/main">
-              <a:ext uri="{FF2B5EF4-FFF2-40B4-BE49-F238E27FC236}">
-                <a16:creationId xmlns:a16="http://schemas.microsoft.com/office/drawing/2014/main" id="{A75A8ABB-2842-4FA6-9946-2EAD63197CFB}"/>
-              </a:ext>
-            </a:extLst>
-          </p:cNvPr>
-          <p:cNvSpPr>
-            <a:spLocks xmlns:a="http://schemas.openxmlformats.org/drawingml/2006/main" noGrp="1"/>
-          </p:cNvSpPr>
-          <p:nvPr/>
-        </p:nvSpPr>
-        <p:spPr>
-          <a:xfrm xmlns:a="http://schemas.openxmlformats.org/drawingml/2006/main">
-            <a:off x="7886700" y="2781300"/>
-            <a:ext cx="3143250" cy="361950"/>
-          </a:xfrm>
-          <a:prstGeom xmlns:a="http://schemas.openxmlformats.org/drawingml/2006/main" prst="rect">
-            <a:avLst/>
-          </a:prstGeom>
-          <a:noFill xmlns:a="http://schemas.openxmlformats.org/drawingml/2006/main"/>
-          <a:ln xmlns:a="http://schemas.openxmlformats.org/drawingml/2006/main" w="0">
-            <a:noFill/>
-            <a:prstDash val="solid"/>
-          </a:ln>
-        </p:spPr>
-        <p:txBody>
-          <a:bodyPr xmlns:a="http://schemas.openxmlformats.org/drawingml/2006/main"/>
-          <a:lstStyle xmlns:a="http://schemas.openxmlformats.org/drawingml/2006/main"/>
-          <a:p xmlns:a="http://schemas.openxmlformats.org/drawingml/2006/main">
-            <a:pPr algn="l">
-              <a:defRPr sz="1875" b="1">
-                <a:solidFill>
-                  <a:srgbClr val="0B2545"/>
-                </a:solidFill>
-              </a:defRPr>
-            </a:pPr>
-            <a:r>
-              <a:rPr sz="1875" b="1">
-                <a:solidFill>
-                  <a:srgbClr val="0B2545"/>
-                </a:solidFill>
-              </a:rPr>
-              <a:t>Operational action</a:t>
-            </a:r>
-          </a:p>
-        </p:txBody>
-      </p:sp>
-      <p:sp>
-        <p:nvSpPr>
-          <p:cNvPr id="15" name="">
-            <a:extLst xmlns:a="http://schemas.openxmlformats.org/drawingml/2006/main">
-              <a:ext uri="{FF2B5EF4-FFF2-40B4-BE49-F238E27FC236}">
-                <a16:creationId xmlns:a16="http://schemas.microsoft.com/office/drawing/2014/main" id="{AD89EA5D-82E6-42C2-9871-5D428044758F}"/>
-              </a:ext>
-            </a:extLst>
-          </p:cNvPr>
-          <p:cNvSpPr>
-            <a:spLocks xmlns:a="http://schemas.openxmlformats.org/drawingml/2006/main" noGrp="1"/>
-          </p:cNvSpPr>
-          <p:nvPr/>
-        </p:nvSpPr>
-        <p:spPr>
-          <a:xfrm xmlns:a="http://schemas.openxmlformats.org/drawingml/2006/main">
-            <a:off x="7886700" y="3352800"/>
-            <a:ext cx="3143250" cy="1047750"/>
-          </a:xfrm>
-          <a:prstGeom xmlns:a="http://schemas.openxmlformats.org/drawingml/2006/main" prst="rect">
-            <a:avLst/>
-          </a:prstGeom>
-          <a:noFill xmlns:a="http://schemas.openxmlformats.org/drawingml/2006/main"/>
-          <a:ln xmlns:a="http://schemas.openxmlformats.org/drawingml/2006/main" w="0">
-            <a:noFill/>
-            <a:prstDash val="solid"/>
-          </a:ln>
-        </p:spPr>
-        <p:txBody>
-          <a:bodyPr xmlns:a="http://schemas.openxmlformats.org/drawingml/2006/main"/>
-          <a:lstStyle xmlns:a="http://schemas.openxmlformats.org/drawingml/2006/main"/>
-          <a:p xmlns:a="http://schemas.openxmlformats.org/drawingml/2006/main">
-            <a:pPr algn="l">
-              <a:defRPr sz="1425" b="0">
-                <a:solidFill>
-                  <a:srgbClr val="667085"/>
-                </a:solidFill>
-              </a:defRPr>
-            </a:pPr>
-            <a:r>
-              <a:rPr sz="1425" b="0">
-                <a:solidFill>
-                  <a:srgbClr val="667085"/>
-                </a:solidFill>
-              </a:rPr>
-              <a:t>REACH PO/receipt history</a:t>
-            </a:r>
-          </a:p>
-          <a:p xmlns:a="http://schemas.openxmlformats.org/drawingml/2006/main">
-            <a:pPr algn="l">
-              <a:defRPr sz="1425" b="0">
-                <a:solidFill>
-                  <a:srgbClr val="667085"/>
-                </a:solidFill>
-              </a:defRPr>
-            </a:pPr>
-            <a:r>
-              <a:rPr sz="1425" b="0">
-                <a:solidFill>
-                  <a:srgbClr val="667085"/>
-                </a:solidFill>
-              </a:rPr>
-              <a:t>advertising attribution</a:t>
-            </a:r>
-          </a:p>
-          <a:p xmlns:a="http://schemas.openxmlformats.org/drawingml/2006/main">
-            <a:pPr algn="l">
-              <a:defRPr sz="1425" b="0">
-                <a:solidFill>
-                  <a:srgbClr val="667085"/>
-                </a:solidFill>
-              </a:defRPr>
-            </a:pPr>
-            <a:r>
-              <a:rPr sz="1425" b="0">
-                <a:solidFill>
-                  <a:srgbClr val="667085"/>
-                </a:solidFill>
-              </a:rPr>
-              <a:t>inventory + 13-week outlook</a:t>
-            </a:r>
-          </a:p>
-        </p:txBody>
-      </p:sp>
-      <p:sp>
-        <p:nvSpPr>
-          <p:cNvPr id="16" name="">
-            <a:extLst xmlns:a="http://schemas.openxmlformats.org/drawingml/2006/main">
-              <a:ext uri="{FF2B5EF4-FFF2-40B4-BE49-F238E27FC236}">
-                <a16:creationId xmlns:a16="http://schemas.microsoft.com/office/drawing/2014/main" id="{50BFDC33-0597-4325-8E5E-1B65C747CBCA}"/>
-              </a:ext>
-            </a:extLst>
-          </p:cNvPr>
-          <p:cNvSpPr>
-            <a:spLocks xmlns:a="http://schemas.openxmlformats.org/drawingml/2006/main" noGrp="1"/>
-          </p:cNvSpPr>
-          <p:nvPr/>
-        </p:nvSpPr>
-        <p:spPr>
-          <a:xfrm xmlns:a="http://schemas.openxmlformats.org/drawingml/2006/main">
-            <a:off x="685800" y="5143500"/>
-            <a:ext cx="10820400" cy="438150"/>
-          </a:xfrm>
-          <a:prstGeom xmlns:a="http://schemas.openxmlformats.org/drawingml/2006/main" prst="rect">
-            <a:avLst/>
-          </a:prstGeom>
-          <a:noFill xmlns:a="http://schemas.openxmlformats.org/drawingml/2006/main"/>
-          <a:ln xmlns:a="http://schemas.openxmlformats.org/drawingml/2006/main" w="0">
-            <a:noFill/>
-            <a:prstDash val="solid"/>
-          </a:ln>
-        </p:spPr>
-        <p:txBody>
-          <a:bodyPr xmlns:a="http://schemas.openxmlformats.org/drawingml/2006/main"/>
-          <a:lstStyle xmlns:a="http://schemas.openxmlformats.org/drawingml/2006/main"/>
-          <a:p xmlns:a="http://schemas.openxmlformats.org/drawingml/2006/main">
-            <a:pPr algn="ctr">
-              <a:defRPr sz="1575" b="1">
-                <a:solidFill>
-                  <a:srgbClr val="0B2545"/>
-                </a:solidFill>
-              </a:defRPr>
-            </a:pPr>
-            <a:r>
-              <a:rPr sz="1575" b="1">
-                <a:solidFill>
-                  <a:srgbClr val="0B2545"/>
-                </a:solidFill>
-              </a:rPr>
-              <a:t>Start cost-aware in GCP; buy managed connectors when reliability or implementation speed justifies the recurring cost.</a:t>
-            </a:r>
-          </a:p>
-        </p:txBody>
-      </p:sp>
-      <p:sp>
-        <p:nvSpPr>
-          <p:cNvPr id="17" name="">
-            <a:extLst xmlns:a="http://schemas.openxmlformats.org/drawingml/2006/main">
-              <a:ext uri="{FF2B5EF4-FFF2-40B4-BE49-F238E27FC236}">
-                <a16:creationId xmlns:a16="http://schemas.microsoft.com/office/drawing/2014/main" id="{741FD7B3-F195-45C4-A23F-2B4837414549}"/>
+                <a16:creationId xmlns:a16="http://schemas.microsoft.com/office/drawing/2014/main" id="{BDC7F103-8269-4E58-BA92-67B3E54CF490}"/>
               </a:ext>
             </a:extLst>
           </p:cNvPr>
@@ -9766,10 +11044,10 @@
       </p:sp>
       <p:sp>
         <p:nvSpPr>
-          <p:cNvPr id="18" name="">
-            <a:extLst xmlns:a="http://schemas.openxmlformats.org/drawingml/2006/main">
-              <a:ext uri="{FF2B5EF4-FFF2-40B4-BE49-F238E27FC236}">
-                <a16:creationId xmlns:a16="http://schemas.microsoft.com/office/drawing/2014/main" id="{1DE52240-90FD-40CF-9150-6ACBFF55D5EF}"/>
+          <p:cNvPr id="13" name="">
+            <a:extLst xmlns:a="http://schemas.openxmlformats.org/drawingml/2006/main">
+              <a:ext uri="{FF2B5EF4-FFF2-40B4-BE49-F238E27FC236}">
+                <a16:creationId xmlns:a16="http://schemas.microsoft.com/office/drawing/2014/main" id="{5A11DD9A-5466-4C72-9BE7-6C124B4BC45F}"/>
               </a:ext>
             </a:extLst>
           </p:cNvPr>
@@ -9817,7 +11095,7 @@
     </p:spTree>
     <p:extLst>
       <p:ext uri="{BB962C8B-B14F-4D97-AF65-F5344CB8AC3E}">
-        <p14:creationId xmlns:p14="http://schemas.microsoft.com/office/powerpoint/2010/main" val="672020330"/>
+        <p14:creationId xmlns:p14="http://schemas.microsoft.com/office/powerpoint/2010/main" val="679416883"/>
       </p:ext>
     </p:extLst>
   </p:cSld>

</xml_diff>